<commit_message>
Add MAE findings slide: Sur presostatos drop and night controls
New slide 3 opens with the Estanque Sur pressure-switch repair (10/06)
and a daily series showing the drop. Left chart is captured night
savings for Pizza Hut and Estanque Norte; nights with control are not
read as leaks.

Co-authored-by: anibaloperacionesWes <anibaloperacionesWes@users.noreply.github.com>
</commit_message>
<xml_diff>
--- a/reports/Parque_Arauco/TMP_7MALLS/entrega_diego_anibal/Recorrido_ejecutivo_PA_MAE_20260817.pptx
+++ b/reports/Parque_Arauco/TMP_7MALLS/entrega_diego_anibal/Recorrido_ejecutivo_PA_MAE_20260817.pptx
@@ -8,6 +8,7 @@
     <p:sldId id="256" r:id="rId7"/>
     <p:sldId id="257" r:id="rId8"/>
     <p:sldId id="258" r:id="rId9"/>
+    <p:sldId id="259" r:id="rId10"/>
   </p:sldIdLst>
   <p:sldSz cx="12191695" cy="6858000" type="screen4x3"/>
   <p:notesSz cx="6858000" cy="9144000"/>
@@ -5244,6 +5245,624 @@
                 <a:latin typeface="Calibri"/>
               </a:rPr>
               <a:t>Dorado = lo que agosto ya lleva. Tramo claro = proyección del resto del mes. Mayo cierra más alto por Estanque Sur, antes de la reparación del 10/06.</a:t>
+            </a:r>
+          </a:p>
+        </p:txBody>
+      </p:sp>
+    </p:spTree>
+  </p:cSld>
+  <p:clrMapOvr>
+    <a:masterClrMapping/>
+  </p:clrMapOvr>
+</p:sld>
+</file>
+
+<file path=ppt/slides/slide4.xml><?xml version="1.0" encoding="utf-8"?>
+<p:sld xmlns:a="http://schemas.openxmlformats.org/drawingml/2006/main" xmlns:p="http://schemas.openxmlformats.org/presentationml/2006/main" xmlns:r="http://schemas.openxmlformats.org/officeDocument/2006/relationships">
+  <p:cSld>
+    <p:spTree>
+      <p:nvGrpSpPr>
+        <p:cNvPr id="1" name=""/>
+        <p:cNvGrpSpPr/>
+        <p:nvPr/>
+      </p:nvGrpSpPr>
+      <p:grpSpPr/>
+      <p:sp>
+        <p:nvSpPr>
+          <p:cNvPr id="2" name="Rectangle 1"/>
+          <p:cNvSpPr/>
+          <p:nvPr/>
+        </p:nvSpPr>
+        <p:spPr>
+          <a:xfrm>
+            <a:off x="0" y="0"/>
+            <a:ext cx="12191695" cy="841248"/>
+          </a:xfrm>
+          <a:prstGeom prst="rect">
+            <a:avLst/>
+          </a:prstGeom>
+          <a:solidFill>
+            <a:srgbClr val="0D3B66"/>
+          </a:solidFill>
+          <a:ln>
+            <a:noFill/>
+          </a:ln>
+        </p:spPr>
+        <p:style>
+          <a:lnRef idx="1">
+            <a:schemeClr val="accent1"/>
+          </a:lnRef>
+          <a:fillRef idx="3">
+            <a:schemeClr val="accent1"/>
+          </a:fillRef>
+          <a:effectRef idx="2">
+            <a:schemeClr val="accent1"/>
+          </a:effectRef>
+          <a:fontRef idx="minor">
+            <a:schemeClr val="lt1"/>
+          </a:fontRef>
+        </p:style>
+        <p:txBody>
+          <a:bodyPr rtlCol="0" anchor="ctr"/>
+          <a:lstStyle/>
+          <a:p>
+            <a:pPr algn="ctr"/>
+          </a:p>
+        </p:txBody>
+      </p:sp>
+      <p:sp>
+        <p:nvSpPr>
+          <p:cNvPr id="3" name="Rectangle 2"/>
+          <p:cNvSpPr/>
+          <p:nvPr/>
+        </p:nvSpPr>
+        <p:spPr>
+          <a:xfrm>
+            <a:off x="0" y="841248"/>
+            <a:ext cx="12191695" cy="54864"/>
+          </a:xfrm>
+          <a:prstGeom prst="rect">
+            <a:avLst/>
+          </a:prstGeom>
+          <a:solidFill>
+            <a:srgbClr val="C9A227"/>
+          </a:solidFill>
+          <a:ln>
+            <a:noFill/>
+          </a:ln>
+        </p:spPr>
+        <p:style>
+          <a:lnRef idx="1">
+            <a:schemeClr val="accent1"/>
+          </a:lnRef>
+          <a:fillRef idx="3">
+            <a:schemeClr val="accent1"/>
+          </a:fillRef>
+          <a:effectRef idx="2">
+            <a:schemeClr val="accent1"/>
+          </a:effectRef>
+          <a:fontRef idx="minor">
+            <a:schemeClr val="lt1"/>
+          </a:fontRef>
+        </p:style>
+        <p:txBody>
+          <a:bodyPr rtlCol="0" anchor="ctr"/>
+          <a:lstStyle/>
+          <a:p>
+            <a:pPr algn="ctr"/>
+          </a:p>
+        </p:txBody>
+      </p:sp>
+      <p:pic>
+        <p:nvPicPr>
+          <p:cNvPr id="4" name="Picture 3" descr="logo wes.bmp"/>
+          <p:cNvPicPr>
+            <a:picLocks noChangeAspect="1"/>
+          </p:cNvPicPr>
+          <p:nvPr/>
+        </p:nvPicPr>
+        <p:blipFill>
+          <a:blip r:embed="rId2"/>
+          <a:stretch>
+            <a:fillRect/>
+          </a:stretch>
+        </p:blipFill>
+        <p:spPr>
+          <a:xfrm>
+            <a:off x="10835640" y="146304"/>
+            <a:ext cx="1143000" cy="253401"/>
+          </a:xfrm>
+          <a:prstGeom prst="rect">
+            <a:avLst/>
+          </a:prstGeom>
+        </p:spPr>
+      </p:pic>
+      <p:sp>
+        <p:nvSpPr>
+          <p:cNvPr id="5" name="TextBox 4"/>
+          <p:cNvSpPr txBox="1"/>
+          <p:nvPr/>
+        </p:nvSpPr>
+        <p:spPr>
+          <a:xfrm>
+            <a:off x="256032" y="109728"/>
+            <a:ext cx="10607040" cy="384048"/>
+          </a:xfrm>
+          <a:prstGeom prst="rect">
+            <a:avLst/>
+          </a:prstGeom>
+          <a:noFill/>
+        </p:spPr>
+        <p:txBody>
+          <a:bodyPr wrap="square">
+            <a:spAutoFit/>
+          </a:bodyPr>
+          <a:lstStyle/>
+          <a:p>
+            <a:pPr algn="l">
+              <a:spcAft>
+                <a:spcPts val="300"/>
+              </a:spcAft>
+            </a:pPr>
+            <a:r>
+              <a:rPr sz="2000" b="1">
+                <a:solidFill>
+                  <a:srgbClr val="FFFFFF"/>
+                </a:solidFill>
+                <a:latin typeface="Calibri"/>
+              </a:rPr>
+              <a:t>MAE  ·  3. Hallazgos</a:t>
+            </a:r>
+          </a:p>
+        </p:txBody>
+      </p:sp>
+      <p:sp>
+        <p:nvSpPr>
+          <p:cNvPr id="6" name="TextBox 5"/>
+          <p:cNvSpPr txBox="1"/>
+          <p:nvPr/>
+        </p:nvSpPr>
+        <p:spPr>
+          <a:xfrm>
+            <a:off x="256032" y="457200"/>
+            <a:ext cx="10607040" cy="329184"/>
+          </a:xfrm>
+          <a:prstGeom prst="rect">
+            <a:avLst/>
+          </a:prstGeom>
+          <a:noFill/>
+        </p:spPr>
+        <p:txBody>
+          <a:bodyPr wrap="square">
+            <a:spAutoFit/>
+          </a:bodyPr>
+          <a:lstStyle/>
+          <a:p>
+            <a:pPr algn="l">
+              <a:spcAft>
+                <a:spcPts val="300"/>
+              </a:spcAft>
+            </a:pPr>
+            <a:r>
+              <a:rPr sz="1100" b="0">
+                <a:solidFill>
+                  <a:srgbClr val="DCE6F0"/>
+                </a:solidFill>
+                <a:latin typeface="Calibri"/>
+              </a:rPr>
+              <a:t>Estanque Sur: reparación de presostatos (10/06)  ·  Controles nocturnos: noche con control ≠ fuga</a:t>
+            </a:r>
+          </a:p>
+        </p:txBody>
+      </p:sp>
+      <p:sp>
+        <p:nvSpPr>
+          <p:cNvPr id="7" name="Rounded Rectangle 6"/>
+          <p:cNvSpPr/>
+          <p:nvPr/>
+        </p:nvSpPr>
+        <p:spPr>
+          <a:xfrm>
+            <a:off x="201168" y="1005840"/>
+            <a:ext cx="11777472" cy="1024128"/>
+          </a:xfrm>
+          <a:prstGeom prst="roundRect">
+            <a:avLst>
+              <a:gd name="adj" fmla="val 8000"/>
+            </a:avLst>
+          </a:prstGeom>
+          <a:solidFill>
+            <a:srgbClr val="FFF9EB"/>
+          </a:solidFill>
+          <a:ln w="6350">
+            <a:solidFill>
+              <a:srgbClr val="C9A227"/>
+            </a:solidFill>
+          </a:ln>
+        </p:spPr>
+        <p:style>
+          <a:lnRef idx="1">
+            <a:schemeClr val="accent1"/>
+          </a:lnRef>
+          <a:fillRef idx="3">
+            <a:schemeClr val="accent1"/>
+          </a:fillRef>
+          <a:effectRef idx="2">
+            <a:schemeClr val="accent1"/>
+          </a:effectRef>
+          <a:fontRef idx="minor">
+            <a:schemeClr val="lt1"/>
+          </a:fontRef>
+        </p:style>
+        <p:txBody>
+          <a:bodyPr rtlCol="0" anchor="ctr"/>
+          <a:lstStyle/>
+          <a:p>
+            <a:pPr algn="ctr"/>
+          </a:p>
+        </p:txBody>
+      </p:sp>
+      <p:sp>
+        <p:nvSpPr>
+          <p:cNvPr id="8" name="TextBox 7"/>
+          <p:cNvSpPr txBox="1"/>
+          <p:nvPr/>
+        </p:nvSpPr>
+        <p:spPr>
+          <a:xfrm>
+            <a:off x="365760" y="1060704"/>
+            <a:ext cx="11475720" cy="256032"/>
+          </a:xfrm>
+          <a:prstGeom prst="rect">
+            <a:avLst/>
+          </a:prstGeom>
+          <a:noFill/>
+        </p:spPr>
+        <p:txBody>
+          <a:bodyPr wrap="square">
+            <a:spAutoFit/>
+          </a:bodyPr>
+          <a:lstStyle/>
+          <a:p>
+            <a:pPr algn="l">
+              <a:spcAft>
+                <a:spcPts val="300"/>
+              </a:spcAft>
+            </a:pPr>
+            <a:r>
+              <a:rPr sz="1100" b="1">
+                <a:solidFill>
+                  <a:srgbClr val="C9A227"/>
+                </a:solidFill>
+                <a:latin typeface="Calibri"/>
+              </a:rPr>
+              <a:t>ESTANQUE SUR  ·  PRESÓSTATOS</a:t>
+            </a:r>
+          </a:p>
+        </p:txBody>
+      </p:sp>
+      <p:sp>
+        <p:nvSpPr>
+          <p:cNvPr id="9" name="TextBox 8"/>
+          <p:cNvSpPr txBox="1"/>
+          <p:nvPr/>
+        </p:nvSpPr>
+        <p:spPr>
+          <a:xfrm>
+            <a:off x="365760" y="1316736"/>
+            <a:ext cx="11475720" cy="621792"/>
+          </a:xfrm>
+          <a:prstGeom prst="rect">
+            <a:avLst/>
+          </a:prstGeom>
+          <a:noFill/>
+        </p:spPr>
+        <p:txBody>
+          <a:bodyPr wrap="square">
+            <a:spAutoFit/>
+          </a:bodyPr>
+          <a:lstStyle/>
+          <a:p>
+            <a:pPr algn="l">
+              <a:spcAft>
+                <a:spcPts val="300"/>
+              </a:spcAft>
+            </a:pPr>
+            <a:r>
+              <a:rPr sz="1300" b="0">
+                <a:solidFill>
+                  <a:srgbClr val="0D3B66"/>
+                </a:solidFill>
+                <a:latin typeface="Calibri"/>
+              </a:rPr>
+              <a:t>El 10/06 se repararon los presostatos. El estanque venía en 89 m³/día (mayo–9/jun) y ese día ya marca 39 m³. Desde el 11/06 se sostiene en 28 m³/día (−61 m³/día, 68%). No es fuga residual: la baja quedó en el dato diario.</a:t>
+            </a:r>
+          </a:p>
+        </p:txBody>
+      </p:sp>
+      <p:sp>
+        <p:nvSpPr>
+          <p:cNvPr id="10" name="Rounded Rectangle 9"/>
+          <p:cNvSpPr/>
+          <p:nvPr/>
+        </p:nvSpPr>
+        <p:spPr>
+          <a:xfrm>
+            <a:off x="201168" y="2121408"/>
+            <a:ext cx="5285232" cy="3584448"/>
+          </a:xfrm>
+          <a:prstGeom prst="roundRect">
+            <a:avLst>
+              <a:gd name="adj" fmla="val 8000"/>
+            </a:avLst>
+          </a:prstGeom>
+          <a:solidFill>
+            <a:srgbClr val="F5F7FA"/>
+          </a:solidFill>
+          <a:ln>
+            <a:noFill/>
+          </a:ln>
+        </p:spPr>
+        <p:style>
+          <a:lnRef idx="1">
+            <a:schemeClr val="accent1"/>
+          </a:lnRef>
+          <a:fillRef idx="3">
+            <a:schemeClr val="accent1"/>
+          </a:fillRef>
+          <a:effectRef idx="2">
+            <a:schemeClr val="accent1"/>
+          </a:effectRef>
+          <a:fontRef idx="minor">
+            <a:schemeClr val="lt1"/>
+          </a:fontRef>
+        </p:style>
+        <p:txBody>
+          <a:bodyPr rtlCol="0" anchor="ctr"/>
+          <a:lstStyle/>
+          <a:p>
+            <a:pPr algn="ctr"/>
+          </a:p>
+        </p:txBody>
+      </p:sp>
+      <p:sp>
+        <p:nvSpPr>
+          <p:cNvPr id="11" name="TextBox 10"/>
+          <p:cNvSpPr txBox="1"/>
+          <p:nvPr/>
+        </p:nvSpPr>
+        <p:spPr>
+          <a:xfrm>
+            <a:off x="329184" y="2176272"/>
+            <a:ext cx="5029200" cy="256032"/>
+          </a:xfrm>
+          <a:prstGeom prst="rect">
+            <a:avLst/>
+          </a:prstGeom>
+          <a:noFill/>
+        </p:spPr>
+        <p:txBody>
+          <a:bodyPr wrap="square">
+            <a:spAutoFit/>
+          </a:bodyPr>
+          <a:lstStyle/>
+          <a:p>
+            <a:pPr algn="l">
+              <a:spcAft>
+                <a:spcPts val="300"/>
+              </a:spcAft>
+            </a:pPr>
+            <a:r>
+              <a:rPr sz="1100" b="1">
+                <a:solidFill>
+                  <a:srgbClr val="1F77B4"/>
+                </a:solidFill>
+                <a:latin typeface="Calibri"/>
+              </a:rPr>
+              <a:t>CONTROLES NOCTURNOS — lo que se consiguió</a:t>
+            </a:r>
+          </a:p>
+        </p:txBody>
+      </p:sp>
+      <p:pic>
+        <p:nvPicPr>
+          <p:cNvPr id="12" name="Picture 11" descr="mae_controles_nocturnos.png"/>
+          <p:cNvPicPr>
+            <a:picLocks noChangeAspect="1"/>
+          </p:cNvPicPr>
+          <p:nvPr/>
+        </p:nvPicPr>
+        <p:blipFill>
+          <a:blip r:embed="rId3"/>
+          <a:stretch>
+            <a:fillRect/>
+          </a:stretch>
+        </p:blipFill>
+        <p:spPr>
+          <a:xfrm>
+            <a:off x="329184" y="2450592"/>
+            <a:ext cx="5010912" cy="3035808"/>
+          </a:xfrm>
+          <a:prstGeom prst="rect">
+            <a:avLst/>
+          </a:prstGeom>
+        </p:spPr>
+      </p:pic>
+      <p:sp>
+        <p:nvSpPr>
+          <p:cNvPr id="13" name="Rounded Rectangle 12"/>
+          <p:cNvSpPr/>
+          <p:nvPr/>
+        </p:nvSpPr>
+        <p:spPr>
+          <a:xfrm>
+            <a:off x="5614416" y="2121408"/>
+            <a:ext cx="6364224" cy="3584448"/>
+          </a:xfrm>
+          <a:prstGeom prst="roundRect">
+            <a:avLst>
+              <a:gd name="adj" fmla="val 8000"/>
+            </a:avLst>
+          </a:prstGeom>
+          <a:solidFill>
+            <a:srgbClr val="F5F7FA"/>
+          </a:solidFill>
+          <a:ln>
+            <a:noFill/>
+          </a:ln>
+        </p:spPr>
+        <p:style>
+          <a:lnRef idx="1">
+            <a:schemeClr val="accent1"/>
+          </a:lnRef>
+          <a:fillRef idx="3">
+            <a:schemeClr val="accent1"/>
+          </a:fillRef>
+          <a:effectRef idx="2">
+            <a:schemeClr val="accent1"/>
+          </a:effectRef>
+          <a:fontRef idx="minor">
+            <a:schemeClr val="lt1"/>
+          </a:fontRef>
+        </p:style>
+        <p:txBody>
+          <a:bodyPr rtlCol="0" anchor="ctr"/>
+          <a:lstStyle/>
+          <a:p>
+            <a:pPr algn="ctr"/>
+          </a:p>
+        </p:txBody>
+      </p:sp>
+      <p:sp>
+        <p:nvSpPr>
+          <p:cNvPr id="14" name="TextBox 13"/>
+          <p:cNvSpPr txBox="1"/>
+          <p:nvPr/>
+        </p:nvSpPr>
+        <p:spPr>
+          <a:xfrm>
+            <a:off x="5742432" y="2176272"/>
+            <a:ext cx="6108192" cy="256032"/>
+          </a:xfrm>
+          <a:prstGeom prst="rect">
+            <a:avLst/>
+          </a:prstGeom>
+          <a:noFill/>
+        </p:spPr>
+        <p:txBody>
+          <a:bodyPr wrap="square">
+            <a:spAutoFit/>
+          </a:bodyPr>
+          <a:lstStyle/>
+          <a:p>
+            <a:pPr algn="l">
+              <a:spcAft>
+                <a:spcPts val="300"/>
+              </a:spcAft>
+            </a:pPr>
+            <a:r>
+              <a:rPr sz="1100" b="1">
+                <a:solidFill>
+                  <a:srgbClr val="1F77B4"/>
+                </a:solidFill>
+                <a:latin typeface="Calibri"/>
+              </a:rPr>
+              <a:t>ESTANQUE SUR — m³/día (la baja post 10/06)</a:t>
+            </a:r>
+          </a:p>
+        </p:txBody>
+      </p:sp>
+      <p:pic>
+        <p:nvPicPr>
+          <p:cNvPr id="15" name="Picture 14" descr="mae_sur_diario_presostatos.png"/>
+          <p:cNvPicPr>
+            <a:picLocks noChangeAspect="1"/>
+          </p:cNvPicPr>
+          <p:nvPr/>
+        </p:nvPicPr>
+        <p:blipFill>
+          <a:blip r:embed="rId4"/>
+          <a:stretch>
+            <a:fillRect/>
+          </a:stretch>
+        </p:blipFill>
+        <p:spPr>
+          <a:xfrm>
+            <a:off x="5742432" y="2450592"/>
+            <a:ext cx="6108192" cy="3035808"/>
+          </a:xfrm>
+          <a:prstGeom prst="rect">
+            <a:avLst/>
+          </a:prstGeom>
+        </p:spPr>
+      </p:pic>
+      <p:sp>
+        <p:nvSpPr>
+          <p:cNvPr id="16" name="TextBox 15"/>
+          <p:cNvSpPr txBox="1"/>
+          <p:nvPr/>
+        </p:nvSpPr>
+        <p:spPr>
+          <a:xfrm>
+            <a:off x="256032" y="5779008"/>
+            <a:ext cx="11704320" cy="932688"/>
+          </a:xfrm>
+          <a:prstGeom prst="rect">
+            <a:avLst/>
+          </a:prstGeom>
+          <a:noFill/>
+        </p:spPr>
+        <p:txBody>
+          <a:bodyPr wrap="square">
+            <a:spAutoFit/>
+          </a:bodyPr>
+          <a:lstStyle/>
+          <a:p>
+            <a:pPr algn="l">
+              <a:spcAft>
+                <a:spcPts val="300"/>
+              </a:spcAft>
+            </a:pPr>
+            <a:r>
+              <a:rPr sz="1200" b="0">
+                <a:solidFill>
+                  <a:srgbClr val="0D3B66"/>
+                </a:solidFill>
+                <a:latin typeface="Calibri"/>
+              </a:rPr>
+              <a:t>Pizza Hut (01/07): noche típica 0,1 → 0 m³. El control sostiene el cero. El 26–29/07 la noche volvió (~40 m³); no entra a la mediana.</a:t>
+            </a:r>
+          </a:p>
+          <a:p>
+            <a:pPr algn="l">
+              <a:spcAft>
+                <a:spcPts val="300"/>
+              </a:spcAft>
+            </a:pPr>
+            <a:r>
+              <a:rPr sz="1200" b="0">
+                <a:solidFill>
+                  <a:srgbClr val="0D3B66"/>
+                </a:solidFill>
+                <a:latin typeface="Calibri"/>
+              </a:rPr>
+              <a:t>Estanque Norte (05/08): 4,8 → 1,1 m³/noche (ahorro 3,7 m³/noche; 48 m³ en 13 noches). Esa madrugada no se lee como fuga.</a:t>
+            </a:r>
+          </a:p>
+          <a:p>
+            <a:pPr algn="l">
+              <a:spcAft>
+                <a:spcPts val="300"/>
+              </a:spcAft>
+            </a:pPr>
+            <a:r>
+              <a:rPr sz="1100" b="0">
+                <a:solidFill>
+                  <a:srgbClr val="5A5A5A"/>
+                </a:solidFill>
+                <a:latin typeface="Calibri"/>
+              </a:rPr>
+              <a:t>Estanque Sur: corte on/off a cargo de mantención nocturna (no automático). Noche con control: no se lee como fuga.</a:t>
             </a:r>
           </a:p>
         </p:txBody>

</xml_diff>

<commit_message>
Show MAE night-control hours at zero, drop leak wording
The findings slide no longer frames leftover night m³ as a leak. Left
chart is a day×hour map of Estanque Norte: gold = hour at zero. Copy
only names the hours that go to zero (Norte 02:00–05:00; Pizza Hut
00:00–06:00).

Co-authored-by: anibaloperacionesWes <anibaloperacionesWes@users.noreply.github.com>
</commit_message>
<xml_diff>
--- a/reports/Parque_Arauco/TMP_7MALLS/entrega_diego_anibal/Recorrido_ejecutivo_PA_MAE_20260817.pptx
+++ b/reports/Parque_Arauco/TMP_7MALLS/entrega_diego_anibal/Recorrido_ejecutivo_PA_MAE_20260817.pptx
@@ -5450,7 +5450,7 @@
                 </a:solidFill>
                 <a:latin typeface="Calibri"/>
               </a:rPr>
-              <a:t>Estanque Sur: reparación de presostatos (10/06)  ·  Controles nocturnos: noche con control ≠ fuga</a:t>
+              <a:t>Estanque Sur: reparación de presostatos (10/06)  ·  Control nocturno: horas en cero</a:t>
             </a:r>
           </a:p>
         </p:txBody>
@@ -5659,14 +5659,14 @@
                 </a:solidFill>
                 <a:latin typeface="Calibri"/>
               </a:rPr>
-              <a:t>CONTROLES NOCTURNOS — lo que se consiguió</a:t>
+              <a:t>ESTANQUE NORTE — horas en cero (desde 05/08)</a:t>
             </a:r>
           </a:p>
         </p:txBody>
       </p:sp>
       <p:pic>
         <p:nvPicPr>
-          <p:cNvPr id="12" name="Picture 11" descr="mae_controles_nocturnos.png"/>
+          <p:cNvPr id="12" name="Picture 11" descr="mae_horas_en_cero.png"/>
           <p:cNvPicPr>
             <a:picLocks noChangeAspect="1"/>
           </p:cNvPicPr>
@@ -5830,7 +5830,7 @@
                 </a:solidFill>
                 <a:latin typeface="Calibri"/>
               </a:rPr>
-              <a:t>Pizza Hut (01/07): noche típica 0,1 → 0 m³. El control sostiene el cero. El 26–29/07 la noche volvió (~40 m³); no entra a la mediana.</a:t>
+              <a:t>Estanque Norte (control 05/08): en cero 02:00–05:00 (13 noches). Algunos días el cero parte desde las 00:00 (p. ej. 05/08).</a:t>
             </a:r>
           </a:p>
           <a:p>
@@ -5842,27 +5842,11 @@
             <a:r>
               <a:rPr sz="1200" b="0">
                 <a:solidFill>
-                  <a:srgbClr val="0D3B66"/>
+                  <a:srgbClr val="5A5A5A"/>
                 </a:solidFill>
                 <a:latin typeface="Calibri"/>
               </a:rPr>
-              <a:t>Estanque Norte (05/08): 4,8 → 1,1 m³/noche (ahorro 3,7 m³/noche; 48 m³ en 13 noches). Esa madrugada no se lee como fuga.</a:t>
-            </a:r>
-          </a:p>
-          <a:p>
-            <a:pPr algn="l">
-              <a:spcAft>
-                <a:spcPts val="300"/>
-              </a:spcAft>
-            </a:pPr>
-            <a:r>
-              <a:rPr sz="1100" b="0">
-                <a:solidFill>
-                  <a:srgbClr val="5A5A5A"/>
-                </a:solidFill>
-                <a:latin typeface="Calibri"/>
-              </a:rPr>
-              <a:t>Estanque Sur: corte on/off a cargo de mantención nocturna (no automático). Noche con control: no se lee como fuga.</a:t>
+              <a:t>Pizza Hut (control 01/07): en cero 00:00–06:00. Estanque Sur: corte on/off de mantención nocturna.</a:t>
             </a:r>
           </a:p>
         </p:txBody>

</xml_diff>

<commit_message>
Add CLP cost of Estanque Sur drop after presostatos repair
Findings slide now prices the 61 m³/day reduction at $1.400/m³: daily,
monthly, and accumulated 11/06–17/08. Same figure sits on the daily chart.

Co-authored-by: anibaloperacionesWes <anibaloperacionesWes@users.noreply.github.com>
</commit_message>
<xml_diff>
--- a/reports/Parque_Arauco/TMP_7MALLS/entrega_diego_anibal/Recorrido_ejecutivo_PA_MAE_20260817.pptx
+++ b/reports/Parque_Arauco/TMP_7MALLS/entrega_diego_anibal/Recorrido_ejecutivo_PA_MAE_20260817.pptx
@@ -5463,8 +5463,8 @@
         </p:nvSpPr>
         <p:spPr>
           <a:xfrm>
-            <a:off x="201168" y="1005840"/>
-            <a:ext cx="11777472" cy="1024128"/>
+            <a:off x="201168" y="987552"/>
+            <a:ext cx="11777472" cy="1170432"/>
           </a:xfrm>
           <a:prstGeom prst="roundRect">
             <a:avLst>
@@ -5510,8 +5510,8 @@
         </p:nvSpPr>
         <p:spPr>
           <a:xfrm>
-            <a:off x="365760" y="1060704"/>
-            <a:ext cx="11475720" cy="256032"/>
+            <a:off x="365760" y="1042415"/>
+            <a:ext cx="11475720" cy="237744"/>
           </a:xfrm>
           <a:prstGeom prst="rect">
             <a:avLst/>
@@ -5549,8 +5549,8 @@
         </p:nvSpPr>
         <p:spPr>
           <a:xfrm>
-            <a:off x="365760" y="1316736"/>
-            <a:ext cx="11475720" cy="621792"/>
+            <a:off x="365760" y="1280160"/>
+            <a:ext cx="11475720" cy="804672"/>
           </a:xfrm>
           <a:prstGeom prst="rect">
             <a:avLst/>
@@ -5569,13 +5569,13 @@
               </a:spcAft>
             </a:pPr>
             <a:r>
-              <a:rPr sz="1300" b="0">
+              <a:rPr sz="1200" b="0">
                 <a:solidFill>
                   <a:srgbClr val="0D3B66"/>
                 </a:solidFill>
                 <a:latin typeface="Calibri"/>
               </a:rPr>
-              <a:t>El 10/06 se repararon los presostatos. El estanque venía en 89 m³/día (mayo–9/jun) y ese día ya marca 39 m³. Desde el 11/06 se sostiene en 28 m³/día (−61 m³/día, 68%). No es fuga residual: la baja quedó en el dato diario.</a:t>
+              <a:t>El 10/06 se repararon los presostatos. El estanque venía en 89 m³/día (mayo–9/jun) y ese día ya marca 39 m³. Desde el 11/06 se sostiene en 28 m³/día (−61 m³/día, 68%). A $1.400/m³: $84.897/día  ·  $2.546.923/mes  ·  acumulado 11/06–17/08: $5.688.128 (4.063 m³ en 67 días).</a:t>
             </a:r>
           </a:p>
         </p:txBody>
@@ -5588,8 +5588,8 @@
         </p:nvSpPr>
         <p:spPr>
           <a:xfrm>
-            <a:off x="201168" y="2121408"/>
-            <a:ext cx="5285232" cy="3584448"/>
+            <a:off x="201168" y="2249424"/>
+            <a:ext cx="5285232" cy="3456432"/>
           </a:xfrm>
           <a:prstGeom prst="roundRect">
             <a:avLst>
@@ -5633,8 +5633,8 @@
         </p:nvSpPr>
         <p:spPr>
           <a:xfrm>
-            <a:off x="329184" y="2176272"/>
-            <a:ext cx="5029200" cy="256032"/>
+            <a:off x="329184" y="2304288"/>
+            <a:ext cx="5029200" cy="237744"/>
           </a:xfrm>
           <a:prstGeom prst="rect">
             <a:avLst/>
@@ -5680,8 +5680,8 @@
         </p:blipFill>
         <p:spPr>
           <a:xfrm>
-            <a:off x="329184" y="2450592"/>
-            <a:ext cx="5010912" cy="3035808"/>
+            <a:off x="329184" y="2560320"/>
+            <a:ext cx="5010912" cy="2926080"/>
           </a:xfrm>
           <a:prstGeom prst="rect">
             <a:avLst/>
@@ -5696,8 +5696,8 @@
         </p:nvSpPr>
         <p:spPr>
           <a:xfrm>
-            <a:off x="5614416" y="2121408"/>
-            <a:ext cx="6364224" cy="3584448"/>
+            <a:off x="5614416" y="2249424"/>
+            <a:ext cx="6364224" cy="3456432"/>
           </a:xfrm>
           <a:prstGeom prst="roundRect">
             <a:avLst>
@@ -5741,8 +5741,8 @@
         </p:nvSpPr>
         <p:spPr>
           <a:xfrm>
-            <a:off x="5742432" y="2176272"/>
-            <a:ext cx="6108192" cy="256032"/>
+            <a:off x="5742432" y="2304288"/>
+            <a:ext cx="6108192" cy="237744"/>
           </a:xfrm>
           <a:prstGeom prst="rect">
             <a:avLst/>
@@ -5767,7 +5767,7 @@
                 </a:solidFill>
                 <a:latin typeface="Calibri"/>
               </a:rPr>
-              <a:t>ESTANQUE SUR — m³/día (la baja post 10/06)</a:t>
+              <a:t>ESTANQUE SUR — m³/día y costo evitado</a:t>
             </a:r>
           </a:p>
         </p:txBody>
@@ -5788,8 +5788,8 @@
         </p:blipFill>
         <p:spPr>
           <a:xfrm>
-            <a:off x="5742432" y="2450592"/>
-            <a:ext cx="6108192" cy="3035808"/>
+            <a:off x="5742432" y="2560320"/>
+            <a:ext cx="6108192" cy="2926080"/>
           </a:xfrm>
           <a:prstGeom prst="rect">
             <a:avLst/>

</xml_diff>

<commit_message>
Restore Norte night before/after chart and state CLP savings
Findings slide uses the previous control bars again. Footer reports
Estanque Norte savings (m³ and CLP) without mentioning leftover
00:00–06:00 flow on some nights.

Co-authored-by: anibaloperacionesWes <anibaloperacionesWes@users.noreply.github.com>
</commit_message>
<xml_diff>
--- a/reports/Parque_Arauco/TMP_7MALLS/entrega_diego_anibal/Recorrido_ejecutivo_PA_MAE_20260817.pptx
+++ b/reports/Parque_Arauco/TMP_7MALLS/entrega_diego_anibal/Recorrido_ejecutivo_PA_MAE_20260817.pptx
@@ -5450,7 +5450,7 @@
                 </a:solidFill>
                 <a:latin typeface="Calibri"/>
               </a:rPr>
-              <a:t>Estanque Sur: reparación de presostatos (10/06)  ·  Control nocturno: horas en cero</a:t>
+              <a:t>Estanque Sur: reparación de presostatos (10/06)  ·  Estanque Norte: control nocturno</a:t>
             </a:r>
           </a:p>
         </p:txBody>
@@ -5659,14 +5659,14 @@
                 </a:solidFill>
                 <a:latin typeface="Calibri"/>
               </a:rPr>
-              <a:t>ESTANQUE NORTE — horas en cero (desde 05/08)</a:t>
+              <a:t>CONTROLES NOCTURNOS — noche típica antes vs con control</a:t>
             </a:r>
           </a:p>
         </p:txBody>
       </p:sp>
       <p:pic>
         <p:nvPicPr>
-          <p:cNvPr id="12" name="Picture 11" descr="mae_horas_en_cero.png"/>
+          <p:cNvPr id="12" name="Picture 11" descr="mae_controles_nocturnos.png"/>
           <p:cNvPicPr>
             <a:picLocks noChangeAspect="1"/>
           </p:cNvPicPr>
@@ -5830,7 +5830,7 @@
                 </a:solidFill>
                 <a:latin typeface="Calibri"/>
               </a:rPr>
-              <a:t>Estanque Norte (control 05/08): en cero 02:00–05:00 (13 noches). Algunos días el cero parte desde las 00:00 (p. ej. 05/08).</a:t>
+              <a:t>Estanque Norte (control 05/08): noche típica 4,8 → 1,1 m³. Ahorro 3,7 m³/noche ($5.194/noche · $155.820/mes). En 13 noches: 48 m³ = $67.522 (tarifa $1.400/m³).</a:t>
             </a:r>
           </a:p>
           <a:p>
@@ -5846,7 +5846,7 @@
                 </a:solidFill>
                 <a:latin typeface="Calibri"/>
               </a:rPr>
-              <a:t>Pizza Hut (control 01/07): en cero 00:00–06:00. Estanque Sur: corte on/off de mantención nocturna.</a:t>
+              <a:t>Pizza Hut: control desde el 01/07. Estanque Sur: corte on/off de mantención nocturna.</a:t>
             </a:r>
           </a:p>
         </p:txBody>

</xml_diff>

<commit_message>
List all four MAE points in one navy footer on findings
Footer is four navy lines: Norte savings, Pizza Hut night, Sur
maintenance cut, and Baños Guardias with control installed but unused.
Pizza Hut control bars use the recinto orange on the night chart.

Co-authored-by: anibaloperacionesWes <anibaloperacionesWes@users.noreply.github.com>
</commit_message>
<xml_diff>
--- a/reports/Parque_Arauco/TMP_7MALLS/entrega_diego_anibal/Recorrido_ejecutivo_PA_MAE_20260817.pptx
+++ b/reports/Parque_Arauco/TMP_7MALLS/entrega_diego_anibal/Recorrido_ejecutivo_PA_MAE_20260817.pptx
@@ -5804,8 +5804,8 @@
         </p:nvSpPr>
         <p:spPr>
           <a:xfrm>
-            <a:off x="256032" y="5779008"/>
-            <a:ext cx="11704320" cy="932688"/>
+            <a:off x="256032" y="5742432"/>
+            <a:ext cx="11704320" cy="1024128"/>
           </a:xfrm>
           <a:prstGeom prst="rect">
             <a:avLst/>
@@ -5842,11 +5842,43 @@
             <a:r>
               <a:rPr sz="1200" b="0">
                 <a:solidFill>
-                  <a:srgbClr val="5A5A5A"/>
+                  <a:srgbClr val="0D3B66"/>
                 </a:solidFill>
                 <a:latin typeface="Calibri"/>
               </a:rPr>
-              <a:t>Pizza Hut: control desde el 01/07. Estanque Sur: corte on/off de mantención nocturna.</a:t>
+              <a:t>Pizza Hut (control 01/07): noche típica 0,1 → 0 m³.</a:t>
+            </a:r>
+          </a:p>
+          <a:p>
+            <a:pPr algn="l">
+              <a:spcAft>
+                <a:spcPts val="300"/>
+              </a:spcAft>
+            </a:pPr>
+            <a:r>
+              <a:rPr sz="1200" b="0">
+                <a:solidFill>
+                  <a:srgbClr val="0D3B66"/>
+                </a:solidFill>
+                <a:latin typeface="Calibri"/>
+              </a:rPr>
+              <a:t>Estanque Sur: corte on/off a cargo de mantención nocturna.</a:t>
+            </a:r>
+          </a:p>
+          <a:p>
+            <a:pPr algn="l">
+              <a:spcAft>
+                <a:spcPts val="300"/>
+              </a:spcAft>
+            </a:pPr>
+            <a:r>
+              <a:rPr sz="1200" b="0">
+                <a:solidFill>
+                  <a:srgbClr val="0D3B66"/>
+                </a:solidFill>
+                <a:latin typeface="Calibri"/>
+              </a:rPr>
+              <a:t>Baños Guardias: control instalado; no está solicitado el uso.</a:t>
             </a:r>
           </a:p>
         </p:txBody>

</xml_diff>

<commit_message>
Add MAM slides to recorrido PPT and monthly chart
Equipos (5 puntos) and May–Aug consumption with July shares; Falabella marked active 11/08.

Co-authored-by: anibaloperacionesWes <anibaloperacionesWes@users.noreply.github.com>
</commit_message>
<xml_diff>
--- a/reports/Parque_Arauco/TMP_7MALLS/entrega_diego_anibal/Recorrido_ejecutivo_PA_MAE_20260817.pptx
+++ b/reports/Parque_Arauco/TMP_7MALLS/entrega_diego_anibal/Recorrido_ejecutivo_PA_MAE_20260817.pptx
@@ -9,6 +9,8 @@
     <p:sldId id="257" r:id="rId8"/>
     <p:sldId id="258" r:id="rId9"/>
     <p:sldId id="259" r:id="rId10"/>
+    <p:sldId id="260" r:id="rId11"/>
+    <p:sldId id="261" r:id="rId12"/>
   </p:sldIdLst>
   <p:sldSz cx="12191695" cy="6858000" type="screen4x3"/>
   <p:notesSz cx="6858000" cy="9144000"/>
@@ -3270,7 +3272,7 @@
                 </a:solidFill>
                 <a:latin typeface="Calibri"/>
               </a:rPr>
-              <a:t>Empezamos por MAE  ·  Mall Arauco Estación</a:t>
+              <a:t>MAE · Estación   ·   MAM · Maipú</a:t>
             </a:r>
           </a:p>
           <a:p>
@@ -5879,6 +5881,2237 @@
                 <a:latin typeface="Calibri"/>
               </a:rPr>
               <a:t>Baños Guardias: control instalado; no está solicitado el uso.</a:t>
+            </a:r>
+          </a:p>
+        </p:txBody>
+      </p:sp>
+    </p:spTree>
+  </p:cSld>
+  <p:clrMapOvr>
+    <a:masterClrMapping/>
+  </p:clrMapOvr>
+</p:sld>
+</file>
+
+<file path=ppt/slides/slide5.xml><?xml version="1.0" encoding="utf-8"?>
+<p:sld xmlns:a="http://schemas.openxmlformats.org/drawingml/2006/main" xmlns:p="http://schemas.openxmlformats.org/presentationml/2006/main" xmlns:r="http://schemas.openxmlformats.org/officeDocument/2006/relationships">
+  <p:cSld>
+    <p:spTree>
+      <p:nvGrpSpPr>
+        <p:cNvPr id="1" name=""/>
+        <p:cNvGrpSpPr/>
+        <p:nvPr/>
+      </p:nvGrpSpPr>
+      <p:grpSpPr/>
+      <p:sp>
+        <p:nvSpPr>
+          <p:cNvPr id="2" name="Rectangle 1"/>
+          <p:cNvSpPr/>
+          <p:nvPr/>
+        </p:nvSpPr>
+        <p:spPr>
+          <a:xfrm>
+            <a:off x="0" y="0"/>
+            <a:ext cx="12191695" cy="841248"/>
+          </a:xfrm>
+          <a:prstGeom prst="rect">
+            <a:avLst/>
+          </a:prstGeom>
+          <a:solidFill>
+            <a:srgbClr val="0D3B66"/>
+          </a:solidFill>
+          <a:ln>
+            <a:noFill/>
+          </a:ln>
+        </p:spPr>
+        <p:style>
+          <a:lnRef idx="1">
+            <a:schemeClr val="accent1"/>
+          </a:lnRef>
+          <a:fillRef idx="3">
+            <a:schemeClr val="accent1"/>
+          </a:fillRef>
+          <a:effectRef idx="2">
+            <a:schemeClr val="accent1"/>
+          </a:effectRef>
+          <a:fontRef idx="minor">
+            <a:schemeClr val="lt1"/>
+          </a:fontRef>
+        </p:style>
+        <p:txBody>
+          <a:bodyPr rtlCol="0" anchor="ctr"/>
+          <a:lstStyle/>
+          <a:p>
+            <a:pPr algn="ctr"/>
+          </a:p>
+        </p:txBody>
+      </p:sp>
+      <p:sp>
+        <p:nvSpPr>
+          <p:cNvPr id="3" name="Rectangle 2"/>
+          <p:cNvSpPr/>
+          <p:nvPr/>
+        </p:nvSpPr>
+        <p:spPr>
+          <a:xfrm>
+            <a:off x="0" y="841248"/>
+            <a:ext cx="12191695" cy="54864"/>
+          </a:xfrm>
+          <a:prstGeom prst="rect">
+            <a:avLst/>
+          </a:prstGeom>
+          <a:solidFill>
+            <a:srgbClr val="C9A227"/>
+          </a:solidFill>
+          <a:ln>
+            <a:noFill/>
+          </a:ln>
+        </p:spPr>
+        <p:style>
+          <a:lnRef idx="1">
+            <a:schemeClr val="accent1"/>
+          </a:lnRef>
+          <a:fillRef idx="3">
+            <a:schemeClr val="accent1"/>
+          </a:fillRef>
+          <a:effectRef idx="2">
+            <a:schemeClr val="accent1"/>
+          </a:effectRef>
+          <a:fontRef idx="minor">
+            <a:schemeClr val="lt1"/>
+          </a:fontRef>
+        </p:style>
+        <p:txBody>
+          <a:bodyPr rtlCol="0" anchor="ctr"/>
+          <a:lstStyle/>
+          <a:p>
+            <a:pPr algn="ctr"/>
+          </a:p>
+        </p:txBody>
+      </p:sp>
+      <p:pic>
+        <p:nvPicPr>
+          <p:cNvPr id="4" name="Picture 3" descr="logo wes.bmp"/>
+          <p:cNvPicPr>
+            <a:picLocks noChangeAspect="1"/>
+          </p:cNvPicPr>
+          <p:nvPr/>
+        </p:nvPicPr>
+        <p:blipFill>
+          <a:blip r:embed="rId2"/>
+          <a:stretch>
+            <a:fillRect/>
+          </a:stretch>
+        </p:blipFill>
+        <p:spPr>
+          <a:xfrm>
+            <a:off x="10835640" y="146304"/>
+            <a:ext cx="1143000" cy="253401"/>
+          </a:xfrm>
+          <a:prstGeom prst="rect">
+            <a:avLst/>
+          </a:prstGeom>
+        </p:spPr>
+      </p:pic>
+      <p:sp>
+        <p:nvSpPr>
+          <p:cNvPr id="5" name="TextBox 4"/>
+          <p:cNvSpPr txBox="1"/>
+          <p:nvPr/>
+        </p:nvSpPr>
+        <p:spPr>
+          <a:xfrm>
+            <a:off x="256032" y="109728"/>
+            <a:ext cx="10607040" cy="384048"/>
+          </a:xfrm>
+          <a:prstGeom prst="rect">
+            <a:avLst/>
+          </a:prstGeom>
+          <a:noFill/>
+        </p:spPr>
+        <p:txBody>
+          <a:bodyPr wrap="square">
+            <a:spAutoFit/>
+          </a:bodyPr>
+          <a:lstStyle/>
+          <a:p>
+            <a:pPr algn="l">
+              <a:spcAft>
+                <a:spcPts val="300"/>
+              </a:spcAft>
+            </a:pPr>
+            <a:r>
+              <a:rPr sz="2000" b="1">
+                <a:solidFill>
+                  <a:srgbClr val="FFFFFF"/>
+                </a:solidFill>
+                <a:latin typeface="Calibri"/>
+              </a:rPr>
+              <a:t>MAM  ·  1. Equipos instalados</a:t>
+            </a:r>
+          </a:p>
+        </p:txBody>
+      </p:sp>
+      <p:sp>
+        <p:nvSpPr>
+          <p:cNvPr id="6" name="TextBox 5"/>
+          <p:cNvSpPr txBox="1"/>
+          <p:nvPr/>
+        </p:nvSpPr>
+        <p:spPr>
+          <a:xfrm>
+            <a:off x="256032" y="457200"/>
+            <a:ext cx="10607040" cy="329184"/>
+          </a:xfrm>
+          <a:prstGeom prst="rect">
+            <a:avLst/>
+          </a:prstGeom>
+          <a:noFill/>
+        </p:spPr>
+        <p:txBody>
+          <a:bodyPr wrap="square">
+            <a:spAutoFit/>
+          </a:bodyPr>
+          <a:lstStyle/>
+          <a:p>
+            <a:pPr algn="l">
+              <a:spcAft>
+                <a:spcPts val="300"/>
+              </a:spcAft>
+            </a:pPr>
+            <a:r>
+              <a:rPr sz="1100" b="0">
+                <a:solidFill>
+                  <a:srgbClr val="DCE6F0"/>
+                </a:solidFill>
+                <a:latin typeface="Calibri"/>
+              </a:rPr>
+              <a:t>5 puntos activos WES   |   Mall Arauco Maipú   |   Recepción 06/11/2025</a:t>
+            </a:r>
+          </a:p>
+        </p:txBody>
+      </p:sp>
+      <p:sp>
+        <p:nvSpPr>
+          <p:cNvPr id="7" name="Rounded Rectangle 6"/>
+          <p:cNvSpPr/>
+          <p:nvPr/>
+        </p:nvSpPr>
+        <p:spPr>
+          <a:xfrm>
+            <a:off x="256032" y="1078992"/>
+            <a:ext cx="3749039" cy="1938528"/>
+          </a:xfrm>
+          <a:prstGeom prst="roundRect">
+            <a:avLst>
+              <a:gd name="adj" fmla="val 8000"/>
+            </a:avLst>
+          </a:prstGeom>
+          <a:solidFill>
+            <a:srgbClr val="F5F7FA"/>
+          </a:solidFill>
+          <a:ln w="6350">
+            <a:solidFill>
+              <a:srgbClr val="1F77B4"/>
+            </a:solidFill>
+          </a:ln>
+        </p:spPr>
+        <p:style>
+          <a:lnRef idx="1">
+            <a:schemeClr val="accent1"/>
+          </a:lnRef>
+          <a:fillRef idx="3">
+            <a:schemeClr val="accent1"/>
+          </a:fillRef>
+          <a:effectRef idx="2">
+            <a:schemeClr val="accent1"/>
+          </a:effectRef>
+          <a:fontRef idx="minor">
+            <a:schemeClr val="lt1"/>
+          </a:fontRef>
+        </p:style>
+        <p:txBody>
+          <a:bodyPr rtlCol="0" anchor="ctr"/>
+          <a:lstStyle/>
+          <a:p>
+            <a:pPr algn="ctr"/>
+          </a:p>
+        </p:txBody>
+      </p:sp>
+      <p:sp>
+        <p:nvSpPr>
+          <p:cNvPr id="8" name="TextBox 7"/>
+          <p:cNvSpPr txBox="1"/>
+          <p:nvPr/>
+        </p:nvSpPr>
+        <p:spPr>
+          <a:xfrm>
+            <a:off x="420624" y="1207007"/>
+            <a:ext cx="3419856" cy="256032"/>
+          </a:xfrm>
+          <a:prstGeom prst="rect">
+            <a:avLst/>
+          </a:prstGeom>
+          <a:noFill/>
+        </p:spPr>
+        <p:txBody>
+          <a:bodyPr wrap="square">
+            <a:spAutoFit/>
+          </a:bodyPr>
+          <a:lstStyle/>
+          <a:p>
+            <a:pPr algn="l">
+              <a:spcAft>
+                <a:spcPts val="300"/>
+              </a:spcAft>
+            </a:pPr>
+            <a:r>
+              <a:rPr sz="1200" b="1">
+                <a:solidFill>
+                  <a:srgbClr val="C9A227"/>
+                </a:solidFill>
+                <a:latin typeface="Calibri"/>
+              </a:rPr>
+              <a:t>000025-08</a:t>
+            </a:r>
+          </a:p>
+        </p:txBody>
+      </p:sp>
+      <p:sp>
+        <p:nvSpPr>
+          <p:cNvPr id="9" name="TextBox 8"/>
+          <p:cNvSpPr txBox="1"/>
+          <p:nvPr/>
+        </p:nvSpPr>
+        <p:spPr>
+          <a:xfrm>
+            <a:off x="420624" y="1499616"/>
+            <a:ext cx="3419856" cy="713232"/>
+          </a:xfrm>
+          <a:prstGeom prst="rect">
+            <a:avLst/>
+          </a:prstGeom>
+          <a:noFill/>
+        </p:spPr>
+        <p:txBody>
+          <a:bodyPr wrap="square">
+            <a:spAutoFit/>
+          </a:bodyPr>
+          <a:lstStyle/>
+          <a:p>
+            <a:pPr algn="l">
+              <a:spcAft>
+                <a:spcPts val="300"/>
+              </a:spcAft>
+            </a:pPr>
+            <a:r>
+              <a:rPr sz="1800" b="1">
+                <a:solidFill>
+                  <a:srgbClr val="0D3B66"/>
+                </a:solidFill>
+                <a:latin typeface="Calibri"/>
+              </a:rPr>
+              <a:t>Placa Bancaria</a:t>
+            </a:r>
+          </a:p>
+        </p:txBody>
+      </p:sp>
+      <p:sp>
+        <p:nvSpPr>
+          <p:cNvPr id="10" name="TextBox 9"/>
+          <p:cNvSpPr txBox="1"/>
+          <p:nvPr/>
+        </p:nvSpPr>
+        <p:spPr>
+          <a:xfrm>
+            <a:off x="420624" y="2286000"/>
+            <a:ext cx="3419856" cy="530352"/>
+          </a:xfrm>
+          <a:prstGeom prst="rect">
+            <a:avLst/>
+          </a:prstGeom>
+          <a:noFill/>
+        </p:spPr>
+        <p:txBody>
+          <a:bodyPr wrap="square">
+            <a:spAutoFit/>
+          </a:bodyPr>
+          <a:lstStyle/>
+          <a:p>
+            <a:pPr algn="l">
+              <a:spcAft>
+                <a:spcPts val="300"/>
+              </a:spcAft>
+            </a:pPr>
+            <a:r>
+              <a:rPr sz="1300" b="0">
+                <a:solidFill>
+                  <a:srgbClr val="5A5A5A"/>
+                </a:solidFill>
+                <a:latin typeface="Calibri"/>
+              </a:rPr>
+              <a:t>Placa bancaria del recinto</a:t>
+            </a:r>
+          </a:p>
+        </p:txBody>
+      </p:sp>
+      <p:sp>
+        <p:nvSpPr>
+          <p:cNvPr id="11" name="Rounded Rectangle 10"/>
+          <p:cNvSpPr/>
+          <p:nvPr/>
+        </p:nvSpPr>
+        <p:spPr>
+          <a:xfrm>
+            <a:off x="4169663" y="1078992"/>
+            <a:ext cx="3749039" cy="1938528"/>
+          </a:xfrm>
+          <a:prstGeom prst="roundRect">
+            <a:avLst>
+              <a:gd name="adj" fmla="val 8000"/>
+            </a:avLst>
+          </a:prstGeom>
+          <a:solidFill>
+            <a:srgbClr val="F5F7FA"/>
+          </a:solidFill>
+          <a:ln w="6350">
+            <a:solidFill>
+              <a:srgbClr val="1F77B4"/>
+            </a:solidFill>
+          </a:ln>
+        </p:spPr>
+        <p:style>
+          <a:lnRef idx="1">
+            <a:schemeClr val="accent1"/>
+          </a:lnRef>
+          <a:fillRef idx="3">
+            <a:schemeClr val="accent1"/>
+          </a:fillRef>
+          <a:effectRef idx="2">
+            <a:schemeClr val="accent1"/>
+          </a:effectRef>
+          <a:fontRef idx="minor">
+            <a:schemeClr val="lt1"/>
+          </a:fontRef>
+        </p:style>
+        <p:txBody>
+          <a:bodyPr rtlCol="0" anchor="ctr"/>
+          <a:lstStyle/>
+          <a:p>
+            <a:pPr algn="ctr"/>
+          </a:p>
+        </p:txBody>
+      </p:sp>
+      <p:sp>
+        <p:nvSpPr>
+          <p:cNvPr id="12" name="TextBox 11"/>
+          <p:cNvSpPr txBox="1"/>
+          <p:nvPr/>
+        </p:nvSpPr>
+        <p:spPr>
+          <a:xfrm>
+            <a:off x="4334255" y="1207007"/>
+            <a:ext cx="3419856" cy="256032"/>
+          </a:xfrm>
+          <a:prstGeom prst="rect">
+            <a:avLst/>
+          </a:prstGeom>
+          <a:noFill/>
+        </p:spPr>
+        <p:txBody>
+          <a:bodyPr wrap="square">
+            <a:spAutoFit/>
+          </a:bodyPr>
+          <a:lstStyle/>
+          <a:p>
+            <a:pPr algn="l">
+              <a:spcAft>
+                <a:spcPts val="300"/>
+              </a:spcAft>
+            </a:pPr>
+            <a:r>
+              <a:rPr sz="1200" b="1">
+                <a:solidFill>
+                  <a:srgbClr val="C9A227"/>
+                </a:solidFill>
+                <a:latin typeface="Calibri"/>
+              </a:rPr>
+              <a:t>000025-10</a:t>
+            </a:r>
+          </a:p>
+        </p:txBody>
+      </p:sp>
+      <p:sp>
+        <p:nvSpPr>
+          <p:cNvPr id="13" name="TextBox 12"/>
+          <p:cNvSpPr txBox="1"/>
+          <p:nvPr/>
+        </p:nvSpPr>
+        <p:spPr>
+          <a:xfrm>
+            <a:off x="4334255" y="1499616"/>
+            <a:ext cx="3419856" cy="713232"/>
+          </a:xfrm>
+          <a:prstGeom prst="rect">
+            <a:avLst/>
+          </a:prstGeom>
+          <a:noFill/>
+        </p:spPr>
+        <p:txBody>
+          <a:bodyPr wrap="square">
+            <a:spAutoFit/>
+          </a:bodyPr>
+          <a:lstStyle/>
+          <a:p>
+            <a:pPr algn="l">
+              <a:spcAft>
+                <a:spcPts val="300"/>
+              </a:spcAft>
+            </a:pPr>
+            <a:r>
+              <a:rPr sz="1800" b="1">
+                <a:solidFill>
+                  <a:srgbClr val="0D3B66"/>
+                </a:solidFill>
+                <a:latin typeface="Calibri"/>
+              </a:rPr>
+              <a:t>Impulsión Ripley</a:t>
+            </a:r>
+          </a:p>
+        </p:txBody>
+      </p:sp>
+      <p:sp>
+        <p:nvSpPr>
+          <p:cNvPr id="14" name="TextBox 13"/>
+          <p:cNvSpPr txBox="1"/>
+          <p:nvPr/>
+        </p:nvSpPr>
+        <p:spPr>
+          <a:xfrm>
+            <a:off x="4334255" y="2286000"/>
+            <a:ext cx="3419856" cy="530352"/>
+          </a:xfrm>
+          <a:prstGeom prst="rect">
+            <a:avLst/>
+          </a:prstGeom>
+          <a:noFill/>
+        </p:spPr>
+        <p:txBody>
+          <a:bodyPr wrap="square">
+            <a:spAutoFit/>
+          </a:bodyPr>
+          <a:lstStyle/>
+          <a:p>
+            <a:pPr algn="l">
+              <a:spcAft>
+                <a:spcPts val="300"/>
+              </a:spcAft>
+            </a:pPr>
+            <a:r>
+              <a:rPr sz="1300" b="0">
+                <a:solidFill>
+                  <a:srgbClr val="5A5A5A"/>
+                </a:solidFill>
+                <a:latin typeface="Calibri"/>
+              </a:rPr>
+              <a:t>Impulsión Ripley</a:t>
+            </a:r>
+          </a:p>
+        </p:txBody>
+      </p:sp>
+      <p:sp>
+        <p:nvSpPr>
+          <p:cNvPr id="15" name="Rounded Rectangle 14"/>
+          <p:cNvSpPr/>
+          <p:nvPr/>
+        </p:nvSpPr>
+        <p:spPr>
+          <a:xfrm>
+            <a:off x="8083296" y="1078992"/>
+            <a:ext cx="3749039" cy="1938528"/>
+          </a:xfrm>
+          <a:prstGeom prst="roundRect">
+            <a:avLst>
+              <a:gd name="adj" fmla="val 8000"/>
+            </a:avLst>
+          </a:prstGeom>
+          <a:solidFill>
+            <a:srgbClr val="F5F7FA"/>
+          </a:solidFill>
+          <a:ln w="6350">
+            <a:solidFill>
+              <a:srgbClr val="1F77B4"/>
+            </a:solidFill>
+          </a:ln>
+        </p:spPr>
+        <p:style>
+          <a:lnRef idx="1">
+            <a:schemeClr val="accent1"/>
+          </a:lnRef>
+          <a:fillRef idx="3">
+            <a:schemeClr val="accent1"/>
+          </a:fillRef>
+          <a:effectRef idx="2">
+            <a:schemeClr val="accent1"/>
+          </a:effectRef>
+          <a:fontRef idx="minor">
+            <a:schemeClr val="lt1"/>
+          </a:fontRef>
+        </p:style>
+        <p:txBody>
+          <a:bodyPr rtlCol="0" anchor="ctr"/>
+          <a:lstStyle/>
+          <a:p>
+            <a:pPr algn="ctr"/>
+          </a:p>
+        </p:txBody>
+      </p:sp>
+      <p:sp>
+        <p:nvSpPr>
+          <p:cNvPr id="16" name="TextBox 15"/>
+          <p:cNvSpPr txBox="1"/>
+          <p:nvPr/>
+        </p:nvSpPr>
+        <p:spPr>
+          <a:xfrm>
+            <a:off x="8247888" y="1207007"/>
+            <a:ext cx="3419856" cy="256032"/>
+          </a:xfrm>
+          <a:prstGeom prst="rect">
+            <a:avLst/>
+          </a:prstGeom>
+          <a:noFill/>
+        </p:spPr>
+        <p:txBody>
+          <a:bodyPr wrap="square">
+            <a:spAutoFit/>
+          </a:bodyPr>
+          <a:lstStyle/>
+          <a:p>
+            <a:pPr algn="l">
+              <a:spcAft>
+                <a:spcPts val="300"/>
+              </a:spcAft>
+            </a:pPr>
+            <a:r>
+              <a:rPr sz="1200" b="1">
+                <a:solidFill>
+                  <a:srgbClr val="C9A227"/>
+                </a:solidFill>
+                <a:latin typeface="Calibri"/>
+              </a:rPr>
+              <a:t>000025-09</a:t>
+            </a:r>
+          </a:p>
+        </p:txBody>
+      </p:sp>
+      <p:sp>
+        <p:nvSpPr>
+          <p:cNvPr id="17" name="TextBox 16"/>
+          <p:cNvSpPr txBox="1"/>
+          <p:nvPr/>
+        </p:nvSpPr>
+        <p:spPr>
+          <a:xfrm>
+            <a:off x="8247888" y="1499616"/>
+            <a:ext cx="3419856" cy="713232"/>
+          </a:xfrm>
+          <a:prstGeom prst="rect">
+            <a:avLst/>
+          </a:prstGeom>
+          <a:noFill/>
+        </p:spPr>
+        <p:txBody>
+          <a:bodyPr wrap="square">
+            <a:spAutoFit/>
+          </a:bodyPr>
+          <a:lstStyle/>
+          <a:p>
+            <a:pPr algn="l">
+              <a:spcAft>
+                <a:spcPts val="300"/>
+              </a:spcAft>
+            </a:pPr>
+            <a:r>
+              <a:rPr sz="1800" b="1">
+                <a:solidFill>
+                  <a:srgbClr val="0D3B66"/>
+                </a:solidFill>
+                <a:latin typeface="Calibri"/>
+              </a:rPr>
+              <a:t>Impulsión Falabella</a:t>
+            </a:r>
+          </a:p>
+        </p:txBody>
+      </p:sp>
+      <p:sp>
+        <p:nvSpPr>
+          <p:cNvPr id="18" name="TextBox 17"/>
+          <p:cNvSpPr txBox="1"/>
+          <p:nvPr/>
+        </p:nvSpPr>
+        <p:spPr>
+          <a:xfrm>
+            <a:off x="8247888" y="2286000"/>
+            <a:ext cx="3419856" cy="530352"/>
+          </a:xfrm>
+          <a:prstGeom prst="rect">
+            <a:avLst/>
+          </a:prstGeom>
+          <a:noFill/>
+        </p:spPr>
+        <p:txBody>
+          <a:bodyPr wrap="square">
+            <a:spAutoFit/>
+          </a:bodyPr>
+          <a:lstStyle/>
+          <a:p>
+            <a:pPr algn="l">
+              <a:spcAft>
+                <a:spcPts val="300"/>
+              </a:spcAft>
+            </a:pPr>
+            <a:r>
+              <a:rPr sz="1300" b="0">
+                <a:solidFill>
+                  <a:srgbClr val="5A5A5A"/>
+                </a:solidFill>
+                <a:latin typeface="Calibri"/>
+              </a:rPr>
+              <a:t>Activo desde 11/08/2026 (OC / cambio de equipo)</a:t>
+            </a:r>
+          </a:p>
+        </p:txBody>
+      </p:sp>
+      <p:sp>
+        <p:nvSpPr>
+          <p:cNvPr id="19" name="Rounded Rectangle 18"/>
+          <p:cNvSpPr/>
+          <p:nvPr/>
+        </p:nvSpPr>
+        <p:spPr>
+          <a:xfrm>
+            <a:off x="256032" y="3182112"/>
+            <a:ext cx="5742432" cy="1938528"/>
+          </a:xfrm>
+          <a:prstGeom prst="roundRect">
+            <a:avLst>
+              <a:gd name="adj" fmla="val 8000"/>
+            </a:avLst>
+          </a:prstGeom>
+          <a:solidFill>
+            <a:srgbClr val="F5F7FA"/>
+          </a:solidFill>
+          <a:ln w="6350">
+            <a:solidFill>
+              <a:srgbClr val="1F77B4"/>
+            </a:solidFill>
+          </a:ln>
+        </p:spPr>
+        <p:style>
+          <a:lnRef idx="1">
+            <a:schemeClr val="accent1"/>
+          </a:lnRef>
+          <a:fillRef idx="3">
+            <a:schemeClr val="accent1"/>
+          </a:fillRef>
+          <a:effectRef idx="2">
+            <a:schemeClr val="accent1"/>
+          </a:effectRef>
+          <a:fontRef idx="minor">
+            <a:schemeClr val="lt1"/>
+          </a:fontRef>
+        </p:style>
+        <p:txBody>
+          <a:bodyPr rtlCol="0" anchor="ctr"/>
+          <a:lstStyle/>
+          <a:p>
+            <a:pPr algn="ctr"/>
+          </a:p>
+        </p:txBody>
+      </p:sp>
+      <p:sp>
+        <p:nvSpPr>
+          <p:cNvPr id="20" name="TextBox 19"/>
+          <p:cNvSpPr txBox="1"/>
+          <p:nvPr/>
+        </p:nvSpPr>
+        <p:spPr>
+          <a:xfrm>
+            <a:off x="420624" y="3310128"/>
+            <a:ext cx="5413248" cy="256032"/>
+          </a:xfrm>
+          <a:prstGeom prst="rect">
+            <a:avLst/>
+          </a:prstGeom>
+          <a:noFill/>
+        </p:spPr>
+        <p:txBody>
+          <a:bodyPr wrap="square">
+            <a:spAutoFit/>
+          </a:bodyPr>
+          <a:lstStyle/>
+          <a:p>
+            <a:pPr algn="l">
+              <a:spcAft>
+                <a:spcPts val="300"/>
+              </a:spcAft>
+            </a:pPr>
+            <a:r>
+              <a:rPr sz="1200" b="1">
+                <a:solidFill>
+                  <a:srgbClr val="C9A227"/>
+                </a:solidFill>
+                <a:latin typeface="Calibri"/>
+              </a:rPr>
+              <a:t>000025-32</a:t>
+            </a:r>
+          </a:p>
+        </p:txBody>
+      </p:sp>
+      <p:sp>
+        <p:nvSpPr>
+          <p:cNvPr id="21" name="TextBox 20"/>
+          <p:cNvSpPr txBox="1"/>
+          <p:nvPr/>
+        </p:nvSpPr>
+        <p:spPr>
+          <a:xfrm>
+            <a:off x="420624" y="3602736"/>
+            <a:ext cx="5413248" cy="713232"/>
+          </a:xfrm>
+          <a:prstGeom prst="rect">
+            <a:avLst/>
+          </a:prstGeom>
+          <a:noFill/>
+        </p:spPr>
+        <p:txBody>
+          <a:bodyPr wrap="square">
+            <a:spAutoFit/>
+          </a:bodyPr>
+          <a:lstStyle/>
+          <a:p>
+            <a:pPr algn="l">
+              <a:spcAft>
+                <a:spcPts val="300"/>
+              </a:spcAft>
+            </a:pPr>
+            <a:r>
+              <a:rPr sz="1800" b="1">
+                <a:solidFill>
+                  <a:srgbClr val="0D3B66"/>
+                </a:solidFill>
+                <a:latin typeface="Calibri"/>
+              </a:rPr>
+              <a:t>Matriz Pasillo Técnico Boulevard</a:t>
+            </a:r>
+          </a:p>
+        </p:txBody>
+      </p:sp>
+      <p:sp>
+        <p:nvSpPr>
+          <p:cNvPr id="22" name="TextBox 21"/>
+          <p:cNvSpPr txBox="1"/>
+          <p:nvPr/>
+        </p:nvSpPr>
+        <p:spPr>
+          <a:xfrm>
+            <a:off x="420624" y="4389120"/>
+            <a:ext cx="5413248" cy="530352"/>
+          </a:xfrm>
+          <a:prstGeom prst="rect">
+            <a:avLst/>
+          </a:prstGeom>
+          <a:noFill/>
+        </p:spPr>
+        <p:txBody>
+          <a:bodyPr wrap="square">
+            <a:spAutoFit/>
+          </a:bodyPr>
+          <a:lstStyle/>
+          <a:p>
+            <a:pPr algn="l">
+              <a:spcAft>
+                <a:spcPts val="300"/>
+              </a:spcAft>
+            </a:pPr>
+            <a:r>
+              <a:rPr sz="1300" b="0">
+                <a:solidFill>
+                  <a:srgbClr val="5A5A5A"/>
+                </a:solidFill>
+                <a:latin typeface="Calibri"/>
+              </a:rPr>
+              <a:t>Matriz pasillo técnico Boulevard</a:t>
+            </a:r>
+          </a:p>
+        </p:txBody>
+      </p:sp>
+      <p:sp>
+        <p:nvSpPr>
+          <p:cNvPr id="23" name="Rounded Rectangle 22"/>
+          <p:cNvSpPr/>
+          <p:nvPr/>
+        </p:nvSpPr>
+        <p:spPr>
+          <a:xfrm>
+            <a:off x="6199632" y="3182112"/>
+            <a:ext cx="5742432" cy="1938528"/>
+          </a:xfrm>
+          <a:prstGeom prst="roundRect">
+            <a:avLst>
+              <a:gd name="adj" fmla="val 8000"/>
+            </a:avLst>
+          </a:prstGeom>
+          <a:solidFill>
+            <a:srgbClr val="F5F7FA"/>
+          </a:solidFill>
+          <a:ln w="6350">
+            <a:solidFill>
+              <a:srgbClr val="1F77B4"/>
+            </a:solidFill>
+          </a:ln>
+        </p:spPr>
+        <p:style>
+          <a:lnRef idx="1">
+            <a:schemeClr val="accent1"/>
+          </a:lnRef>
+          <a:fillRef idx="3">
+            <a:schemeClr val="accent1"/>
+          </a:fillRef>
+          <a:effectRef idx="2">
+            <a:schemeClr val="accent1"/>
+          </a:effectRef>
+          <a:fontRef idx="minor">
+            <a:schemeClr val="lt1"/>
+          </a:fontRef>
+        </p:style>
+        <p:txBody>
+          <a:bodyPr rtlCol="0" anchor="ctr"/>
+          <a:lstStyle/>
+          <a:p>
+            <a:pPr algn="ctr"/>
+          </a:p>
+        </p:txBody>
+      </p:sp>
+      <p:sp>
+        <p:nvSpPr>
+          <p:cNvPr id="24" name="TextBox 23"/>
+          <p:cNvSpPr txBox="1"/>
+          <p:nvPr/>
+        </p:nvSpPr>
+        <p:spPr>
+          <a:xfrm>
+            <a:off x="6364224" y="3310128"/>
+            <a:ext cx="5413248" cy="256032"/>
+          </a:xfrm>
+          <a:prstGeom prst="rect">
+            <a:avLst/>
+          </a:prstGeom>
+          <a:noFill/>
+        </p:spPr>
+        <p:txBody>
+          <a:bodyPr wrap="square">
+            <a:spAutoFit/>
+          </a:bodyPr>
+          <a:lstStyle/>
+          <a:p>
+            <a:pPr algn="l">
+              <a:spcAft>
+                <a:spcPts val="300"/>
+              </a:spcAft>
+            </a:pPr>
+            <a:r>
+              <a:rPr sz="1200" b="1">
+                <a:solidFill>
+                  <a:srgbClr val="C9A227"/>
+                </a:solidFill>
+                <a:latin typeface="Calibri"/>
+              </a:rPr>
+              <a:t>000025-33</a:t>
+            </a:r>
+          </a:p>
+        </p:txBody>
+      </p:sp>
+      <p:sp>
+        <p:nvSpPr>
+          <p:cNvPr id="25" name="TextBox 24"/>
+          <p:cNvSpPr txBox="1"/>
+          <p:nvPr/>
+        </p:nvSpPr>
+        <p:spPr>
+          <a:xfrm>
+            <a:off x="6364224" y="3602736"/>
+            <a:ext cx="5413248" cy="713232"/>
+          </a:xfrm>
+          <a:prstGeom prst="rect">
+            <a:avLst/>
+          </a:prstGeom>
+          <a:noFill/>
+        </p:spPr>
+        <p:txBody>
+          <a:bodyPr wrap="square">
+            <a:spAutoFit/>
+          </a:bodyPr>
+          <a:lstStyle/>
+          <a:p>
+            <a:pPr algn="l">
+              <a:spcAft>
+                <a:spcPts val="300"/>
+              </a:spcAft>
+            </a:pPr>
+            <a:r>
+              <a:rPr sz="1800" b="1">
+                <a:solidFill>
+                  <a:srgbClr val="0D3B66"/>
+                </a:solidFill>
+                <a:latin typeface="Calibri"/>
+              </a:rPr>
+              <a:t>Salida de emergencia pasillo 1 ARROW</a:t>
+            </a:r>
+          </a:p>
+        </p:txBody>
+      </p:sp>
+      <p:sp>
+        <p:nvSpPr>
+          <p:cNvPr id="26" name="TextBox 25"/>
+          <p:cNvSpPr txBox="1"/>
+          <p:nvPr/>
+        </p:nvSpPr>
+        <p:spPr>
+          <a:xfrm>
+            <a:off x="6364224" y="4389120"/>
+            <a:ext cx="5413248" cy="530352"/>
+          </a:xfrm>
+          <a:prstGeom prst="rect">
+            <a:avLst/>
+          </a:prstGeom>
+          <a:noFill/>
+        </p:spPr>
+        <p:txBody>
+          <a:bodyPr wrap="square">
+            <a:spAutoFit/>
+          </a:bodyPr>
+          <a:lstStyle/>
+          <a:p>
+            <a:pPr algn="l">
+              <a:spcAft>
+                <a:spcPts val="300"/>
+              </a:spcAft>
+            </a:pPr>
+            <a:r>
+              <a:rPr sz="1300" b="0">
+                <a:solidFill>
+                  <a:srgbClr val="5A5A5A"/>
+                </a:solidFill>
+                <a:latin typeface="Calibri"/>
+              </a:rPr>
+              <a:t>Salida de emergencia pasillo 1 ARROW</a:t>
+            </a:r>
+          </a:p>
+        </p:txBody>
+      </p:sp>
+      <p:sp>
+        <p:nvSpPr>
+          <p:cNvPr id="27" name="Rounded Rectangle 26"/>
+          <p:cNvSpPr/>
+          <p:nvPr/>
+        </p:nvSpPr>
+        <p:spPr>
+          <a:xfrm>
+            <a:off x="256032" y="5394960"/>
+            <a:ext cx="11686032" cy="1170432"/>
+          </a:xfrm>
+          <a:prstGeom prst="roundRect">
+            <a:avLst>
+              <a:gd name="adj" fmla="val 8000"/>
+            </a:avLst>
+          </a:prstGeom>
+          <a:solidFill>
+            <a:srgbClr val="FFF9EB"/>
+          </a:solidFill>
+          <a:ln w="6350">
+            <a:solidFill>
+              <a:srgbClr val="C9A227"/>
+            </a:solidFill>
+          </a:ln>
+        </p:spPr>
+        <p:style>
+          <a:lnRef idx="1">
+            <a:schemeClr val="accent1"/>
+          </a:lnRef>
+          <a:fillRef idx="3">
+            <a:schemeClr val="accent1"/>
+          </a:fillRef>
+          <a:effectRef idx="2">
+            <a:schemeClr val="accent1"/>
+          </a:effectRef>
+          <a:fontRef idx="minor">
+            <a:schemeClr val="lt1"/>
+          </a:fontRef>
+        </p:style>
+        <p:txBody>
+          <a:bodyPr rtlCol="0" anchor="ctr"/>
+          <a:lstStyle/>
+          <a:p>
+            <a:pPr algn="ctr"/>
+          </a:p>
+        </p:txBody>
+      </p:sp>
+      <p:sp>
+        <p:nvSpPr>
+          <p:cNvPr id="28" name="TextBox 27"/>
+          <p:cNvSpPr txBox="1"/>
+          <p:nvPr/>
+        </p:nvSpPr>
+        <p:spPr>
+          <a:xfrm>
+            <a:off x="438912" y="5504688"/>
+            <a:ext cx="11338560" cy="256032"/>
+          </a:xfrm>
+          <a:prstGeom prst="rect">
+            <a:avLst/>
+          </a:prstGeom>
+          <a:noFill/>
+        </p:spPr>
+        <p:txBody>
+          <a:bodyPr wrap="square">
+            <a:spAutoFit/>
+          </a:bodyPr>
+          <a:lstStyle/>
+          <a:p>
+            <a:pPr algn="l">
+              <a:spcAft>
+                <a:spcPts val="300"/>
+              </a:spcAft>
+            </a:pPr>
+            <a:r>
+              <a:rPr sz="1100" b="1">
+                <a:solidFill>
+                  <a:srgbClr val="C9A227"/>
+                </a:solidFill>
+                <a:latin typeface="Calibri"/>
+              </a:rPr>
+              <a:t>RECINTO</a:t>
+            </a:r>
+          </a:p>
+        </p:txBody>
+      </p:sp>
+      <p:sp>
+        <p:nvSpPr>
+          <p:cNvPr id="29" name="TextBox 28"/>
+          <p:cNvSpPr txBox="1"/>
+          <p:nvPr/>
+        </p:nvSpPr>
+        <p:spPr>
+          <a:xfrm>
+            <a:off x="438912" y="5779008"/>
+            <a:ext cx="11338560" cy="658368"/>
+          </a:xfrm>
+          <a:prstGeom prst="rect">
+            <a:avLst/>
+          </a:prstGeom>
+          <a:noFill/>
+        </p:spPr>
+        <p:txBody>
+          <a:bodyPr wrap="square">
+            <a:spAutoFit/>
+          </a:bodyPr>
+          <a:lstStyle/>
+          <a:p>
+            <a:pPr algn="l">
+              <a:spcAft>
+                <a:spcPts val="300"/>
+              </a:spcAft>
+            </a:pPr>
+            <a:r>
+              <a:rPr sz="1300" b="0">
+                <a:solidFill>
+                  <a:srgbClr val="0D3B66"/>
+                </a:solidFill>
+                <a:latin typeface="Calibri"/>
+              </a:rPr>
+              <a:t>Recepción 06/11/2025  ·  Capacitación 14/11/2025  ·  Usuarios: Miguel Rupayan — Encargado de Operaciones  ·  Constanza Vilches — Analista Ambiental  ·  Equipo Mantención: C. Bustamante, O. Cuevas y Supervisor Eléctrico</a:t>
+            </a:r>
+          </a:p>
+        </p:txBody>
+      </p:sp>
+    </p:spTree>
+  </p:cSld>
+  <p:clrMapOvr>
+    <a:masterClrMapping/>
+  </p:clrMapOvr>
+</p:sld>
+</file>
+
+<file path=ppt/slides/slide6.xml><?xml version="1.0" encoding="utf-8"?>
+<p:sld xmlns:a="http://schemas.openxmlformats.org/drawingml/2006/main" xmlns:p="http://schemas.openxmlformats.org/presentationml/2006/main" xmlns:r="http://schemas.openxmlformats.org/officeDocument/2006/relationships">
+  <p:cSld>
+    <p:spTree>
+      <p:nvGrpSpPr>
+        <p:cNvPr id="1" name=""/>
+        <p:cNvGrpSpPr/>
+        <p:nvPr/>
+      </p:nvGrpSpPr>
+      <p:grpSpPr/>
+      <p:sp>
+        <p:nvSpPr>
+          <p:cNvPr id="2" name="Rectangle 1"/>
+          <p:cNvSpPr/>
+          <p:nvPr/>
+        </p:nvSpPr>
+        <p:spPr>
+          <a:xfrm>
+            <a:off x="0" y="0"/>
+            <a:ext cx="12191695" cy="841248"/>
+          </a:xfrm>
+          <a:prstGeom prst="rect">
+            <a:avLst/>
+          </a:prstGeom>
+          <a:solidFill>
+            <a:srgbClr val="0D3B66"/>
+          </a:solidFill>
+          <a:ln>
+            <a:noFill/>
+          </a:ln>
+        </p:spPr>
+        <p:style>
+          <a:lnRef idx="1">
+            <a:schemeClr val="accent1"/>
+          </a:lnRef>
+          <a:fillRef idx="3">
+            <a:schemeClr val="accent1"/>
+          </a:fillRef>
+          <a:effectRef idx="2">
+            <a:schemeClr val="accent1"/>
+          </a:effectRef>
+          <a:fontRef idx="minor">
+            <a:schemeClr val="lt1"/>
+          </a:fontRef>
+        </p:style>
+        <p:txBody>
+          <a:bodyPr rtlCol="0" anchor="ctr"/>
+          <a:lstStyle/>
+          <a:p>
+            <a:pPr algn="ctr"/>
+          </a:p>
+        </p:txBody>
+      </p:sp>
+      <p:sp>
+        <p:nvSpPr>
+          <p:cNvPr id="3" name="Rectangle 2"/>
+          <p:cNvSpPr/>
+          <p:nvPr/>
+        </p:nvSpPr>
+        <p:spPr>
+          <a:xfrm>
+            <a:off x="0" y="841248"/>
+            <a:ext cx="12191695" cy="54864"/>
+          </a:xfrm>
+          <a:prstGeom prst="rect">
+            <a:avLst/>
+          </a:prstGeom>
+          <a:solidFill>
+            <a:srgbClr val="C9A227"/>
+          </a:solidFill>
+          <a:ln>
+            <a:noFill/>
+          </a:ln>
+        </p:spPr>
+        <p:style>
+          <a:lnRef idx="1">
+            <a:schemeClr val="accent1"/>
+          </a:lnRef>
+          <a:fillRef idx="3">
+            <a:schemeClr val="accent1"/>
+          </a:fillRef>
+          <a:effectRef idx="2">
+            <a:schemeClr val="accent1"/>
+          </a:effectRef>
+          <a:fontRef idx="minor">
+            <a:schemeClr val="lt1"/>
+          </a:fontRef>
+        </p:style>
+        <p:txBody>
+          <a:bodyPr rtlCol="0" anchor="ctr"/>
+          <a:lstStyle/>
+          <a:p>
+            <a:pPr algn="ctr"/>
+          </a:p>
+        </p:txBody>
+      </p:sp>
+      <p:pic>
+        <p:nvPicPr>
+          <p:cNvPr id="4" name="Picture 3" descr="logo wes.bmp"/>
+          <p:cNvPicPr>
+            <a:picLocks noChangeAspect="1"/>
+          </p:cNvPicPr>
+          <p:nvPr/>
+        </p:nvPicPr>
+        <p:blipFill>
+          <a:blip r:embed="rId2"/>
+          <a:stretch>
+            <a:fillRect/>
+          </a:stretch>
+        </p:blipFill>
+        <p:spPr>
+          <a:xfrm>
+            <a:off x="10835640" y="146304"/>
+            <a:ext cx="1143000" cy="253401"/>
+          </a:xfrm>
+          <a:prstGeom prst="rect">
+            <a:avLst/>
+          </a:prstGeom>
+        </p:spPr>
+      </p:pic>
+      <p:sp>
+        <p:nvSpPr>
+          <p:cNvPr id="5" name="TextBox 4"/>
+          <p:cNvSpPr txBox="1"/>
+          <p:nvPr/>
+        </p:nvSpPr>
+        <p:spPr>
+          <a:xfrm>
+            <a:off x="256032" y="109728"/>
+            <a:ext cx="10607040" cy="384048"/>
+          </a:xfrm>
+          <a:prstGeom prst="rect">
+            <a:avLst/>
+          </a:prstGeom>
+          <a:noFill/>
+        </p:spPr>
+        <p:txBody>
+          <a:bodyPr wrap="square">
+            <a:spAutoFit/>
+          </a:bodyPr>
+          <a:lstStyle/>
+          <a:p>
+            <a:pPr algn="l">
+              <a:spcAft>
+                <a:spcPts val="300"/>
+              </a:spcAft>
+            </a:pPr>
+            <a:r>
+              <a:rPr sz="2000" b="1">
+                <a:solidFill>
+                  <a:srgbClr val="FFFFFF"/>
+                </a:solidFill>
+                <a:latin typeface="Calibri"/>
+              </a:rPr>
+              <a:t>MAM  ·  2. Consumo mensualizado</a:t>
+            </a:r>
+          </a:p>
+        </p:txBody>
+      </p:sp>
+      <p:sp>
+        <p:nvSpPr>
+          <p:cNvPr id="6" name="TextBox 5"/>
+          <p:cNvSpPr txBox="1"/>
+          <p:nvPr/>
+        </p:nvSpPr>
+        <p:spPr>
+          <a:xfrm>
+            <a:off x="256032" y="457200"/>
+            <a:ext cx="10607040" cy="329184"/>
+          </a:xfrm>
+          <a:prstGeom prst="rect">
+            <a:avLst/>
+          </a:prstGeom>
+          <a:noFill/>
+        </p:spPr>
+        <p:txBody>
+          <a:bodyPr wrap="square">
+            <a:spAutoFit/>
+          </a:bodyPr>
+          <a:lstStyle/>
+          <a:p>
+            <a:pPr algn="l">
+              <a:spcAft>
+                <a:spcPts val="300"/>
+              </a:spcAft>
+            </a:pPr>
+            <a:r>
+              <a:rPr sz="1100" b="0">
+                <a:solidFill>
+                  <a:srgbClr val="DCE6F0"/>
+                </a:solidFill>
+                <a:latin typeface="Calibri"/>
+              </a:rPr>
+              <a:t>Suma de los 5 puntos WES   |   01/05/2026 – 17/08/2026   |   Agosto: a la fecha vs proyección al 31</a:t>
+            </a:r>
+          </a:p>
+        </p:txBody>
+      </p:sp>
+      <p:sp>
+        <p:nvSpPr>
+          <p:cNvPr id="7" name="Rounded Rectangle 6"/>
+          <p:cNvSpPr/>
+          <p:nvPr/>
+        </p:nvSpPr>
+        <p:spPr>
+          <a:xfrm>
+            <a:off x="201168" y="1024128"/>
+            <a:ext cx="7973568" cy="4617720"/>
+          </a:xfrm>
+          <a:prstGeom prst="roundRect">
+            <a:avLst>
+              <a:gd name="adj" fmla="val 8000"/>
+            </a:avLst>
+          </a:prstGeom>
+          <a:solidFill>
+            <a:srgbClr val="F5F7FA"/>
+          </a:solidFill>
+          <a:ln>
+            <a:noFill/>
+          </a:ln>
+        </p:spPr>
+        <p:style>
+          <a:lnRef idx="1">
+            <a:schemeClr val="accent1"/>
+          </a:lnRef>
+          <a:fillRef idx="3">
+            <a:schemeClr val="accent1"/>
+          </a:fillRef>
+          <a:effectRef idx="2">
+            <a:schemeClr val="accent1"/>
+          </a:effectRef>
+          <a:fontRef idx="minor">
+            <a:schemeClr val="lt1"/>
+          </a:fontRef>
+        </p:style>
+        <p:txBody>
+          <a:bodyPr rtlCol="0" anchor="ctr"/>
+          <a:lstStyle/>
+          <a:p>
+            <a:pPr algn="ctr"/>
+          </a:p>
+        </p:txBody>
+      </p:sp>
+      <p:pic>
+        <p:nvPicPr>
+          <p:cNvPr id="8" name="Picture 7" descr="mam_mensual_may_ago.png"/>
+          <p:cNvPicPr>
+            <a:picLocks noChangeAspect="1"/>
+          </p:cNvPicPr>
+          <p:nvPr/>
+        </p:nvPicPr>
+        <p:blipFill>
+          <a:blip r:embed="rId3"/>
+          <a:stretch>
+            <a:fillRect/>
+          </a:stretch>
+        </p:blipFill>
+        <p:spPr>
+          <a:xfrm>
+            <a:off x="347472" y="1115568"/>
+            <a:ext cx="7680960" cy="3759628"/>
+          </a:xfrm>
+          <a:prstGeom prst="rect">
+            <a:avLst/>
+          </a:prstGeom>
+        </p:spPr>
+      </p:pic>
+      <p:sp>
+        <p:nvSpPr>
+          <p:cNvPr id="9" name="Rounded Rectangle 8"/>
+          <p:cNvSpPr/>
+          <p:nvPr/>
+        </p:nvSpPr>
+        <p:spPr>
+          <a:xfrm>
+            <a:off x="8302752" y="1024128"/>
+            <a:ext cx="3675887" cy="4617720"/>
+          </a:xfrm>
+          <a:prstGeom prst="roundRect">
+            <a:avLst>
+              <a:gd name="adj" fmla="val 8000"/>
+            </a:avLst>
+          </a:prstGeom>
+          <a:solidFill>
+            <a:srgbClr val="FFFFFF"/>
+          </a:solidFill>
+          <a:ln w="6350">
+            <a:solidFill>
+              <a:srgbClr val="1F77B4"/>
+            </a:solidFill>
+          </a:ln>
+        </p:spPr>
+        <p:style>
+          <a:lnRef idx="1">
+            <a:schemeClr val="accent1"/>
+          </a:lnRef>
+          <a:fillRef idx="3">
+            <a:schemeClr val="accent1"/>
+          </a:fillRef>
+          <a:effectRef idx="2">
+            <a:schemeClr val="accent1"/>
+          </a:effectRef>
+          <a:fontRef idx="minor">
+            <a:schemeClr val="lt1"/>
+          </a:fontRef>
+        </p:style>
+        <p:txBody>
+          <a:bodyPr rtlCol="0" anchor="ctr"/>
+          <a:lstStyle/>
+          <a:p>
+            <a:pPr algn="ctr"/>
+          </a:p>
+        </p:txBody>
+      </p:sp>
+      <p:sp>
+        <p:nvSpPr>
+          <p:cNvPr id="10" name="TextBox 9"/>
+          <p:cNvSpPr txBox="1"/>
+          <p:nvPr/>
+        </p:nvSpPr>
+        <p:spPr>
+          <a:xfrm>
+            <a:off x="8430768" y="1078992"/>
+            <a:ext cx="3419856" cy="219456"/>
+          </a:xfrm>
+          <a:prstGeom prst="rect">
+            <a:avLst/>
+          </a:prstGeom>
+          <a:noFill/>
+        </p:spPr>
+        <p:txBody>
+          <a:bodyPr wrap="square">
+            <a:spAutoFit/>
+          </a:bodyPr>
+          <a:lstStyle/>
+          <a:p>
+            <a:pPr algn="l">
+              <a:spcAft>
+                <a:spcPts val="300"/>
+              </a:spcAft>
+            </a:pPr>
+            <a:r>
+              <a:rPr sz="1100" b="1">
+                <a:solidFill>
+                  <a:srgbClr val="1F77B4"/>
+                </a:solidFill>
+                <a:latin typeface="Calibri"/>
+              </a:rPr>
+              <a:t>JULIO · último mes cerrado</a:t>
+            </a:r>
+          </a:p>
+        </p:txBody>
+      </p:sp>
+      <p:sp>
+        <p:nvSpPr>
+          <p:cNvPr id="11" name="TextBox 10"/>
+          <p:cNvSpPr txBox="1"/>
+          <p:nvPr/>
+        </p:nvSpPr>
+        <p:spPr>
+          <a:xfrm>
+            <a:off x="8430768" y="1298448"/>
+            <a:ext cx="3419856" cy="384048"/>
+          </a:xfrm>
+          <a:prstGeom prst="rect">
+            <a:avLst/>
+          </a:prstGeom>
+          <a:noFill/>
+        </p:spPr>
+        <p:txBody>
+          <a:bodyPr wrap="square">
+            <a:spAutoFit/>
+          </a:bodyPr>
+          <a:lstStyle/>
+          <a:p>
+            <a:pPr algn="l">
+              <a:spcAft>
+                <a:spcPts val="300"/>
+              </a:spcAft>
+            </a:pPr>
+            <a:r>
+              <a:rPr sz="1200" b="0">
+                <a:solidFill>
+                  <a:srgbClr val="5A5A5A"/>
+                </a:solidFill>
+                <a:latin typeface="Calibri"/>
+              </a:rPr>
+              <a:t>El recinto sumó 10.356 m³. Peso de cada equipo:</a:t>
+            </a:r>
+          </a:p>
+        </p:txBody>
+      </p:sp>
+      <p:sp>
+        <p:nvSpPr>
+          <p:cNvPr id="12" name="Rounded Rectangle 11"/>
+          <p:cNvSpPr/>
+          <p:nvPr/>
+        </p:nvSpPr>
+        <p:spPr>
+          <a:xfrm>
+            <a:off x="8430768" y="1719072"/>
+            <a:ext cx="3419856" cy="713232"/>
+          </a:xfrm>
+          <a:prstGeom prst="roundRect">
+            <a:avLst>
+              <a:gd name="adj" fmla="val 8000"/>
+            </a:avLst>
+          </a:prstGeom>
+          <a:solidFill>
+            <a:srgbClr val="F5F7FA"/>
+          </a:solidFill>
+          <a:ln w="6350">
+            <a:solidFill>
+              <a:srgbClr val="0D3B66"/>
+            </a:solidFill>
+          </a:ln>
+        </p:spPr>
+        <p:style>
+          <a:lnRef idx="1">
+            <a:schemeClr val="accent1"/>
+          </a:lnRef>
+          <a:fillRef idx="3">
+            <a:schemeClr val="accent1"/>
+          </a:fillRef>
+          <a:effectRef idx="2">
+            <a:schemeClr val="accent1"/>
+          </a:effectRef>
+          <a:fontRef idx="minor">
+            <a:schemeClr val="lt1"/>
+          </a:fontRef>
+        </p:style>
+        <p:txBody>
+          <a:bodyPr rtlCol="0" anchor="ctr"/>
+          <a:lstStyle/>
+          <a:p>
+            <a:pPr algn="ctr"/>
+          </a:p>
+        </p:txBody>
+      </p:sp>
+      <p:sp>
+        <p:nvSpPr>
+          <p:cNvPr id="13" name="TextBox 12"/>
+          <p:cNvSpPr txBox="1"/>
+          <p:nvPr/>
+        </p:nvSpPr>
+        <p:spPr>
+          <a:xfrm>
+            <a:off x="8558784" y="1764792"/>
+            <a:ext cx="3163824" cy="219456"/>
+          </a:xfrm>
+          <a:prstGeom prst="rect">
+            <a:avLst/>
+          </a:prstGeom>
+          <a:noFill/>
+        </p:spPr>
+        <p:txBody>
+          <a:bodyPr wrap="square">
+            <a:spAutoFit/>
+          </a:bodyPr>
+          <a:lstStyle/>
+          <a:p>
+            <a:pPr algn="l">
+              <a:spcAft>
+                <a:spcPts val="300"/>
+              </a:spcAft>
+            </a:pPr>
+            <a:r>
+              <a:rPr sz="1200" b="1">
+                <a:solidFill>
+                  <a:srgbClr val="0D3B66"/>
+                </a:solidFill>
+                <a:latin typeface="Calibri"/>
+              </a:rPr>
+              <a:t>Placa Bancaria</a:t>
+            </a:r>
+          </a:p>
+        </p:txBody>
+      </p:sp>
+      <p:sp>
+        <p:nvSpPr>
+          <p:cNvPr id="14" name="TextBox 13"/>
+          <p:cNvSpPr txBox="1"/>
+          <p:nvPr/>
+        </p:nvSpPr>
+        <p:spPr>
+          <a:xfrm>
+            <a:off x="8558784" y="2011679"/>
+            <a:ext cx="3163824" cy="347472"/>
+          </a:xfrm>
+          <a:prstGeom prst="rect">
+            <a:avLst/>
+          </a:prstGeom>
+          <a:noFill/>
+        </p:spPr>
+        <p:txBody>
+          <a:bodyPr wrap="square">
+            <a:spAutoFit/>
+          </a:bodyPr>
+          <a:lstStyle/>
+          <a:p>
+            <a:pPr algn="l">
+              <a:spcAft>
+                <a:spcPts val="300"/>
+              </a:spcAft>
+            </a:pPr>
+            <a:r>
+              <a:rPr sz="1600" b="1">
+                <a:solidFill>
+                  <a:srgbClr val="0D3B66"/>
+                </a:solidFill>
+                <a:latin typeface="Calibri"/>
+              </a:rPr>
+              <a:t>7.084 m³    68 %</a:t>
+            </a:r>
+          </a:p>
+        </p:txBody>
+      </p:sp>
+      <p:sp>
+        <p:nvSpPr>
+          <p:cNvPr id="15" name="Rounded Rectangle 14"/>
+          <p:cNvSpPr/>
+          <p:nvPr/>
+        </p:nvSpPr>
+        <p:spPr>
+          <a:xfrm>
+            <a:off x="8430768" y="2468879"/>
+            <a:ext cx="3419856" cy="713232"/>
+          </a:xfrm>
+          <a:prstGeom prst="roundRect">
+            <a:avLst>
+              <a:gd name="adj" fmla="val 8000"/>
+            </a:avLst>
+          </a:prstGeom>
+          <a:solidFill>
+            <a:srgbClr val="F5F7FA"/>
+          </a:solidFill>
+          <a:ln w="6350">
+            <a:solidFill>
+              <a:srgbClr val="1F77B4"/>
+            </a:solidFill>
+          </a:ln>
+        </p:spPr>
+        <p:style>
+          <a:lnRef idx="1">
+            <a:schemeClr val="accent1"/>
+          </a:lnRef>
+          <a:fillRef idx="3">
+            <a:schemeClr val="accent1"/>
+          </a:fillRef>
+          <a:effectRef idx="2">
+            <a:schemeClr val="accent1"/>
+          </a:effectRef>
+          <a:fontRef idx="minor">
+            <a:schemeClr val="lt1"/>
+          </a:fontRef>
+        </p:style>
+        <p:txBody>
+          <a:bodyPr rtlCol="0" anchor="ctr"/>
+          <a:lstStyle/>
+          <a:p>
+            <a:pPr algn="ctr"/>
+          </a:p>
+        </p:txBody>
+      </p:sp>
+      <p:sp>
+        <p:nvSpPr>
+          <p:cNvPr id="16" name="TextBox 15"/>
+          <p:cNvSpPr txBox="1"/>
+          <p:nvPr/>
+        </p:nvSpPr>
+        <p:spPr>
+          <a:xfrm>
+            <a:off x="8558784" y="2514599"/>
+            <a:ext cx="3163824" cy="219456"/>
+          </a:xfrm>
+          <a:prstGeom prst="rect">
+            <a:avLst/>
+          </a:prstGeom>
+          <a:noFill/>
+        </p:spPr>
+        <p:txBody>
+          <a:bodyPr wrap="square">
+            <a:spAutoFit/>
+          </a:bodyPr>
+          <a:lstStyle/>
+          <a:p>
+            <a:pPr algn="l">
+              <a:spcAft>
+                <a:spcPts val="300"/>
+              </a:spcAft>
+            </a:pPr>
+            <a:r>
+              <a:rPr sz="1200" b="1">
+                <a:solidFill>
+                  <a:srgbClr val="1F77B4"/>
+                </a:solidFill>
+                <a:latin typeface="Calibri"/>
+              </a:rPr>
+              <a:t>Ripley</a:t>
+            </a:r>
+          </a:p>
+        </p:txBody>
+      </p:sp>
+      <p:sp>
+        <p:nvSpPr>
+          <p:cNvPr id="17" name="TextBox 16"/>
+          <p:cNvSpPr txBox="1"/>
+          <p:nvPr/>
+        </p:nvSpPr>
+        <p:spPr>
+          <a:xfrm>
+            <a:off x="8558784" y="2761487"/>
+            <a:ext cx="3163824" cy="347472"/>
+          </a:xfrm>
+          <a:prstGeom prst="rect">
+            <a:avLst/>
+          </a:prstGeom>
+          <a:noFill/>
+        </p:spPr>
+        <p:txBody>
+          <a:bodyPr wrap="square">
+            <a:spAutoFit/>
+          </a:bodyPr>
+          <a:lstStyle/>
+          <a:p>
+            <a:pPr algn="l">
+              <a:spcAft>
+                <a:spcPts val="300"/>
+              </a:spcAft>
+            </a:pPr>
+            <a:r>
+              <a:rPr sz="1600" b="1">
+                <a:solidFill>
+                  <a:srgbClr val="0D3B66"/>
+                </a:solidFill>
+                <a:latin typeface="Calibri"/>
+              </a:rPr>
+              <a:t>3.245 m³    31 %</a:t>
+            </a:r>
+          </a:p>
+        </p:txBody>
+      </p:sp>
+      <p:sp>
+        <p:nvSpPr>
+          <p:cNvPr id="18" name="Rounded Rectangle 17"/>
+          <p:cNvSpPr/>
+          <p:nvPr/>
+        </p:nvSpPr>
+        <p:spPr>
+          <a:xfrm>
+            <a:off x="8430768" y="3218687"/>
+            <a:ext cx="3419856" cy="713232"/>
+          </a:xfrm>
+          <a:prstGeom prst="roundRect">
+            <a:avLst>
+              <a:gd name="adj" fmla="val 8000"/>
+            </a:avLst>
+          </a:prstGeom>
+          <a:solidFill>
+            <a:srgbClr val="F5F7FA"/>
+          </a:solidFill>
+          <a:ln w="6350">
+            <a:solidFill>
+              <a:srgbClr val="7BA3C9"/>
+            </a:solidFill>
+          </a:ln>
+        </p:spPr>
+        <p:style>
+          <a:lnRef idx="1">
+            <a:schemeClr val="accent1"/>
+          </a:lnRef>
+          <a:fillRef idx="3">
+            <a:schemeClr val="accent1"/>
+          </a:fillRef>
+          <a:effectRef idx="2">
+            <a:schemeClr val="accent1"/>
+          </a:effectRef>
+          <a:fontRef idx="minor">
+            <a:schemeClr val="lt1"/>
+          </a:fontRef>
+        </p:style>
+        <p:txBody>
+          <a:bodyPr rtlCol="0" anchor="ctr"/>
+          <a:lstStyle/>
+          <a:p>
+            <a:pPr algn="ctr"/>
+          </a:p>
+        </p:txBody>
+      </p:sp>
+      <p:sp>
+        <p:nvSpPr>
+          <p:cNvPr id="19" name="TextBox 18"/>
+          <p:cNvSpPr txBox="1"/>
+          <p:nvPr/>
+        </p:nvSpPr>
+        <p:spPr>
+          <a:xfrm>
+            <a:off x="8558784" y="3264407"/>
+            <a:ext cx="3163824" cy="219456"/>
+          </a:xfrm>
+          <a:prstGeom prst="rect">
+            <a:avLst/>
+          </a:prstGeom>
+          <a:noFill/>
+        </p:spPr>
+        <p:txBody>
+          <a:bodyPr wrap="square">
+            <a:spAutoFit/>
+          </a:bodyPr>
+          <a:lstStyle/>
+          <a:p>
+            <a:pPr algn="l">
+              <a:spcAft>
+                <a:spcPts val="300"/>
+              </a:spcAft>
+            </a:pPr>
+            <a:r>
+              <a:rPr sz="1200" b="1">
+                <a:solidFill>
+                  <a:srgbClr val="7BA3C9"/>
+                </a:solidFill>
+                <a:latin typeface="Calibri"/>
+              </a:rPr>
+              <a:t>Pasillo Técnico</a:t>
+            </a:r>
+          </a:p>
+        </p:txBody>
+      </p:sp>
+      <p:sp>
+        <p:nvSpPr>
+          <p:cNvPr id="20" name="TextBox 19"/>
+          <p:cNvSpPr txBox="1"/>
+          <p:nvPr/>
+        </p:nvSpPr>
+        <p:spPr>
+          <a:xfrm>
+            <a:off x="8558784" y="3511295"/>
+            <a:ext cx="3163824" cy="347472"/>
+          </a:xfrm>
+          <a:prstGeom prst="rect">
+            <a:avLst/>
+          </a:prstGeom>
+          <a:noFill/>
+        </p:spPr>
+        <p:txBody>
+          <a:bodyPr wrap="square">
+            <a:spAutoFit/>
+          </a:bodyPr>
+          <a:lstStyle/>
+          <a:p>
+            <a:pPr algn="l">
+              <a:spcAft>
+                <a:spcPts val="300"/>
+              </a:spcAft>
+            </a:pPr>
+            <a:r>
+              <a:rPr sz="1600" b="1">
+                <a:solidFill>
+                  <a:srgbClr val="0D3B66"/>
+                </a:solidFill>
+                <a:latin typeface="Calibri"/>
+              </a:rPr>
+              <a:t>26 m³    0 %</a:t>
+            </a:r>
+          </a:p>
+        </p:txBody>
+      </p:sp>
+      <p:sp>
+        <p:nvSpPr>
+          <p:cNvPr id="21" name="Rounded Rectangle 20"/>
+          <p:cNvSpPr/>
+          <p:nvPr/>
+        </p:nvSpPr>
+        <p:spPr>
+          <a:xfrm>
+            <a:off x="8430768" y="3968496"/>
+            <a:ext cx="3419856" cy="713232"/>
+          </a:xfrm>
+          <a:prstGeom prst="roundRect">
+            <a:avLst>
+              <a:gd name="adj" fmla="val 8000"/>
+            </a:avLst>
+          </a:prstGeom>
+          <a:solidFill>
+            <a:srgbClr val="F5F7FA"/>
+          </a:solidFill>
+          <a:ln w="6350">
+            <a:solidFill>
+              <a:srgbClr val="5A8C6E"/>
+            </a:solidFill>
+          </a:ln>
+        </p:spPr>
+        <p:style>
+          <a:lnRef idx="1">
+            <a:schemeClr val="accent1"/>
+          </a:lnRef>
+          <a:fillRef idx="3">
+            <a:schemeClr val="accent1"/>
+          </a:fillRef>
+          <a:effectRef idx="2">
+            <a:schemeClr val="accent1"/>
+          </a:effectRef>
+          <a:fontRef idx="minor">
+            <a:schemeClr val="lt1"/>
+          </a:fontRef>
+        </p:style>
+        <p:txBody>
+          <a:bodyPr rtlCol="0" anchor="ctr"/>
+          <a:lstStyle/>
+          <a:p>
+            <a:pPr algn="ctr"/>
+          </a:p>
+        </p:txBody>
+      </p:sp>
+      <p:sp>
+        <p:nvSpPr>
+          <p:cNvPr id="22" name="TextBox 21"/>
+          <p:cNvSpPr txBox="1"/>
+          <p:nvPr/>
+        </p:nvSpPr>
+        <p:spPr>
+          <a:xfrm>
+            <a:off x="8558784" y="4014215"/>
+            <a:ext cx="3163824" cy="219456"/>
+          </a:xfrm>
+          <a:prstGeom prst="rect">
+            <a:avLst/>
+          </a:prstGeom>
+          <a:noFill/>
+        </p:spPr>
+        <p:txBody>
+          <a:bodyPr wrap="square">
+            <a:spAutoFit/>
+          </a:bodyPr>
+          <a:lstStyle/>
+          <a:p>
+            <a:pPr algn="l">
+              <a:spcAft>
+                <a:spcPts val="300"/>
+              </a:spcAft>
+            </a:pPr>
+            <a:r>
+              <a:rPr sz="1200" b="1">
+                <a:solidFill>
+                  <a:srgbClr val="5A8C6E"/>
+                </a:solidFill>
+                <a:latin typeface="Calibri"/>
+              </a:rPr>
+              <a:t>Salida ARROW</a:t>
+            </a:r>
+          </a:p>
+        </p:txBody>
+      </p:sp>
+      <p:sp>
+        <p:nvSpPr>
+          <p:cNvPr id="23" name="TextBox 22"/>
+          <p:cNvSpPr txBox="1"/>
+          <p:nvPr/>
+        </p:nvSpPr>
+        <p:spPr>
+          <a:xfrm>
+            <a:off x="8558784" y="4261104"/>
+            <a:ext cx="3163824" cy="347472"/>
+          </a:xfrm>
+          <a:prstGeom prst="rect">
+            <a:avLst/>
+          </a:prstGeom>
+          <a:noFill/>
+        </p:spPr>
+        <p:txBody>
+          <a:bodyPr wrap="square">
+            <a:spAutoFit/>
+          </a:bodyPr>
+          <a:lstStyle/>
+          <a:p>
+            <a:pPr algn="l">
+              <a:spcAft>
+                <a:spcPts val="300"/>
+              </a:spcAft>
+            </a:pPr>
+            <a:r>
+              <a:rPr sz="1600" b="1">
+                <a:solidFill>
+                  <a:srgbClr val="0D3B66"/>
+                </a:solidFill>
+                <a:latin typeface="Calibri"/>
+              </a:rPr>
+              <a:t>1 m³    0 %</a:t>
+            </a:r>
+          </a:p>
+        </p:txBody>
+      </p:sp>
+      <p:sp>
+        <p:nvSpPr>
+          <p:cNvPr id="24" name="Rounded Rectangle 23"/>
+          <p:cNvSpPr/>
+          <p:nvPr/>
+        </p:nvSpPr>
+        <p:spPr>
+          <a:xfrm>
+            <a:off x="8430768" y="4718304"/>
+            <a:ext cx="3419856" cy="713232"/>
+          </a:xfrm>
+          <a:prstGeom prst="roundRect">
+            <a:avLst>
+              <a:gd name="adj" fmla="val 8000"/>
+            </a:avLst>
+          </a:prstGeom>
+          <a:solidFill>
+            <a:srgbClr val="F5F7FA"/>
+          </a:solidFill>
+          <a:ln w="6350">
+            <a:solidFill>
+              <a:srgbClr val="C9A227"/>
+            </a:solidFill>
+          </a:ln>
+        </p:spPr>
+        <p:style>
+          <a:lnRef idx="1">
+            <a:schemeClr val="accent1"/>
+          </a:lnRef>
+          <a:fillRef idx="3">
+            <a:schemeClr val="accent1"/>
+          </a:fillRef>
+          <a:effectRef idx="2">
+            <a:schemeClr val="accent1"/>
+          </a:effectRef>
+          <a:fontRef idx="minor">
+            <a:schemeClr val="lt1"/>
+          </a:fontRef>
+        </p:style>
+        <p:txBody>
+          <a:bodyPr rtlCol="0" anchor="ctr"/>
+          <a:lstStyle/>
+          <a:p>
+            <a:pPr algn="ctr"/>
+          </a:p>
+        </p:txBody>
+      </p:sp>
+      <p:sp>
+        <p:nvSpPr>
+          <p:cNvPr id="25" name="TextBox 24"/>
+          <p:cNvSpPr txBox="1"/>
+          <p:nvPr/>
+        </p:nvSpPr>
+        <p:spPr>
+          <a:xfrm>
+            <a:off x="8558784" y="4764024"/>
+            <a:ext cx="3163824" cy="219456"/>
+          </a:xfrm>
+          <a:prstGeom prst="rect">
+            <a:avLst/>
+          </a:prstGeom>
+          <a:noFill/>
+        </p:spPr>
+        <p:txBody>
+          <a:bodyPr wrap="square">
+            <a:spAutoFit/>
+          </a:bodyPr>
+          <a:lstStyle/>
+          <a:p>
+            <a:pPr algn="l">
+              <a:spcAft>
+                <a:spcPts val="300"/>
+              </a:spcAft>
+            </a:pPr>
+            <a:r>
+              <a:rPr sz="1200" b="1">
+                <a:solidFill>
+                  <a:srgbClr val="C9A227"/>
+                </a:solidFill>
+                <a:latin typeface="Calibri"/>
+              </a:rPr>
+              <a:t>Falabella</a:t>
+            </a:r>
+          </a:p>
+        </p:txBody>
+      </p:sp>
+      <p:sp>
+        <p:nvSpPr>
+          <p:cNvPr id="26" name="TextBox 25"/>
+          <p:cNvSpPr txBox="1"/>
+          <p:nvPr/>
+        </p:nvSpPr>
+        <p:spPr>
+          <a:xfrm>
+            <a:off x="8558784" y="5010912"/>
+            <a:ext cx="3163824" cy="347472"/>
+          </a:xfrm>
+          <a:prstGeom prst="rect">
+            <a:avLst/>
+          </a:prstGeom>
+          <a:noFill/>
+        </p:spPr>
+        <p:txBody>
+          <a:bodyPr wrap="square">
+            <a:spAutoFit/>
+          </a:bodyPr>
+          <a:lstStyle/>
+          <a:p>
+            <a:pPr algn="l">
+              <a:spcAft>
+                <a:spcPts val="300"/>
+              </a:spcAft>
+            </a:pPr>
+            <a:r>
+              <a:rPr sz="1400" b="1">
+                <a:solidFill>
+                  <a:srgbClr val="0D3B66"/>
+                </a:solidFill>
+                <a:latin typeface="Calibri"/>
+              </a:rPr>
+              <a:t>0 m³    0 %  ·  activo 11/08</a:t>
+            </a:r>
+          </a:p>
+        </p:txBody>
+      </p:sp>
+      <p:sp>
+        <p:nvSpPr>
+          <p:cNvPr id="27" name="TextBox 26"/>
+          <p:cNvSpPr txBox="1"/>
+          <p:nvPr/>
+        </p:nvSpPr>
+        <p:spPr>
+          <a:xfrm>
+            <a:off x="256032" y="5742432"/>
+            <a:ext cx="11887200" cy="960120"/>
+          </a:xfrm>
+          <a:prstGeom prst="rect">
+            <a:avLst/>
+          </a:prstGeom>
+          <a:noFill/>
+        </p:spPr>
+        <p:txBody>
+          <a:bodyPr wrap="square">
+            <a:spAutoFit/>
+          </a:bodyPr>
+          <a:lstStyle/>
+          <a:p>
+            <a:pPr algn="l">
+              <a:spcAft>
+                <a:spcPts val="300"/>
+              </a:spcAft>
+            </a:pPr>
+            <a:r>
+              <a:rPr sz="1300" b="0">
+                <a:solidFill>
+                  <a:srgbClr val="0D3B66"/>
+                </a:solidFill>
+                <a:latin typeface="Calibri"/>
+              </a:rPr>
+              <a:t>Mayo 7.511 m³   ·   Junio 10.014 m³   ·   Julio 10.356 m³   ·   Agosto 1–17: 4.165 m³   ·   Proyección agosto: 7.595 m³ (245 m³/día × 31).</a:t>
+            </a:r>
+          </a:p>
+          <a:p>
+            <a:pPr algn="l">
+              <a:spcAft>
+                <a:spcPts val="300"/>
+              </a:spcAft>
+            </a:pPr>
+            <a:r>
+              <a:rPr sz="1200" b="0">
+                <a:solidFill>
+                  <a:srgbClr val="5A5A5A"/>
+                </a:solidFill>
+                <a:latin typeface="Calibri"/>
+              </a:rPr>
+              <a:t>Dorado = lo que agosto ya lleva. Tramo claro = proyección del resto del mes. Junio sube por Placa Bancaria (salto 18/06). Falabella no entra en julio: activo desde el 11/08.</a:t>
             </a:r>
           </a:p>
         </p:txBody>

</xml_diff>

<commit_message>
Add MAM one-slide preview to recorrido PPT
Proposal slide plus PNG mockup: compact equipment chips, monthly chart, and July shares. Two detailed MAM slides kept for comparison.

Co-authored-by: anibaloperacionesWes <anibaloperacionesWes@users.noreply.github.com>
</commit_message>
<xml_diff>
--- a/reports/Parque_Arauco/TMP_7MALLS/entrega_diego_anibal/Recorrido_ejecutivo_PA_MAE_20260817.pptx
+++ b/reports/Parque_Arauco/TMP_7MALLS/entrega_diego_anibal/Recorrido_ejecutivo_PA_MAE_20260817.pptx
@@ -11,6 +11,7 @@
     <p:sldId id="259" r:id="rId10"/>
     <p:sldId id="260" r:id="rId11"/>
     <p:sldId id="261" r:id="rId12"/>
+    <p:sldId id="262" r:id="rId13"/>
   </p:sldIdLst>
   <p:sldSz cx="12191695" cy="6858000" type="screen4x3"/>
   <p:notesSz cx="6858000" cy="9144000"/>
@@ -8112,6 +8113,1914 @@
                 <a:latin typeface="Calibri"/>
               </a:rPr>
               <a:t>Dorado = lo que agosto ya lleva. Tramo claro = proyección del resto del mes. Junio sube por Placa Bancaria (salto 18/06). Falabella no entra en julio: activo desde el 11/08.</a:t>
+            </a:r>
+          </a:p>
+        </p:txBody>
+      </p:sp>
+    </p:spTree>
+  </p:cSld>
+  <p:clrMapOvr>
+    <a:masterClrMapping/>
+  </p:clrMapOvr>
+</p:sld>
+</file>
+
+<file path=ppt/slides/slide7.xml><?xml version="1.0" encoding="utf-8"?>
+<p:sld xmlns:a="http://schemas.openxmlformats.org/drawingml/2006/main" xmlns:p="http://schemas.openxmlformats.org/presentationml/2006/main" xmlns:r="http://schemas.openxmlformats.org/officeDocument/2006/relationships">
+  <p:cSld>
+    <p:spTree>
+      <p:nvGrpSpPr>
+        <p:cNvPr id="1" name=""/>
+        <p:cNvGrpSpPr/>
+        <p:nvPr/>
+      </p:nvGrpSpPr>
+      <p:grpSpPr/>
+      <p:sp>
+        <p:nvSpPr>
+          <p:cNvPr id="2" name="Rectangle 1"/>
+          <p:cNvSpPr/>
+          <p:nvPr/>
+        </p:nvSpPr>
+        <p:spPr>
+          <a:xfrm>
+            <a:off x="0" y="0"/>
+            <a:ext cx="12191695" cy="841248"/>
+          </a:xfrm>
+          <a:prstGeom prst="rect">
+            <a:avLst/>
+          </a:prstGeom>
+          <a:solidFill>
+            <a:srgbClr val="0D3B66"/>
+          </a:solidFill>
+          <a:ln>
+            <a:noFill/>
+          </a:ln>
+        </p:spPr>
+        <p:style>
+          <a:lnRef idx="1">
+            <a:schemeClr val="accent1"/>
+          </a:lnRef>
+          <a:fillRef idx="3">
+            <a:schemeClr val="accent1"/>
+          </a:fillRef>
+          <a:effectRef idx="2">
+            <a:schemeClr val="accent1"/>
+          </a:effectRef>
+          <a:fontRef idx="minor">
+            <a:schemeClr val="lt1"/>
+          </a:fontRef>
+        </p:style>
+        <p:txBody>
+          <a:bodyPr rtlCol="0" anchor="ctr"/>
+          <a:lstStyle/>
+          <a:p>
+            <a:pPr algn="ctr"/>
+          </a:p>
+        </p:txBody>
+      </p:sp>
+      <p:sp>
+        <p:nvSpPr>
+          <p:cNvPr id="3" name="Rectangle 2"/>
+          <p:cNvSpPr/>
+          <p:nvPr/>
+        </p:nvSpPr>
+        <p:spPr>
+          <a:xfrm>
+            <a:off x="0" y="841248"/>
+            <a:ext cx="12191695" cy="54864"/>
+          </a:xfrm>
+          <a:prstGeom prst="rect">
+            <a:avLst/>
+          </a:prstGeom>
+          <a:solidFill>
+            <a:srgbClr val="C9A227"/>
+          </a:solidFill>
+          <a:ln>
+            <a:noFill/>
+          </a:ln>
+        </p:spPr>
+        <p:style>
+          <a:lnRef idx="1">
+            <a:schemeClr val="accent1"/>
+          </a:lnRef>
+          <a:fillRef idx="3">
+            <a:schemeClr val="accent1"/>
+          </a:fillRef>
+          <a:effectRef idx="2">
+            <a:schemeClr val="accent1"/>
+          </a:effectRef>
+          <a:fontRef idx="minor">
+            <a:schemeClr val="lt1"/>
+          </a:fontRef>
+        </p:style>
+        <p:txBody>
+          <a:bodyPr rtlCol="0" anchor="ctr"/>
+          <a:lstStyle/>
+          <a:p>
+            <a:pPr algn="ctr"/>
+          </a:p>
+        </p:txBody>
+      </p:sp>
+      <p:pic>
+        <p:nvPicPr>
+          <p:cNvPr id="4" name="Picture 3" descr="logo wes.bmp"/>
+          <p:cNvPicPr>
+            <a:picLocks noChangeAspect="1"/>
+          </p:cNvPicPr>
+          <p:nvPr/>
+        </p:nvPicPr>
+        <p:blipFill>
+          <a:blip r:embed="rId2"/>
+          <a:stretch>
+            <a:fillRect/>
+          </a:stretch>
+        </p:blipFill>
+        <p:spPr>
+          <a:xfrm>
+            <a:off x="10835640" y="146304"/>
+            <a:ext cx="1143000" cy="253401"/>
+          </a:xfrm>
+          <a:prstGeom prst="rect">
+            <a:avLst/>
+          </a:prstGeom>
+        </p:spPr>
+      </p:pic>
+      <p:sp>
+        <p:nvSpPr>
+          <p:cNvPr id="5" name="TextBox 4"/>
+          <p:cNvSpPr txBox="1"/>
+          <p:nvPr/>
+        </p:nvSpPr>
+        <p:spPr>
+          <a:xfrm>
+            <a:off x="256032" y="109728"/>
+            <a:ext cx="10607040" cy="384048"/>
+          </a:xfrm>
+          <a:prstGeom prst="rect">
+            <a:avLst/>
+          </a:prstGeom>
+          <a:noFill/>
+        </p:spPr>
+        <p:txBody>
+          <a:bodyPr wrap="square">
+            <a:spAutoFit/>
+          </a:bodyPr>
+          <a:lstStyle/>
+          <a:p>
+            <a:pPr algn="l">
+              <a:spcAft>
+                <a:spcPts val="300"/>
+              </a:spcAft>
+            </a:pPr>
+            <a:r>
+              <a:rPr sz="2000" b="1">
+                <a:solidFill>
+                  <a:srgbClr val="FFFFFF"/>
+                </a:solidFill>
+                <a:latin typeface="Calibri"/>
+              </a:rPr>
+              <a:t>MAM  ·  Equipos y consumo</a:t>
+            </a:r>
+          </a:p>
+        </p:txBody>
+      </p:sp>
+      <p:sp>
+        <p:nvSpPr>
+          <p:cNvPr id="6" name="TextBox 5"/>
+          <p:cNvSpPr txBox="1"/>
+          <p:nvPr/>
+        </p:nvSpPr>
+        <p:spPr>
+          <a:xfrm>
+            <a:off x="256032" y="457200"/>
+            <a:ext cx="10607040" cy="329184"/>
+          </a:xfrm>
+          <a:prstGeom prst="rect">
+            <a:avLst/>
+          </a:prstGeom>
+          <a:noFill/>
+        </p:spPr>
+        <p:txBody>
+          <a:bodyPr wrap="square">
+            <a:spAutoFit/>
+          </a:bodyPr>
+          <a:lstStyle/>
+          <a:p>
+            <a:pPr algn="l">
+              <a:spcAft>
+                <a:spcPts val="300"/>
+              </a:spcAft>
+            </a:pPr>
+            <a:r>
+              <a:rPr sz="1100" b="0">
+                <a:solidFill>
+                  <a:srgbClr val="DCE6F0"/>
+                </a:solidFill>
+                <a:latin typeface="Calibri"/>
+              </a:rPr>
+              <a:t>Mall Arauco Maipú   |   5 puntos WES   |   01/05/2026 – 17/08/2026   |   propuesta: una lámina</a:t>
+            </a:r>
+          </a:p>
+        </p:txBody>
+      </p:sp>
+      <p:sp>
+        <p:nvSpPr>
+          <p:cNvPr id="7" name="Rounded Rectangle 6"/>
+          <p:cNvSpPr/>
+          <p:nvPr/>
+        </p:nvSpPr>
+        <p:spPr>
+          <a:xfrm>
+            <a:off x="201168" y="1024128"/>
+            <a:ext cx="2286000" cy="658368"/>
+          </a:xfrm>
+          <a:prstGeom prst="roundRect">
+            <a:avLst>
+              <a:gd name="adj" fmla="val 8000"/>
+            </a:avLst>
+          </a:prstGeom>
+          <a:solidFill>
+            <a:srgbClr val="F5F7FA"/>
+          </a:solidFill>
+          <a:ln w="6350">
+            <a:solidFill>
+              <a:srgbClr val="1F77B4"/>
+            </a:solidFill>
+          </a:ln>
+        </p:spPr>
+        <p:style>
+          <a:lnRef idx="1">
+            <a:schemeClr val="accent1"/>
+          </a:lnRef>
+          <a:fillRef idx="3">
+            <a:schemeClr val="accent1"/>
+          </a:fillRef>
+          <a:effectRef idx="2">
+            <a:schemeClr val="accent1"/>
+          </a:effectRef>
+          <a:fontRef idx="minor">
+            <a:schemeClr val="lt1"/>
+          </a:fontRef>
+        </p:style>
+        <p:txBody>
+          <a:bodyPr rtlCol="0" anchor="ctr"/>
+          <a:lstStyle/>
+          <a:p>
+            <a:pPr algn="ctr"/>
+          </a:p>
+        </p:txBody>
+      </p:sp>
+      <p:sp>
+        <p:nvSpPr>
+          <p:cNvPr id="8" name="TextBox 7"/>
+          <p:cNvSpPr txBox="1"/>
+          <p:nvPr/>
+        </p:nvSpPr>
+        <p:spPr>
+          <a:xfrm>
+            <a:off x="292608" y="1060704"/>
+            <a:ext cx="2121408" cy="201168"/>
+          </a:xfrm>
+          <a:prstGeom prst="rect">
+            <a:avLst/>
+          </a:prstGeom>
+          <a:noFill/>
+        </p:spPr>
+        <p:txBody>
+          <a:bodyPr wrap="square">
+            <a:spAutoFit/>
+          </a:bodyPr>
+          <a:lstStyle/>
+          <a:p>
+            <a:pPr algn="l">
+              <a:spcAft>
+                <a:spcPts val="300"/>
+              </a:spcAft>
+            </a:pPr>
+            <a:r>
+              <a:rPr sz="1000" b="1">
+                <a:solidFill>
+                  <a:srgbClr val="C9A227"/>
+                </a:solidFill>
+                <a:latin typeface="Calibri"/>
+              </a:rPr>
+              <a:t>000025-08</a:t>
+            </a:r>
+          </a:p>
+        </p:txBody>
+      </p:sp>
+      <p:sp>
+        <p:nvSpPr>
+          <p:cNvPr id="9" name="TextBox 8"/>
+          <p:cNvSpPr txBox="1"/>
+          <p:nvPr/>
+        </p:nvSpPr>
+        <p:spPr>
+          <a:xfrm>
+            <a:off x="292608" y="1261872"/>
+            <a:ext cx="2121408" cy="219456"/>
+          </a:xfrm>
+          <a:prstGeom prst="rect">
+            <a:avLst/>
+          </a:prstGeom>
+          <a:noFill/>
+        </p:spPr>
+        <p:txBody>
+          <a:bodyPr wrap="square">
+            <a:spAutoFit/>
+          </a:bodyPr>
+          <a:lstStyle/>
+          <a:p>
+            <a:pPr algn="l">
+              <a:spcAft>
+                <a:spcPts val="300"/>
+              </a:spcAft>
+            </a:pPr>
+            <a:r>
+              <a:rPr sz="1200" b="1">
+                <a:solidFill>
+                  <a:srgbClr val="0D3B66"/>
+                </a:solidFill>
+                <a:latin typeface="Calibri"/>
+              </a:rPr>
+              <a:t>Placa Bancaria</a:t>
+            </a:r>
+          </a:p>
+        </p:txBody>
+      </p:sp>
+      <p:sp>
+        <p:nvSpPr>
+          <p:cNvPr id="10" name="Rounded Rectangle 9"/>
+          <p:cNvSpPr/>
+          <p:nvPr/>
+        </p:nvSpPr>
+        <p:spPr>
+          <a:xfrm>
+            <a:off x="2578608" y="1024128"/>
+            <a:ext cx="2286000" cy="658368"/>
+          </a:xfrm>
+          <a:prstGeom prst="roundRect">
+            <a:avLst>
+              <a:gd name="adj" fmla="val 8000"/>
+            </a:avLst>
+          </a:prstGeom>
+          <a:solidFill>
+            <a:srgbClr val="F5F7FA"/>
+          </a:solidFill>
+          <a:ln w="6350">
+            <a:solidFill>
+              <a:srgbClr val="1F77B4"/>
+            </a:solidFill>
+          </a:ln>
+        </p:spPr>
+        <p:style>
+          <a:lnRef idx="1">
+            <a:schemeClr val="accent1"/>
+          </a:lnRef>
+          <a:fillRef idx="3">
+            <a:schemeClr val="accent1"/>
+          </a:fillRef>
+          <a:effectRef idx="2">
+            <a:schemeClr val="accent1"/>
+          </a:effectRef>
+          <a:fontRef idx="minor">
+            <a:schemeClr val="lt1"/>
+          </a:fontRef>
+        </p:style>
+        <p:txBody>
+          <a:bodyPr rtlCol="0" anchor="ctr"/>
+          <a:lstStyle/>
+          <a:p>
+            <a:pPr algn="ctr"/>
+          </a:p>
+        </p:txBody>
+      </p:sp>
+      <p:sp>
+        <p:nvSpPr>
+          <p:cNvPr id="11" name="TextBox 10"/>
+          <p:cNvSpPr txBox="1"/>
+          <p:nvPr/>
+        </p:nvSpPr>
+        <p:spPr>
+          <a:xfrm>
+            <a:off x="2670048" y="1060704"/>
+            <a:ext cx="2121408" cy="201168"/>
+          </a:xfrm>
+          <a:prstGeom prst="rect">
+            <a:avLst/>
+          </a:prstGeom>
+          <a:noFill/>
+        </p:spPr>
+        <p:txBody>
+          <a:bodyPr wrap="square">
+            <a:spAutoFit/>
+          </a:bodyPr>
+          <a:lstStyle/>
+          <a:p>
+            <a:pPr algn="l">
+              <a:spcAft>
+                <a:spcPts val="300"/>
+              </a:spcAft>
+            </a:pPr>
+            <a:r>
+              <a:rPr sz="1000" b="1">
+                <a:solidFill>
+                  <a:srgbClr val="C9A227"/>
+                </a:solidFill>
+                <a:latin typeface="Calibri"/>
+              </a:rPr>
+              <a:t>000025-10</a:t>
+            </a:r>
+          </a:p>
+        </p:txBody>
+      </p:sp>
+      <p:sp>
+        <p:nvSpPr>
+          <p:cNvPr id="12" name="TextBox 11"/>
+          <p:cNvSpPr txBox="1"/>
+          <p:nvPr/>
+        </p:nvSpPr>
+        <p:spPr>
+          <a:xfrm>
+            <a:off x="2670048" y="1261872"/>
+            <a:ext cx="2121408" cy="219456"/>
+          </a:xfrm>
+          <a:prstGeom prst="rect">
+            <a:avLst/>
+          </a:prstGeom>
+          <a:noFill/>
+        </p:spPr>
+        <p:txBody>
+          <a:bodyPr wrap="square">
+            <a:spAutoFit/>
+          </a:bodyPr>
+          <a:lstStyle/>
+          <a:p>
+            <a:pPr algn="l">
+              <a:spcAft>
+                <a:spcPts val="300"/>
+              </a:spcAft>
+            </a:pPr>
+            <a:r>
+              <a:rPr sz="1200" b="1">
+                <a:solidFill>
+                  <a:srgbClr val="0D3B66"/>
+                </a:solidFill>
+                <a:latin typeface="Calibri"/>
+              </a:rPr>
+              <a:t>Ripley</a:t>
+            </a:r>
+          </a:p>
+        </p:txBody>
+      </p:sp>
+      <p:sp>
+        <p:nvSpPr>
+          <p:cNvPr id="13" name="Rounded Rectangle 12"/>
+          <p:cNvSpPr/>
+          <p:nvPr/>
+        </p:nvSpPr>
+        <p:spPr>
+          <a:xfrm>
+            <a:off x="4956048" y="1024128"/>
+            <a:ext cx="2286000" cy="658368"/>
+          </a:xfrm>
+          <a:prstGeom prst="roundRect">
+            <a:avLst>
+              <a:gd name="adj" fmla="val 8000"/>
+            </a:avLst>
+          </a:prstGeom>
+          <a:solidFill>
+            <a:srgbClr val="F5F7FA"/>
+          </a:solidFill>
+          <a:ln w="6350">
+            <a:solidFill>
+              <a:srgbClr val="C9A227"/>
+            </a:solidFill>
+          </a:ln>
+        </p:spPr>
+        <p:style>
+          <a:lnRef idx="1">
+            <a:schemeClr val="accent1"/>
+          </a:lnRef>
+          <a:fillRef idx="3">
+            <a:schemeClr val="accent1"/>
+          </a:fillRef>
+          <a:effectRef idx="2">
+            <a:schemeClr val="accent1"/>
+          </a:effectRef>
+          <a:fontRef idx="minor">
+            <a:schemeClr val="lt1"/>
+          </a:fontRef>
+        </p:style>
+        <p:txBody>
+          <a:bodyPr rtlCol="0" anchor="ctr"/>
+          <a:lstStyle/>
+          <a:p>
+            <a:pPr algn="ctr"/>
+          </a:p>
+        </p:txBody>
+      </p:sp>
+      <p:sp>
+        <p:nvSpPr>
+          <p:cNvPr id="14" name="TextBox 13"/>
+          <p:cNvSpPr txBox="1"/>
+          <p:nvPr/>
+        </p:nvSpPr>
+        <p:spPr>
+          <a:xfrm>
+            <a:off x="5047488" y="1060704"/>
+            <a:ext cx="2121408" cy="201168"/>
+          </a:xfrm>
+          <a:prstGeom prst="rect">
+            <a:avLst/>
+          </a:prstGeom>
+          <a:noFill/>
+        </p:spPr>
+        <p:txBody>
+          <a:bodyPr wrap="square">
+            <a:spAutoFit/>
+          </a:bodyPr>
+          <a:lstStyle/>
+          <a:p>
+            <a:pPr algn="l">
+              <a:spcAft>
+                <a:spcPts val="300"/>
+              </a:spcAft>
+            </a:pPr>
+            <a:r>
+              <a:rPr sz="1000" b="1">
+                <a:solidFill>
+                  <a:srgbClr val="C9A227"/>
+                </a:solidFill>
+                <a:latin typeface="Calibri"/>
+              </a:rPr>
+              <a:t>000025-09</a:t>
+            </a:r>
+          </a:p>
+        </p:txBody>
+      </p:sp>
+      <p:sp>
+        <p:nvSpPr>
+          <p:cNvPr id="15" name="TextBox 14"/>
+          <p:cNvSpPr txBox="1"/>
+          <p:nvPr/>
+        </p:nvSpPr>
+        <p:spPr>
+          <a:xfrm>
+            <a:off x="5047488" y="1261872"/>
+            <a:ext cx="2121408" cy="219456"/>
+          </a:xfrm>
+          <a:prstGeom prst="rect">
+            <a:avLst/>
+          </a:prstGeom>
+          <a:noFill/>
+        </p:spPr>
+        <p:txBody>
+          <a:bodyPr wrap="square">
+            <a:spAutoFit/>
+          </a:bodyPr>
+          <a:lstStyle/>
+          <a:p>
+            <a:pPr algn="l">
+              <a:spcAft>
+                <a:spcPts val="300"/>
+              </a:spcAft>
+            </a:pPr>
+            <a:r>
+              <a:rPr sz="1200" b="1">
+                <a:solidFill>
+                  <a:srgbClr val="0D3B66"/>
+                </a:solidFill>
+                <a:latin typeface="Calibri"/>
+              </a:rPr>
+              <a:t>Falabella</a:t>
+            </a:r>
+          </a:p>
+        </p:txBody>
+      </p:sp>
+      <p:sp>
+        <p:nvSpPr>
+          <p:cNvPr id="16" name="TextBox 15"/>
+          <p:cNvSpPr txBox="1"/>
+          <p:nvPr/>
+        </p:nvSpPr>
+        <p:spPr>
+          <a:xfrm>
+            <a:off x="5047488" y="1463040"/>
+            <a:ext cx="2121408" cy="182880"/>
+          </a:xfrm>
+          <a:prstGeom prst="rect">
+            <a:avLst/>
+          </a:prstGeom>
+          <a:noFill/>
+        </p:spPr>
+        <p:txBody>
+          <a:bodyPr wrap="square">
+            <a:spAutoFit/>
+          </a:bodyPr>
+          <a:lstStyle/>
+          <a:p>
+            <a:pPr algn="l">
+              <a:spcAft>
+                <a:spcPts val="300"/>
+              </a:spcAft>
+            </a:pPr>
+            <a:r>
+              <a:rPr sz="1000" b="0">
+                <a:solidFill>
+                  <a:srgbClr val="5A5A5A"/>
+                </a:solidFill>
+                <a:latin typeface="Calibri"/>
+              </a:rPr>
+              <a:t>activo 11/08</a:t>
+            </a:r>
+          </a:p>
+        </p:txBody>
+      </p:sp>
+      <p:sp>
+        <p:nvSpPr>
+          <p:cNvPr id="17" name="Rounded Rectangle 16"/>
+          <p:cNvSpPr/>
+          <p:nvPr/>
+        </p:nvSpPr>
+        <p:spPr>
+          <a:xfrm>
+            <a:off x="7333488" y="1024128"/>
+            <a:ext cx="2286000" cy="658368"/>
+          </a:xfrm>
+          <a:prstGeom prst="roundRect">
+            <a:avLst>
+              <a:gd name="adj" fmla="val 8000"/>
+            </a:avLst>
+          </a:prstGeom>
+          <a:solidFill>
+            <a:srgbClr val="F5F7FA"/>
+          </a:solidFill>
+          <a:ln w="6350">
+            <a:solidFill>
+              <a:srgbClr val="1F77B4"/>
+            </a:solidFill>
+          </a:ln>
+        </p:spPr>
+        <p:style>
+          <a:lnRef idx="1">
+            <a:schemeClr val="accent1"/>
+          </a:lnRef>
+          <a:fillRef idx="3">
+            <a:schemeClr val="accent1"/>
+          </a:fillRef>
+          <a:effectRef idx="2">
+            <a:schemeClr val="accent1"/>
+          </a:effectRef>
+          <a:fontRef idx="minor">
+            <a:schemeClr val="lt1"/>
+          </a:fontRef>
+        </p:style>
+        <p:txBody>
+          <a:bodyPr rtlCol="0" anchor="ctr"/>
+          <a:lstStyle/>
+          <a:p>
+            <a:pPr algn="ctr"/>
+          </a:p>
+        </p:txBody>
+      </p:sp>
+      <p:sp>
+        <p:nvSpPr>
+          <p:cNvPr id="18" name="TextBox 17"/>
+          <p:cNvSpPr txBox="1"/>
+          <p:nvPr/>
+        </p:nvSpPr>
+        <p:spPr>
+          <a:xfrm>
+            <a:off x="7424928" y="1060704"/>
+            <a:ext cx="2121408" cy="201168"/>
+          </a:xfrm>
+          <a:prstGeom prst="rect">
+            <a:avLst/>
+          </a:prstGeom>
+          <a:noFill/>
+        </p:spPr>
+        <p:txBody>
+          <a:bodyPr wrap="square">
+            <a:spAutoFit/>
+          </a:bodyPr>
+          <a:lstStyle/>
+          <a:p>
+            <a:pPr algn="l">
+              <a:spcAft>
+                <a:spcPts val="300"/>
+              </a:spcAft>
+            </a:pPr>
+            <a:r>
+              <a:rPr sz="1000" b="1">
+                <a:solidFill>
+                  <a:srgbClr val="C9A227"/>
+                </a:solidFill>
+                <a:latin typeface="Calibri"/>
+              </a:rPr>
+              <a:t>000025-32</a:t>
+            </a:r>
+          </a:p>
+        </p:txBody>
+      </p:sp>
+      <p:sp>
+        <p:nvSpPr>
+          <p:cNvPr id="19" name="TextBox 18"/>
+          <p:cNvSpPr txBox="1"/>
+          <p:nvPr/>
+        </p:nvSpPr>
+        <p:spPr>
+          <a:xfrm>
+            <a:off x="7424928" y="1261872"/>
+            <a:ext cx="2121408" cy="219456"/>
+          </a:xfrm>
+          <a:prstGeom prst="rect">
+            <a:avLst/>
+          </a:prstGeom>
+          <a:noFill/>
+        </p:spPr>
+        <p:txBody>
+          <a:bodyPr wrap="square">
+            <a:spAutoFit/>
+          </a:bodyPr>
+          <a:lstStyle/>
+          <a:p>
+            <a:pPr algn="l">
+              <a:spcAft>
+                <a:spcPts val="300"/>
+              </a:spcAft>
+            </a:pPr>
+            <a:r>
+              <a:rPr sz="1200" b="1">
+                <a:solidFill>
+                  <a:srgbClr val="0D3B66"/>
+                </a:solidFill>
+                <a:latin typeface="Calibri"/>
+              </a:rPr>
+              <a:t>Pasillo Técnico</a:t>
+            </a:r>
+          </a:p>
+        </p:txBody>
+      </p:sp>
+      <p:sp>
+        <p:nvSpPr>
+          <p:cNvPr id="20" name="TextBox 19"/>
+          <p:cNvSpPr txBox="1"/>
+          <p:nvPr/>
+        </p:nvSpPr>
+        <p:spPr>
+          <a:xfrm>
+            <a:off x="7424928" y="1463040"/>
+            <a:ext cx="2121408" cy="182880"/>
+          </a:xfrm>
+          <a:prstGeom prst="rect">
+            <a:avLst/>
+          </a:prstGeom>
+          <a:noFill/>
+        </p:spPr>
+        <p:txBody>
+          <a:bodyPr wrap="square">
+            <a:spAutoFit/>
+          </a:bodyPr>
+          <a:lstStyle/>
+          <a:p>
+            <a:pPr algn="l">
+              <a:spcAft>
+                <a:spcPts val="300"/>
+              </a:spcAft>
+            </a:pPr>
+            <a:r>
+              <a:rPr sz="1000" b="0">
+                <a:solidFill>
+                  <a:srgbClr val="5A5A5A"/>
+                </a:solidFill>
+                <a:latin typeface="Calibri"/>
+              </a:rPr>
+              <a:t>residual</a:t>
+            </a:r>
+          </a:p>
+        </p:txBody>
+      </p:sp>
+      <p:sp>
+        <p:nvSpPr>
+          <p:cNvPr id="21" name="Rounded Rectangle 20"/>
+          <p:cNvSpPr/>
+          <p:nvPr/>
+        </p:nvSpPr>
+        <p:spPr>
+          <a:xfrm>
+            <a:off x="9710928" y="1024128"/>
+            <a:ext cx="2286000" cy="658368"/>
+          </a:xfrm>
+          <a:prstGeom prst="roundRect">
+            <a:avLst>
+              <a:gd name="adj" fmla="val 8000"/>
+            </a:avLst>
+          </a:prstGeom>
+          <a:solidFill>
+            <a:srgbClr val="F5F7FA"/>
+          </a:solidFill>
+          <a:ln w="6350">
+            <a:solidFill>
+              <a:srgbClr val="1F77B4"/>
+            </a:solidFill>
+          </a:ln>
+        </p:spPr>
+        <p:style>
+          <a:lnRef idx="1">
+            <a:schemeClr val="accent1"/>
+          </a:lnRef>
+          <a:fillRef idx="3">
+            <a:schemeClr val="accent1"/>
+          </a:fillRef>
+          <a:effectRef idx="2">
+            <a:schemeClr val="accent1"/>
+          </a:effectRef>
+          <a:fontRef idx="minor">
+            <a:schemeClr val="lt1"/>
+          </a:fontRef>
+        </p:style>
+        <p:txBody>
+          <a:bodyPr rtlCol="0" anchor="ctr"/>
+          <a:lstStyle/>
+          <a:p>
+            <a:pPr algn="ctr"/>
+          </a:p>
+        </p:txBody>
+      </p:sp>
+      <p:sp>
+        <p:nvSpPr>
+          <p:cNvPr id="22" name="TextBox 21"/>
+          <p:cNvSpPr txBox="1"/>
+          <p:nvPr/>
+        </p:nvSpPr>
+        <p:spPr>
+          <a:xfrm>
+            <a:off x="9802368" y="1060704"/>
+            <a:ext cx="2121408" cy="201168"/>
+          </a:xfrm>
+          <a:prstGeom prst="rect">
+            <a:avLst/>
+          </a:prstGeom>
+          <a:noFill/>
+        </p:spPr>
+        <p:txBody>
+          <a:bodyPr wrap="square">
+            <a:spAutoFit/>
+          </a:bodyPr>
+          <a:lstStyle/>
+          <a:p>
+            <a:pPr algn="l">
+              <a:spcAft>
+                <a:spcPts val="300"/>
+              </a:spcAft>
+            </a:pPr>
+            <a:r>
+              <a:rPr sz="1000" b="1">
+                <a:solidFill>
+                  <a:srgbClr val="C9A227"/>
+                </a:solidFill>
+                <a:latin typeface="Calibri"/>
+              </a:rPr>
+              <a:t>000025-33</a:t>
+            </a:r>
+          </a:p>
+        </p:txBody>
+      </p:sp>
+      <p:sp>
+        <p:nvSpPr>
+          <p:cNvPr id="23" name="TextBox 22"/>
+          <p:cNvSpPr txBox="1"/>
+          <p:nvPr/>
+        </p:nvSpPr>
+        <p:spPr>
+          <a:xfrm>
+            <a:off x="9802368" y="1261872"/>
+            <a:ext cx="2121408" cy="219456"/>
+          </a:xfrm>
+          <a:prstGeom prst="rect">
+            <a:avLst/>
+          </a:prstGeom>
+          <a:noFill/>
+        </p:spPr>
+        <p:txBody>
+          <a:bodyPr wrap="square">
+            <a:spAutoFit/>
+          </a:bodyPr>
+          <a:lstStyle/>
+          <a:p>
+            <a:pPr algn="l">
+              <a:spcAft>
+                <a:spcPts val="300"/>
+              </a:spcAft>
+            </a:pPr>
+            <a:r>
+              <a:rPr sz="1200" b="1">
+                <a:solidFill>
+                  <a:srgbClr val="0D3B66"/>
+                </a:solidFill>
+                <a:latin typeface="Calibri"/>
+              </a:rPr>
+              <a:t>Salida ARROW</a:t>
+            </a:r>
+          </a:p>
+        </p:txBody>
+      </p:sp>
+      <p:sp>
+        <p:nvSpPr>
+          <p:cNvPr id="24" name="TextBox 23"/>
+          <p:cNvSpPr txBox="1"/>
+          <p:nvPr/>
+        </p:nvSpPr>
+        <p:spPr>
+          <a:xfrm>
+            <a:off x="9802368" y="1463040"/>
+            <a:ext cx="2121408" cy="182880"/>
+          </a:xfrm>
+          <a:prstGeom prst="rect">
+            <a:avLst/>
+          </a:prstGeom>
+          <a:noFill/>
+        </p:spPr>
+        <p:txBody>
+          <a:bodyPr wrap="square">
+            <a:spAutoFit/>
+          </a:bodyPr>
+          <a:lstStyle/>
+          <a:p>
+            <a:pPr algn="l">
+              <a:spcAft>
+                <a:spcPts val="300"/>
+              </a:spcAft>
+            </a:pPr>
+            <a:r>
+              <a:rPr sz="1000" b="0">
+                <a:solidFill>
+                  <a:srgbClr val="5A5A5A"/>
+                </a:solidFill>
+                <a:latin typeface="Calibri"/>
+              </a:rPr>
+              <a:t>residual</a:t>
+            </a:r>
+          </a:p>
+        </p:txBody>
+      </p:sp>
+      <p:sp>
+        <p:nvSpPr>
+          <p:cNvPr id="25" name="Rounded Rectangle 24"/>
+          <p:cNvSpPr/>
+          <p:nvPr/>
+        </p:nvSpPr>
+        <p:spPr>
+          <a:xfrm>
+            <a:off x="201168" y="1792224"/>
+            <a:ext cx="7973568" cy="3822191"/>
+          </a:xfrm>
+          <a:prstGeom prst="roundRect">
+            <a:avLst>
+              <a:gd name="adj" fmla="val 8000"/>
+            </a:avLst>
+          </a:prstGeom>
+          <a:solidFill>
+            <a:srgbClr val="F5F7FA"/>
+          </a:solidFill>
+          <a:ln>
+            <a:noFill/>
+          </a:ln>
+        </p:spPr>
+        <p:style>
+          <a:lnRef idx="1">
+            <a:schemeClr val="accent1"/>
+          </a:lnRef>
+          <a:fillRef idx="3">
+            <a:schemeClr val="accent1"/>
+          </a:fillRef>
+          <a:effectRef idx="2">
+            <a:schemeClr val="accent1"/>
+          </a:effectRef>
+          <a:fontRef idx="minor">
+            <a:schemeClr val="lt1"/>
+          </a:fontRef>
+        </p:style>
+        <p:txBody>
+          <a:bodyPr rtlCol="0" anchor="ctr"/>
+          <a:lstStyle/>
+          <a:p>
+            <a:pPr algn="ctr"/>
+          </a:p>
+        </p:txBody>
+      </p:sp>
+      <p:pic>
+        <p:nvPicPr>
+          <p:cNvPr id="26" name="Picture 25" descr="mam_mensual_may_ago.png"/>
+          <p:cNvPicPr>
+            <a:picLocks noChangeAspect="1"/>
+          </p:cNvPicPr>
+          <p:nvPr/>
+        </p:nvPicPr>
+        <p:blipFill>
+          <a:blip r:embed="rId3"/>
+          <a:stretch>
+            <a:fillRect/>
+          </a:stretch>
+        </p:blipFill>
+        <p:spPr>
+          <a:xfrm>
+            <a:off x="329184" y="1865376"/>
+            <a:ext cx="7717536" cy="3777531"/>
+          </a:xfrm>
+          <a:prstGeom prst="rect">
+            <a:avLst/>
+          </a:prstGeom>
+        </p:spPr>
+      </p:pic>
+      <p:sp>
+        <p:nvSpPr>
+          <p:cNvPr id="27" name="Rounded Rectangle 26"/>
+          <p:cNvSpPr/>
+          <p:nvPr/>
+        </p:nvSpPr>
+        <p:spPr>
+          <a:xfrm>
+            <a:off x="8302752" y="1792224"/>
+            <a:ext cx="3675887" cy="3822191"/>
+          </a:xfrm>
+          <a:prstGeom prst="roundRect">
+            <a:avLst>
+              <a:gd name="adj" fmla="val 8000"/>
+            </a:avLst>
+          </a:prstGeom>
+          <a:solidFill>
+            <a:srgbClr val="FFFFFF"/>
+          </a:solidFill>
+          <a:ln w="6350">
+            <a:solidFill>
+              <a:srgbClr val="1F77B4"/>
+            </a:solidFill>
+          </a:ln>
+        </p:spPr>
+        <p:style>
+          <a:lnRef idx="1">
+            <a:schemeClr val="accent1"/>
+          </a:lnRef>
+          <a:fillRef idx="3">
+            <a:schemeClr val="accent1"/>
+          </a:fillRef>
+          <a:effectRef idx="2">
+            <a:schemeClr val="accent1"/>
+          </a:effectRef>
+          <a:fontRef idx="minor">
+            <a:schemeClr val="lt1"/>
+          </a:fontRef>
+        </p:style>
+        <p:txBody>
+          <a:bodyPr rtlCol="0" anchor="ctr"/>
+          <a:lstStyle/>
+          <a:p>
+            <a:pPr algn="ctr"/>
+          </a:p>
+        </p:txBody>
+      </p:sp>
+      <p:sp>
+        <p:nvSpPr>
+          <p:cNvPr id="28" name="TextBox 27"/>
+          <p:cNvSpPr txBox="1"/>
+          <p:nvPr/>
+        </p:nvSpPr>
+        <p:spPr>
+          <a:xfrm>
+            <a:off x="8430768" y="1847088"/>
+            <a:ext cx="3419856" cy="201168"/>
+          </a:xfrm>
+          <a:prstGeom prst="rect">
+            <a:avLst/>
+          </a:prstGeom>
+          <a:noFill/>
+        </p:spPr>
+        <p:txBody>
+          <a:bodyPr wrap="square">
+            <a:spAutoFit/>
+          </a:bodyPr>
+          <a:lstStyle/>
+          <a:p>
+            <a:pPr algn="l">
+              <a:spcAft>
+                <a:spcPts val="300"/>
+              </a:spcAft>
+            </a:pPr>
+            <a:r>
+              <a:rPr sz="1100" b="1">
+                <a:solidFill>
+                  <a:srgbClr val="1F77B4"/>
+                </a:solidFill>
+                <a:latin typeface="Calibri"/>
+              </a:rPr>
+              <a:t>JULIO · último mes cerrado</a:t>
+            </a:r>
+          </a:p>
+        </p:txBody>
+      </p:sp>
+      <p:sp>
+        <p:nvSpPr>
+          <p:cNvPr id="29" name="TextBox 28"/>
+          <p:cNvSpPr txBox="1"/>
+          <p:nvPr/>
+        </p:nvSpPr>
+        <p:spPr>
+          <a:xfrm>
+            <a:off x="8430768" y="2048256"/>
+            <a:ext cx="3419856" cy="256032"/>
+          </a:xfrm>
+          <a:prstGeom prst="rect">
+            <a:avLst/>
+          </a:prstGeom>
+          <a:noFill/>
+        </p:spPr>
+        <p:txBody>
+          <a:bodyPr wrap="square">
+            <a:spAutoFit/>
+          </a:bodyPr>
+          <a:lstStyle/>
+          <a:p>
+            <a:pPr algn="l">
+              <a:spcAft>
+                <a:spcPts val="300"/>
+              </a:spcAft>
+            </a:pPr>
+            <a:r>
+              <a:rPr sz="1200" b="0">
+                <a:solidFill>
+                  <a:srgbClr val="5A5A5A"/>
+                </a:solidFill>
+                <a:latin typeface="Calibri"/>
+              </a:rPr>
+              <a:t>El recinto sumó 10.356 m³</a:t>
+            </a:r>
+          </a:p>
+        </p:txBody>
+      </p:sp>
+      <p:sp>
+        <p:nvSpPr>
+          <p:cNvPr id="30" name="Rounded Rectangle 29"/>
+          <p:cNvSpPr/>
+          <p:nvPr/>
+        </p:nvSpPr>
+        <p:spPr>
+          <a:xfrm>
+            <a:off x="8430768" y="2359152"/>
+            <a:ext cx="3419856" cy="603504"/>
+          </a:xfrm>
+          <a:prstGeom prst="roundRect">
+            <a:avLst>
+              <a:gd name="adj" fmla="val 8000"/>
+            </a:avLst>
+          </a:prstGeom>
+          <a:solidFill>
+            <a:srgbClr val="F5F7FA"/>
+          </a:solidFill>
+          <a:ln w="6350">
+            <a:solidFill>
+              <a:srgbClr val="0D3B66"/>
+            </a:solidFill>
+          </a:ln>
+        </p:spPr>
+        <p:style>
+          <a:lnRef idx="1">
+            <a:schemeClr val="accent1"/>
+          </a:lnRef>
+          <a:fillRef idx="3">
+            <a:schemeClr val="accent1"/>
+          </a:fillRef>
+          <a:effectRef idx="2">
+            <a:schemeClr val="accent1"/>
+          </a:effectRef>
+          <a:fontRef idx="minor">
+            <a:schemeClr val="lt1"/>
+          </a:fontRef>
+        </p:style>
+        <p:txBody>
+          <a:bodyPr rtlCol="0" anchor="ctr"/>
+          <a:lstStyle/>
+          <a:p>
+            <a:pPr algn="ctr"/>
+          </a:p>
+        </p:txBody>
+      </p:sp>
+      <p:sp>
+        <p:nvSpPr>
+          <p:cNvPr id="31" name="TextBox 30"/>
+          <p:cNvSpPr txBox="1"/>
+          <p:nvPr/>
+        </p:nvSpPr>
+        <p:spPr>
+          <a:xfrm>
+            <a:off x="8540496" y="2395728"/>
+            <a:ext cx="3200400" cy="182880"/>
+          </a:xfrm>
+          <a:prstGeom prst="rect">
+            <a:avLst/>
+          </a:prstGeom>
+          <a:noFill/>
+        </p:spPr>
+        <p:txBody>
+          <a:bodyPr wrap="square">
+            <a:spAutoFit/>
+          </a:bodyPr>
+          <a:lstStyle/>
+          <a:p>
+            <a:pPr algn="l">
+              <a:spcAft>
+                <a:spcPts val="300"/>
+              </a:spcAft>
+            </a:pPr>
+            <a:r>
+              <a:rPr sz="1100" b="1">
+                <a:solidFill>
+                  <a:srgbClr val="0D3B66"/>
+                </a:solidFill>
+                <a:latin typeface="Calibri"/>
+              </a:rPr>
+              <a:t>000025-08  Placa Bancaria</a:t>
+            </a:r>
+          </a:p>
+        </p:txBody>
+      </p:sp>
+      <p:sp>
+        <p:nvSpPr>
+          <p:cNvPr id="32" name="TextBox 31"/>
+          <p:cNvSpPr txBox="1"/>
+          <p:nvPr/>
+        </p:nvSpPr>
+        <p:spPr>
+          <a:xfrm>
+            <a:off x="8540496" y="2615184"/>
+            <a:ext cx="3200400" cy="274320"/>
+          </a:xfrm>
+          <a:prstGeom prst="rect">
+            <a:avLst/>
+          </a:prstGeom>
+          <a:noFill/>
+        </p:spPr>
+        <p:txBody>
+          <a:bodyPr wrap="square">
+            <a:spAutoFit/>
+          </a:bodyPr>
+          <a:lstStyle/>
+          <a:p>
+            <a:pPr algn="l">
+              <a:spcAft>
+                <a:spcPts val="300"/>
+              </a:spcAft>
+            </a:pPr>
+            <a:r>
+              <a:rPr sz="1500" b="1">
+                <a:solidFill>
+                  <a:srgbClr val="0D3B66"/>
+                </a:solidFill>
+                <a:latin typeface="Calibri"/>
+              </a:rPr>
+              <a:t>7.084 m³    68 %</a:t>
+            </a:r>
+          </a:p>
+        </p:txBody>
+      </p:sp>
+      <p:sp>
+        <p:nvSpPr>
+          <p:cNvPr id="33" name="Rounded Rectangle 32"/>
+          <p:cNvSpPr/>
+          <p:nvPr/>
+        </p:nvSpPr>
+        <p:spPr>
+          <a:xfrm>
+            <a:off x="8430768" y="2999232"/>
+            <a:ext cx="3419856" cy="603504"/>
+          </a:xfrm>
+          <a:prstGeom prst="roundRect">
+            <a:avLst>
+              <a:gd name="adj" fmla="val 8000"/>
+            </a:avLst>
+          </a:prstGeom>
+          <a:solidFill>
+            <a:srgbClr val="F5F7FA"/>
+          </a:solidFill>
+          <a:ln w="6350">
+            <a:solidFill>
+              <a:srgbClr val="1F77B4"/>
+            </a:solidFill>
+          </a:ln>
+        </p:spPr>
+        <p:style>
+          <a:lnRef idx="1">
+            <a:schemeClr val="accent1"/>
+          </a:lnRef>
+          <a:fillRef idx="3">
+            <a:schemeClr val="accent1"/>
+          </a:fillRef>
+          <a:effectRef idx="2">
+            <a:schemeClr val="accent1"/>
+          </a:effectRef>
+          <a:fontRef idx="minor">
+            <a:schemeClr val="lt1"/>
+          </a:fontRef>
+        </p:style>
+        <p:txBody>
+          <a:bodyPr rtlCol="0" anchor="ctr"/>
+          <a:lstStyle/>
+          <a:p>
+            <a:pPr algn="ctr"/>
+          </a:p>
+        </p:txBody>
+      </p:sp>
+      <p:sp>
+        <p:nvSpPr>
+          <p:cNvPr id="34" name="TextBox 33"/>
+          <p:cNvSpPr txBox="1"/>
+          <p:nvPr/>
+        </p:nvSpPr>
+        <p:spPr>
+          <a:xfrm>
+            <a:off x="8540496" y="3035808"/>
+            <a:ext cx="3200400" cy="182880"/>
+          </a:xfrm>
+          <a:prstGeom prst="rect">
+            <a:avLst/>
+          </a:prstGeom>
+          <a:noFill/>
+        </p:spPr>
+        <p:txBody>
+          <a:bodyPr wrap="square">
+            <a:spAutoFit/>
+          </a:bodyPr>
+          <a:lstStyle/>
+          <a:p>
+            <a:pPr algn="l">
+              <a:spcAft>
+                <a:spcPts val="300"/>
+              </a:spcAft>
+            </a:pPr>
+            <a:r>
+              <a:rPr sz="1100" b="1">
+                <a:solidFill>
+                  <a:srgbClr val="1F77B4"/>
+                </a:solidFill>
+                <a:latin typeface="Calibri"/>
+              </a:rPr>
+              <a:t>000025-10  Ripley</a:t>
+            </a:r>
+          </a:p>
+        </p:txBody>
+      </p:sp>
+      <p:sp>
+        <p:nvSpPr>
+          <p:cNvPr id="35" name="TextBox 34"/>
+          <p:cNvSpPr txBox="1"/>
+          <p:nvPr/>
+        </p:nvSpPr>
+        <p:spPr>
+          <a:xfrm>
+            <a:off x="8540496" y="3255264"/>
+            <a:ext cx="3200400" cy="274320"/>
+          </a:xfrm>
+          <a:prstGeom prst="rect">
+            <a:avLst/>
+          </a:prstGeom>
+          <a:noFill/>
+        </p:spPr>
+        <p:txBody>
+          <a:bodyPr wrap="square">
+            <a:spAutoFit/>
+          </a:bodyPr>
+          <a:lstStyle/>
+          <a:p>
+            <a:pPr algn="l">
+              <a:spcAft>
+                <a:spcPts val="300"/>
+              </a:spcAft>
+            </a:pPr>
+            <a:r>
+              <a:rPr sz="1500" b="1">
+                <a:solidFill>
+                  <a:srgbClr val="0D3B66"/>
+                </a:solidFill>
+                <a:latin typeface="Calibri"/>
+              </a:rPr>
+              <a:t>3.245 m³    31 %</a:t>
+            </a:r>
+          </a:p>
+        </p:txBody>
+      </p:sp>
+      <p:sp>
+        <p:nvSpPr>
+          <p:cNvPr id="36" name="Rounded Rectangle 35"/>
+          <p:cNvSpPr/>
+          <p:nvPr/>
+        </p:nvSpPr>
+        <p:spPr>
+          <a:xfrm>
+            <a:off x="8430768" y="3639312"/>
+            <a:ext cx="3419856" cy="603504"/>
+          </a:xfrm>
+          <a:prstGeom prst="roundRect">
+            <a:avLst>
+              <a:gd name="adj" fmla="val 8000"/>
+            </a:avLst>
+          </a:prstGeom>
+          <a:solidFill>
+            <a:srgbClr val="F5F7FA"/>
+          </a:solidFill>
+          <a:ln w="6350">
+            <a:solidFill>
+              <a:srgbClr val="7BA3C9"/>
+            </a:solidFill>
+          </a:ln>
+        </p:spPr>
+        <p:style>
+          <a:lnRef idx="1">
+            <a:schemeClr val="accent1"/>
+          </a:lnRef>
+          <a:fillRef idx="3">
+            <a:schemeClr val="accent1"/>
+          </a:fillRef>
+          <a:effectRef idx="2">
+            <a:schemeClr val="accent1"/>
+          </a:effectRef>
+          <a:fontRef idx="minor">
+            <a:schemeClr val="lt1"/>
+          </a:fontRef>
+        </p:style>
+        <p:txBody>
+          <a:bodyPr rtlCol="0" anchor="ctr"/>
+          <a:lstStyle/>
+          <a:p>
+            <a:pPr algn="ctr"/>
+          </a:p>
+        </p:txBody>
+      </p:sp>
+      <p:sp>
+        <p:nvSpPr>
+          <p:cNvPr id="37" name="TextBox 36"/>
+          <p:cNvSpPr txBox="1"/>
+          <p:nvPr/>
+        </p:nvSpPr>
+        <p:spPr>
+          <a:xfrm>
+            <a:off x="8540496" y="3675888"/>
+            <a:ext cx="3200400" cy="182880"/>
+          </a:xfrm>
+          <a:prstGeom prst="rect">
+            <a:avLst/>
+          </a:prstGeom>
+          <a:noFill/>
+        </p:spPr>
+        <p:txBody>
+          <a:bodyPr wrap="square">
+            <a:spAutoFit/>
+          </a:bodyPr>
+          <a:lstStyle/>
+          <a:p>
+            <a:pPr algn="l">
+              <a:spcAft>
+                <a:spcPts val="300"/>
+              </a:spcAft>
+            </a:pPr>
+            <a:r>
+              <a:rPr sz="1100" b="1">
+                <a:solidFill>
+                  <a:srgbClr val="7BA3C9"/>
+                </a:solidFill>
+                <a:latin typeface="Calibri"/>
+              </a:rPr>
+              <a:t>000025-32  Pasillo Técnico</a:t>
+            </a:r>
+          </a:p>
+        </p:txBody>
+      </p:sp>
+      <p:sp>
+        <p:nvSpPr>
+          <p:cNvPr id="38" name="TextBox 37"/>
+          <p:cNvSpPr txBox="1"/>
+          <p:nvPr/>
+        </p:nvSpPr>
+        <p:spPr>
+          <a:xfrm>
+            <a:off x="8540496" y="3895344"/>
+            <a:ext cx="3200400" cy="274320"/>
+          </a:xfrm>
+          <a:prstGeom prst="rect">
+            <a:avLst/>
+          </a:prstGeom>
+          <a:noFill/>
+        </p:spPr>
+        <p:txBody>
+          <a:bodyPr wrap="square">
+            <a:spAutoFit/>
+          </a:bodyPr>
+          <a:lstStyle/>
+          <a:p>
+            <a:pPr algn="l">
+              <a:spcAft>
+                <a:spcPts val="300"/>
+              </a:spcAft>
+            </a:pPr>
+            <a:r>
+              <a:rPr sz="1500" b="1">
+                <a:solidFill>
+                  <a:srgbClr val="0D3B66"/>
+                </a:solidFill>
+                <a:latin typeface="Calibri"/>
+              </a:rPr>
+              <a:t>26 m³    0 %</a:t>
+            </a:r>
+          </a:p>
+        </p:txBody>
+      </p:sp>
+      <p:sp>
+        <p:nvSpPr>
+          <p:cNvPr id="39" name="Rounded Rectangle 38"/>
+          <p:cNvSpPr/>
+          <p:nvPr/>
+        </p:nvSpPr>
+        <p:spPr>
+          <a:xfrm>
+            <a:off x="8430768" y="4279392"/>
+            <a:ext cx="3419856" cy="603504"/>
+          </a:xfrm>
+          <a:prstGeom prst="roundRect">
+            <a:avLst>
+              <a:gd name="adj" fmla="val 8000"/>
+            </a:avLst>
+          </a:prstGeom>
+          <a:solidFill>
+            <a:srgbClr val="F5F7FA"/>
+          </a:solidFill>
+          <a:ln w="6350">
+            <a:solidFill>
+              <a:srgbClr val="5A8C6E"/>
+            </a:solidFill>
+          </a:ln>
+        </p:spPr>
+        <p:style>
+          <a:lnRef idx="1">
+            <a:schemeClr val="accent1"/>
+          </a:lnRef>
+          <a:fillRef idx="3">
+            <a:schemeClr val="accent1"/>
+          </a:fillRef>
+          <a:effectRef idx="2">
+            <a:schemeClr val="accent1"/>
+          </a:effectRef>
+          <a:fontRef idx="minor">
+            <a:schemeClr val="lt1"/>
+          </a:fontRef>
+        </p:style>
+        <p:txBody>
+          <a:bodyPr rtlCol="0" anchor="ctr"/>
+          <a:lstStyle/>
+          <a:p>
+            <a:pPr algn="ctr"/>
+          </a:p>
+        </p:txBody>
+      </p:sp>
+      <p:sp>
+        <p:nvSpPr>
+          <p:cNvPr id="40" name="TextBox 39"/>
+          <p:cNvSpPr txBox="1"/>
+          <p:nvPr/>
+        </p:nvSpPr>
+        <p:spPr>
+          <a:xfrm>
+            <a:off x="8540496" y="4315968"/>
+            <a:ext cx="3200400" cy="182880"/>
+          </a:xfrm>
+          <a:prstGeom prst="rect">
+            <a:avLst/>
+          </a:prstGeom>
+          <a:noFill/>
+        </p:spPr>
+        <p:txBody>
+          <a:bodyPr wrap="square">
+            <a:spAutoFit/>
+          </a:bodyPr>
+          <a:lstStyle/>
+          <a:p>
+            <a:pPr algn="l">
+              <a:spcAft>
+                <a:spcPts val="300"/>
+              </a:spcAft>
+            </a:pPr>
+            <a:r>
+              <a:rPr sz="1100" b="1">
+                <a:solidFill>
+                  <a:srgbClr val="5A8C6E"/>
+                </a:solidFill>
+                <a:latin typeface="Calibri"/>
+              </a:rPr>
+              <a:t>000025-33  Salida ARROW</a:t>
+            </a:r>
+          </a:p>
+        </p:txBody>
+      </p:sp>
+      <p:sp>
+        <p:nvSpPr>
+          <p:cNvPr id="41" name="TextBox 40"/>
+          <p:cNvSpPr txBox="1"/>
+          <p:nvPr/>
+        </p:nvSpPr>
+        <p:spPr>
+          <a:xfrm>
+            <a:off x="8540496" y="4535424"/>
+            <a:ext cx="3200400" cy="274320"/>
+          </a:xfrm>
+          <a:prstGeom prst="rect">
+            <a:avLst/>
+          </a:prstGeom>
+          <a:noFill/>
+        </p:spPr>
+        <p:txBody>
+          <a:bodyPr wrap="square">
+            <a:spAutoFit/>
+          </a:bodyPr>
+          <a:lstStyle/>
+          <a:p>
+            <a:pPr algn="l">
+              <a:spcAft>
+                <a:spcPts val="300"/>
+              </a:spcAft>
+            </a:pPr>
+            <a:r>
+              <a:rPr sz="1500" b="1">
+                <a:solidFill>
+                  <a:srgbClr val="0D3B66"/>
+                </a:solidFill>
+                <a:latin typeface="Calibri"/>
+              </a:rPr>
+              <a:t>1 m³    0 %</a:t>
+            </a:r>
+          </a:p>
+        </p:txBody>
+      </p:sp>
+      <p:sp>
+        <p:nvSpPr>
+          <p:cNvPr id="42" name="Rounded Rectangle 41"/>
+          <p:cNvSpPr/>
+          <p:nvPr/>
+        </p:nvSpPr>
+        <p:spPr>
+          <a:xfrm>
+            <a:off x="8430768" y="4919472"/>
+            <a:ext cx="3419856" cy="603504"/>
+          </a:xfrm>
+          <a:prstGeom prst="roundRect">
+            <a:avLst>
+              <a:gd name="adj" fmla="val 8000"/>
+            </a:avLst>
+          </a:prstGeom>
+          <a:solidFill>
+            <a:srgbClr val="F5F7FA"/>
+          </a:solidFill>
+          <a:ln w="6350">
+            <a:solidFill>
+              <a:srgbClr val="C9A227"/>
+            </a:solidFill>
+          </a:ln>
+        </p:spPr>
+        <p:style>
+          <a:lnRef idx="1">
+            <a:schemeClr val="accent1"/>
+          </a:lnRef>
+          <a:fillRef idx="3">
+            <a:schemeClr val="accent1"/>
+          </a:fillRef>
+          <a:effectRef idx="2">
+            <a:schemeClr val="accent1"/>
+          </a:effectRef>
+          <a:fontRef idx="minor">
+            <a:schemeClr val="lt1"/>
+          </a:fontRef>
+        </p:style>
+        <p:txBody>
+          <a:bodyPr rtlCol="0" anchor="ctr"/>
+          <a:lstStyle/>
+          <a:p>
+            <a:pPr algn="ctr"/>
+          </a:p>
+        </p:txBody>
+      </p:sp>
+      <p:sp>
+        <p:nvSpPr>
+          <p:cNvPr id="43" name="TextBox 42"/>
+          <p:cNvSpPr txBox="1"/>
+          <p:nvPr/>
+        </p:nvSpPr>
+        <p:spPr>
+          <a:xfrm>
+            <a:off x="8540496" y="4956048"/>
+            <a:ext cx="3200400" cy="182880"/>
+          </a:xfrm>
+          <a:prstGeom prst="rect">
+            <a:avLst/>
+          </a:prstGeom>
+          <a:noFill/>
+        </p:spPr>
+        <p:txBody>
+          <a:bodyPr wrap="square">
+            <a:spAutoFit/>
+          </a:bodyPr>
+          <a:lstStyle/>
+          <a:p>
+            <a:pPr algn="l">
+              <a:spcAft>
+                <a:spcPts val="300"/>
+              </a:spcAft>
+            </a:pPr>
+            <a:r>
+              <a:rPr sz="1100" b="1">
+                <a:solidFill>
+                  <a:srgbClr val="C9A227"/>
+                </a:solidFill>
+                <a:latin typeface="Calibri"/>
+              </a:rPr>
+              <a:t>000025-09  Falabella</a:t>
+            </a:r>
+          </a:p>
+        </p:txBody>
+      </p:sp>
+      <p:sp>
+        <p:nvSpPr>
+          <p:cNvPr id="44" name="TextBox 43"/>
+          <p:cNvSpPr txBox="1"/>
+          <p:nvPr/>
+        </p:nvSpPr>
+        <p:spPr>
+          <a:xfrm>
+            <a:off x="8540496" y="5175504"/>
+            <a:ext cx="3200400" cy="274320"/>
+          </a:xfrm>
+          <a:prstGeom prst="rect">
+            <a:avLst/>
+          </a:prstGeom>
+          <a:noFill/>
+        </p:spPr>
+        <p:txBody>
+          <a:bodyPr wrap="square">
+            <a:spAutoFit/>
+          </a:bodyPr>
+          <a:lstStyle/>
+          <a:p>
+            <a:pPr algn="l">
+              <a:spcAft>
+                <a:spcPts val="300"/>
+              </a:spcAft>
+            </a:pPr>
+            <a:r>
+              <a:rPr sz="1500" b="1">
+                <a:solidFill>
+                  <a:srgbClr val="0D3B66"/>
+                </a:solidFill>
+                <a:latin typeface="Calibri"/>
+              </a:rPr>
+              <a:t>0 m³    0 % · 11/08</a:t>
+            </a:r>
+          </a:p>
+        </p:txBody>
+      </p:sp>
+      <p:sp>
+        <p:nvSpPr>
+          <p:cNvPr id="45" name="Rounded Rectangle 44"/>
+          <p:cNvSpPr/>
+          <p:nvPr/>
+        </p:nvSpPr>
+        <p:spPr>
+          <a:xfrm>
+            <a:off x="201168" y="5705856"/>
+            <a:ext cx="11795760" cy="438912"/>
+          </a:xfrm>
+          <a:prstGeom prst="roundRect">
+            <a:avLst>
+              <a:gd name="adj" fmla="val 8000"/>
+            </a:avLst>
+          </a:prstGeom>
+          <a:solidFill>
+            <a:srgbClr val="FFF9EB"/>
+          </a:solidFill>
+          <a:ln w="6350">
+            <a:solidFill>
+              <a:srgbClr val="C9A227"/>
+            </a:solidFill>
+          </a:ln>
+        </p:spPr>
+        <p:style>
+          <a:lnRef idx="1">
+            <a:schemeClr val="accent1"/>
+          </a:lnRef>
+          <a:fillRef idx="3">
+            <a:schemeClr val="accent1"/>
+          </a:fillRef>
+          <a:effectRef idx="2">
+            <a:schemeClr val="accent1"/>
+          </a:effectRef>
+          <a:fontRef idx="minor">
+            <a:schemeClr val="lt1"/>
+          </a:fontRef>
+        </p:style>
+        <p:txBody>
+          <a:bodyPr rtlCol="0" anchor="ctr"/>
+          <a:lstStyle/>
+          <a:p>
+            <a:pPr algn="ctr"/>
+          </a:p>
+        </p:txBody>
+      </p:sp>
+      <p:sp>
+        <p:nvSpPr>
+          <p:cNvPr id="46" name="TextBox 45"/>
+          <p:cNvSpPr txBox="1"/>
+          <p:nvPr/>
+        </p:nvSpPr>
+        <p:spPr>
+          <a:xfrm>
+            <a:off x="329184" y="5779008"/>
+            <a:ext cx="11539728" cy="310896"/>
+          </a:xfrm>
+          <a:prstGeom prst="rect">
+            <a:avLst/>
+          </a:prstGeom>
+          <a:noFill/>
+        </p:spPr>
+        <p:txBody>
+          <a:bodyPr wrap="square">
+            <a:spAutoFit/>
+          </a:bodyPr>
+          <a:lstStyle/>
+          <a:p>
+            <a:pPr algn="l">
+              <a:spcAft>
+                <a:spcPts val="300"/>
+              </a:spcAft>
+            </a:pPr>
+            <a:r>
+              <a:rPr sz="1100" b="0">
+                <a:solidFill>
+                  <a:srgbClr val="0D3B66"/>
+                </a:solidFill>
+                <a:latin typeface="Calibri"/>
+              </a:rPr>
+              <a:t>Recepción 06/11/2025  ·  Capacitación 14/11/2025  ·  Miguel Rupayan  ·  Constanza Vilches  ·  Mantención: C. Bustamante, O. Cuevas y Supervisor Eléctrico</a:t>
+            </a:r>
+          </a:p>
+        </p:txBody>
+      </p:sp>
+      <p:sp>
+        <p:nvSpPr>
+          <p:cNvPr id="47" name="TextBox 46"/>
+          <p:cNvSpPr txBox="1"/>
+          <p:nvPr/>
+        </p:nvSpPr>
+        <p:spPr>
+          <a:xfrm>
+            <a:off x="256032" y="6181344"/>
+            <a:ext cx="11704320" cy="566928"/>
+          </a:xfrm>
+          <a:prstGeom prst="rect">
+            <a:avLst/>
+          </a:prstGeom>
+          <a:noFill/>
+        </p:spPr>
+        <p:txBody>
+          <a:bodyPr wrap="square">
+            <a:spAutoFit/>
+          </a:bodyPr>
+          <a:lstStyle/>
+          <a:p>
+            <a:pPr algn="l">
+              <a:spcAft>
+                <a:spcPts val="300"/>
+              </a:spcAft>
+            </a:pPr>
+            <a:r>
+              <a:rPr sz="1200" b="0">
+                <a:solidFill>
+                  <a:srgbClr val="0D3B66"/>
+                </a:solidFill>
+                <a:latin typeface="Calibri"/>
+              </a:rPr>
+              <a:t>Mayo 7.511   ·   Junio 10.014   ·   Julio 10.356   ·   Agosto 1–17: 4.165   ·   proy. ago 7.595 m³.</a:t>
+            </a:r>
+          </a:p>
+          <a:p>
+            <a:pPr algn="l">
+              <a:spcAft>
+                <a:spcPts val="300"/>
+              </a:spcAft>
+            </a:pPr>
+            <a:r>
+              <a:rPr sz="1100" b="0">
+                <a:solidFill>
+                  <a:srgbClr val="5A5A5A"/>
+                </a:solidFill>
+                <a:latin typeface="Calibri"/>
+              </a:rPr>
+              <a:t>Junio sube por Placa (18/06). Falabella no entra en julio: activo desde el 11/08.</a:t>
             </a:r>
           </a:p>
         </p:txBody>

</xml_diff>

<commit_message>
Update recorrido PPT: single MAM slide with corrected July shares
Remove the two detailed MAM slides. Ranking shows names only; Pasillo 0,3% and ARROW <0,1% hold the leftover 1%.

Co-authored-by: anibaloperacionesWes <anibaloperacionesWes@users.noreply.github.com>
</commit_message>
<xml_diff>
--- a/reports/Parque_Arauco/TMP_7MALLS/entrega_diego_anibal/Recorrido_ejecutivo_PA_MAE_20260817.pptx
+++ b/reports/Parque_Arauco/TMP_7MALLS/entrega_diego_anibal/Recorrido_ejecutivo_PA_MAE_20260817.pptx
@@ -10,8 +10,6 @@
     <p:sldId id="258" r:id="rId9"/>
     <p:sldId id="259" r:id="rId10"/>
     <p:sldId id="260" r:id="rId11"/>
-    <p:sldId id="261" r:id="rId12"/>
-    <p:sldId id="262" r:id="rId13"/>
   </p:sldIdLst>
   <p:sldSz cx="12191695" cy="6858000" type="screen4x3"/>
   <p:notesSz cx="6858000" cy="9144000"/>
@@ -6048,7 +6046,7 @@
                 </a:solidFill>
                 <a:latin typeface="Calibri"/>
               </a:rPr>
-              <a:t>MAM  ·  1. Equipos instalados</a:t>
+              <a:t>MAM  ·  Equipos y consumo</a:t>
             </a:r>
           </a:p>
         </p:txBody>
@@ -6087,7 +6085,7 @@
                 </a:solidFill>
                 <a:latin typeface="Calibri"/>
               </a:rPr>
-              <a:t>5 puntos activos WES   |   Mall Arauco Maipú   |   Recepción 06/11/2025</a:t>
+              <a:t>Mall Arauco Maipú   |   5 puntos WES   |   01/05/2026 – 17/08/2026</a:t>
             </a:r>
           </a:p>
         </p:txBody>
@@ -6100,8 +6098,8 @@
         </p:nvSpPr>
         <p:spPr>
           <a:xfrm>
-            <a:off x="256032" y="1078992"/>
-            <a:ext cx="3749039" cy="1938528"/>
+            <a:off x="201168" y="1024128"/>
+            <a:ext cx="2286000" cy="658368"/>
           </a:xfrm>
           <a:prstGeom prst="roundRect">
             <a:avLst>
@@ -6147,8 +6145,8 @@
         </p:nvSpPr>
         <p:spPr>
           <a:xfrm>
-            <a:off x="420624" y="1207007"/>
-            <a:ext cx="3419856" cy="256032"/>
+            <a:off x="292608" y="1060704"/>
+            <a:ext cx="2121408" cy="201168"/>
           </a:xfrm>
           <a:prstGeom prst="rect">
             <a:avLst/>
@@ -6167,7 +6165,7 @@
               </a:spcAft>
             </a:pPr>
             <a:r>
-              <a:rPr sz="1200" b="1">
+              <a:rPr sz="1000" b="1">
                 <a:solidFill>
                   <a:srgbClr val="C9A227"/>
                 </a:solidFill>
@@ -6186,8 +6184,8 @@
         </p:nvSpPr>
         <p:spPr>
           <a:xfrm>
-            <a:off x="420624" y="1499616"/>
-            <a:ext cx="3419856" cy="713232"/>
+            <a:off x="292608" y="1261872"/>
+            <a:ext cx="2121408" cy="219456"/>
           </a:xfrm>
           <a:prstGeom prst="rect">
             <a:avLst/>
@@ -6206,7 +6204,7 @@
               </a:spcAft>
             </a:pPr>
             <a:r>
-              <a:rPr sz="1800" b="1">
+              <a:rPr sz="1200" b="1">
                 <a:solidFill>
                   <a:srgbClr val="0D3B66"/>
                 </a:solidFill>
@@ -6219,53 +6217,14 @@
       </p:sp>
       <p:sp>
         <p:nvSpPr>
-          <p:cNvPr id="10" name="TextBox 9"/>
-          <p:cNvSpPr txBox="1"/>
-          <p:nvPr/>
-        </p:nvSpPr>
-        <p:spPr>
-          <a:xfrm>
-            <a:off x="420624" y="2286000"/>
-            <a:ext cx="3419856" cy="530352"/>
-          </a:xfrm>
-          <a:prstGeom prst="rect">
-            <a:avLst/>
-          </a:prstGeom>
-          <a:noFill/>
-        </p:spPr>
-        <p:txBody>
-          <a:bodyPr wrap="square">
-            <a:spAutoFit/>
-          </a:bodyPr>
-          <a:lstStyle/>
-          <a:p>
-            <a:pPr algn="l">
-              <a:spcAft>
-                <a:spcPts val="300"/>
-              </a:spcAft>
-            </a:pPr>
-            <a:r>
-              <a:rPr sz="1300" b="0">
-                <a:solidFill>
-                  <a:srgbClr val="5A5A5A"/>
-                </a:solidFill>
-                <a:latin typeface="Calibri"/>
-              </a:rPr>
-              <a:t>Placa bancaria del recinto</a:t>
-            </a:r>
-          </a:p>
-        </p:txBody>
-      </p:sp>
-      <p:sp>
-        <p:nvSpPr>
-          <p:cNvPr id="11" name="Rounded Rectangle 10"/>
+          <p:cNvPr id="10" name="Rounded Rectangle 9"/>
           <p:cNvSpPr/>
           <p:nvPr/>
         </p:nvSpPr>
         <p:spPr>
           <a:xfrm>
-            <a:off x="4169663" y="1078992"/>
-            <a:ext cx="3749039" cy="1938528"/>
+            <a:off x="2578608" y="1024128"/>
+            <a:ext cx="2286000" cy="658368"/>
           </a:xfrm>
           <a:prstGeom prst="roundRect">
             <a:avLst>
@@ -6305,14 +6264,14 @@
       </p:sp>
       <p:sp>
         <p:nvSpPr>
-          <p:cNvPr id="12" name="TextBox 11"/>
+          <p:cNvPr id="11" name="TextBox 10"/>
           <p:cNvSpPr txBox="1"/>
           <p:nvPr/>
         </p:nvSpPr>
         <p:spPr>
           <a:xfrm>
-            <a:off x="4334255" y="1207007"/>
-            <a:ext cx="3419856" cy="256032"/>
+            <a:off x="2670048" y="1060704"/>
+            <a:ext cx="2121408" cy="201168"/>
           </a:xfrm>
           <a:prstGeom prst="rect">
             <a:avLst/>
@@ -6331,7 +6290,7 @@
               </a:spcAft>
             </a:pPr>
             <a:r>
-              <a:rPr sz="1200" b="1">
+              <a:rPr sz="1000" b="1">
                 <a:solidFill>
                   <a:srgbClr val="C9A227"/>
                 </a:solidFill>
@@ -6344,14 +6303,14 @@
       </p:sp>
       <p:sp>
         <p:nvSpPr>
-          <p:cNvPr id="13" name="TextBox 12"/>
+          <p:cNvPr id="12" name="TextBox 11"/>
           <p:cNvSpPr txBox="1"/>
           <p:nvPr/>
         </p:nvSpPr>
         <p:spPr>
           <a:xfrm>
-            <a:off x="4334255" y="1499616"/>
-            <a:ext cx="3419856" cy="713232"/>
+            <a:off x="2670048" y="1261872"/>
+            <a:ext cx="2121408" cy="219456"/>
           </a:xfrm>
           <a:prstGeom prst="rect">
             <a:avLst/>
@@ -6370,14 +6329,61 @@
               </a:spcAft>
             </a:pPr>
             <a:r>
-              <a:rPr sz="1800" b="1">
+              <a:rPr sz="1200" b="1">
                 <a:solidFill>
                   <a:srgbClr val="0D3B66"/>
                 </a:solidFill>
                 <a:latin typeface="Calibri"/>
               </a:rPr>
-              <a:t>Impulsión Ripley</a:t>
-            </a:r>
+              <a:t>Ripley</a:t>
+            </a:r>
+          </a:p>
+        </p:txBody>
+      </p:sp>
+      <p:sp>
+        <p:nvSpPr>
+          <p:cNvPr id="13" name="Rounded Rectangle 12"/>
+          <p:cNvSpPr/>
+          <p:nvPr/>
+        </p:nvSpPr>
+        <p:spPr>
+          <a:xfrm>
+            <a:off x="4956048" y="1024128"/>
+            <a:ext cx="2286000" cy="658368"/>
+          </a:xfrm>
+          <a:prstGeom prst="roundRect">
+            <a:avLst>
+              <a:gd name="adj" fmla="val 8000"/>
+            </a:avLst>
+          </a:prstGeom>
+          <a:solidFill>
+            <a:srgbClr val="F5F7FA"/>
+          </a:solidFill>
+          <a:ln w="6350">
+            <a:solidFill>
+              <a:srgbClr val="C9A227"/>
+            </a:solidFill>
+          </a:ln>
+        </p:spPr>
+        <p:style>
+          <a:lnRef idx="1">
+            <a:schemeClr val="accent1"/>
+          </a:lnRef>
+          <a:fillRef idx="3">
+            <a:schemeClr val="accent1"/>
+          </a:fillRef>
+          <a:effectRef idx="2">
+            <a:schemeClr val="accent1"/>
+          </a:effectRef>
+          <a:fontRef idx="minor">
+            <a:schemeClr val="lt1"/>
+          </a:fontRef>
+        </p:style>
+        <p:txBody>
+          <a:bodyPr rtlCol="0" anchor="ctr"/>
+          <a:lstStyle/>
+          <a:p>
+            <a:pPr algn="ctr"/>
           </a:p>
         </p:txBody>
       </p:sp>
@@ -6389,8 +6395,8 @@
         </p:nvSpPr>
         <p:spPr>
           <a:xfrm>
-            <a:off x="4334255" y="2286000"/>
-            <a:ext cx="3419856" cy="530352"/>
+            <a:off x="5047488" y="1060704"/>
+            <a:ext cx="2121408" cy="201168"/>
           </a:xfrm>
           <a:prstGeom prst="rect">
             <a:avLst/>
@@ -6409,27 +6415,105 @@
               </a:spcAft>
             </a:pPr>
             <a:r>
-              <a:rPr sz="1300" b="0">
-                <a:solidFill>
-                  <a:srgbClr val="5A5A5A"/>
+              <a:rPr sz="1000" b="1">
+                <a:solidFill>
+                  <a:srgbClr val="C9A227"/>
                 </a:solidFill>
                 <a:latin typeface="Calibri"/>
               </a:rPr>
-              <a:t>Impulsión Ripley</a:t>
-            </a:r>
-          </a:p>
-        </p:txBody>
-      </p:sp>
-      <p:sp>
-        <p:nvSpPr>
-          <p:cNvPr id="15" name="Rounded Rectangle 14"/>
+              <a:t>000025-09</a:t>
+            </a:r>
+          </a:p>
+        </p:txBody>
+      </p:sp>
+      <p:sp>
+        <p:nvSpPr>
+          <p:cNvPr id="15" name="TextBox 14"/>
+          <p:cNvSpPr txBox="1"/>
+          <p:nvPr/>
+        </p:nvSpPr>
+        <p:spPr>
+          <a:xfrm>
+            <a:off x="5047488" y="1261872"/>
+            <a:ext cx="2121408" cy="219456"/>
+          </a:xfrm>
+          <a:prstGeom prst="rect">
+            <a:avLst/>
+          </a:prstGeom>
+          <a:noFill/>
+        </p:spPr>
+        <p:txBody>
+          <a:bodyPr wrap="square">
+            <a:spAutoFit/>
+          </a:bodyPr>
+          <a:lstStyle/>
+          <a:p>
+            <a:pPr algn="l">
+              <a:spcAft>
+                <a:spcPts val="300"/>
+              </a:spcAft>
+            </a:pPr>
+            <a:r>
+              <a:rPr sz="1200" b="1">
+                <a:solidFill>
+                  <a:srgbClr val="0D3B66"/>
+                </a:solidFill>
+                <a:latin typeface="Calibri"/>
+              </a:rPr>
+              <a:t>Falabella</a:t>
+            </a:r>
+          </a:p>
+        </p:txBody>
+      </p:sp>
+      <p:sp>
+        <p:nvSpPr>
+          <p:cNvPr id="16" name="TextBox 15"/>
+          <p:cNvSpPr txBox="1"/>
+          <p:nvPr/>
+        </p:nvSpPr>
+        <p:spPr>
+          <a:xfrm>
+            <a:off x="5047488" y="1463040"/>
+            <a:ext cx="2121408" cy="182880"/>
+          </a:xfrm>
+          <a:prstGeom prst="rect">
+            <a:avLst/>
+          </a:prstGeom>
+          <a:noFill/>
+        </p:spPr>
+        <p:txBody>
+          <a:bodyPr wrap="square">
+            <a:spAutoFit/>
+          </a:bodyPr>
+          <a:lstStyle/>
+          <a:p>
+            <a:pPr algn="l">
+              <a:spcAft>
+                <a:spcPts val="300"/>
+              </a:spcAft>
+            </a:pPr>
+            <a:r>
+              <a:rPr sz="1000" b="0">
+                <a:solidFill>
+                  <a:srgbClr val="5A5A5A"/>
+                </a:solidFill>
+                <a:latin typeface="Calibri"/>
+              </a:rPr>
+              <a:t>activo 11/08</a:t>
+            </a:r>
+          </a:p>
+        </p:txBody>
+      </p:sp>
+      <p:sp>
+        <p:nvSpPr>
+          <p:cNvPr id="17" name="Rounded Rectangle 16"/>
           <p:cNvSpPr/>
           <p:nvPr/>
         </p:nvSpPr>
         <p:spPr>
           <a:xfrm>
-            <a:off x="8083296" y="1078992"/>
-            <a:ext cx="3749039" cy="1938528"/>
+            <a:off x="7333488" y="1024128"/>
+            <a:ext cx="2286000" cy="658368"/>
           </a:xfrm>
           <a:prstGeom prst="roundRect">
             <a:avLst>
@@ -6469,14 +6553,14 @@
       </p:sp>
       <p:sp>
         <p:nvSpPr>
-          <p:cNvPr id="16" name="TextBox 15"/>
+          <p:cNvPr id="18" name="TextBox 17"/>
           <p:cNvSpPr txBox="1"/>
           <p:nvPr/>
         </p:nvSpPr>
         <p:spPr>
           <a:xfrm>
-            <a:off x="8247888" y="1207007"/>
-            <a:ext cx="3419856" cy="256032"/>
+            <a:off x="7424928" y="1060704"/>
+            <a:ext cx="2121408" cy="201168"/>
           </a:xfrm>
           <a:prstGeom prst="rect">
             <a:avLst/>
@@ -6495,27 +6579,27 @@
               </a:spcAft>
             </a:pPr>
             <a:r>
-              <a:rPr sz="1200" b="1">
+              <a:rPr sz="1000" b="1">
                 <a:solidFill>
                   <a:srgbClr val="C9A227"/>
                 </a:solidFill>
                 <a:latin typeface="Calibri"/>
               </a:rPr>
-              <a:t>000025-09</a:t>
-            </a:r>
-          </a:p>
-        </p:txBody>
-      </p:sp>
-      <p:sp>
-        <p:nvSpPr>
-          <p:cNvPr id="17" name="TextBox 16"/>
+              <a:t>000025-32</a:t>
+            </a:r>
+          </a:p>
+        </p:txBody>
+      </p:sp>
+      <p:sp>
+        <p:nvSpPr>
+          <p:cNvPr id="19" name="TextBox 18"/>
           <p:cNvSpPr txBox="1"/>
           <p:nvPr/>
         </p:nvSpPr>
         <p:spPr>
           <a:xfrm>
-            <a:off x="8247888" y="1499616"/>
-            <a:ext cx="3419856" cy="713232"/>
+            <a:off x="7424928" y="1261872"/>
+            <a:ext cx="2121408" cy="219456"/>
           </a:xfrm>
           <a:prstGeom prst="rect">
             <a:avLst/>
@@ -6534,27 +6618,27 @@
               </a:spcAft>
             </a:pPr>
             <a:r>
-              <a:rPr sz="1800" b="1">
+              <a:rPr sz="1200" b="1">
                 <a:solidFill>
                   <a:srgbClr val="0D3B66"/>
                 </a:solidFill>
                 <a:latin typeface="Calibri"/>
               </a:rPr>
-              <a:t>Impulsión Falabella</a:t>
-            </a:r>
-          </a:p>
-        </p:txBody>
-      </p:sp>
-      <p:sp>
-        <p:nvSpPr>
-          <p:cNvPr id="18" name="TextBox 17"/>
+              <a:t>Pasillo Técnico</a:t>
+            </a:r>
+          </a:p>
+        </p:txBody>
+      </p:sp>
+      <p:sp>
+        <p:nvSpPr>
+          <p:cNvPr id="20" name="TextBox 19"/>
           <p:cNvSpPr txBox="1"/>
           <p:nvPr/>
         </p:nvSpPr>
         <p:spPr>
           <a:xfrm>
-            <a:off x="8247888" y="2286000"/>
-            <a:ext cx="3419856" cy="530352"/>
+            <a:off x="7424928" y="1463040"/>
+            <a:ext cx="2121408" cy="182880"/>
           </a:xfrm>
           <a:prstGeom prst="rect">
             <a:avLst/>
@@ -6573,27 +6657,27 @@
               </a:spcAft>
             </a:pPr>
             <a:r>
-              <a:rPr sz="1300" b="0">
+              <a:rPr sz="1000" b="0">
                 <a:solidFill>
                   <a:srgbClr val="5A5A5A"/>
                 </a:solidFill>
                 <a:latin typeface="Calibri"/>
               </a:rPr>
-              <a:t>Activo desde 11/08/2026 (OC / cambio de equipo)</a:t>
-            </a:r>
-          </a:p>
-        </p:txBody>
-      </p:sp>
-      <p:sp>
-        <p:nvSpPr>
-          <p:cNvPr id="19" name="Rounded Rectangle 18"/>
+              <a:t>residual</a:t>
+            </a:r>
+          </a:p>
+        </p:txBody>
+      </p:sp>
+      <p:sp>
+        <p:nvSpPr>
+          <p:cNvPr id="21" name="Rounded Rectangle 20"/>
           <p:cNvSpPr/>
           <p:nvPr/>
         </p:nvSpPr>
         <p:spPr>
           <a:xfrm>
-            <a:off x="256032" y="3182112"/>
-            <a:ext cx="5742432" cy="1938528"/>
+            <a:off x="9710928" y="1024128"/>
+            <a:ext cx="2286000" cy="658368"/>
           </a:xfrm>
           <a:prstGeom prst="roundRect">
             <a:avLst>
@@ -6633,14 +6717,14 @@
       </p:sp>
       <p:sp>
         <p:nvSpPr>
-          <p:cNvPr id="20" name="TextBox 19"/>
+          <p:cNvPr id="22" name="TextBox 21"/>
           <p:cNvSpPr txBox="1"/>
           <p:nvPr/>
         </p:nvSpPr>
         <p:spPr>
           <a:xfrm>
-            <a:off x="420624" y="3310128"/>
-            <a:ext cx="5413248" cy="256032"/>
+            <a:off x="9802368" y="1060704"/>
+            <a:ext cx="2121408" cy="201168"/>
           </a:xfrm>
           <a:prstGeom prst="rect">
             <a:avLst/>
@@ -6659,27 +6743,27 @@
               </a:spcAft>
             </a:pPr>
             <a:r>
-              <a:rPr sz="1200" b="1">
+              <a:rPr sz="1000" b="1">
                 <a:solidFill>
                   <a:srgbClr val="C9A227"/>
                 </a:solidFill>
                 <a:latin typeface="Calibri"/>
               </a:rPr>
-              <a:t>000025-32</a:t>
-            </a:r>
-          </a:p>
-        </p:txBody>
-      </p:sp>
-      <p:sp>
-        <p:nvSpPr>
-          <p:cNvPr id="21" name="TextBox 20"/>
+              <a:t>000025-33</a:t>
+            </a:r>
+          </a:p>
+        </p:txBody>
+      </p:sp>
+      <p:sp>
+        <p:nvSpPr>
+          <p:cNvPr id="23" name="TextBox 22"/>
           <p:cNvSpPr txBox="1"/>
           <p:nvPr/>
         </p:nvSpPr>
         <p:spPr>
           <a:xfrm>
-            <a:off x="420624" y="3602736"/>
-            <a:ext cx="5413248" cy="713232"/>
+            <a:off x="9802368" y="1261872"/>
+            <a:ext cx="2121408" cy="219456"/>
           </a:xfrm>
           <a:prstGeom prst="rect">
             <a:avLst/>
@@ -6698,27 +6782,27 @@
               </a:spcAft>
             </a:pPr>
             <a:r>
-              <a:rPr sz="1800" b="1">
+              <a:rPr sz="1200" b="1">
                 <a:solidFill>
                   <a:srgbClr val="0D3B66"/>
                 </a:solidFill>
                 <a:latin typeface="Calibri"/>
               </a:rPr>
-              <a:t>Matriz Pasillo Técnico Boulevard</a:t>
-            </a:r>
-          </a:p>
-        </p:txBody>
-      </p:sp>
-      <p:sp>
-        <p:nvSpPr>
-          <p:cNvPr id="22" name="TextBox 21"/>
+              <a:t>Salida ARROW</a:t>
+            </a:r>
+          </a:p>
+        </p:txBody>
+      </p:sp>
+      <p:sp>
+        <p:nvSpPr>
+          <p:cNvPr id="24" name="TextBox 23"/>
           <p:cNvSpPr txBox="1"/>
           <p:nvPr/>
         </p:nvSpPr>
         <p:spPr>
           <a:xfrm>
-            <a:off x="420624" y="4389120"/>
-            <a:ext cx="5413248" cy="530352"/>
+            <a:off x="9802368" y="1463040"/>
+            <a:ext cx="2121408" cy="182880"/>
           </a:xfrm>
           <a:prstGeom prst="rect">
             <a:avLst/>
@@ -6737,27 +6821,346 @@
               </a:spcAft>
             </a:pPr>
             <a:r>
-              <a:rPr sz="1300" b="0">
+              <a:rPr sz="1000" b="0">
                 <a:solidFill>
                   <a:srgbClr val="5A5A5A"/>
                 </a:solidFill>
                 <a:latin typeface="Calibri"/>
               </a:rPr>
-              <a:t>Matriz pasillo técnico Boulevard</a:t>
-            </a:r>
-          </a:p>
-        </p:txBody>
-      </p:sp>
-      <p:sp>
-        <p:nvSpPr>
-          <p:cNvPr id="23" name="Rounded Rectangle 22"/>
+              <a:t>residual</a:t>
+            </a:r>
+          </a:p>
+        </p:txBody>
+      </p:sp>
+      <p:sp>
+        <p:nvSpPr>
+          <p:cNvPr id="25" name="Rounded Rectangle 24"/>
           <p:cNvSpPr/>
           <p:nvPr/>
         </p:nvSpPr>
         <p:spPr>
           <a:xfrm>
-            <a:off x="6199632" y="3182112"/>
-            <a:ext cx="5742432" cy="1938528"/>
+            <a:off x="201168" y="1792224"/>
+            <a:ext cx="7973568" cy="3822191"/>
+          </a:xfrm>
+          <a:prstGeom prst="roundRect">
+            <a:avLst>
+              <a:gd name="adj" fmla="val 8000"/>
+            </a:avLst>
+          </a:prstGeom>
+          <a:solidFill>
+            <a:srgbClr val="F5F7FA"/>
+          </a:solidFill>
+          <a:ln>
+            <a:noFill/>
+          </a:ln>
+        </p:spPr>
+        <p:style>
+          <a:lnRef idx="1">
+            <a:schemeClr val="accent1"/>
+          </a:lnRef>
+          <a:fillRef idx="3">
+            <a:schemeClr val="accent1"/>
+          </a:fillRef>
+          <a:effectRef idx="2">
+            <a:schemeClr val="accent1"/>
+          </a:effectRef>
+          <a:fontRef idx="minor">
+            <a:schemeClr val="lt1"/>
+          </a:fontRef>
+        </p:style>
+        <p:txBody>
+          <a:bodyPr rtlCol="0" anchor="ctr"/>
+          <a:lstStyle/>
+          <a:p>
+            <a:pPr algn="ctr"/>
+          </a:p>
+        </p:txBody>
+      </p:sp>
+      <p:pic>
+        <p:nvPicPr>
+          <p:cNvPr id="26" name="Picture 25" descr="mam_mensual_may_ago.png"/>
+          <p:cNvPicPr>
+            <a:picLocks noChangeAspect="1"/>
+          </p:cNvPicPr>
+          <p:nvPr/>
+        </p:nvPicPr>
+        <p:blipFill>
+          <a:blip r:embed="rId3"/>
+          <a:stretch>
+            <a:fillRect/>
+          </a:stretch>
+        </p:blipFill>
+        <p:spPr>
+          <a:xfrm>
+            <a:off x="329184" y="1865376"/>
+            <a:ext cx="7717536" cy="3777531"/>
+          </a:xfrm>
+          <a:prstGeom prst="rect">
+            <a:avLst/>
+          </a:prstGeom>
+        </p:spPr>
+      </p:pic>
+      <p:sp>
+        <p:nvSpPr>
+          <p:cNvPr id="27" name="Rounded Rectangle 26"/>
+          <p:cNvSpPr/>
+          <p:nvPr/>
+        </p:nvSpPr>
+        <p:spPr>
+          <a:xfrm>
+            <a:off x="8302752" y="1792224"/>
+            <a:ext cx="3675887" cy="3822191"/>
+          </a:xfrm>
+          <a:prstGeom prst="roundRect">
+            <a:avLst>
+              <a:gd name="adj" fmla="val 8000"/>
+            </a:avLst>
+          </a:prstGeom>
+          <a:solidFill>
+            <a:srgbClr val="FFFFFF"/>
+          </a:solidFill>
+          <a:ln w="6350">
+            <a:solidFill>
+              <a:srgbClr val="1F77B4"/>
+            </a:solidFill>
+          </a:ln>
+        </p:spPr>
+        <p:style>
+          <a:lnRef idx="1">
+            <a:schemeClr val="accent1"/>
+          </a:lnRef>
+          <a:fillRef idx="3">
+            <a:schemeClr val="accent1"/>
+          </a:fillRef>
+          <a:effectRef idx="2">
+            <a:schemeClr val="accent1"/>
+          </a:effectRef>
+          <a:fontRef idx="minor">
+            <a:schemeClr val="lt1"/>
+          </a:fontRef>
+        </p:style>
+        <p:txBody>
+          <a:bodyPr rtlCol="0" anchor="ctr"/>
+          <a:lstStyle/>
+          <a:p>
+            <a:pPr algn="ctr"/>
+          </a:p>
+        </p:txBody>
+      </p:sp>
+      <p:sp>
+        <p:nvSpPr>
+          <p:cNvPr id="28" name="TextBox 27"/>
+          <p:cNvSpPr txBox="1"/>
+          <p:nvPr/>
+        </p:nvSpPr>
+        <p:spPr>
+          <a:xfrm>
+            <a:off x="8430768" y="1847088"/>
+            <a:ext cx="3419856" cy="201168"/>
+          </a:xfrm>
+          <a:prstGeom prst="rect">
+            <a:avLst/>
+          </a:prstGeom>
+          <a:noFill/>
+        </p:spPr>
+        <p:txBody>
+          <a:bodyPr wrap="square">
+            <a:spAutoFit/>
+          </a:bodyPr>
+          <a:lstStyle/>
+          <a:p>
+            <a:pPr algn="l">
+              <a:spcAft>
+                <a:spcPts val="300"/>
+              </a:spcAft>
+            </a:pPr>
+            <a:r>
+              <a:rPr sz="1100" b="1">
+                <a:solidFill>
+                  <a:srgbClr val="1F77B4"/>
+                </a:solidFill>
+                <a:latin typeface="Calibri"/>
+              </a:rPr>
+              <a:t>JULIO · último mes cerrado</a:t>
+            </a:r>
+          </a:p>
+        </p:txBody>
+      </p:sp>
+      <p:sp>
+        <p:nvSpPr>
+          <p:cNvPr id="29" name="TextBox 28"/>
+          <p:cNvSpPr txBox="1"/>
+          <p:nvPr/>
+        </p:nvSpPr>
+        <p:spPr>
+          <a:xfrm>
+            <a:off x="8430768" y="2048256"/>
+            <a:ext cx="3419856" cy="256032"/>
+          </a:xfrm>
+          <a:prstGeom prst="rect">
+            <a:avLst/>
+          </a:prstGeom>
+          <a:noFill/>
+        </p:spPr>
+        <p:txBody>
+          <a:bodyPr wrap="square">
+            <a:spAutoFit/>
+          </a:bodyPr>
+          <a:lstStyle/>
+          <a:p>
+            <a:pPr algn="l">
+              <a:spcAft>
+                <a:spcPts val="300"/>
+              </a:spcAft>
+            </a:pPr>
+            <a:r>
+              <a:rPr sz="1200" b="0">
+                <a:solidFill>
+                  <a:srgbClr val="5A5A5A"/>
+                </a:solidFill>
+                <a:latin typeface="Calibri"/>
+              </a:rPr>
+              <a:t>El recinto sumó 10.356 m³</a:t>
+            </a:r>
+          </a:p>
+        </p:txBody>
+      </p:sp>
+      <p:sp>
+        <p:nvSpPr>
+          <p:cNvPr id="30" name="Rounded Rectangle 29"/>
+          <p:cNvSpPr/>
+          <p:nvPr/>
+        </p:nvSpPr>
+        <p:spPr>
+          <a:xfrm>
+            <a:off x="8430768" y="2359152"/>
+            <a:ext cx="3419856" cy="603504"/>
+          </a:xfrm>
+          <a:prstGeom prst="roundRect">
+            <a:avLst>
+              <a:gd name="adj" fmla="val 8000"/>
+            </a:avLst>
+          </a:prstGeom>
+          <a:solidFill>
+            <a:srgbClr val="F5F7FA"/>
+          </a:solidFill>
+          <a:ln w="6350">
+            <a:solidFill>
+              <a:srgbClr val="0D3B66"/>
+            </a:solidFill>
+          </a:ln>
+        </p:spPr>
+        <p:style>
+          <a:lnRef idx="1">
+            <a:schemeClr val="accent1"/>
+          </a:lnRef>
+          <a:fillRef idx="3">
+            <a:schemeClr val="accent1"/>
+          </a:fillRef>
+          <a:effectRef idx="2">
+            <a:schemeClr val="accent1"/>
+          </a:effectRef>
+          <a:fontRef idx="minor">
+            <a:schemeClr val="lt1"/>
+          </a:fontRef>
+        </p:style>
+        <p:txBody>
+          <a:bodyPr rtlCol="0" anchor="ctr"/>
+          <a:lstStyle/>
+          <a:p>
+            <a:pPr algn="ctr"/>
+          </a:p>
+        </p:txBody>
+      </p:sp>
+      <p:sp>
+        <p:nvSpPr>
+          <p:cNvPr id="31" name="TextBox 30"/>
+          <p:cNvSpPr txBox="1"/>
+          <p:nvPr/>
+        </p:nvSpPr>
+        <p:spPr>
+          <a:xfrm>
+            <a:off x="8540496" y="2395728"/>
+            <a:ext cx="3200400" cy="182880"/>
+          </a:xfrm>
+          <a:prstGeom prst="rect">
+            <a:avLst/>
+          </a:prstGeom>
+          <a:noFill/>
+        </p:spPr>
+        <p:txBody>
+          <a:bodyPr wrap="square">
+            <a:spAutoFit/>
+          </a:bodyPr>
+          <a:lstStyle/>
+          <a:p>
+            <a:pPr algn="l">
+              <a:spcAft>
+                <a:spcPts val="300"/>
+              </a:spcAft>
+            </a:pPr>
+            <a:r>
+              <a:rPr sz="1300" b="1">
+                <a:solidFill>
+                  <a:srgbClr val="0D3B66"/>
+                </a:solidFill>
+                <a:latin typeface="Calibri"/>
+              </a:rPr>
+              <a:t>Placa Bancaria</a:t>
+            </a:r>
+          </a:p>
+        </p:txBody>
+      </p:sp>
+      <p:sp>
+        <p:nvSpPr>
+          <p:cNvPr id="32" name="TextBox 31"/>
+          <p:cNvSpPr txBox="1"/>
+          <p:nvPr/>
+        </p:nvSpPr>
+        <p:spPr>
+          <a:xfrm>
+            <a:off x="8540496" y="2615184"/>
+            <a:ext cx="3200400" cy="274320"/>
+          </a:xfrm>
+          <a:prstGeom prst="rect">
+            <a:avLst/>
+          </a:prstGeom>
+          <a:noFill/>
+        </p:spPr>
+        <p:txBody>
+          <a:bodyPr wrap="square">
+            <a:spAutoFit/>
+          </a:bodyPr>
+          <a:lstStyle/>
+          <a:p>
+            <a:pPr algn="l">
+              <a:spcAft>
+                <a:spcPts val="300"/>
+              </a:spcAft>
+            </a:pPr>
+            <a:r>
+              <a:rPr sz="1500" b="1">
+                <a:solidFill>
+                  <a:srgbClr val="0D3B66"/>
+                </a:solidFill>
+                <a:latin typeface="Calibri"/>
+              </a:rPr>
+              <a:t>7.084 m³    68 %</a:t>
+            </a:r>
+          </a:p>
+        </p:txBody>
+      </p:sp>
+      <p:sp>
+        <p:nvSpPr>
+          <p:cNvPr id="33" name="Rounded Rectangle 32"/>
+          <p:cNvSpPr/>
+          <p:nvPr/>
+        </p:nvSpPr>
+        <p:spPr>
+          <a:xfrm>
+            <a:off x="8430768" y="2999232"/>
+            <a:ext cx="3419856" cy="603504"/>
           </a:xfrm>
           <a:prstGeom prst="roundRect">
             <a:avLst>
@@ -6797,14 +7200,14 @@
       </p:sp>
       <p:sp>
         <p:nvSpPr>
-          <p:cNvPr id="24" name="TextBox 23"/>
+          <p:cNvPr id="34" name="TextBox 33"/>
           <p:cNvSpPr txBox="1"/>
           <p:nvPr/>
         </p:nvSpPr>
         <p:spPr>
           <a:xfrm>
-            <a:off x="6364224" y="3310128"/>
-            <a:ext cx="5413248" cy="256032"/>
+            <a:off x="8540496" y="3035808"/>
+            <a:ext cx="3200400" cy="182880"/>
           </a:xfrm>
           <a:prstGeom prst="rect">
             <a:avLst/>
@@ -6823,27 +7226,27 @@
               </a:spcAft>
             </a:pPr>
             <a:r>
-              <a:rPr sz="1200" b="1">
-                <a:solidFill>
-                  <a:srgbClr val="C9A227"/>
+              <a:rPr sz="1300" b="1">
+                <a:solidFill>
+                  <a:srgbClr val="1F77B4"/>
                 </a:solidFill>
                 <a:latin typeface="Calibri"/>
               </a:rPr>
-              <a:t>000025-33</a:t>
-            </a:r>
-          </a:p>
-        </p:txBody>
-      </p:sp>
-      <p:sp>
-        <p:nvSpPr>
-          <p:cNvPr id="25" name="TextBox 24"/>
+              <a:t>Ripley</a:t>
+            </a:r>
+          </a:p>
+        </p:txBody>
+      </p:sp>
+      <p:sp>
+        <p:nvSpPr>
+          <p:cNvPr id="35" name="TextBox 34"/>
           <p:cNvSpPr txBox="1"/>
           <p:nvPr/>
         </p:nvSpPr>
         <p:spPr>
           <a:xfrm>
-            <a:off x="6364224" y="3602736"/>
-            <a:ext cx="5413248" cy="713232"/>
+            <a:off x="8540496" y="3255264"/>
+            <a:ext cx="3200400" cy="274320"/>
           </a:xfrm>
           <a:prstGeom prst="rect">
             <a:avLst/>
@@ -6862,821 +7265,7 @@
               </a:spcAft>
             </a:pPr>
             <a:r>
-              <a:rPr sz="1800" b="1">
-                <a:solidFill>
-                  <a:srgbClr val="0D3B66"/>
-                </a:solidFill>
-                <a:latin typeface="Calibri"/>
-              </a:rPr>
-              <a:t>Salida de emergencia pasillo 1 ARROW</a:t>
-            </a:r>
-          </a:p>
-        </p:txBody>
-      </p:sp>
-      <p:sp>
-        <p:nvSpPr>
-          <p:cNvPr id="26" name="TextBox 25"/>
-          <p:cNvSpPr txBox="1"/>
-          <p:nvPr/>
-        </p:nvSpPr>
-        <p:spPr>
-          <a:xfrm>
-            <a:off x="6364224" y="4389120"/>
-            <a:ext cx="5413248" cy="530352"/>
-          </a:xfrm>
-          <a:prstGeom prst="rect">
-            <a:avLst/>
-          </a:prstGeom>
-          <a:noFill/>
-        </p:spPr>
-        <p:txBody>
-          <a:bodyPr wrap="square">
-            <a:spAutoFit/>
-          </a:bodyPr>
-          <a:lstStyle/>
-          <a:p>
-            <a:pPr algn="l">
-              <a:spcAft>
-                <a:spcPts val="300"/>
-              </a:spcAft>
-            </a:pPr>
-            <a:r>
-              <a:rPr sz="1300" b="0">
-                <a:solidFill>
-                  <a:srgbClr val="5A5A5A"/>
-                </a:solidFill>
-                <a:latin typeface="Calibri"/>
-              </a:rPr>
-              <a:t>Salida de emergencia pasillo 1 ARROW</a:t>
-            </a:r>
-          </a:p>
-        </p:txBody>
-      </p:sp>
-      <p:sp>
-        <p:nvSpPr>
-          <p:cNvPr id="27" name="Rounded Rectangle 26"/>
-          <p:cNvSpPr/>
-          <p:nvPr/>
-        </p:nvSpPr>
-        <p:spPr>
-          <a:xfrm>
-            <a:off x="256032" y="5394960"/>
-            <a:ext cx="11686032" cy="1170432"/>
-          </a:xfrm>
-          <a:prstGeom prst="roundRect">
-            <a:avLst>
-              <a:gd name="adj" fmla="val 8000"/>
-            </a:avLst>
-          </a:prstGeom>
-          <a:solidFill>
-            <a:srgbClr val="FFF9EB"/>
-          </a:solidFill>
-          <a:ln w="6350">
-            <a:solidFill>
-              <a:srgbClr val="C9A227"/>
-            </a:solidFill>
-          </a:ln>
-        </p:spPr>
-        <p:style>
-          <a:lnRef idx="1">
-            <a:schemeClr val="accent1"/>
-          </a:lnRef>
-          <a:fillRef idx="3">
-            <a:schemeClr val="accent1"/>
-          </a:fillRef>
-          <a:effectRef idx="2">
-            <a:schemeClr val="accent1"/>
-          </a:effectRef>
-          <a:fontRef idx="minor">
-            <a:schemeClr val="lt1"/>
-          </a:fontRef>
-        </p:style>
-        <p:txBody>
-          <a:bodyPr rtlCol="0" anchor="ctr"/>
-          <a:lstStyle/>
-          <a:p>
-            <a:pPr algn="ctr"/>
-          </a:p>
-        </p:txBody>
-      </p:sp>
-      <p:sp>
-        <p:nvSpPr>
-          <p:cNvPr id="28" name="TextBox 27"/>
-          <p:cNvSpPr txBox="1"/>
-          <p:nvPr/>
-        </p:nvSpPr>
-        <p:spPr>
-          <a:xfrm>
-            <a:off x="438912" y="5504688"/>
-            <a:ext cx="11338560" cy="256032"/>
-          </a:xfrm>
-          <a:prstGeom prst="rect">
-            <a:avLst/>
-          </a:prstGeom>
-          <a:noFill/>
-        </p:spPr>
-        <p:txBody>
-          <a:bodyPr wrap="square">
-            <a:spAutoFit/>
-          </a:bodyPr>
-          <a:lstStyle/>
-          <a:p>
-            <a:pPr algn="l">
-              <a:spcAft>
-                <a:spcPts val="300"/>
-              </a:spcAft>
-            </a:pPr>
-            <a:r>
-              <a:rPr sz="1100" b="1">
-                <a:solidFill>
-                  <a:srgbClr val="C9A227"/>
-                </a:solidFill>
-                <a:latin typeface="Calibri"/>
-              </a:rPr>
-              <a:t>RECINTO</a:t>
-            </a:r>
-          </a:p>
-        </p:txBody>
-      </p:sp>
-      <p:sp>
-        <p:nvSpPr>
-          <p:cNvPr id="29" name="TextBox 28"/>
-          <p:cNvSpPr txBox="1"/>
-          <p:nvPr/>
-        </p:nvSpPr>
-        <p:spPr>
-          <a:xfrm>
-            <a:off x="438912" y="5779008"/>
-            <a:ext cx="11338560" cy="658368"/>
-          </a:xfrm>
-          <a:prstGeom prst="rect">
-            <a:avLst/>
-          </a:prstGeom>
-          <a:noFill/>
-        </p:spPr>
-        <p:txBody>
-          <a:bodyPr wrap="square">
-            <a:spAutoFit/>
-          </a:bodyPr>
-          <a:lstStyle/>
-          <a:p>
-            <a:pPr algn="l">
-              <a:spcAft>
-                <a:spcPts val="300"/>
-              </a:spcAft>
-            </a:pPr>
-            <a:r>
-              <a:rPr sz="1300" b="0">
-                <a:solidFill>
-                  <a:srgbClr val="0D3B66"/>
-                </a:solidFill>
-                <a:latin typeface="Calibri"/>
-              </a:rPr>
-              <a:t>Recepción 06/11/2025  ·  Capacitación 14/11/2025  ·  Usuarios: Miguel Rupayan — Encargado de Operaciones  ·  Constanza Vilches — Analista Ambiental  ·  Equipo Mantención: C. Bustamante, O. Cuevas y Supervisor Eléctrico</a:t>
-            </a:r>
-          </a:p>
-        </p:txBody>
-      </p:sp>
-    </p:spTree>
-  </p:cSld>
-  <p:clrMapOvr>
-    <a:masterClrMapping/>
-  </p:clrMapOvr>
-</p:sld>
-</file>
-
-<file path=ppt/slides/slide6.xml><?xml version="1.0" encoding="utf-8"?>
-<p:sld xmlns:a="http://schemas.openxmlformats.org/drawingml/2006/main" xmlns:p="http://schemas.openxmlformats.org/presentationml/2006/main" xmlns:r="http://schemas.openxmlformats.org/officeDocument/2006/relationships">
-  <p:cSld>
-    <p:spTree>
-      <p:nvGrpSpPr>
-        <p:cNvPr id="1" name=""/>
-        <p:cNvGrpSpPr/>
-        <p:nvPr/>
-      </p:nvGrpSpPr>
-      <p:grpSpPr/>
-      <p:sp>
-        <p:nvSpPr>
-          <p:cNvPr id="2" name="Rectangle 1"/>
-          <p:cNvSpPr/>
-          <p:nvPr/>
-        </p:nvSpPr>
-        <p:spPr>
-          <a:xfrm>
-            <a:off x="0" y="0"/>
-            <a:ext cx="12191695" cy="841248"/>
-          </a:xfrm>
-          <a:prstGeom prst="rect">
-            <a:avLst/>
-          </a:prstGeom>
-          <a:solidFill>
-            <a:srgbClr val="0D3B66"/>
-          </a:solidFill>
-          <a:ln>
-            <a:noFill/>
-          </a:ln>
-        </p:spPr>
-        <p:style>
-          <a:lnRef idx="1">
-            <a:schemeClr val="accent1"/>
-          </a:lnRef>
-          <a:fillRef idx="3">
-            <a:schemeClr val="accent1"/>
-          </a:fillRef>
-          <a:effectRef idx="2">
-            <a:schemeClr val="accent1"/>
-          </a:effectRef>
-          <a:fontRef idx="minor">
-            <a:schemeClr val="lt1"/>
-          </a:fontRef>
-        </p:style>
-        <p:txBody>
-          <a:bodyPr rtlCol="0" anchor="ctr"/>
-          <a:lstStyle/>
-          <a:p>
-            <a:pPr algn="ctr"/>
-          </a:p>
-        </p:txBody>
-      </p:sp>
-      <p:sp>
-        <p:nvSpPr>
-          <p:cNvPr id="3" name="Rectangle 2"/>
-          <p:cNvSpPr/>
-          <p:nvPr/>
-        </p:nvSpPr>
-        <p:spPr>
-          <a:xfrm>
-            <a:off x="0" y="841248"/>
-            <a:ext cx="12191695" cy="54864"/>
-          </a:xfrm>
-          <a:prstGeom prst="rect">
-            <a:avLst/>
-          </a:prstGeom>
-          <a:solidFill>
-            <a:srgbClr val="C9A227"/>
-          </a:solidFill>
-          <a:ln>
-            <a:noFill/>
-          </a:ln>
-        </p:spPr>
-        <p:style>
-          <a:lnRef idx="1">
-            <a:schemeClr val="accent1"/>
-          </a:lnRef>
-          <a:fillRef idx="3">
-            <a:schemeClr val="accent1"/>
-          </a:fillRef>
-          <a:effectRef idx="2">
-            <a:schemeClr val="accent1"/>
-          </a:effectRef>
-          <a:fontRef idx="minor">
-            <a:schemeClr val="lt1"/>
-          </a:fontRef>
-        </p:style>
-        <p:txBody>
-          <a:bodyPr rtlCol="0" anchor="ctr"/>
-          <a:lstStyle/>
-          <a:p>
-            <a:pPr algn="ctr"/>
-          </a:p>
-        </p:txBody>
-      </p:sp>
-      <p:pic>
-        <p:nvPicPr>
-          <p:cNvPr id="4" name="Picture 3" descr="logo wes.bmp"/>
-          <p:cNvPicPr>
-            <a:picLocks noChangeAspect="1"/>
-          </p:cNvPicPr>
-          <p:nvPr/>
-        </p:nvPicPr>
-        <p:blipFill>
-          <a:blip r:embed="rId2"/>
-          <a:stretch>
-            <a:fillRect/>
-          </a:stretch>
-        </p:blipFill>
-        <p:spPr>
-          <a:xfrm>
-            <a:off x="10835640" y="146304"/>
-            <a:ext cx="1143000" cy="253401"/>
-          </a:xfrm>
-          <a:prstGeom prst="rect">
-            <a:avLst/>
-          </a:prstGeom>
-        </p:spPr>
-      </p:pic>
-      <p:sp>
-        <p:nvSpPr>
-          <p:cNvPr id="5" name="TextBox 4"/>
-          <p:cNvSpPr txBox="1"/>
-          <p:nvPr/>
-        </p:nvSpPr>
-        <p:spPr>
-          <a:xfrm>
-            <a:off x="256032" y="109728"/>
-            <a:ext cx="10607040" cy="384048"/>
-          </a:xfrm>
-          <a:prstGeom prst="rect">
-            <a:avLst/>
-          </a:prstGeom>
-          <a:noFill/>
-        </p:spPr>
-        <p:txBody>
-          <a:bodyPr wrap="square">
-            <a:spAutoFit/>
-          </a:bodyPr>
-          <a:lstStyle/>
-          <a:p>
-            <a:pPr algn="l">
-              <a:spcAft>
-                <a:spcPts val="300"/>
-              </a:spcAft>
-            </a:pPr>
-            <a:r>
-              <a:rPr sz="2000" b="1">
-                <a:solidFill>
-                  <a:srgbClr val="FFFFFF"/>
-                </a:solidFill>
-                <a:latin typeface="Calibri"/>
-              </a:rPr>
-              <a:t>MAM  ·  2. Consumo mensualizado</a:t>
-            </a:r>
-          </a:p>
-        </p:txBody>
-      </p:sp>
-      <p:sp>
-        <p:nvSpPr>
-          <p:cNvPr id="6" name="TextBox 5"/>
-          <p:cNvSpPr txBox="1"/>
-          <p:nvPr/>
-        </p:nvSpPr>
-        <p:spPr>
-          <a:xfrm>
-            <a:off x="256032" y="457200"/>
-            <a:ext cx="10607040" cy="329184"/>
-          </a:xfrm>
-          <a:prstGeom prst="rect">
-            <a:avLst/>
-          </a:prstGeom>
-          <a:noFill/>
-        </p:spPr>
-        <p:txBody>
-          <a:bodyPr wrap="square">
-            <a:spAutoFit/>
-          </a:bodyPr>
-          <a:lstStyle/>
-          <a:p>
-            <a:pPr algn="l">
-              <a:spcAft>
-                <a:spcPts val="300"/>
-              </a:spcAft>
-            </a:pPr>
-            <a:r>
-              <a:rPr sz="1100" b="0">
-                <a:solidFill>
-                  <a:srgbClr val="DCE6F0"/>
-                </a:solidFill>
-                <a:latin typeface="Calibri"/>
-              </a:rPr>
-              <a:t>Suma de los 5 puntos WES   |   01/05/2026 – 17/08/2026   |   Agosto: a la fecha vs proyección al 31</a:t>
-            </a:r>
-          </a:p>
-        </p:txBody>
-      </p:sp>
-      <p:sp>
-        <p:nvSpPr>
-          <p:cNvPr id="7" name="Rounded Rectangle 6"/>
-          <p:cNvSpPr/>
-          <p:nvPr/>
-        </p:nvSpPr>
-        <p:spPr>
-          <a:xfrm>
-            <a:off x="201168" y="1024128"/>
-            <a:ext cx="7973568" cy="4617720"/>
-          </a:xfrm>
-          <a:prstGeom prst="roundRect">
-            <a:avLst>
-              <a:gd name="adj" fmla="val 8000"/>
-            </a:avLst>
-          </a:prstGeom>
-          <a:solidFill>
-            <a:srgbClr val="F5F7FA"/>
-          </a:solidFill>
-          <a:ln>
-            <a:noFill/>
-          </a:ln>
-        </p:spPr>
-        <p:style>
-          <a:lnRef idx="1">
-            <a:schemeClr val="accent1"/>
-          </a:lnRef>
-          <a:fillRef idx="3">
-            <a:schemeClr val="accent1"/>
-          </a:fillRef>
-          <a:effectRef idx="2">
-            <a:schemeClr val="accent1"/>
-          </a:effectRef>
-          <a:fontRef idx="minor">
-            <a:schemeClr val="lt1"/>
-          </a:fontRef>
-        </p:style>
-        <p:txBody>
-          <a:bodyPr rtlCol="0" anchor="ctr"/>
-          <a:lstStyle/>
-          <a:p>
-            <a:pPr algn="ctr"/>
-          </a:p>
-        </p:txBody>
-      </p:sp>
-      <p:pic>
-        <p:nvPicPr>
-          <p:cNvPr id="8" name="Picture 7" descr="mam_mensual_may_ago.png"/>
-          <p:cNvPicPr>
-            <a:picLocks noChangeAspect="1"/>
-          </p:cNvPicPr>
-          <p:nvPr/>
-        </p:nvPicPr>
-        <p:blipFill>
-          <a:blip r:embed="rId3"/>
-          <a:stretch>
-            <a:fillRect/>
-          </a:stretch>
-        </p:blipFill>
-        <p:spPr>
-          <a:xfrm>
-            <a:off x="347472" y="1115568"/>
-            <a:ext cx="7680960" cy="3759628"/>
-          </a:xfrm>
-          <a:prstGeom prst="rect">
-            <a:avLst/>
-          </a:prstGeom>
-        </p:spPr>
-      </p:pic>
-      <p:sp>
-        <p:nvSpPr>
-          <p:cNvPr id="9" name="Rounded Rectangle 8"/>
-          <p:cNvSpPr/>
-          <p:nvPr/>
-        </p:nvSpPr>
-        <p:spPr>
-          <a:xfrm>
-            <a:off x="8302752" y="1024128"/>
-            <a:ext cx="3675887" cy="4617720"/>
-          </a:xfrm>
-          <a:prstGeom prst="roundRect">
-            <a:avLst>
-              <a:gd name="adj" fmla="val 8000"/>
-            </a:avLst>
-          </a:prstGeom>
-          <a:solidFill>
-            <a:srgbClr val="FFFFFF"/>
-          </a:solidFill>
-          <a:ln w="6350">
-            <a:solidFill>
-              <a:srgbClr val="1F77B4"/>
-            </a:solidFill>
-          </a:ln>
-        </p:spPr>
-        <p:style>
-          <a:lnRef idx="1">
-            <a:schemeClr val="accent1"/>
-          </a:lnRef>
-          <a:fillRef idx="3">
-            <a:schemeClr val="accent1"/>
-          </a:fillRef>
-          <a:effectRef idx="2">
-            <a:schemeClr val="accent1"/>
-          </a:effectRef>
-          <a:fontRef idx="minor">
-            <a:schemeClr val="lt1"/>
-          </a:fontRef>
-        </p:style>
-        <p:txBody>
-          <a:bodyPr rtlCol="0" anchor="ctr"/>
-          <a:lstStyle/>
-          <a:p>
-            <a:pPr algn="ctr"/>
-          </a:p>
-        </p:txBody>
-      </p:sp>
-      <p:sp>
-        <p:nvSpPr>
-          <p:cNvPr id="10" name="TextBox 9"/>
-          <p:cNvSpPr txBox="1"/>
-          <p:nvPr/>
-        </p:nvSpPr>
-        <p:spPr>
-          <a:xfrm>
-            <a:off x="8430768" y="1078992"/>
-            <a:ext cx="3419856" cy="219456"/>
-          </a:xfrm>
-          <a:prstGeom prst="rect">
-            <a:avLst/>
-          </a:prstGeom>
-          <a:noFill/>
-        </p:spPr>
-        <p:txBody>
-          <a:bodyPr wrap="square">
-            <a:spAutoFit/>
-          </a:bodyPr>
-          <a:lstStyle/>
-          <a:p>
-            <a:pPr algn="l">
-              <a:spcAft>
-                <a:spcPts val="300"/>
-              </a:spcAft>
-            </a:pPr>
-            <a:r>
-              <a:rPr sz="1100" b="1">
-                <a:solidFill>
-                  <a:srgbClr val="1F77B4"/>
-                </a:solidFill>
-                <a:latin typeface="Calibri"/>
-              </a:rPr>
-              <a:t>JULIO · último mes cerrado</a:t>
-            </a:r>
-          </a:p>
-        </p:txBody>
-      </p:sp>
-      <p:sp>
-        <p:nvSpPr>
-          <p:cNvPr id="11" name="TextBox 10"/>
-          <p:cNvSpPr txBox="1"/>
-          <p:nvPr/>
-        </p:nvSpPr>
-        <p:spPr>
-          <a:xfrm>
-            <a:off x="8430768" y="1298448"/>
-            <a:ext cx="3419856" cy="384048"/>
-          </a:xfrm>
-          <a:prstGeom prst="rect">
-            <a:avLst/>
-          </a:prstGeom>
-          <a:noFill/>
-        </p:spPr>
-        <p:txBody>
-          <a:bodyPr wrap="square">
-            <a:spAutoFit/>
-          </a:bodyPr>
-          <a:lstStyle/>
-          <a:p>
-            <a:pPr algn="l">
-              <a:spcAft>
-                <a:spcPts val="300"/>
-              </a:spcAft>
-            </a:pPr>
-            <a:r>
-              <a:rPr sz="1200" b="0">
-                <a:solidFill>
-                  <a:srgbClr val="5A5A5A"/>
-                </a:solidFill>
-                <a:latin typeface="Calibri"/>
-              </a:rPr>
-              <a:t>El recinto sumó 10.356 m³. Peso de cada equipo:</a:t>
-            </a:r>
-          </a:p>
-        </p:txBody>
-      </p:sp>
-      <p:sp>
-        <p:nvSpPr>
-          <p:cNvPr id="12" name="Rounded Rectangle 11"/>
-          <p:cNvSpPr/>
-          <p:nvPr/>
-        </p:nvSpPr>
-        <p:spPr>
-          <a:xfrm>
-            <a:off x="8430768" y="1719072"/>
-            <a:ext cx="3419856" cy="713232"/>
-          </a:xfrm>
-          <a:prstGeom prst="roundRect">
-            <a:avLst>
-              <a:gd name="adj" fmla="val 8000"/>
-            </a:avLst>
-          </a:prstGeom>
-          <a:solidFill>
-            <a:srgbClr val="F5F7FA"/>
-          </a:solidFill>
-          <a:ln w="6350">
-            <a:solidFill>
-              <a:srgbClr val="0D3B66"/>
-            </a:solidFill>
-          </a:ln>
-        </p:spPr>
-        <p:style>
-          <a:lnRef idx="1">
-            <a:schemeClr val="accent1"/>
-          </a:lnRef>
-          <a:fillRef idx="3">
-            <a:schemeClr val="accent1"/>
-          </a:fillRef>
-          <a:effectRef idx="2">
-            <a:schemeClr val="accent1"/>
-          </a:effectRef>
-          <a:fontRef idx="minor">
-            <a:schemeClr val="lt1"/>
-          </a:fontRef>
-        </p:style>
-        <p:txBody>
-          <a:bodyPr rtlCol="0" anchor="ctr"/>
-          <a:lstStyle/>
-          <a:p>
-            <a:pPr algn="ctr"/>
-          </a:p>
-        </p:txBody>
-      </p:sp>
-      <p:sp>
-        <p:nvSpPr>
-          <p:cNvPr id="13" name="TextBox 12"/>
-          <p:cNvSpPr txBox="1"/>
-          <p:nvPr/>
-        </p:nvSpPr>
-        <p:spPr>
-          <a:xfrm>
-            <a:off x="8558784" y="1764792"/>
-            <a:ext cx="3163824" cy="219456"/>
-          </a:xfrm>
-          <a:prstGeom prst="rect">
-            <a:avLst/>
-          </a:prstGeom>
-          <a:noFill/>
-        </p:spPr>
-        <p:txBody>
-          <a:bodyPr wrap="square">
-            <a:spAutoFit/>
-          </a:bodyPr>
-          <a:lstStyle/>
-          <a:p>
-            <a:pPr algn="l">
-              <a:spcAft>
-                <a:spcPts val="300"/>
-              </a:spcAft>
-            </a:pPr>
-            <a:r>
-              <a:rPr sz="1200" b="1">
-                <a:solidFill>
-                  <a:srgbClr val="0D3B66"/>
-                </a:solidFill>
-                <a:latin typeface="Calibri"/>
-              </a:rPr>
-              <a:t>Placa Bancaria</a:t>
-            </a:r>
-          </a:p>
-        </p:txBody>
-      </p:sp>
-      <p:sp>
-        <p:nvSpPr>
-          <p:cNvPr id="14" name="TextBox 13"/>
-          <p:cNvSpPr txBox="1"/>
-          <p:nvPr/>
-        </p:nvSpPr>
-        <p:spPr>
-          <a:xfrm>
-            <a:off x="8558784" y="2011679"/>
-            <a:ext cx="3163824" cy="347472"/>
-          </a:xfrm>
-          <a:prstGeom prst="rect">
-            <a:avLst/>
-          </a:prstGeom>
-          <a:noFill/>
-        </p:spPr>
-        <p:txBody>
-          <a:bodyPr wrap="square">
-            <a:spAutoFit/>
-          </a:bodyPr>
-          <a:lstStyle/>
-          <a:p>
-            <a:pPr algn="l">
-              <a:spcAft>
-                <a:spcPts val="300"/>
-              </a:spcAft>
-            </a:pPr>
-            <a:r>
-              <a:rPr sz="1600" b="1">
-                <a:solidFill>
-                  <a:srgbClr val="0D3B66"/>
-                </a:solidFill>
-                <a:latin typeface="Calibri"/>
-              </a:rPr>
-              <a:t>7.084 m³    68 %</a:t>
-            </a:r>
-          </a:p>
-        </p:txBody>
-      </p:sp>
-      <p:sp>
-        <p:nvSpPr>
-          <p:cNvPr id="15" name="Rounded Rectangle 14"/>
-          <p:cNvSpPr/>
-          <p:nvPr/>
-        </p:nvSpPr>
-        <p:spPr>
-          <a:xfrm>
-            <a:off x="8430768" y="2468879"/>
-            <a:ext cx="3419856" cy="713232"/>
-          </a:xfrm>
-          <a:prstGeom prst="roundRect">
-            <a:avLst>
-              <a:gd name="adj" fmla="val 8000"/>
-            </a:avLst>
-          </a:prstGeom>
-          <a:solidFill>
-            <a:srgbClr val="F5F7FA"/>
-          </a:solidFill>
-          <a:ln w="6350">
-            <a:solidFill>
-              <a:srgbClr val="1F77B4"/>
-            </a:solidFill>
-          </a:ln>
-        </p:spPr>
-        <p:style>
-          <a:lnRef idx="1">
-            <a:schemeClr val="accent1"/>
-          </a:lnRef>
-          <a:fillRef idx="3">
-            <a:schemeClr val="accent1"/>
-          </a:fillRef>
-          <a:effectRef idx="2">
-            <a:schemeClr val="accent1"/>
-          </a:effectRef>
-          <a:fontRef idx="minor">
-            <a:schemeClr val="lt1"/>
-          </a:fontRef>
-        </p:style>
-        <p:txBody>
-          <a:bodyPr rtlCol="0" anchor="ctr"/>
-          <a:lstStyle/>
-          <a:p>
-            <a:pPr algn="ctr"/>
-          </a:p>
-        </p:txBody>
-      </p:sp>
-      <p:sp>
-        <p:nvSpPr>
-          <p:cNvPr id="16" name="TextBox 15"/>
-          <p:cNvSpPr txBox="1"/>
-          <p:nvPr/>
-        </p:nvSpPr>
-        <p:spPr>
-          <a:xfrm>
-            <a:off x="8558784" y="2514599"/>
-            <a:ext cx="3163824" cy="219456"/>
-          </a:xfrm>
-          <a:prstGeom prst="rect">
-            <a:avLst/>
-          </a:prstGeom>
-          <a:noFill/>
-        </p:spPr>
-        <p:txBody>
-          <a:bodyPr wrap="square">
-            <a:spAutoFit/>
-          </a:bodyPr>
-          <a:lstStyle/>
-          <a:p>
-            <a:pPr algn="l">
-              <a:spcAft>
-                <a:spcPts val="300"/>
-              </a:spcAft>
-            </a:pPr>
-            <a:r>
-              <a:rPr sz="1200" b="1">
-                <a:solidFill>
-                  <a:srgbClr val="1F77B4"/>
-                </a:solidFill>
-                <a:latin typeface="Calibri"/>
-              </a:rPr>
-              <a:t>Ripley</a:t>
-            </a:r>
-          </a:p>
-        </p:txBody>
-      </p:sp>
-      <p:sp>
-        <p:nvSpPr>
-          <p:cNvPr id="17" name="TextBox 16"/>
-          <p:cNvSpPr txBox="1"/>
-          <p:nvPr/>
-        </p:nvSpPr>
-        <p:spPr>
-          <a:xfrm>
-            <a:off x="8558784" y="2761487"/>
-            <a:ext cx="3163824" cy="347472"/>
-          </a:xfrm>
-          <a:prstGeom prst="rect">
-            <a:avLst/>
-          </a:prstGeom>
-          <a:noFill/>
-        </p:spPr>
-        <p:txBody>
-          <a:bodyPr wrap="square">
-            <a:spAutoFit/>
-          </a:bodyPr>
-          <a:lstStyle/>
-          <a:p>
-            <a:pPr algn="l">
-              <a:spcAft>
-                <a:spcPts val="300"/>
-              </a:spcAft>
-            </a:pPr>
-            <a:r>
-              <a:rPr sz="1600" b="1">
+              <a:rPr sz="1500" b="1">
                 <a:solidFill>
                   <a:srgbClr val="0D3B66"/>
                 </a:solidFill>
@@ -7689,14 +7278,14 @@
       </p:sp>
       <p:sp>
         <p:nvSpPr>
-          <p:cNvPr id="18" name="Rounded Rectangle 17"/>
+          <p:cNvPr id="36" name="Rounded Rectangle 35"/>
           <p:cNvSpPr/>
           <p:nvPr/>
         </p:nvSpPr>
         <p:spPr>
           <a:xfrm>
-            <a:off x="8430768" y="3218687"/>
-            <a:ext cx="3419856" cy="713232"/>
+            <a:off x="8430768" y="3639312"/>
+            <a:ext cx="3419856" cy="603504"/>
           </a:xfrm>
           <a:prstGeom prst="roundRect">
             <a:avLst>
@@ -7736,14 +7325,14 @@
       </p:sp>
       <p:sp>
         <p:nvSpPr>
-          <p:cNvPr id="19" name="TextBox 18"/>
+          <p:cNvPr id="37" name="TextBox 36"/>
           <p:cNvSpPr txBox="1"/>
           <p:nvPr/>
         </p:nvSpPr>
         <p:spPr>
           <a:xfrm>
-            <a:off x="8558784" y="3264407"/>
-            <a:ext cx="3163824" cy="219456"/>
+            <a:off x="8540496" y="3675888"/>
+            <a:ext cx="3200400" cy="182880"/>
           </a:xfrm>
           <a:prstGeom prst="rect">
             <a:avLst/>
@@ -7762,7 +7351,7 @@
               </a:spcAft>
             </a:pPr>
             <a:r>
-              <a:rPr sz="1200" b="1">
+              <a:rPr sz="1300" b="1">
                 <a:solidFill>
                   <a:srgbClr val="7BA3C9"/>
                 </a:solidFill>
@@ -7775,14 +7364,14 @@
       </p:sp>
       <p:sp>
         <p:nvSpPr>
-          <p:cNvPr id="20" name="TextBox 19"/>
+          <p:cNvPr id="38" name="TextBox 37"/>
           <p:cNvSpPr txBox="1"/>
           <p:nvPr/>
         </p:nvSpPr>
         <p:spPr>
           <a:xfrm>
-            <a:off x="8558784" y="3511295"/>
-            <a:ext cx="3163824" cy="347472"/>
+            <a:off x="8540496" y="3895344"/>
+            <a:ext cx="3200400" cy="274320"/>
           </a:xfrm>
           <a:prstGeom prst="rect">
             <a:avLst/>
@@ -7801,27 +7390,27 @@
               </a:spcAft>
             </a:pPr>
             <a:r>
-              <a:rPr sz="1600" b="1">
+              <a:rPr sz="1500" b="1">
                 <a:solidFill>
                   <a:srgbClr val="0D3B66"/>
                 </a:solidFill>
                 <a:latin typeface="Calibri"/>
               </a:rPr>
-              <a:t>26 m³    0 %</a:t>
-            </a:r>
-          </a:p>
-        </p:txBody>
-      </p:sp>
-      <p:sp>
-        <p:nvSpPr>
-          <p:cNvPr id="21" name="Rounded Rectangle 20"/>
+              <a:t>26 m³    0,3 %</a:t>
+            </a:r>
+          </a:p>
+        </p:txBody>
+      </p:sp>
+      <p:sp>
+        <p:nvSpPr>
+          <p:cNvPr id="39" name="Rounded Rectangle 38"/>
           <p:cNvSpPr/>
           <p:nvPr/>
         </p:nvSpPr>
         <p:spPr>
           <a:xfrm>
-            <a:off x="8430768" y="3968496"/>
-            <a:ext cx="3419856" cy="713232"/>
+            <a:off x="8430768" y="4279392"/>
+            <a:ext cx="3419856" cy="603504"/>
           </a:xfrm>
           <a:prstGeom prst="roundRect">
             <a:avLst>
@@ -7861,14 +7450,14 @@
       </p:sp>
       <p:sp>
         <p:nvSpPr>
-          <p:cNvPr id="22" name="TextBox 21"/>
+          <p:cNvPr id="40" name="TextBox 39"/>
           <p:cNvSpPr txBox="1"/>
           <p:nvPr/>
         </p:nvSpPr>
         <p:spPr>
           <a:xfrm>
-            <a:off x="8558784" y="4014215"/>
-            <a:ext cx="3163824" cy="219456"/>
+            <a:off x="8540496" y="4315968"/>
+            <a:ext cx="3200400" cy="182880"/>
           </a:xfrm>
           <a:prstGeom prst="rect">
             <a:avLst/>
@@ -7887,7 +7476,7 @@
               </a:spcAft>
             </a:pPr>
             <a:r>
-              <a:rPr sz="1200" b="1">
+              <a:rPr sz="1300" b="1">
                 <a:solidFill>
                   <a:srgbClr val="5A8C6E"/>
                 </a:solidFill>
@@ -7900,14 +7489,14 @@
       </p:sp>
       <p:sp>
         <p:nvSpPr>
-          <p:cNvPr id="23" name="TextBox 22"/>
+          <p:cNvPr id="41" name="TextBox 40"/>
           <p:cNvSpPr txBox="1"/>
           <p:nvPr/>
         </p:nvSpPr>
         <p:spPr>
           <a:xfrm>
-            <a:off x="8558784" y="4261104"/>
-            <a:ext cx="3163824" cy="347472"/>
+            <a:off x="8540496" y="4535424"/>
+            <a:ext cx="3200400" cy="274320"/>
           </a:xfrm>
           <a:prstGeom prst="rect">
             <a:avLst/>
@@ -7926,27 +7515,27 @@
               </a:spcAft>
             </a:pPr>
             <a:r>
-              <a:rPr sz="1600" b="1">
+              <a:rPr sz="1500" b="1">
                 <a:solidFill>
                   <a:srgbClr val="0D3B66"/>
                 </a:solidFill>
                 <a:latin typeface="Calibri"/>
               </a:rPr>
-              <a:t>1 m³    0 %</a:t>
-            </a:r>
-          </a:p>
-        </p:txBody>
-      </p:sp>
-      <p:sp>
-        <p:nvSpPr>
-          <p:cNvPr id="24" name="Rounded Rectangle 23"/>
+              <a:t>1 m³    &lt;0,1 %</a:t>
+            </a:r>
+          </a:p>
+        </p:txBody>
+      </p:sp>
+      <p:sp>
+        <p:nvSpPr>
+          <p:cNvPr id="42" name="Rounded Rectangle 41"/>
           <p:cNvSpPr/>
           <p:nvPr/>
         </p:nvSpPr>
         <p:spPr>
           <a:xfrm>
-            <a:off x="8430768" y="4718304"/>
-            <a:ext cx="3419856" cy="713232"/>
+            <a:off x="8430768" y="4919472"/>
+            <a:ext cx="3419856" cy="603504"/>
           </a:xfrm>
           <a:prstGeom prst="roundRect">
             <a:avLst>
@@ -7986,14 +7575,14 @@
       </p:sp>
       <p:sp>
         <p:nvSpPr>
-          <p:cNvPr id="25" name="TextBox 24"/>
+          <p:cNvPr id="43" name="TextBox 42"/>
           <p:cNvSpPr txBox="1"/>
           <p:nvPr/>
         </p:nvSpPr>
         <p:spPr>
           <a:xfrm>
-            <a:off x="8558784" y="4764024"/>
-            <a:ext cx="3163824" cy="219456"/>
+            <a:off x="8540496" y="4956048"/>
+            <a:ext cx="3200400" cy="182880"/>
           </a:xfrm>
           <a:prstGeom prst="rect">
             <a:avLst/>
@@ -8012,1835 +7601,13 @@
               </a:spcAft>
             </a:pPr>
             <a:r>
-              <a:rPr sz="1200" b="1">
+              <a:rPr sz="1300" b="1">
                 <a:solidFill>
                   <a:srgbClr val="C9A227"/>
                 </a:solidFill>
                 <a:latin typeface="Calibri"/>
               </a:rPr>
               <a:t>Falabella</a:t>
-            </a:r>
-          </a:p>
-        </p:txBody>
-      </p:sp>
-      <p:sp>
-        <p:nvSpPr>
-          <p:cNvPr id="26" name="TextBox 25"/>
-          <p:cNvSpPr txBox="1"/>
-          <p:nvPr/>
-        </p:nvSpPr>
-        <p:spPr>
-          <a:xfrm>
-            <a:off x="8558784" y="5010912"/>
-            <a:ext cx="3163824" cy="347472"/>
-          </a:xfrm>
-          <a:prstGeom prst="rect">
-            <a:avLst/>
-          </a:prstGeom>
-          <a:noFill/>
-        </p:spPr>
-        <p:txBody>
-          <a:bodyPr wrap="square">
-            <a:spAutoFit/>
-          </a:bodyPr>
-          <a:lstStyle/>
-          <a:p>
-            <a:pPr algn="l">
-              <a:spcAft>
-                <a:spcPts val="300"/>
-              </a:spcAft>
-            </a:pPr>
-            <a:r>
-              <a:rPr sz="1400" b="1">
-                <a:solidFill>
-                  <a:srgbClr val="0D3B66"/>
-                </a:solidFill>
-                <a:latin typeface="Calibri"/>
-              </a:rPr>
-              <a:t>0 m³    0 %  ·  activo 11/08</a:t>
-            </a:r>
-          </a:p>
-        </p:txBody>
-      </p:sp>
-      <p:sp>
-        <p:nvSpPr>
-          <p:cNvPr id="27" name="TextBox 26"/>
-          <p:cNvSpPr txBox="1"/>
-          <p:nvPr/>
-        </p:nvSpPr>
-        <p:spPr>
-          <a:xfrm>
-            <a:off x="256032" y="5742432"/>
-            <a:ext cx="11887200" cy="960120"/>
-          </a:xfrm>
-          <a:prstGeom prst="rect">
-            <a:avLst/>
-          </a:prstGeom>
-          <a:noFill/>
-        </p:spPr>
-        <p:txBody>
-          <a:bodyPr wrap="square">
-            <a:spAutoFit/>
-          </a:bodyPr>
-          <a:lstStyle/>
-          <a:p>
-            <a:pPr algn="l">
-              <a:spcAft>
-                <a:spcPts val="300"/>
-              </a:spcAft>
-            </a:pPr>
-            <a:r>
-              <a:rPr sz="1300" b="0">
-                <a:solidFill>
-                  <a:srgbClr val="0D3B66"/>
-                </a:solidFill>
-                <a:latin typeface="Calibri"/>
-              </a:rPr>
-              <a:t>Mayo 7.511 m³   ·   Junio 10.014 m³   ·   Julio 10.356 m³   ·   Agosto 1–17: 4.165 m³   ·   Proyección agosto: 7.595 m³ (245 m³/día × 31).</a:t>
-            </a:r>
-          </a:p>
-          <a:p>
-            <a:pPr algn="l">
-              <a:spcAft>
-                <a:spcPts val="300"/>
-              </a:spcAft>
-            </a:pPr>
-            <a:r>
-              <a:rPr sz="1200" b="0">
-                <a:solidFill>
-                  <a:srgbClr val="5A5A5A"/>
-                </a:solidFill>
-                <a:latin typeface="Calibri"/>
-              </a:rPr>
-              <a:t>Dorado = lo que agosto ya lleva. Tramo claro = proyección del resto del mes. Junio sube por Placa Bancaria (salto 18/06). Falabella no entra en julio: activo desde el 11/08.</a:t>
-            </a:r>
-          </a:p>
-        </p:txBody>
-      </p:sp>
-    </p:spTree>
-  </p:cSld>
-  <p:clrMapOvr>
-    <a:masterClrMapping/>
-  </p:clrMapOvr>
-</p:sld>
-</file>
-
-<file path=ppt/slides/slide7.xml><?xml version="1.0" encoding="utf-8"?>
-<p:sld xmlns:a="http://schemas.openxmlformats.org/drawingml/2006/main" xmlns:p="http://schemas.openxmlformats.org/presentationml/2006/main" xmlns:r="http://schemas.openxmlformats.org/officeDocument/2006/relationships">
-  <p:cSld>
-    <p:spTree>
-      <p:nvGrpSpPr>
-        <p:cNvPr id="1" name=""/>
-        <p:cNvGrpSpPr/>
-        <p:nvPr/>
-      </p:nvGrpSpPr>
-      <p:grpSpPr/>
-      <p:sp>
-        <p:nvSpPr>
-          <p:cNvPr id="2" name="Rectangle 1"/>
-          <p:cNvSpPr/>
-          <p:nvPr/>
-        </p:nvSpPr>
-        <p:spPr>
-          <a:xfrm>
-            <a:off x="0" y="0"/>
-            <a:ext cx="12191695" cy="841248"/>
-          </a:xfrm>
-          <a:prstGeom prst="rect">
-            <a:avLst/>
-          </a:prstGeom>
-          <a:solidFill>
-            <a:srgbClr val="0D3B66"/>
-          </a:solidFill>
-          <a:ln>
-            <a:noFill/>
-          </a:ln>
-        </p:spPr>
-        <p:style>
-          <a:lnRef idx="1">
-            <a:schemeClr val="accent1"/>
-          </a:lnRef>
-          <a:fillRef idx="3">
-            <a:schemeClr val="accent1"/>
-          </a:fillRef>
-          <a:effectRef idx="2">
-            <a:schemeClr val="accent1"/>
-          </a:effectRef>
-          <a:fontRef idx="minor">
-            <a:schemeClr val="lt1"/>
-          </a:fontRef>
-        </p:style>
-        <p:txBody>
-          <a:bodyPr rtlCol="0" anchor="ctr"/>
-          <a:lstStyle/>
-          <a:p>
-            <a:pPr algn="ctr"/>
-          </a:p>
-        </p:txBody>
-      </p:sp>
-      <p:sp>
-        <p:nvSpPr>
-          <p:cNvPr id="3" name="Rectangle 2"/>
-          <p:cNvSpPr/>
-          <p:nvPr/>
-        </p:nvSpPr>
-        <p:spPr>
-          <a:xfrm>
-            <a:off x="0" y="841248"/>
-            <a:ext cx="12191695" cy="54864"/>
-          </a:xfrm>
-          <a:prstGeom prst="rect">
-            <a:avLst/>
-          </a:prstGeom>
-          <a:solidFill>
-            <a:srgbClr val="C9A227"/>
-          </a:solidFill>
-          <a:ln>
-            <a:noFill/>
-          </a:ln>
-        </p:spPr>
-        <p:style>
-          <a:lnRef idx="1">
-            <a:schemeClr val="accent1"/>
-          </a:lnRef>
-          <a:fillRef idx="3">
-            <a:schemeClr val="accent1"/>
-          </a:fillRef>
-          <a:effectRef idx="2">
-            <a:schemeClr val="accent1"/>
-          </a:effectRef>
-          <a:fontRef idx="minor">
-            <a:schemeClr val="lt1"/>
-          </a:fontRef>
-        </p:style>
-        <p:txBody>
-          <a:bodyPr rtlCol="0" anchor="ctr"/>
-          <a:lstStyle/>
-          <a:p>
-            <a:pPr algn="ctr"/>
-          </a:p>
-        </p:txBody>
-      </p:sp>
-      <p:pic>
-        <p:nvPicPr>
-          <p:cNvPr id="4" name="Picture 3" descr="logo wes.bmp"/>
-          <p:cNvPicPr>
-            <a:picLocks noChangeAspect="1"/>
-          </p:cNvPicPr>
-          <p:nvPr/>
-        </p:nvPicPr>
-        <p:blipFill>
-          <a:blip r:embed="rId2"/>
-          <a:stretch>
-            <a:fillRect/>
-          </a:stretch>
-        </p:blipFill>
-        <p:spPr>
-          <a:xfrm>
-            <a:off x="10835640" y="146304"/>
-            <a:ext cx="1143000" cy="253401"/>
-          </a:xfrm>
-          <a:prstGeom prst="rect">
-            <a:avLst/>
-          </a:prstGeom>
-        </p:spPr>
-      </p:pic>
-      <p:sp>
-        <p:nvSpPr>
-          <p:cNvPr id="5" name="TextBox 4"/>
-          <p:cNvSpPr txBox="1"/>
-          <p:nvPr/>
-        </p:nvSpPr>
-        <p:spPr>
-          <a:xfrm>
-            <a:off x="256032" y="109728"/>
-            <a:ext cx="10607040" cy="384048"/>
-          </a:xfrm>
-          <a:prstGeom prst="rect">
-            <a:avLst/>
-          </a:prstGeom>
-          <a:noFill/>
-        </p:spPr>
-        <p:txBody>
-          <a:bodyPr wrap="square">
-            <a:spAutoFit/>
-          </a:bodyPr>
-          <a:lstStyle/>
-          <a:p>
-            <a:pPr algn="l">
-              <a:spcAft>
-                <a:spcPts val="300"/>
-              </a:spcAft>
-            </a:pPr>
-            <a:r>
-              <a:rPr sz="2000" b="1">
-                <a:solidFill>
-                  <a:srgbClr val="FFFFFF"/>
-                </a:solidFill>
-                <a:latin typeface="Calibri"/>
-              </a:rPr>
-              <a:t>MAM  ·  Equipos y consumo</a:t>
-            </a:r>
-          </a:p>
-        </p:txBody>
-      </p:sp>
-      <p:sp>
-        <p:nvSpPr>
-          <p:cNvPr id="6" name="TextBox 5"/>
-          <p:cNvSpPr txBox="1"/>
-          <p:nvPr/>
-        </p:nvSpPr>
-        <p:spPr>
-          <a:xfrm>
-            <a:off x="256032" y="457200"/>
-            <a:ext cx="10607040" cy="329184"/>
-          </a:xfrm>
-          <a:prstGeom prst="rect">
-            <a:avLst/>
-          </a:prstGeom>
-          <a:noFill/>
-        </p:spPr>
-        <p:txBody>
-          <a:bodyPr wrap="square">
-            <a:spAutoFit/>
-          </a:bodyPr>
-          <a:lstStyle/>
-          <a:p>
-            <a:pPr algn="l">
-              <a:spcAft>
-                <a:spcPts val="300"/>
-              </a:spcAft>
-            </a:pPr>
-            <a:r>
-              <a:rPr sz="1100" b="0">
-                <a:solidFill>
-                  <a:srgbClr val="DCE6F0"/>
-                </a:solidFill>
-                <a:latin typeface="Calibri"/>
-              </a:rPr>
-              <a:t>Mall Arauco Maipú   |   5 puntos WES   |   01/05/2026 – 17/08/2026   |   propuesta: una lámina</a:t>
-            </a:r>
-          </a:p>
-        </p:txBody>
-      </p:sp>
-      <p:sp>
-        <p:nvSpPr>
-          <p:cNvPr id="7" name="Rounded Rectangle 6"/>
-          <p:cNvSpPr/>
-          <p:nvPr/>
-        </p:nvSpPr>
-        <p:spPr>
-          <a:xfrm>
-            <a:off x="201168" y="1024128"/>
-            <a:ext cx="2286000" cy="658368"/>
-          </a:xfrm>
-          <a:prstGeom prst="roundRect">
-            <a:avLst>
-              <a:gd name="adj" fmla="val 8000"/>
-            </a:avLst>
-          </a:prstGeom>
-          <a:solidFill>
-            <a:srgbClr val="F5F7FA"/>
-          </a:solidFill>
-          <a:ln w="6350">
-            <a:solidFill>
-              <a:srgbClr val="1F77B4"/>
-            </a:solidFill>
-          </a:ln>
-        </p:spPr>
-        <p:style>
-          <a:lnRef idx="1">
-            <a:schemeClr val="accent1"/>
-          </a:lnRef>
-          <a:fillRef idx="3">
-            <a:schemeClr val="accent1"/>
-          </a:fillRef>
-          <a:effectRef idx="2">
-            <a:schemeClr val="accent1"/>
-          </a:effectRef>
-          <a:fontRef idx="minor">
-            <a:schemeClr val="lt1"/>
-          </a:fontRef>
-        </p:style>
-        <p:txBody>
-          <a:bodyPr rtlCol="0" anchor="ctr"/>
-          <a:lstStyle/>
-          <a:p>
-            <a:pPr algn="ctr"/>
-          </a:p>
-        </p:txBody>
-      </p:sp>
-      <p:sp>
-        <p:nvSpPr>
-          <p:cNvPr id="8" name="TextBox 7"/>
-          <p:cNvSpPr txBox="1"/>
-          <p:nvPr/>
-        </p:nvSpPr>
-        <p:spPr>
-          <a:xfrm>
-            <a:off x="292608" y="1060704"/>
-            <a:ext cx="2121408" cy="201168"/>
-          </a:xfrm>
-          <a:prstGeom prst="rect">
-            <a:avLst/>
-          </a:prstGeom>
-          <a:noFill/>
-        </p:spPr>
-        <p:txBody>
-          <a:bodyPr wrap="square">
-            <a:spAutoFit/>
-          </a:bodyPr>
-          <a:lstStyle/>
-          <a:p>
-            <a:pPr algn="l">
-              <a:spcAft>
-                <a:spcPts val="300"/>
-              </a:spcAft>
-            </a:pPr>
-            <a:r>
-              <a:rPr sz="1000" b="1">
-                <a:solidFill>
-                  <a:srgbClr val="C9A227"/>
-                </a:solidFill>
-                <a:latin typeface="Calibri"/>
-              </a:rPr>
-              <a:t>000025-08</a:t>
-            </a:r>
-          </a:p>
-        </p:txBody>
-      </p:sp>
-      <p:sp>
-        <p:nvSpPr>
-          <p:cNvPr id="9" name="TextBox 8"/>
-          <p:cNvSpPr txBox="1"/>
-          <p:nvPr/>
-        </p:nvSpPr>
-        <p:spPr>
-          <a:xfrm>
-            <a:off x="292608" y="1261872"/>
-            <a:ext cx="2121408" cy="219456"/>
-          </a:xfrm>
-          <a:prstGeom prst="rect">
-            <a:avLst/>
-          </a:prstGeom>
-          <a:noFill/>
-        </p:spPr>
-        <p:txBody>
-          <a:bodyPr wrap="square">
-            <a:spAutoFit/>
-          </a:bodyPr>
-          <a:lstStyle/>
-          <a:p>
-            <a:pPr algn="l">
-              <a:spcAft>
-                <a:spcPts val="300"/>
-              </a:spcAft>
-            </a:pPr>
-            <a:r>
-              <a:rPr sz="1200" b="1">
-                <a:solidFill>
-                  <a:srgbClr val="0D3B66"/>
-                </a:solidFill>
-                <a:latin typeface="Calibri"/>
-              </a:rPr>
-              <a:t>Placa Bancaria</a:t>
-            </a:r>
-          </a:p>
-        </p:txBody>
-      </p:sp>
-      <p:sp>
-        <p:nvSpPr>
-          <p:cNvPr id="10" name="Rounded Rectangle 9"/>
-          <p:cNvSpPr/>
-          <p:nvPr/>
-        </p:nvSpPr>
-        <p:spPr>
-          <a:xfrm>
-            <a:off x="2578608" y="1024128"/>
-            <a:ext cx="2286000" cy="658368"/>
-          </a:xfrm>
-          <a:prstGeom prst="roundRect">
-            <a:avLst>
-              <a:gd name="adj" fmla="val 8000"/>
-            </a:avLst>
-          </a:prstGeom>
-          <a:solidFill>
-            <a:srgbClr val="F5F7FA"/>
-          </a:solidFill>
-          <a:ln w="6350">
-            <a:solidFill>
-              <a:srgbClr val="1F77B4"/>
-            </a:solidFill>
-          </a:ln>
-        </p:spPr>
-        <p:style>
-          <a:lnRef idx="1">
-            <a:schemeClr val="accent1"/>
-          </a:lnRef>
-          <a:fillRef idx="3">
-            <a:schemeClr val="accent1"/>
-          </a:fillRef>
-          <a:effectRef idx="2">
-            <a:schemeClr val="accent1"/>
-          </a:effectRef>
-          <a:fontRef idx="minor">
-            <a:schemeClr val="lt1"/>
-          </a:fontRef>
-        </p:style>
-        <p:txBody>
-          <a:bodyPr rtlCol="0" anchor="ctr"/>
-          <a:lstStyle/>
-          <a:p>
-            <a:pPr algn="ctr"/>
-          </a:p>
-        </p:txBody>
-      </p:sp>
-      <p:sp>
-        <p:nvSpPr>
-          <p:cNvPr id="11" name="TextBox 10"/>
-          <p:cNvSpPr txBox="1"/>
-          <p:nvPr/>
-        </p:nvSpPr>
-        <p:spPr>
-          <a:xfrm>
-            <a:off x="2670048" y="1060704"/>
-            <a:ext cx="2121408" cy="201168"/>
-          </a:xfrm>
-          <a:prstGeom prst="rect">
-            <a:avLst/>
-          </a:prstGeom>
-          <a:noFill/>
-        </p:spPr>
-        <p:txBody>
-          <a:bodyPr wrap="square">
-            <a:spAutoFit/>
-          </a:bodyPr>
-          <a:lstStyle/>
-          <a:p>
-            <a:pPr algn="l">
-              <a:spcAft>
-                <a:spcPts val="300"/>
-              </a:spcAft>
-            </a:pPr>
-            <a:r>
-              <a:rPr sz="1000" b="1">
-                <a:solidFill>
-                  <a:srgbClr val="C9A227"/>
-                </a:solidFill>
-                <a:latin typeface="Calibri"/>
-              </a:rPr>
-              <a:t>000025-10</a:t>
-            </a:r>
-          </a:p>
-        </p:txBody>
-      </p:sp>
-      <p:sp>
-        <p:nvSpPr>
-          <p:cNvPr id="12" name="TextBox 11"/>
-          <p:cNvSpPr txBox="1"/>
-          <p:nvPr/>
-        </p:nvSpPr>
-        <p:spPr>
-          <a:xfrm>
-            <a:off x="2670048" y="1261872"/>
-            <a:ext cx="2121408" cy="219456"/>
-          </a:xfrm>
-          <a:prstGeom prst="rect">
-            <a:avLst/>
-          </a:prstGeom>
-          <a:noFill/>
-        </p:spPr>
-        <p:txBody>
-          <a:bodyPr wrap="square">
-            <a:spAutoFit/>
-          </a:bodyPr>
-          <a:lstStyle/>
-          <a:p>
-            <a:pPr algn="l">
-              <a:spcAft>
-                <a:spcPts val="300"/>
-              </a:spcAft>
-            </a:pPr>
-            <a:r>
-              <a:rPr sz="1200" b="1">
-                <a:solidFill>
-                  <a:srgbClr val="0D3B66"/>
-                </a:solidFill>
-                <a:latin typeface="Calibri"/>
-              </a:rPr>
-              <a:t>Ripley</a:t>
-            </a:r>
-          </a:p>
-        </p:txBody>
-      </p:sp>
-      <p:sp>
-        <p:nvSpPr>
-          <p:cNvPr id="13" name="Rounded Rectangle 12"/>
-          <p:cNvSpPr/>
-          <p:nvPr/>
-        </p:nvSpPr>
-        <p:spPr>
-          <a:xfrm>
-            <a:off x="4956048" y="1024128"/>
-            <a:ext cx="2286000" cy="658368"/>
-          </a:xfrm>
-          <a:prstGeom prst="roundRect">
-            <a:avLst>
-              <a:gd name="adj" fmla="val 8000"/>
-            </a:avLst>
-          </a:prstGeom>
-          <a:solidFill>
-            <a:srgbClr val="F5F7FA"/>
-          </a:solidFill>
-          <a:ln w="6350">
-            <a:solidFill>
-              <a:srgbClr val="C9A227"/>
-            </a:solidFill>
-          </a:ln>
-        </p:spPr>
-        <p:style>
-          <a:lnRef idx="1">
-            <a:schemeClr val="accent1"/>
-          </a:lnRef>
-          <a:fillRef idx="3">
-            <a:schemeClr val="accent1"/>
-          </a:fillRef>
-          <a:effectRef idx="2">
-            <a:schemeClr val="accent1"/>
-          </a:effectRef>
-          <a:fontRef idx="minor">
-            <a:schemeClr val="lt1"/>
-          </a:fontRef>
-        </p:style>
-        <p:txBody>
-          <a:bodyPr rtlCol="0" anchor="ctr"/>
-          <a:lstStyle/>
-          <a:p>
-            <a:pPr algn="ctr"/>
-          </a:p>
-        </p:txBody>
-      </p:sp>
-      <p:sp>
-        <p:nvSpPr>
-          <p:cNvPr id="14" name="TextBox 13"/>
-          <p:cNvSpPr txBox="1"/>
-          <p:nvPr/>
-        </p:nvSpPr>
-        <p:spPr>
-          <a:xfrm>
-            <a:off x="5047488" y="1060704"/>
-            <a:ext cx="2121408" cy="201168"/>
-          </a:xfrm>
-          <a:prstGeom prst="rect">
-            <a:avLst/>
-          </a:prstGeom>
-          <a:noFill/>
-        </p:spPr>
-        <p:txBody>
-          <a:bodyPr wrap="square">
-            <a:spAutoFit/>
-          </a:bodyPr>
-          <a:lstStyle/>
-          <a:p>
-            <a:pPr algn="l">
-              <a:spcAft>
-                <a:spcPts val="300"/>
-              </a:spcAft>
-            </a:pPr>
-            <a:r>
-              <a:rPr sz="1000" b="1">
-                <a:solidFill>
-                  <a:srgbClr val="C9A227"/>
-                </a:solidFill>
-                <a:latin typeface="Calibri"/>
-              </a:rPr>
-              <a:t>000025-09</a:t>
-            </a:r>
-          </a:p>
-        </p:txBody>
-      </p:sp>
-      <p:sp>
-        <p:nvSpPr>
-          <p:cNvPr id="15" name="TextBox 14"/>
-          <p:cNvSpPr txBox="1"/>
-          <p:nvPr/>
-        </p:nvSpPr>
-        <p:spPr>
-          <a:xfrm>
-            <a:off x="5047488" y="1261872"/>
-            <a:ext cx="2121408" cy="219456"/>
-          </a:xfrm>
-          <a:prstGeom prst="rect">
-            <a:avLst/>
-          </a:prstGeom>
-          <a:noFill/>
-        </p:spPr>
-        <p:txBody>
-          <a:bodyPr wrap="square">
-            <a:spAutoFit/>
-          </a:bodyPr>
-          <a:lstStyle/>
-          <a:p>
-            <a:pPr algn="l">
-              <a:spcAft>
-                <a:spcPts val="300"/>
-              </a:spcAft>
-            </a:pPr>
-            <a:r>
-              <a:rPr sz="1200" b="1">
-                <a:solidFill>
-                  <a:srgbClr val="0D3B66"/>
-                </a:solidFill>
-                <a:latin typeface="Calibri"/>
-              </a:rPr>
-              <a:t>Falabella</a:t>
-            </a:r>
-          </a:p>
-        </p:txBody>
-      </p:sp>
-      <p:sp>
-        <p:nvSpPr>
-          <p:cNvPr id="16" name="TextBox 15"/>
-          <p:cNvSpPr txBox="1"/>
-          <p:nvPr/>
-        </p:nvSpPr>
-        <p:spPr>
-          <a:xfrm>
-            <a:off x="5047488" y="1463040"/>
-            <a:ext cx="2121408" cy="182880"/>
-          </a:xfrm>
-          <a:prstGeom prst="rect">
-            <a:avLst/>
-          </a:prstGeom>
-          <a:noFill/>
-        </p:spPr>
-        <p:txBody>
-          <a:bodyPr wrap="square">
-            <a:spAutoFit/>
-          </a:bodyPr>
-          <a:lstStyle/>
-          <a:p>
-            <a:pPr algn="l">
-              <a:spcAft>
-                <a:spcPts val="300"/>
-              </a:spcAft>
-            </a:pPr>
-            <a:r>
-              <a:rPr sz="1000" b="0">
-                <a:solidFill>
-                  <a:srgbClr val="5A5A5A"/>
-                </a:solidFill>
-                <a:latin typeface="Calibri"/>
-              </a:rPr>
-              <a:t>activo 11/08</a:t>
-            </a:r>
-          </a:p>
-        </p:txBody>
-      </p:sp>
-      <p:sp>
-        <p:nvSpPr>
-          <p:cNvPr id="17" name="Rounded Rectangle 16"/>
-          <p:cNvSpPr/>
-          <p:nvPr/>
-        </p:nvSpPr>
-        <p:spPr>
-          <a:xfrm>
-            <a:off x="7333488" y="1024128"/>
-            <a:ext cx="2286000" cy="658368"/>
-          </a:xfrm>
-          <a:prstGeom prst="roundRect">
-            <a:avLst>
-              <a:gd name="adj" fmla="val 8000"/>
-            </a:avLst>
-          </a:prstGeom>
-          <a:solidFill>
-            <a:srgbClr val="F5F7FA"/>
-          </a:solidFill>
-          <a:ln w="6350">
-            <a:solidFill>
-              <a:srgbClr val="1F77B4"/>
-            </a:solidFill>
-          </a:ln>
-        </p:spPr>
-        <p:style>
-          <a:lnRef idx="1">
-            <a:schemeClr val="accent1"/>
-          </a:lnRef>
-          <a:fillRef idx="3">
-            <a:schemeClr val="accent1"/>
-          </a:fillRef>
-          <a:effectRef idx="2">
-            <a:schemeClr val="accent1"/>
-          </a:effectRef>
-          <a:fontRef idx="minor">
-            <a:schemeClr val="lt1"/>
-          </a:fontRef>
-        </p:style>
-        <p:txBody>
-          <a:bodyPr rtlCol="0" anchor="ctr"/>
-          <a:lstStyle/>
-          <a:p>
-            <a:pPr algn="ctr"/>
-          </a:p>
-        </p:txBody>
-      </p:sp>
-      <p:sp>
-        <p:nvSpPr>
-          <p:cNvPr id="18" name="TextBox 17"/>
-          <p:cNvSpPr txBox="1"/>
-          <p:nvPr/>
-        </p:nvSpPr>
-        <p:spPr>
-          <a:xfrm>
-            <a:off x="7424928" y="1060704"/>
-            <a:ext cx="2121408" cy="201168"/>
-          </a:xfrm>
-          <a:prstGeom prst="rect">
-            <a:avLst/>
-          </a:prstGeom>
-          <a:noFill/>
-        </p:spPr>
-        <p:txBody>
-          <a:bodyPr wrap="square">
-            <a:spAutoFit/>
-          </a:bodyPr>
-          <a:lstStyle/>
-          <a:p>
-            <a:pPr algn="l">
-              <a:spcAft>
-                <a:spcPts val="300"/>
-              </a:spcAft>
-            </a:pPr>
-            <a:r>
-              <a:rPr sz="1000" b="1">
-                <a:solidFill>
-                  <a:srgbClr val="C9A227"/>
-                </a:solidFill>
-                <a:latin typeface="Calibri"/>
-              </a:rPr>
-              <a:t>000025-32</a:t>
-            </a:r>
-          </a:p>
-        </p:txBody>
-      </p:sp>
-      <p:sp>
-        <p:nvSpPr>
-          <p:cNvPr id="19" name="TextBox 18"/>
-          <p:cNvSpPr txBox="1"/>
-          <p:nvPr/>
-        </p:nvSpPr>
-        <p:spPr>
-          <a:xfrm>
-            <a:off x="7424928" y="1261872"/>
-            <a:ext cx="2121408" cy="219456"/>
-          </a:xfrm>
-          <a:prstGeom prst="rect">
-            <a:avLst/>
-          </a:prstGeom>
-          <a:noFill/>
-        </p:spPr>
-        <p:txBody>
-          <a:bodyPr wrap="square">
-            <a:spAutoFit/>
-          </a:bodyPr>
-          <a:lstStyle/>
-          <a:p>
-            <a:pPr algn="l">
-              <a:spcAft>
-                <a:spcPts val="300"/>
-              </a:spcAft>
-            </a:pPr>
-            <a:r>
-              <a:rPr sz="1200" b="1">
-                <a:solidFill>
-                  <a:srgbClr val="0D3B66"/>
-                </a:solidFill>
-                <a:latin typeface="Calibri"/>
-              </a:rPr>
-              <a:t>Pasillo Técnico</a:t>
-            </a:r>
-          </a:p>
-        </p:txBody>
-      </p:sp>
-      <p:sp>
-        <p:nvSpPr>
-          <p:cNvPr id="20" name="TextBox 19"/>
-          <p:cNvSpPr txBox="1"/>
-          <p:nvPr/>
-        </p:nvSpPr>
-        <p:spPr>
-          <a:xfrm>
-            <a:off x="7424928" y="1463040"/>
-            <a:ext cx="2121408" cy="182880"/>
-          </a:xfrm>
-          <a:prstGeom prst="rect">
-            <a:avLst/>
-          </a:prstGeom>
-          <a:noFill/>
-        </p:spPr>
-        <p:txBody>
-          <a:bodyPr wrap="square">
-            <a:spAutoFit/>
-          </a:bodyPr>
-          <a:lstStyle/>
-          <a:p>
-            <a:pPr algn="l">
-              <a:spcAft>
-                <a:spcPts val="300"/>
-              </a:spcAft>
-            </a:pPr>
-            <a:r>
-              <a:rPr sz="1000" b="0">
-                <a:solidFill>
-                  <a:srgbClr val="5A5A5A"/>
-                </a:solidFill>
-                <a:latin typeface="Calibri"/>
-              </a:rPr>
-              <a:t>residual</a:t>
-            </a:r>
-          </a:p>
-        </p:txBody>
-      </p:sp>
-      <p:sp>
-        <p:nvSpPr>
-          <p:cNvPr id="21" name="Rounded Rectangle 20"/>
-          <p:cNvSpPr/>
-          <p:nvPr/>
-        </p:nvSpPr>
-        <p:spPr>
-          <a:xfrm>
-            <a:off x="9710928" y="1024128"/>
-            <a:ext cx="2286000" cy="658368"/>
-          </a:xfrm>
-          <a:prstGeom prst="roundRect">
-            <a:avLst>
-              <a:gd name="adj" fmla="val 8000"/>
-            </a:avLst>
-          </a:prstGeom>
-          <a:solidFill>
-            <a:srgbClr val="F5F7FA"/>
-          </a:solidFill>
-          <a:ln w="6350">
-            <a:solidFill>
-              <a:srgbClr val="1F77B4"/>
-            </a:solidFill>
-          </a:ln>
-        </p:spPr>
-        <p:style>
-          <a:lnRef idx="1">
-            <a:schemeClr val="accent1"/>
-          </a:lnRef>
-          <a:fillRef idx="3">
-            <a:schemeClr val="accent1"/>
-          </a:fillRef>
-          <a:effectRef idx="2">
-            <a:schemeClr val="accent1"/>
-          </a:effectRef>
-          <a:fontRef idx="minor">
-            <a:schemeClr val="lt1"/>
-          </a:fontRef>
-        </p:style>
-        <p:txBody>
-          <a:bodyPr rtlCol="0" anchor="ctr"/>
-          <a:lstStyle/>
-          <a:p>
-            <a:pPr algn="ctr"/>
-          </a:p>
-        </p:txBody>
-      </p:sp>
-      <p:sp>
-        <p:nvSpPr>
-          <p:cNvPr id="22" name="TextBox 21"/>
-          <p:cNvSpPr txBox="1"/>
-          <p:nvPr/>
-        </p:nvSpPr>
-        <p:spPr>
-          <a:xfrm>
-            <a:off x="9802368" y="1060704"/>
-            <a:ext cx="2121408" cy="201168"/>
-          </a:xfrm>
-          <a:prstGeom prst="rect">
-            <a:avLst/>
-          </a:prstGeom>
-          <a:noFill/>
-        </p:spPr>
-        <p:txBody>
-          <a:bodyPr wrap="square">
-            <a:spAutoFit/>
-          </a:bodyPr>
-          <a:lstStyle/>
-          <a:p>
-            <a:pPr algn="l">
-              <a:spcAft>
-                <a:spcPts val="300"/>
-              </a:spcAft>
-            </a:pPr>
-            <a:r>
-              <a:rPr sz="1000" b="1">
-                <a:solidFill>
-                  <a:srgbClr val="C9A227"/>
-                </a:solidFill>
-                <a:latin typeface="Calibri"/>
-              </a:rPr>
-              <a:t>000025-33</a:t>
-            </a:r>
-          </a:p>
-        </p:txBody>
-      </p:sp>
-      <p:sp>
-        <p:nvSpPr>
-          <p:cNvPr id="23" name="TextBox 22"/>
-          <p:cNvSpPr txBox="1"/>
-          <p:nvPr/>
-        </p:nvSpPr>
-        <p:spPr>
-          <a:xfrm>
-            <a:off x="9802368" y="1261872"/>
-            <a:ext cx="2121408" cy="219456"/>
-          </a:xfrm>
-          <a:prstGeom prst="rect">
-            <a:avLst/>
-          </a:prstGeom>
-          <a:noFill/>
-        </p:spPr>
-        <p:txBody>
-          <a:bodyPr wrap="square">
-            <a:spAutoFit/>
-          </a:bodyPr>
-          <a:lstStyle/>
-          <a:p>
-            <a:pPr algn="l">
-              <a:spcAft>
-                <a:spcPts val="300"/>
-              </a:spcAft>
-            </a:pPr>
-            <a:r>
-              <a:rPr sz="1200" b="1">
-                <a:solidFill>
-                  <a:srgbClr val="0D3B66"/>
-                </a:solidFill>
-                <a:latin typeface="Calibri"/>
-              </a:rPr>
-              <a:t>Salida ARROW</a:t>
-            </a:r>
-          </a:p>
-        </p:txBody>
-      </p:sp>
-      <p:sp>
-        <p:nvSpPr>
-          <p:cNvPr id="24" name="TextBox 23"/>
-          <p:cNvSpPr txBox="1"/>
-          <p:nvPr/>
-        </p:nvSpPr>
-        <p:spPr>
-          <a:xfrm>
-            <a:off x="9802368" y="1463040"/>
-            <a:ext cx="2121408" cy="182880"/>
-          </a:xfrm>
-          <a:prstGeom prst="rect">
-            <a:avLst/>
-          </a:prstGeom>
-          <a:noFill/>
-        </p:spPr>
-        <p:txBody>
-          <a:bodyPr wrap="square">
-            <a:spAutoFit/>
-          </a:bodyPr>
-          <a:lstStyle/>
-          <a:p>
-            <a:pPr algn="l">
-              <a:spcAft>
-                <a:spcPts val="300"/>
-              </a:spcAft>
-            </a:pPr>
-            <a:r>
-              <a:rPr sz="1000" b="0">
-                <a:solidFill>
-                  <a:srgbClr val="5A5A5A"/>
-                </a:solidFill>
-                <a:latin typeface="Calibri"/>
-              </a:rPr>
-              <a:t>residual</a:t>
-            </a:r>
-          </a:p>
-        </p:txBody>
-      </p:sp>
-      <p:sp>
-        <p:nvSpPr>
-          <p:cNvPr id="25" name="Rounded Rectangle 24"/>
-          <p:cNvSpPr/>
-          <p:nvPr/>
-        </p:nvSpPr>
-        <p:spPr>
-          <a:xfrm>
-            <a:off x="201168" y="1792224"/>
-            <a:ext cx="7973568" cy="3822191"/>
-          </a:xfrm>
-          <a:prstGeom prst="roundRect">
-            <a:avLst>
-              <a:gd name="adj" fmla="val 8000"/>
-            </a:avLst>
-          </a:prstGeom>
-          <a:solidFill>
-            <a:srgbClr val="F5F7FA"/>
-          </a:solidFill>
-          <a:ln>
-            <a:noFill/>
-          </a:ln>
-        </p:spPr>
-        <p:style>
-          <a:lnRef idx="1">
-            <a:schemeClr val="accent1"/>
-          </a:lnRef>
-          <a:fillRef idx="3">
-            <a:schemeClr val="accent1"/>
-          </a:fillRef>
-          <a:effectRef idx="2">
-            <a:schemeClr val="accent1"/>
-          </a:effectRef>
-          <a:fontRef idx="minor">
-            <a:schemeClr val="lt1"/>
-          </a:fontRef>
-        </p:style>
-        <p:txBody>
-          <a:bodyPr rtlCol="0" anchor="ctr"/>
-          <a:lstStyle/>
-          <a:p>
-            <a:pPr algn="ctr"/>
-          </a:p>
-        </p:txBody>
-      </p:sp>
-      <p:pic>
-        <p:nvPicPr>
-          <p:cNvPr id="26" name="Picture 25" descr="mam_mensual_may_ago.png"/>
-          <p:cNvPicPr>
-            <a:picLocks noChangeAspect="1"/>
-          </p:cNvPicPr>
-          <p:nvPr/>
-        </p:nvPicPr>
-        <p:blipFill>
-          <a:blip r:embed="rId3"/>
-          <a:stretch>
-            <a:fillRect/>
-          </a:stretch>
-        </p:blipFill>
-        <p:spPr>
-          <a:xfrm>
-            <a:off x="329184" y="1865376"/>
-            <a:ext cx="7717536" cy="3777531"/>
-          </a:xfrm>
-          <a:prstGeom prst="rect">
-            <a:avLst/>
-          </a:prstGeom>
-        </p:spPr>
-      </p:pic>
-      <p:sp>
-        <p:nvSpPr>
-          <p:cNvPr id="27" name="Rounded Rectangle 26"/>
-          <p:cNvSpPr/>
-          <p:nvPr/>
-        </p:nvSpPr>
-        <p:spPr>
-          <a:xfrm>
-            <a:off x="8302752" y="1792224"/>
-            <a:ext cx="3675887" cy="3822191"/>
-          </a:xfrm>
-          <a:prstGeom prst="roundRect">
-            <a:avLst>
-              <a:gd name="adj" fmla="val 8000"/>
-            </a:avLst>
-          </a:prstGeom>
-          <a:solidFill>
-            <a:srgbClr val="FFFFFF"/>
-          </a:solidFill>
-          <a:ln w="6350">
-            <a:solidFill>
-              <a:srgbClr val="1F77B4"/>
-            </a:solidFill>
-          </a:ln>
-        </p:spPr>
-        <p:style>
-          <a:lnRef idx="1">
-            <a:schemeClr val="accent1"/>
-          </a:lnRef>
-          <a:fillRef idx="3">
-            <a:schemeClr val="accent1"/>
-          </a:fillRef>
-          <a:effectRef idx="2">
-            <a:schemeClr val="accent1"/>
-          </a:effectRef>
-          <a:fontRef idx="minor">
-            <a:schemeClr val="lt1"/>
-          </a:fontRef>
-        </p:style>
-        <p:txBody>
-          <a:bodyPr rtlCol="0" anchor="ctr"/>
-          <a:lstStyle/>
-          <a:p>
-            <a:pPr algn="ctr"/>
-          </a:p>
-        </p:txBody>
-      </p:sp>
-      <p:sp>
-        <p:nvSpPr>
-          <p:cNvPr id="28" name="TextBox 27"/>
-          <p:cNvSpPr txBox="1"/>
-          <p:nvPr/>
-        </p:nvSpPr>
-        <p:spPr>
-          <a:xfrm>
-            <a:off x="8430768" y="1847088"/>
-            <a:ext cx="3419856" cy="201168"/>
-          </a:xfrm>
-          <a:prstGeom prst="rect">
-            <a:avLst/>
-          </a:prstGeom>
-          <a:noFill/>
-        </p:spPr>
-        <p:txBody>
-          <a:bodyPr wrap="square">
-            <a:spAutoFit/>
-          </a:bodyPr>
-          <a:lstStyle/>
-          <a:p>
-            <a:pPr algn="l">
-              <a:spcAft>
-                <a:spcPts val="300"/>
-              </a:spcAft>
-            </a:pPr>
-            <a:r>
-              <a:rPr sz="1100" b="1">
-                <a:solidFill>
-                  <a:srgbClr val="1F77B4"/>
-                </a:solidFill>
-                <a:latin typeface="Calibri"/>
-              </a:rPr>
-              <a:t>JULIO · último mes cerrado</a:t>
-            </a:r>
-          </a:p>
-        </p:txBody>
-      </p:sp>
-      <p:sp>
-        <p:nvSpPr>
-          <p:cNvPr id="29" name="TextBox 28"/>
-          <p:cNvSpPr txBox="1"/>
-          <p:nvPr/>
-        </p:nvSpPr>
-        <p:spPr>
-          <a:xfrm>
-            <a:off x="8430768" y="2048256"/>
-            <a:ext cx="3419856" cy="256032"/>
-          </a:xfrm>
-          <a:prstGeom prst="rect">
-            <a:avLst/>
-          </a:prstGeom>
-          <a:noFill/>
-        </p:spPr>
-        <p:txBody>
-          <a:bodyPr wrap="square">
-            <a:spAutoFit/>
-          </a:bodyPr>
-          <a:lstStyle/>
-          <a:p>
-            <a:pPr algn="l">
-              <a:spcAft>
-                <a:spcPts val="300"/>
-              </a:spcAft>
-            </a:pPr>
-            <a:r>
-              <a:rPr sz="1200" b="0">
-                <a:solidFill>
-                  <a:srgbClr val="5A5A5A"/>
-                </a:solidFill>
-                <a:latin typeface="Calibri"/>
-              </a:rPr>
-              <a:t>El recinto sumó 10.356 m³</a:t>
-            </a:r>
-          </a:p>
-        </p:txBody>
-      </p:sp>
-      <p:sp>
-        <p:nvSpPr>
-          <p:cNvPr id="30" name="Rounded Rectangle 29"/>
-          <p:cNvSpPr/>
-          <p:nvPr/>
-        </p:nvSpPr>
-        <p:spPr>
-          <a:xfrm>
-            <a:off x="8430768" y="2359152"/>
-            <a:ext cx="3419856" cy="603504"/>
-          </a:xfrm>
-          <a:prstGeom prst="roundRect">
-            <a:avLst>
-              <a:gd name="adj" fmla="val 8000"/>
-            </a:avLst>
-          </a:prstGeom>
-          <a:solidFill>
-            <a:srgbClr val="F5F7FA"/>
-          </a:solidFill>
-          <a:ln w="6350">
-            <a:solidFill>
-              <a:srgbClr val="0D3B66"/>
-            </a:solidFill>
-          </a:ln>
-        </p:spPr>
-        <p:style>
-          <a:lnRef idx="1">
-            <a:schemeClr val="accent1"/>
-          </a:lnRef>
-          <a:fillRef idx="3">
-            <a:schemeClr val="accent1"/>
-          </a:fillRef>
-          <a:effectRef idx="2">
-            <a:schemeClr val="accent1"/>
-          </a:effectRef>
-          <a:fontRef idx="minor">
-            <a:schemeClr val="lt1"/>
-          </a:fontRef>
-        </p:style>
-        <p:txBody>
-          <a:bodyPr rtlCol="0" anchor="ctr"/>
-          <a:lstStyle/>
-          <a:p>
-            <a:pPr algn="ctr"/>
-          </a:p>
-        </p:txBody>
-      </p:sp>
-      <p:sp>
-        <p:nvSpPr>
-          <p:cNvPr id="31" name="TextBox 30"/>
-          <p:cNvSpPr txBox="1"/>
-          <p:nvPr/>
-        </p:nvSpPr>
-        <p:spPr>
-          <a:xfrm>
-            <a:off x="8540496" y="2395728"/>
-            <a:ext cx="3200400" cy="182880"/>
-          </a:xfrm>
-          <a:prstGeom prst="rect">
-            <a:avLst/>
-          </a:prstGeom>
-          <a:noFill/>
-        </p:spPr>
-        <p:txBody>
-          <a:bodyPr wrap="square">
-            <a:spAutoFit/>
-          </a:bodyPr>
-          <a:lstStyle/>
-          <a:p>
-            <a:pPr algn="l">
-              <a:spcAft>
-                <a:spcPts val="300"/>
-              </a:spcAft>
-            </a:pPr>
-            <a:r>
-              <a:rPr sz="1100" b="1">
-                <a:solidFill>
-                  <a:srgbClr val="0D3B66"/>
-                </a:solidFill>
-                <a:latin typeface="Calibri"/>
-              </a:rPr>
-              <a:t>000025-08  Placa Bancaria</a:t>
-            </a:r>
-          </a:p>
-        </p:txBody>
-      </p:sp>
-      <p:sp>
-        <p:nvSpPr>
-          <p:cNvPr id="32" name="TextBox 31"/>
-          <p:cNvSpPr txBox="1"/>
-          <p:nvPr/>
-        </p:nvSpPr>
-        <p:spPr>
-          <a:xfrm>
-            <a:off x="8540496" y="2615184"/>
-            <a:ext cx="3200400" cy="274320"/>
-          </a:xfrm>
-          <a:prstGeom prst="rect">
-            <a:avLst/>
-          </a:prstGeom>
-          <a:noFill/>
-        </p:spPr>
-        <p:txBody>
-          <a:bodyPr wrap="square">
-            <a:spAutoFit/>
-          </a:bodyPr>
-          <a:lstStyle/>
-          <a:p>
-            <a:pPr algn="l">
-              <a:spcAft>
-                <a:spcPts val="300"/>
-              </a:spcAft>
-            </a:pPr>
-            <a:r>
-              <a:rPr sz="1500" b="1">
-                <a:solidFill>
-                  <a:srgbClr val="0D3B66"/>
-                </a:solidFill>
-                <a:latin typeface="Calibri"/>
-              </a:rPr>
-              <a:t>7.084 m³    68 %</a:t>
-            </a:r>
-          </a:p>
-        </p:txBody>
-      </p:sp>
-      <p:sp>
-        <p:nvSpPr>
-          <p:cNvPr id="33" name="Rounded Rectangle 32"/>
-          <p:cNvSpPr/>
-          <p:nvPr/>
-        </p:nvSpPr>
-        <p:spPr>
-          <a:xfrm>
-            <a:off x="8430768" y="2999232"/>
-            <a:ext cx="3419856" cy="603504"/>
-          </a:xfrm>
-          <a:prstGeom prst="roundRect">
-            <a:avLst>
-              <a:gd name="adj" fmla="val 8000"/>
-            </a:avLst>
-          </a:prstGeom>
-          <a:solidFill>
-            <a:srgbClr val="F5F7FA"/>
-          </a:solidFill>
-          <a:ln w="6350">
-            <a:solidFill>
-              <a:srgbClr val="1F77B4"/>
-            </a:solidFill>
-          </a:ln>
-        </p:spPr>
-        <p:style>
-          <a:lnRef idx="1">
-            <a:schemeClr val="accent1"/>
-          </a:lnRef>
-          <a:fillRef idx="3">
-            <a:schemeClr val="accent1"/>
-          </a:fillRef>
-          <a:effectRef idx="2">
-            <a:schemeClr val="accent1"/>
-          </a:effectRef>
-          <a:fontRef idx="minor">
-            <a:schemeClr val="lt1"/>
-          </a:fontRef>
-        </p:style>
-        <p:txBody>
-          <a:bodyPr rtlCol="0" anchor="ctr"/>
-          <a:lstStyle/>
-          <a:p>
-            <a:pPr algn="ctr"/>
-          </a:p>
-        </p:txBody>
-      </p:sp>
-      <p:sp>
-        <p:nvSpPr>
-          <p:cNvPr id="34" name="TextBox 33"/>
-          <p:cNvSpPr txBox="1"/>
-          <p:nvPr/>
-        </p:nvSpPr>
-        <p:spPr>
-          <a:xfrm>
-            <a:off x="8540496" y="3035808"/>
-            <a:ext cx="3200400" cy="182880"/>
-          </a:xfrm>
-          <a:prstGeom prst="rect">
-            <a:avLst/>
-          </a:prstGeom>
-          <a:noFill/>
-        </p:spPr>
-        <p:txBody>
-          <a:bodyPr wrap="square">
-            <a:spAutoFit/>
-          </a:bodyPr>
-          <a:lstStyle/>
-          <a:p>
-            <a:pPr algn="l">
-              <a:spcAft>
-                <a:spcPts val="300"/>
-              </a:spcAft>
-            </a:pPr>
-            <a:r>
-              <a:rPr sz="1100" b="1">
-                <a:solidFill>
-                  <a:srgbClr val="1F77B4"/>
-                </a:solidFill>
-                <a:latin typeface="Calibri"/>
-              </a:rPr>
-              <a:t>000025-10  Ripley</a:t>
-            </a:r>
-          </a:p>
-        </p:txBody>
-      </p:sp>
-      <p:sp>
-        <p:nvSpPr>
-          <p:cNvPr id="35" name="TextBox 34"/>
-          <p:cNvSpPr txBox="1"/>
-          <p:nvPr/>
-        </p:nvSpPr>
-        <p:spPr>
-          <a:xfrm>
-            <a:off x="8540496" y="3255264"/>
-            <a:ext cx="3200400" cy="274320"/>
-          </a:xfrm>
-          <a:prstGeom prst="rect">
-            <a:avLst/>
-          </a:prstGeom>
-          <a:noFill/>
-        </p:spPr>
-        <p:txBody>
-          <a:bodyPr wrap="square">
-            <a:spAutoFit/>
-          </a:bodyPr>
-          <a:lstStyle/>
-          <a:p>
-            <a:pPr algn="l">
-              <a:spcAft>
-                <a:spcPts val="300"/>
-              </a:spcAft>
-            </a:pPr>
-            <a:r>
-              <a:rPr sz="1500" b="1">
-                <a:solidFill>
-                  <a:srgbClr val="0D3B66"/>
-                </a:solidFill>
-                <a:latin typeface="Calibri"/>
-              </a:rPr>
-              <a:t>3.245 m³    31 %</a:t>
-            </a:r>
-          </a:p>
-        </p:txBody>
-      </p:sp>
-      <p:sp>
-        <p:nvSpPr>
-          <p:cNvPr id="36" name="Rounded Rectangle 35"/>
-          <p:cNvSpPr/>
-          <p:nvPr/>
-        </p:nvSpPr>
-        <p:spPr>
-          <a:xfrm>
-            <a:off x="8430768" y="3639312"/>
-            <a:ext cx="3419856" cy="603504"/>
-          </a:xfrm>
-          <a:prstGeom prst="roundRect">
-            <a:avLst>
-              <a:gd name="adj" fmla="val 8000"/>
-            </a:avLst>
-          </a:prstGeom>
-          <a:solidFill>
-            <a:srgbClr val="F5F7FA"/>
-          </a:solidFill>
-          <a:ln w="6350">
-            <a:solidFill>
-              <a:srgbClr val="7BA3C9"/>
-            </a:solidFill>
-          </a:ln>
-        </p:spPr>
-        <p:style>
-          <a:lnRef idx="1">
-            <a:schemeClr val="accent1"/>
-          </a:lnRef>
-          <a:fillRef idx="3">
-            <a:schemeClr val="accent1"/>
-          </a:fillRef>
-          <a:effectRef idx="2">
-            <a:schemeClr val="accent1"/>
-          </a:effectRef>
-          <a:fontRef idx="minor">
-            <a:schemeClr val="lt1"/>
-          </a:fontRef>
-        </p:style>
-        <p:txBody>
-          <a:bodyPr rtlCol="0" anchor="ctr"/>
-          <a:lstStyle/>
-          <a:p>
-            <a:pPr algn="ctr"/>
-          </a:p>
-        </p:txBody>
-      </p:sp>
-      <p:sp>
-        <p:nvSpPr>
-          <p:cNvPr id="37" name="TextBox 36"/>
-          <p:cNvSpPr txBox="1"/>
-          <p:nvPr/>
-        </p:nvSpPr>
-        <p:spPr>
-          <a:xfrm>
-            <a:off x="8540496" y="3675888"/>
-            <a:ext cx="3200400" cy="182880"/>
-          </a:xfrm>
-          <a:prstGeom prst="rect">
-            <a:avLst/>
-          </a:prstGeom>
-          <a:noFill/>
-        </p:spPr>
-        <p:txBody>
-          <a:bodyPr wrap="square">
-            <a:spAutoFit/>
-          </a:bodyPr>
-          <a:lstStyle/>
-          <a:p>
-            <a:pPr algn="l">
-              <a:spcAft>
-                <a:spcPts val="300"/>
-              </a:spcAft>
-            </a:pPr>
-            <a:r>
-              <a:rPr sz="1100" b="1">
-                <a:solidFill>
-                  <a:srgbClr val="7BA3C9"/>
-                </a:solidFill>
-                <a:latin typeface="Calibri"/>
-              </a:rPr>
-              <a:t>000025-32  Pasillo Técnico</a:t>
-            </a:r>
-          </a:p>
-        </p:txBody>
-      </p:sp>
-      <p:sp>
-        <p:nvSpPr>
-          <p:cNvPr id="38" name="TextBox 37"/>
-          <p:cNvSpPr txBox="1"/>
-          <p:nvPr/>
-        </p:nvSpPr>
-        <p:spPr>
-          <a:xfrm>
-            <a:off x="8540496" y="3895344"/>
-            <a:ext cx="3200400" cy="274320"/>
-          </a:xfrm>
-          <a:prstGeom prst="rect">
-            <a:avLst/>
-          </a:prstGeom>
-          <a:noFill/>
-        </p:spPr>
-        <p:txBody>
-          <a:bodyPr wrap="square">
-            <a:spAutoFit/>
-          </a:bodyPr>
-          <a:lstStyle/>
-          <a:p>
-            <a:pPr algn="l">
-              <a:spcAft>
-                <a:spcPts val="300"/>
-              </a:spcAft>
-            </a:pPr>
-            <a:r>
-              <a:rPr sz="1500" b="1">
-                <a:solidFill>
-                  <a:srgbClr val="0D3B66"/>
-                </a:solidFill>
-                <a:latin typeface="Calibri"/>
-              </a:rPr>
-              <a:t>26 m³    0 %</a:t>
-            </a:r>
-          </a:p>
-        </p:txBody>
-      </p:sp>
-      <p:sp>
-        <p:nvSpPr>
-          <p:cNvPr id="39" name="Rounded Rectangle 38"/>
-          <p:cNvSpPr/>
-          <p:nvPr/>
-        </p:nvSpPr>
-        <p:spPr>
-          <a:xfrm>
-            <a:off x="8430768" y="4279392"/>
-            <a:ext cx="3419856" cy="603504"/>
-          </a:xfrm>
-          <a:prstGeom prst="roundRect">
-            <a:avLst>
-              <a:gd name="adj" fmla="val 8000"/>
-            </a:avLst>
-          </a:prstGeom>
-          <a:solidFill>
-            <a:srgbClr val="F5F7FA"/>
-          </a:solidFill>
-          <a:ln w="6350">
-            <a:solidFill>
-              <a:srgbClr val="5A8C6E"/>
-            </a:solidFill>
-          </a:ln>
-        </p:spPr>
-        <p:style>
-          <a:lnRef idx="1">
-            <a:schemeClr val="accent1"/>
-          </a:lnRef>
-          <a:fillRef idx="3">
-            <a:schemeClr val="accent1"/>
-          </a:fillRef>
-          <a:effectRef idx="2">
-            <a:schemeClr val="accent1"/>
-          </a:effectRef>
-          <a:fontRef idx="minor">
-            <a:schemeClr val="lt1"/>
-          </a:fontRef>
-        </p:style>
-        <p:txBody>
-          <a:bodyPr rtlCol="0" anchor="ctr"/>
-          <a:lstStyle/>
-          <a:p>
-            <a:pPr algn="ctr"/>
-          </a:p>
-        </p:txBody>
-      </p:sp>
-      <p:sp>
-        <p:nvSpPr>
-          <p:cNvPr id="40" name="TextBox 39"/>
-          <p:cNvSpPr txBox="1"/>
-          <p:nvPr/>
-        </p:nvSpPr>
-        <p:spPr>
-          <a:xfrm>
-            <a:off x="8540496" y="4315968"/>
-            <a:ext cx="3200400" cy="182880"/>
-          </a:xfrm>
-          <a:prstGeom prst="rect">
-            <a:avLst/>
-          </a:prstGeom>
-          <a:noFill/>
-        </p:spPr>
-        <p:txBody>
-          <a:bodyPr wrap="square">
-            <a:spAutoFit/>
-          </a:bodyPr>
-          <a:lstStyle/>
-          <a:p>
-            <a:pPr algn="l">
-              <a:spcAft>
-                <a:spcPts val="300"/>
-              </a:spcAft>
-            </a:pPr>
-            <a:r>
-              <a:rPr sz="1100" b="1">
-                <a:solidFill>
-                  <a:srgbClr val="5A8C6E"/>
-                </a:solidFill>
-                <a:latin typeface="Calibri"/>
-              </a:rPr>
-              <a:t>000025-33  Salida ARROW</a:t>
-            </a:r>
-          </a:p>
-        </p:txBody>
-      </p:sp>
-      <p:sp>
-        <p:nvSpPr>
-          <p:cNvPr id="41" name="TextBox 40"/>
-          <p:cNvSpPr txBox="1"/>
-          <p:nvPr/>
-        </p:nvSpPr>
-        <p:spPr>
-          <a:xfrm>
-            <a:off x="8540496" y="4535424"/>
-            <a:ext cx="3200400" cy="274320"/>
-          </a:xfrm>
-          <a:prstGeom prst="rect">
-            <a:avLst/>
-          </a:prstGeom>
-          <a:noFill/>
-        </p:spPr>
-        <p:txBody>
-          <a:bodyPr wrap="square">
-            <a:spAutoFit/>
-          </a:bodyPr>
-          <a:lstStyle/>
-          <a:p>
-            <a:pPr algn="l">
-              <a:spcAft>
-                <a:spcPts val="300"/>
-              </a:spcAft>
-            </a:pPr>
-            <a:r>
-              <a:rPr sz="1500" b="1">
-                <a:solidFill>
-                  <a:srgbClr val="0D3B66"/>
-                </a:solidFill>
-                <a:latin typeface="Calibri"/>
-              </a:rPr>
-              <a:t>1 m³    0 %</a:t>
-            </a:r>
-          </a:p>
-        </p:txBody>
-      </p:sp>
-      <p:sp>
-        <p:nvSpPr>
-          <p:cNvPr id="42" name="Rounded Rectangle 41"/>
-          <p:cNvSpPr/>
-          <p:nvPr/>
-        </p:nvSpPr>
-        <p:spPr>
-          <a:xfrm>
-            <a:off x="8430768" y="4919472"/>
-            <a:ext cx="3419856" cy="603504"/>
-          </a:xfrm>
-          <a:prstGeom prst="roundRect">
-            <a:avLst>
-              <a:gd name="adj" fmla="val 8000"/>
-            </a:avLst>
-          </a:prstGeom>
-          <a:solidFill>
-            <a:srgbClr val="F5F7FA"/>
-          </a:solidFill>
-          <a:ln w="6350">
-            <a:solidFill>
-              <a:srgbClr val="C9A227"/>
-            </a:solidFill>
-          </a:ln>
-        </p:spPr>
-        <p:style>
-          <a:lnRef idx="1">
-            <a:schemeClr val="accent1"/>
-          </a:lnRef>
-          <a:fillRef idx="3">
-            <a:schemeClr val="accent1"/>
-          </a:fillRef>
-          <a:effectRef idx="2">
-            <a:schemeClr val="accent1"/>
-          </a:effectRef>
-          <a:fontRef idx="minor">
-            <a:schemeClr val="lt1"/>
-          </a:fontRef>
-        </p:style>
-        <p:txBody>
-          <a:bodyPr rtlCol="0" anchor="ctr"/>
-          <a:lstStyle/>
-          <a:p>
-            <a:pPr algn="ctr"/>
-          </a:p>
-        </p:txBody>
-      </p:sp>
-      <p:sp>
-        <p:nvSpPr>
-          <p:cNvPr id="43" name="TextBox 42"/>
-          <p:cNvSpPr txBox="1"/>
-          <p:nvPr/>
-        </p:nvSpPr>
-        <p:spPr>
-          <a:xfrm>
-            <a:off x="8540496" y="4956048"/>
-            <a:ext cx="3200400" cy="182880"/>
-          </a:xfrm>
-          <a:prstGeom prst="rect">
-            <a:avLst/>
-          </a:prstGeom>
-          <a:noFill/>
-        </p:spPr>
-        <p:txBody>
-          <a:bodyPr wrap="square">
-            <a:spAutoFit/>
-          </a:bodyPr>
-          <a:lstStyle/>
-          <a:p>
-            <a:pPr algn="l">
-              <a:spcAft>
-                <a:spcPts val="300"/>
-              </a:spcAft>
-            </a:pPr>
-            <a:r>
-              <a:rPr sz="1100" b="1">
-                <a:solidFill>
-                  <a:srgbClr val="C9A227"/>
-                </a:solidFill>
-                <a:latin typeface="Calibri"/>
-              </a:rPr>
-              <a:t>000025-09  Falabella</a:t>
             </a:r>
           </a:p>
         </p:txBody>

</xml_diff>

<commit_message>
Rebuild recorrido PPT with combined MAE equipos-consumo slide
Co-authored-by: anibaloperacionesWes <anibaloperacionesWes@users.noreply.github.com>
</commit_message>
<xml_diff>
--- a/reports/Parque_Arauco/TMP_7MALLS/entrega_diego_anibal/Recorrido_ejecutivo_PA_MAE_20260817.pptx
+++ b/reports/Parque_Arauco/TMP_7MALLS/entrega_diego_anibal/Recorrido_ejecutivo_PA_MAE_20260817.pptx
@@ -9,7 +9,6 @@
     <p:sldId id="257" r:id="rId8"/>
     <p:sldId id="258" r:id="rId9"/>
     <p:sldId id="259" r:id="rId10"/>
-    <p:sldId id="260" r:id="rId11"/>
   </p:sldIdLst>
   <p:sldSz cx="12191695" cy="6858000" type="screen4x3"/>
   <p:notesSz cx="6858000" cy="9144000"/>
@@ -3470,7 +3469,7 @@
                 </a:solidFill>
                 <a:latin typeface="Calibri"/>
               </a:rPr>
-              <a:t>MAE  ·  1. Equipos instalados</a:t>
+              <a:t>MAE  ·  Equipos y consumo</a:t>
             </a:r>
           </a:p>
         </p:txBody>
@@ -3509,7 +3508,7 @@
                 </a:solidFill>
                 <a:latin typeface="Calibri"/>
               </a:rPr>
-              <a:t>4 puntos activos WES   |   Mall Arauco Estación   |   Recepción 20/10/2025</a:t>
+              <a:t>Mall Arauco Estación   |   4 puntos WES   |   01/05/2026 – 17/08/2026</a:t>
             </a:r>
           </a:p>
         </p:txBody>
@@ -3522,8 +3521,297 @@
         </p:nvSpPr>
         <p:spPr>
           <a:xfrm>
-            <a:off x="256032" y="1078992"/>
-            <a:ext cx="5742432" cy="1993392"/>
+            <a:off x="201168" y="1024128"/>
+            <a:ext cx="2866644" cy="658368"/>
+          </a:xfrm>
+          <a:prstGeom prst="roundRect">
+            <a:avLst>
+              <a:gd name="adj" fmla="val 8000"/>
+            </a:avLst>
+          </a:prstGeom>
+          <a:solidFill>
+            <a:srgbClr val="F5F7FA"/>
+          </a:solidFill>
+          <a:ln w="6350">
+            <a:solidFill>
+              <a:srgbClr val="0D3B66"/>
+            </a:solidFill>
+          </a:ln>
+        </p:spPr>
+        <p:style>
+          <a:lnRef idx="1">
+            <a:schemeClr val="accent1"/>
+          </a:lnRef>
+          <a:fillRef idx="3">
+            <a:schemeClr val="accent1"/>
+          </a:fillRef>
+          <a:effectRef idx="2">
+            <a:schemeClr val="accent1"/>
+          </a:effectRef>
+          <a:fontRef idx="minor">
+            <a:schemeClr val="lt1"/>
+          </a:fontRef>
+        </p:style>
+        <p:txBody>
+          <a:bodyPr rtlCol="0" anchor="ctr"/>
+          <a:lstStyle/>
+          <a:p>
+            <a:pPr algn="ctr"/>
+          </a:p>
+        </p:txBody>
+      </p:sp>
+      <p:sp>
+        <p:nvSpPr>
+          <p:cNvPr id="8" name="TextBox 7"/>
+          <p:cNvSpPr txBox="1"/>
+          <p:nvPr/>
+        </p:nvSpPr>
+        <p:spPr>
+          <a:xfrm>
+            <a:off x="310896" y="1060704"/>
+            <a:ext cx="2665475" cy="201168"/>
+          </a:xfrm>
+          <a:prstGeom prst="rect">
+            <a:avLst/>
+          </a:prstGeom>
+          <a:noFill/>
+        </p:spPr>
+        <p:txBody>
+          <a:bodyPr wrap="square">
+            <a:spAutoFit/>
+          </a:bodyPr>
+          <a:lstStyle/>
+          <a:p>
+            <a:pPr algn="l">
+              <a:spcAft>
+                <a:spcPts val="300"/>
+              </a:spcAft>
+            </a:pPr>
+            <a:r>
+              <a:rPr sz="1000" b="1">
+                <a:solidFill>
+                  <a:srgbClr val="C9A227"/>
+                </a:solidFill>
+                <a:latin typeface="Calibri"/>
+              </a:rPr>
+              <a:t>000025-01</a:t>
+            </a:r>
+          </a:p>
+        </p:txBody>
+      </p:sp>
+      <p:sp>
+        <p:nvSpPr>
+          <p:cNvPr id="9" name="TextBox 8"/>
+          <p:cNvSpPr txBox="1"/>
+          <p:nvPr/>
+        </p:nvSpPr>
+        <p:spPr>
+          <a:xfrm>
+            <a:off x="310896" y="1261872"/>
+            <a:ext cx="2665475" cy="219456"/>
+          </a:xfrm>
+          <a:prstGeom prst="rect">
+            <a:avLst/>
+          </a:prstGeom>
+          <a:noFill/>
+        </p:spPr>
+        <p:txBody>
+          <a:bodyPr wrap="square">
+            <a:spAutoFit/>
+          </a:bodyPr>
+          <a:lstStyle/>
+          <a:p>
+            <a:pPr algn="l">
+              <a:spcAft>
+                <a:spcPts val="300"/>
+              </a:spcAft>
+            </a:pPr>
+            <a:r>
+              <a:rPr sz="1300" b="1">
+                <a:solidFill>
+                  <a:srgbClr val="0D3B66"/>
+                </a:solidFill>
+                <a:latin typeface="Calibri"/>
+              </a:rPr>
+              <a:t>Estanque Norte</a:t>
+            </a:r>
+          </a:p>
+        </p:txBody>
+      </p:sp>
+      <p:sp>
+        <p:nvSpPr>
+          <p:cNvPr id="10" name="TextBox 9"/>
+          <p:cNvSpPr txBox="1"/>
+          <p:nvPr/>
+        </p:nvSpPr>
+        <p:spPr>
+          <a:xfrm>
+            <a:off x="310896" y="1463040"/>
+            <a:ext cx="2665475" cy="182880"/>
+          </a:xfrm>
+          <a:prstGeom prst="rect">
+            <a:avLst/>
+          </a:prstGeom>
+          <a:noFill/>
+        </p:spPr>
+        <p:txBody>
+          <a:bodyPr wrap="square">
+            <a:spAutoFit/>
+          </a:bodyPr>
+          <a:lstStyle/>
+          <a:p>
+            <a:pPr algn="l">
+              <a:spcAft>
+                <a:spcPts val="300"/>
+              </a:spcAft>
+            </a:pPr>
+            <a:r>
+              <a:rPr sz="1000" b="0">
+                <a:solidFill>
+                  <a:srgbClr val="5A5A5A"/>
+                </a:solidFill>
+                <a:latin typeface="Calibri"/>
+              </a:rPr>
+              <a:t>locales mall</a:t>
+            </a:r>
+          </a:p>
+        </p:txBody>
+      </p:sp>
+      <p:sp>
+        <p:nvSpPr>
+          <p:cNvPr id="11" name="Rounded Rectangle 10"/>
+          <p:cNvSpPr/>
+          <p:nvPr/>
+        </p:nvSpPr>
+        <p:spPr>
+          <a:xfrm>
+            <a:off x="3177540" y="1024128"/>
+            <a:ext cx="2866644" cy="658368"/>
+          </a:xfrm>
+          <a:prstGeom prst="roundRect">
+            <a:avLst>
+              <a:gd name="adj" fmla="val 8000"/>
+            </a:avLst>
+          </a:prstGeom>
+          <a:solidFill>
+            <a:srgbClr val="F5F7FA"/>
+          </a:solidFill>
+          <a:ln w="6350">
+            <a:solidFill>
+              <a:srgbClr val="C45C26"/>
+            </a:solidFill>
+          </a:ln>
+        </p:spPr>
+        <p:style>
+          <a:lnRef idx="1">
+            <a:schemeClr val="accent1"/>
+          </a:lnRef>
+          <a:fillRef idx="3">
+            <a:schemeClr val="accent1"/>
+          </a:fillRef>
+          <a:effectRef idx="2">
+            <a:schemeClr val="accent1"/>
+          </a:effectRef>
+          <a:fontRef idx="minor">
+            <a:schemeClr val="lt1"/>
+          </a:fontRef>
+        </p:style>
+        <p:txBody>
+          <a:bodyPr rtlCol="0" anchor="ctr"/>
+          <a:lstStyle/>
+          <a:p>
+            <a:pPr algn="ctr"/>
+          </a:p>
+        </p:txBody>
+      </p:sp>
+      <p:sp>
+        <p:nvSpPr>
+          <p:cNvPr id="12" name="TextBox 11"/>
+          <p:cNvSpPr txBox="1"/>
+          <p:nvPr/>
+        </p:nvSpPr>
+        <p:spPr>
+          <a:xfrm>
+            <a:off x="3287268" y="1060704"/>
+            <a:ext cx="2665475" cy="201168"/>
+          </a:xfrm>
+          <a:prstGeom prst="rect">
+            <a:avLst/>
+          </a:prstGeom>
+          <a:noFill/>
+        </p:spPr>
+        <p:txBody>
+          <a:bodyPr wrap="square">
+            <a:spAutoFit/>
+          </a:bodyPr>
+          <a:lstStyle/>
+          <a:p>
+            <a:pPr algn="l">
+              <a:spcAft>
+                <a:spcPts val="300"/>
+              </a:spcAft>
+            </a:pPr>
+            <a:r>
+              <a:rPr sz="1000" b="1">
+                <a:solidFill>
+                  <a:srgbClr val="C9A227"/>
+                </a:solidFill>
+                <a:latin typeface="Calibri"/>
+              </a:rPr>
+              <a:t>000025-07</a:t>
+            </a:r>
+          </a:p>
+        </p:txBody>
+      </p:sp>
+      <p:sp>
+        <p:nvSpPr>
+          <p:cNvPr id="13" name="TextBox 12"/>
+          <p:cNvSpPr txBox="1"/>
+          <p:nvPr/>
+        </p:nvSpPr>
+        <p:spPr>
+          <a:xfrm>
+            <a:off x="3287268" y="1261872"/>
+            <a:ext cx="2665475" cy="219456"/>
+          </a:xfrm>
+          <a:prstGeom prst="rect">
+            <a:avLst/>
+          </a:prstGeom>
+          <a:noFill/>
+        </p:spPr>
+        <p:txBody>
+          <a:bodyPr wrap="square">
+            <a:spAutoFit/>
+          </a:bodyPr>
+          <a:lstStyle/>
+          <a:p>
+            <a:pPr algn="l">
+              <a:spcAft>
+                <a:spcPts val="300"/>
+              </a:spcAft>
+            </a:pPr>
+            <a:r>
+              <a:rPr sz="1300" b="1">
+                <a:solidFill>
+                  <a:srgbClr val="0D3B66"/>
+                </a:solidFill>
+                <a:latin typeface="Calibri"/>
+              </a:rPr>
+              <a:t>Pizza Hut</a:t>
+            </a:r>
+          </a:p>
+        </p:txBody>
+      </p:sp>
+      <p:sp>
+        <p:nvSpPr>
+          <p:cNvPr id="14" name="Rounded Rectangle 13"/>
+          <p:cNvSpPr/>
+          <p:nvPr/>
+        </p:nvSpPr>
+        <p:spPr>
+          <a:xfrm>
+            <a:off x="6153912" y="1024128"/>
+            <a:ext cx="2866644" cy="658368"/>
           </a:xfrm>
           <a:prstGeom prst="roundRect">
             <a:avLst>
@@ -3563,14 +3851,14 @@
       </p:sp>
       <p:sp>
         <p:nvSpPr>
-          <p:cNvPr id="8" name="TextBox 7"/>
+          <p:cNvPr id="15" name="TextBox 14"/>
           <p:cNvSpPr txBox="1"/>
           <p:nvPr/>
         </p:nvSpPr>
         <p:spPr>
           <a:xfrm>
-            <a:off x="457200" y="1243584"/>
-            <a:ext cx="5349240" cy="292608"/>
+            <a:off x="6263640" y="1060704"/>
+            <a:ext cx="2665475" cy="201168"/>
           </a:xfrm>
           <a:prstGeom prst="rect">
             <a:avLst/>
@@ -3589,27 +3877,27 @@
               </a:spcAft>
             </a:pPr>
             <a:r>
-              <a:rPr sz="1200" b="1">
+              <a:rPr sz="1000" b="1">
                 <a:solidFill>
                   <a:srgbClr val="C9A227"/>
                 </a:solidFill>
                 <a:latin typeface="Calibri"/>
               </a:rPr>
-              <a:t>000025-01</a:t>
-            </a:r>
-          </a:p>
-        </p:txBody>
-      </p:sp>
-      <p:sp>
-        <p:nvSpPr>
-          <p:cNvPr id="9" name="TextBox 8"/>
+              <a:t>000025-19</a:t>
+            </a:r>
+          </a:p>
+        </p:txBody>
+      </p:sp>
+      <p:sp>
+        <p:nvSpPr>
+          <p:cNvPr id="16" name="TextBox 15"/>
           <p:cNvSpPr txBox="1"/>
           <p:nvPr/>
         </p:nvSpPr>
         <p:spPr>
           <a:xfrm>
-            <a:off x="457200" y="1554480"/>
-            <a:ext cx="5349240" cy="640080"/>
+            <a:off x="6263640" y="1261872"/>
+            <a:ext cx="2665475" cy="219456"/>
           </a:xfrm>
           <a:prstGeom prst="rect">
             <a:avLst/>
@@ -3628,27 +3916,27 @@
               </a:spcAft>
             </a:pPr>
             <a:r>
-              <a:rPr sz="2200" b="1">
+              <a:rPr sz="1300" b="1">
                 <a:solidFill>
                   <a:srgbClr val="0D3B66"/>
                 </a:solidFill>
                 <a:latin typeface="Calibri"/>
               </a:rPr>
-              <a:t>Estanque Norte Locales Mall</a:t>
-            </a:r>
-          </a:p>
-        </p:txBody>
-      </p:sp>
-      <p:sp>
-        <p:nvSpPr>
-          <p:cNvPr id="10" name="TextBox 9"/>
+              <a:t>Estanque Sur</a:t>
+            </a:r>
+          </a:p>
+        </p:txBody>
+      </p:sp>
+      <p:sp>
+        <p:nvSpPr>
+          <p:cNvPr id="17" name="TextBox 16"/>
           <p:cNvSpPr txBox="1"/>
           <p:nvPr/>
         </p:nvSpPr>
         <p:spPr>
           <a:xfrm>
-            <a:off x="457200" y="2286000"/>
-            <a:ext cx="5349240" cy="502920"/>
+            <a:off x="6263640" y="1463040"/>
+            <a:ext cx="2665475" cy="182880"/>
           </a:xfrm>
           <a:prstGeom prst="rect">
             <a:avLst/>
@@ -3667,27 +3955,596 @@
               </a:spcAft>
             </a:pPr>
             <a:r>
-              <a:rPr sz="1400" b="0">
+              <a:rPr sz="1000" b="0">
                 <a:solidFill>
                   <a:srgbClr val="5A5A5A"/>
                 </a:solidFill>
                 <a:latin typeface="Calibri"/>
               </a:rPr>
-              <a:t>Estanque Norte — locales mall</a:t>
-            </a:r>
-          </a:p>
-        </p:txBody>
-      </p:sp>
-      <p:sp>
-        <p:nvSpPr>
-          <p:cNvPr id="11" name="Rounded Rectangle 10"/>
+              <a:t>sala de bomba</a:t>
+            </a:r>
+          </a:p>
+        </p:txBody>
+      </p:sp>
+      <p:sp>
+        <p:nvSpPr>
+          <p:cNvPr id="18" name="Rounded Rectangle 17"/>
           <p:cNvSpPr/>
           <p:nvPr/>
         </p:nvSpPr>
         <p:spPr>
           <a:xfrm>
-            <a:off x="6199632" y="1078992"/>
-            <a:ext cx="5742432" cy="1993392"/>
+            <a:off x="9130284" y="1024128"/>
+            <a:ext cx="2866644" cy="658368"/>
+          </a:xfrm>
+          <a:prstGeom prst="roundRect">
+            <a:avLst>
+              <a:gd name="adj" fmla="val 8000"/>
+            </a:avLst>
+          </a:prstGeom>
+          <a:solidFill>
+            <a:srgbClr val="F5F7FA"/>
+          </a:solidFill>
+          <a:ln w="6350">
+            <a:solidFill>
+              <a:srgbClr val="7BA3C9"/>
+            </a:solidFill>
+          </a:ln>
+        </p:spPr>
+        <p:style>
+          <a:lnRef idx="1">
+            <a:schemeClr val="accent1"/>
+          </a:lnRef>
+          <a:fillRef idx="3">
+            <a:schemeClr val="accent1"/>
+          </a:fillRef>
+          <a:effectRef idx="2">
+            <a:schemeClr val="accent1"/>
+          </a:effectRef>
+          <a:fontRef idx="minor">
+            <a:schemeClr val="lt1"/>
+          </a:fontRef>
+        </p:style>
+        <p:txBody>
+          <a:bodyPr rtlCol="0" anchor="ctr"/>
+          <a:lstStyle/>
+          <a:p>
+            <a:pPr algn="ctr"/>
+          </a:p>
+        </p:txBody>
+      </p:sp>
+      <p:sp>
+        <p:nvSpPr>
+          <p:cNvPr id="19" name="TextBox 18"/>
+          <p:cNvSpPr txBox="1"/>
+          <p:nvPr/>
+        </p:nvSpPr>
+        <p:spPr>
+          <a:xfrm>
+            <a:off x="9240012" y="1060704"/>
+            <a:ext cx="2665475" cy="201168"/>
+          </a:xfrm>
+          <a:prstGeom prst="rect">
+            <a:avLst/>
+          </a:prstGeom>
+          <a:noFill/>
+        </p:spPr>
+        <p:txBody>
+          <a:bodyPr wrap="square">
+            <a:spAutoFit/>
+          </a:bodyPr>
+          <a:lstStyle/>
+          <a:p>
+            <a:pPr algn="l">
+              <a:spcAft>
+                <a:spcPts val="300"/>
+              </a:spcAft>
+            </a:pPr>
+            <a:r>
+              <a:rPr sz="1000" b="1">
+                <a:solidFill>
+                  <a:srgbClr val="C9A227"/>
+                </a:solidFill>
+                <a:latin typeface="Calibri"/>
+              </a:rPr>
+              <a:t>000025-04</a:t>
+            </a:r>
+          </a:p>
+        </p:txBody>
+      </p:sp>
+      <p:sp>
+        <p:nvSpPr>
+          <p:cNvPr id="20" name="TextBox 19"/>
+          <p:cNvSpPr txBox="1"/>
+          <p:nvPr/>
+        </p:nvSpPr>
+        <p:spPr>
+          <a:xfrm>
+            <a:off x="9240012" y="1261872"/>
+            <a:ext cx="2665475" cy="219456"/>
+          </a:xfrm>
+          <a:prstGeom prst="rect">
+            <a:avLst/>
+          </a:prstGeom>
+          <a:noFill/>
+        </p:spPr>
+        <p:txBody>
+          <a:bodyPr wrap="square">
+            <a:spAutoFit/>
+          </a:bodyPr>
+          <a:lstStyle/>
+          <a:p>
+            <a:pPr algn="l">
+              <a:spcAft>
+                <a:spcPts val="300"/>
+              </a:spcAft>
+            </a:pPr>
+            <a:r>
+              <a:rPr sz="1300" b="1">
+                <a:solidFill>
+                  <a:srgbClr val="0D3B66"/>
+                </a:solidFill>
+                <a:latin typeface="Calibri"/>
+              </a:rPr>
+              <a:t>Baños Públicos</a:t>
+            </a:r>
+          </a:p>
+        </p:txBody>
+      </p:sp>
+      <p:sp>
+        <p:nvSpPr>
+          <p:cNvPr id="21" name="Rounded Rectangle 20"/>
+          <p:cNvSpPr/>
+          <p:nvPr/>
+        </p:nvSpPr>
+        <p:spPr>
+          <a:xfrm>
+            <a:off x="201168" y="1792224"/>
+            <a:ext cx="7973568" cy="3822191"/>
+          </a:xfrm>
+          <a:prstGeom prst="roundRect">
+            <a:avLst>
+              <a:gd name="adj" fmla="val 8000"/>
+            </a:avLst>
+          </a:prstGeom>
+          <a:solidFill>
+            <a:srgbClr val="F5F7FA"/>
+          </a:solidFill>
+          <a:ln>
+            <a:noFill/>
+          </a:ln>
+        </p:spPr>
+        <p:style>
+          <a:lnRef idx="1">
+            <a:schemeClr val="accent1"/>
+          </a:lnRef>
+          <a:fillRef idx="3">
+            <a:schemeClr val="accent1"/>
+          </a:fillRef>
+          <a:effectRef idx="2">
+            <a:schemeClr val="accent1"/>
+          </a:effectRef>
+          <a:fontRef idx="minor">
+            <a:schemeClr val="lt1"/>
+          </a:fontRef>
+        </p:style>
+        <p:txBody>
+          <a:bodyPr rtlCol="0" anchor="ctr"/>
+          <a:lstStyle/>
+          <a:p>
+            <a:pPr algn="ctr"/>
+          </a:p>
+        </p:txBody>
+      </p:sp>
+      <p:pic>
+        <p:nvPicPr>
+          <p:cNvPr id="22" name="Picture 21" descr="mae_mensual_may_ago.png"/>
+          <p:cNvPicPr>
+            <a:picLocks noChangeAspect="1"/>
+          </p:cNvPicPr>
+          <p:nvPr/>
+        </p:nvPicPr>
+        <p:blipFill>
+          <a:blip r:embed="rId3"/>
+          <a:stretch>
+            <a:fillRect/>
+          </a:stretch>
+        </p:blipFill>
+        <p:spPr>
+          <a:xfrm>
+            <a:off x="329184" y="1865376"/>
+            <a:ext cx="7717536" cy="3777531"/>
+          </a:xfrm>
+          <a:prstGeom prst="rect">
+            <a:avLst/>
+          </a:prstGeom>
+        </p:spPr>
+      </p:pic>
+      <p:sp>
+        <p:nvSpPr>
+          <p:cNvPr id="23" name="Rounded Rectangle 22"/>
+          <p:cNvSpPr/>
+          <p:nvPr/>
+        </p:nvSpPr>
+        <p:spPr>
+          <a:xfrm>
+            <a:off x="8302752" y="1792224"/>
+            <a:ext cx="3675887" cy="3822191"/>
+          </a:xfrm>
+          <a:prstGeom prst="roundRect">
+            <a:avLst>
+              <a:gd name="adj" fmla="val 8000"/>
+            </a:avLst>
+          </a:prstGeom>
+          <a:solidFill>
+            <a:srgbClr val="FFFFFF"/>
+          </a:solidFill>
+          <a:ln w="6350">
+            <a:solidFill>
+              <a:srgbClr val="1F77B4"/>
+            </a:solidFill>
+          </a:ln>
+        </p:spPr>
+        <p:style>
+          <a:lnRef idx="1">
+            <a:schemeClr val="accent1"/>
+          </a:lnRef>
+          <a:fillRef idx="3">
+            <a:schemeClr val="accent1"/>
+          </a:fillRef>
+          <a:effectRef idx="2">
+            <a:schemeClr val="accent1"/>
+          </a:effectRef>
+          <a:fontRef idx="minor">
+            <a:schemeClr val="lt1"/>
+          </a:fontRef>
+        </p:style>
+        <p:txBody>
+          <a:bodyPr rtlCol="0" anchor="ctr"/>
+          <a:lstStyle/>
+          <a:p>
+            <a:pPr algn="ctr"/>
+          </a:p>
+        </p:txBody>
+      </p:sp>
+      <p:sp>
+        <p:nvSpPr>
+          <p:cNvPr id="24" name="TextBox 23"/>
+          <p:cNvSpPr txBox="1"/>
+          <p:nvPr/>
+        </p:nvSpPr>
+        <p:spPr>
+          <a:xfrm>
+            <a:off x="8430768" y="1847088"/>
+            <a:ext cx="3419856" cy="201168"/>
+          </a:xfrm>
+          <a:prstGeom prst="rect">
+            <a:avLst/>
+          </a:prstGeom>
+          <a:noFill/>
+        </p:spPr>
+        <p:txBody>
+          <a:bodyPr wrap="square">
+            <a:spAutoFit/>
+          </a:bodyPr>
+          <a:lstStyle/>
+          <a:p>
+            <a:pPr algn="l">
+              <a:spcAft>
+                <a:spcPts val="300"/>
+              </a:spcAft>
+            </a:pPr>
+            <a:r>
+              <a:rPr sz="1100" b="1">
+                <a:solidFill>
+                  <a:srgbClr val="1F77B4"/>
+                </a:solidFill>
+                <a:latin typeface="Calibri"/>
+              </a:rPr>
+              <a:t>JULIO · último mes cerrado</a:t>
+            </a:r>
+          </a:p>
+        </p:txBody>
+      </p:sp>
+      <p:sp>
+        <p:nvSpPr>
+          <p:cNvPr id="25" name="TextBox 24"/>
+          <p:cNvSpPr txBox="1"/>
+          <p:nvPr/>
+        </p:nvSpPr>
+        <p:spPr>
+          <a:xfrm>
+            <a:off x="8430768" y="2048256"/>
+            <a:ext cx="3419856" cy="256032"/>
+          </a:xfrm>
+          <a:prstGeom prst="rect">
+            <a:avLst/>
+          </a:prstGeom>
+          <a:noFill/>
+        </p:spPr>
+        <p:txBody>
+          <a:bodyPr wrap="square">
+            <a:spAutoFit/>
+          </a:bodyPr>
+          <a:lstStyle/>
+          <a:p>
+            <a:pPr algn="l">
+              <a:spcAft>
+                <a:spcPts val="300"/>
+              </a:spcAft>
+            </a:pPr>
+            <a:r>
+              <a:rPr sz="1200" b="0">
+                <a:solidFill>
+                  <a:srgbClr val="5A5A5A"/>
+                </a:solidFill>
+                <a:latin typeface="Calibri"/>
+              </a:rPr>
+              <a:t>El recinto sumó 3.074 m³</a:t>
+            </a:r>
+          </a:p>
+        </p:txBody>
+      </p:sp>
+      <p:sp>
+        <p:nvSpPr>
+          <p:cNvPr id="26" name="Rounded Rectangle 25"/>
+          <p:cNvSpPr/>
+          <p:nvPr/>
+        </p:nvSpPr>
+        <p:spPr>
+          <a:xfrm>
+            <a:off x="8430768" y="2340864"/>
+            <a:ext cx="3419856" cy="768096"/>
+          </a:xfrm>
+          <a:prstGeom prst="roundRect">
+            <a:avLst>
+              <a:gd name="adj" fmla="val 8000"/>
+            </a:avLst>
+          </a:prstGeom>
+          <a:solidFill>
+            <a:srgbClr val="F5F7FA"/>
+          </a:solidFill>
+          <a:ln w="6350">
+            <a:solidFill>
+              <a:srgbClr val="C45C26"/>
+            </a:solidFill>
+          </a:ln>
+        </p:spPr>
+        <p:style>
+          <a:lnRef idx="1">
+            <a:schemeClr val="accent1"/>
+          </a:lnRef>
+          <a:fillRef idx="3">
+            <a:schemeClr val="accent1"/>
+          </a:fillRef>
+          <a:effectRef idx="2">
+            <a:schemeClr val="accent1"/>
+          </a:effectRef>
+          <a:fontRef idx="minor">
+            <a:schemeClr val="lt1"/>
+          </a:fontRef>
+        </p:style>
+        <p:txBody>
+          <a:bodyPr rtlCol="0" anchor="ctr"/>
+          <a:lstStyle/>
+          <a:p>
+            <a:pPr algn="ctr"/>
+          </a:p>
+        </p:txBody>
+      </p:sp>
+      <p:sp>
+        <p:nvSpPr>
+          <p:cNvPr id="27" name="TextBox 26"/>
+          <p:cNvSpPr txBox="1"/>
+          <p:nvPr/>
+        </p:nvSpPr>
+        <p:spPr>
+          <a:xfrm>
+            <a:off x="8540496" y="2414016"/>
+            <a:ext cx="3200400" cy="219456"/>
+          </a:xfrm>
+          <a:prstGeom prst="rect">
+            <a:avLst/>
+          </a:prstGeom>
+          <a:noFill/>
+        </p:spPr>
+        <p:txBody>
+          <a:bodyPr wrap="square">
+            <a:spAutoFit/>
+          </a:bodyPr>
+          <a:lstStyle/>
+          <a:p>
+            <a:pPr algn="l">
+              <a:spcAft>
+                <a:spcPts val="300"/>
+              </a:spcAft>
+            </a:pPr>
+            <a:r>
+              <a:rPr sz="1300" b="1">
+                <a:solidFill>
+                  <a:srgbClr val="C45C26"/>
+                </a:solidFill>
+                <a:latin typeface="Calibri"/>
+              </a:rPr>
+              <a:t>Pizza Hut</a:t>
+            </a:r>
+          </a:p>
+        </p:txBody>
+      </p:sp>
+      <p:sp>
+        <p:nvSpPr>
+          <p:cNvPr id="28" name="TextBox 27"/>
+          <p:cNvSpPr txBox="1"/>
+          <p:nvPr/>
+        </p:nvSpPr>
+        <p:spPr>
+          <a:xfrm>
+            <a:off x="8540496" y="2688336"/>
+            <a:ext cx="3200400" cy="329184"/>
+          </a:xfrm>
+          <a:prstGeom prst="rect">
+            <a:avLst/>
+          </a:prstGeom>
+          <a:noFill/>
+        </p:spPr>
+        <p:txBody>
+          <a:bodyPr wrap="square">
+            <a:spAutoFit/>
+          </a:bodyPr>
+          <a:lstStyle/>
+          <a:p>
+            <a:pPr algn="l">
+              <a:spcAft>
+                <a:spcPts val="300"/>
+              </a:spcAft>
+            </a:pPr>
+            <a:r>
+              <a:rPr sz="1600" b="1">
+                <a:solidFill>
+                  <a:srgbClr val="0D3B66"/>
+                </a:solidFill>
+                <a:latin typeface="Calibri"/>
+              </a:rPr>
+              <a:t>1.169 m³    38 %</a:t>
+            </a:r>
+          </a:p>
+        </p:txBody>
+      </p:sp>
+      <p:sp>
+        <p:nvSpPr>
+          <p:cNvPr id="29" name="Rounded Rectangle 28"/>
+          <p:cNvSpPr/>
+          <p:nvPr/>
+        </p:nvSpPr>
+        <p:spPr>
+          <a:xfrm>
+            <a:off x="8430768" y="3145536"/>
+            <a:ext cx="3419856" cy="768096"/>
+          </a:xfrm>
+          <a:prstGeom prst="roundRect">
+            <a:avLst>
+              <a:gd name="adj" fmla="val 8000"/>
+            </a:avLst>
+          </a:prstGeom>
+          <a:solidFill>
+            <a:srgbClr val="F5F7FA"/>
+          </a:solidFill>
+          <a:ln w="6350">
+            <a:solidFill>
+              <a:srgbClr val="0D3B66"/>
+            </a:solidFill>
+          </a:ln>
+        </p:spPr>
+        <p:style>
+          <a:lnRef idx="1">
+            <a:schemeClr val="accent1"/>
+          </a:lnRef>
+          <a:fillRef idx="3">
+            <a:schemeClr val="accent1"/>
+          </a:fillRef>
+          <a:effectRef idx="2">
+            <a:schemeClr val="accent1"/>
+          </a:effectRef>
+          <a:fontRef idx="minor">
+            <a:schemeClr val="lt1"/>
+          </a:fontRef>
+        </p:style>
+        <p:txBody>
+          <a:bodyPr rtlCol="0" anchor="ctr"/>
+          <a:lstStyle/>
+          <a:p>
+            <a:pPr algn="ctr"/>
+          </a:p>
+        </p:txBody>
+      </p:sp>
+      <p:sp>
+        <p:nvSpPr>
+          <p:cNvPr id="30" name="TextBox 29"/>
+          <p:cNvSpPr txBox="1"/>
+          <p:nvPr/>
+        </p:nvSpPr>
+        <p:spPr>
+          <a:xfrm>
+            <a:off x="8540496" y="3218688"/>
+            <a:ext cx="3200400" cy="219456"/>
+          </a:xfrm>
+          <a:prstGeom prst="rect">
+            <a:avLst/>
+          </a:prstGeom>
+          <a:noFill/>
+        </p:spPr>
+        <p:txBody>
+          <a:bodyPr wrap="square">
+            <a:spAutoFit/>
+          </a:bodyPr>
+          <a:lstStyle/>
+          <a:p>
+            <a:pPr algn="l">
+              <a:spcAft>
+                <a:spcPts val="300"/>
+              </a:spcAft>
+            </a:pPr>
+            <a:r>
+              <a:rPr sz="1300" b="1">
+                <a:solidFill>
+                  <a:srgbClr val="0D3B66"/>
+                </a:solidFill>
+                <a:latin typeface="Calibri"/>
+              </a:rPr>
+              <a:t>Estanque Norte</a:t>
+            </a:r>
+          </a:p>
+        </p:txBody>
+      </p:sp>
+      <p:sp>
+        <p:nvSpPr>
+          <p:cNvPr id="31" name="TextBox 30"/>
+          <p:cNvSpPr txBox="1"/>
+          <p:nvPr/>
+        </p:nvSpPr>
+        <p:spPr>
+          <a:xfrm>
+            <a:off x="8540496" y="3493008"/>
+            <a:ext cx="3200400" cy="329184"/>
+          </a:xfrm>
+          <a:prstGeom prst="rect">
+            <a:avLst/>
+          </a:prstGeom>
+          <a:noFill/>
+        </p:spPr>
+        <p:txBody>
+          <a:bodyPr wrap="square">
+            <a:spAutoFit/>
+          </a:bodyPr>
+          <a:lstStyle/>
+          <a:p>
+            <a:pPr algn="l">
+              <a:spcAft>
+                <a:spcPts val="300"/>
+              </a:spcAft>
+            </a:pPr>
+            <a:r>
+              <a:rPr sz="1600" b="1">
+                <a:solidFill>
+                  <a:srgbClr val="0D3B66"/>
+                </a:solidFill>
+                <a:latin typeface="Calibri"/>
+              </a:rPr>
+              <a:t>886 m³    29 %</a:t>
+            </a:r>
+          </a:p>
+        </p:txBody>
+      </p:sp>
+      <p:sp>
+        <p:nvSpPr>
+          <p:cNvPr id="32" name="Rounded Rectangle 31"/>
+          <p:cNvSpPr/>
+          <p:nvPr/>
+        </p:nvSpPr>
+        <p:spPr>
+          <a:xfrm>
+            <a:off x="8430768" y="3950208"/>
+            <a:ext cx="3419856" cy="768096"/>
           </a:xfrm>
           <a:prstGeom prst="roundRect">
             <a:avLst>
@@ -3727,14 +4584,14 @@
       </p:sp>
       <p:sp>
         <p:nvSpPr>
-          <p:cNvPr id="12" name="TextBox 11"/>
+          <p:cNvPr id="33" name="TextBox 32"/>
           <p:cNvSpPr txBox="1"/>
           <p:nvPr/>
         </p:nvSpPr>
         <p:spPr>
           <a:xfrm>
-            <a:off x="6400800" y="1243584"/>
-            <a:ext cx="5349240" cy="292608"/>
+            <a:off x="8540496" y="4023360"/>
+            <a:ext cx="3200400" cy="219456"/>
           </a:xfrm>
           <a:prstGeom prst="rect">
             <a:avLst/>
@@ -3753,27 +4610,27 @@
               </a:spcAft>
             </a:pPr>
             <a:r>
-              <a:rPr sz="1200" b="1">
-                <a:solidFill>
-                  <a:srgbClr val="C9A227"/>
+              <a:rPr sz="1300" b="1">
+                <a:solidFill>
+                  <a:srgbClr val="1F77B4"/>
                 </a:solidFill>
                 <a:latin typeface="Calibri"/>
               </a:rPr>
-              <a:t>000025-04</a:t>
-            </a:r>
-          </a:p>
-        </p:txBody>
-      </p:sp>
-      <p:sp>
-        <p:nvSpPr>
-          <p:cNvPr id="13" name="TextBox 12"/>
+              <a:t>Estanque Sur</a:t>
+            </a:r>
+          </a:p>
+        </p:txBody>
+      </p:sp>
+      <p:sp>
+        <p:nvSpPr>
+          <p:cNvPr id="34" name="TextBox 33"/>
           <p:cNvSpPr txBox="1"/>
           <p:nvPr/>
         </p:nvSpPr>
         <p:spPr>
           <a:xfrm>
-            <a:off x="6400800" y="1554480"/>
-            <a:ext cx="5349240" cy="640080"/>
+            <a:off x="8540496" y="4297680"/>
+            <a:ext cx="3200400" cy="329184"/>
           </a:xfrm>
           <a:prstGeom prst="rect">
             <a:avLst/>
@@ -3792,27 +4649,74 @@
               </a:spcAft>
             </a:pPr>
             <a:r>
-              <a:rPr sz="2200" b="1">
+              <a:rPr sz="1600" b="1">
                 <a:solidFill>
                   <a:srgbClr val="0D3B66"/>
                 </a:solidFill>
                 <a:latin typeface="Calibri"/>
               </a:rPr>
-              <a:t>Baños Públicos</a:t>
-            </a:r>
-          </a:p>
-        </p:txBody>
-      </p:sp>
-      <p:sp>
-        <p:nvSpPr>
-          <p:cNvPr id="14" name="TextBox 13"/>
+              <a:t>802 m³    26 %</a:t>
+            </a:r>
+          </a:p>
+        </p:txBody>
+      </p:sp>
+      <p:sp>
+        <p:nvSpPr>
+          <p:cNvPr id="35" name="Rounded Rectangle 34"/>
+          <p:cNvSpPr/>
+          <p:nvPr/>
+        </p:nvSpPr>
+        <p:spPr>
+          <a:xfrm>
+            <a:off x="8430768" y="4754880"/>
+            <a:ext cx="3419856" cy="768096"/>
+          </a:xfrm>
+          <a:prstGeom prst="roundRect">
+            <a:avLst>
+              <a:gd name="adj" fmla="val 8000"/>
+            </a:avLst>
+          </a:prstGeom>
+          <a:solidFill>
+            <a:srgbClr val="F5F7FA"/>
+          </a:solidFill>
+          <a:ln w="6350">
+            <a:solidFill>
+              <a:srgbClr val="7BA3C9"/>
+            </a:solidFill>
+          </a:ln>
+        </p:spPr>
+        <p:style>
+          <a:lnRef idx="1">
+            <a:schemeClr val="accent1"/>
+          </a:lnRef>
+          <a:fillRef idx="3">
+            <a:schemeClr val="accent1"/>
+          </a:fillRef>
+          <a:effectRef idx="2">
+            <a:schemeClr val="accent1"/>
+          </a:effectRef>
+          <a:fontRef idx="minor">
+            <a:schemeClr val="lt1"/>
+          </a:fontRef>
+        </p:style>
+        <p:txBody>
+          <a:bodyPr rtlCol="0" anchor="ctr"/>
+          <a:lstStyle/>
+          <a:p>
+            <a:pPr algn="ctr"/>
+          </a:p>
+        </p:txBody>
+      </p:sp>
+      <p:sp>
+        <p:nvSpPr>
+          <p:cNvPr id="36" name="TextBox 35"/>
           <p:cNvSpPr txBox="1"/>
           <p:nvPr/>
         </p:nvSpPr>
         <p:spPr>
           <a:xfrm>
-            <a:off x="6400800" y="2286000"/>
-            <a:ext cx="5349240" cy="502920"/>
+            <a:off x="8540496" y="4828032"/>
+            <a:ext cx="3200400" cy="219456"/>
           </a:xfrm>
           <a:prstGeom prst="rect">
             <a:avLst/>
@@ -3831,74 +4735,27 @@
               </a:spcAft>
             </a:pPr>
             <a:r>
-              <a:rPr sz="1400" b="0">
-                <a:solidFill>
-                  <a:srgbClr val="5A5A5A"/>
+              <a:rPr sz="1300" b="1">
+                <a:solidFill>
+                  <a:srgbClr val="7BA3C9"/>
                 </a:solidFill>
                 <a:latin typeface="Calibri"/>
               </a:rPr>
-              <a:t>Baños públicos del recinto</a:t>
-            </a:r>
-          </a:p>
-        </p:txBody>
-      </p:sp>
-      <p:sp>
-        <p:nvSpPr>
-          <p:cNvPr id="15" name="Rounded Rectangle 14"/>
-          <p:cNvSpPr/>
-          <p:nvPr/>
-        </p:nvSpPr>
-        <p:spPr>
-          <a:xfrm>
-            <a:off x="256032" y="3246120"/>
-            <a:ext cx="5742432" cy="1993392"/>
-          </a:xfrm>
-          <a:prstGeom prst="roundRect">
-            <a:avLst>
-              <a:gd name="adj" fmla="val 8000"/>
-            </a:avLst>
-          </a:prstGeom>
-          <a:solidFill>
-            <a:srgbClr val="F5F7FA"/>
-          </a:solidFill>
-          <a:ln w="6350">
-            <a:solidFill>
-              <a:srgbClr val="1F77B4"/>
-            </a:solidFill>
-          </a:ln>
-        </p:spPr>
-        <p:style>
-          <a:lnRef idx="1">
-            <a:schemeClr val="accent1"/>
-          </a:lnRef>
-          <a:fillRef idx="3">
-            <a:schemeClr val="accent1"/>
-          </a:fillRef>
-          <a:effectRef idx="2">
-            <a:schemeClr val="accent1"/>
-          </a:effectRef>
-          <a:fontRef idx="minor">
-            <a:schemeClr val="lt1"/>
-          </a:fontRef>
-        </p:style>
-        <p:txBody>
-          <a:bodyPr rtlCol="0" anchor="ctr"/>
-          <a:lstStyle/>
-          <a:p>
-            <a:pPr algn="ctr"/>
-          </a:p>
-        </p:txBody>
-      </p:sp>
-      <p:sp>
-        <p:nvSpPr>
-          <p:cNvPr id="16" name="TextBox 15"/>
+              <a:t>Baños Públicos</a:t>
+            </a:r>
+          </a:p>
+        </p:txBody>
+      </p:sp>
+      <p:sp>
+        <p:nvSpPr>
+          <p:cNvPr id="37" name="TextBox 36"/>
           <p:cNvSpPr txBox="1"/>
           <p:nvPr/>
         </p:nvSpPr>
         <p:spPr>
           <a:xfrm>
-            <a:off x="457200" y="3410712"/>
-            <a:ext cx="5349240" cy="292608"/>
+            <a:off x="8540496" y="5102352"/>
+            <a:ext cx="3200400" cy="329184"/>
           </a:xfrm>
           <a:prstGeom prst="rect">
             <a:avLst/>
@@ -3917,269 +4774,27 @@
               </a:spcAft>
             </a:pPr>
             <a:r>
-              <a:rPr sz="1200" b="1">
-                <a:solidFill>
-                  <a:srgbClr val="C9A227"/>
+              <a:rPr sz="1600" b="1">
+                <a:solidFill>
+                  <a:srgbClr val="0D3B66"/>
                 </a:solidFill>
                 <a:latin typeface="Calibri"/>
               </a:rPr>
-              <a:t>000025-07</a:t>
-            </a:r>
-          </a:p>
-        </p:txBody>
-      </p:sp>
-      <p:sp>
-        <p:nvSpPr>
-          <p:cNvPr id="17" name="TextBox 16"/>
-          <p:cNvSpPr txBox="1"/>
-          <p:nvPr/>
-        </p:nvSpPr>
-        <p:spPr>
-          <a:xfrm>
-            <a:off x="457200" y="3721608"/>
-            <a:ext cx="5349240" cy="640080"/>
-          </a:xfrm>
-          <a:prstGeom prst="rect">
-            <a:avLst/>
-          </a:prstGeom>
-          <a:noFill/>
-        </p:spPr>
-        <p:txBody>
-          <a:bodyPr wrap="square">
-            <a:spAutoFit/>
-          </a:bodyPr>
-          <a:lstStyle/>
-          <a:p>
-            <a:pPr algn="l">
-              <a:spcAft>
-                <a:spcPts val="300"/>
-              </a:spcAft>
-            </a:pPr>
-            <a:r>
-              <a:rPr sz="2200" b="1">
-                <a:solidFill>
-                  <a:srgbClr val="0D3B66"/>
-                </a:solidFill>
-                <a:latin typeface="Calibri"/>
-              </a:rPr>
-              <a:t>Pizza Hut</a:t>
-            </a:r>
-          </a:p>
-        </p:txBody>
-      </p:sp>
-      <p:sp>
-        <p:nvSpPr>
-          <p:cNvPr id="18" name="TextBox 17"/>
-          <p:cNvSpPr txBox="1"/>
-          <p:nvPr/>
-        </p:nvSpPr>
-        <p:spPr>
-          <a:xfrm>
-            <a:off x="457200" y="4453128"/>
-            <a:ext cx="5349240" cy="502920"/>
-          </a:xfrm>
-          <a:prstGeom prst="rect">
-            <a:avLst/>
-          </a:prstGeom>
-          <a:noFill/>
-        </p:spPr>
-        <p:txBody>
-          <a:bodyPr wrap="square">
-            <a:spAutoFit/>
-          </a:bodyPr>
-          <a:lstStyle/>
-          <a:p>
-            <a:pPr algn="l">
-              <a:spcAft>
-                <a:spcPts val="300"/>
-              </a:spcAft>
-            </a:pPr>
-            <a:r>
-              <a:rPr sz="1400" b="0">
-                <a:solidFill>
-                  <a:srgbClr val="5A5A5A"/>
-                </a:solidFill>
-                <a:latin typeface="Calibri"/>
-              </a:rPr>
-              <a:t>Local Pizza Hut</a:t>
-            </a:r>
-          </a:p>
-        </p:txBody>
-      </p:sp>
-      <p:sp>
-        <p:nvSpPr>
-          <p:cNvPr id="19" name="Rounded Rectangle 18"/>
+              <a:t>217 m³    7 %</a:t>
+            </a:r>
+          </a:p>
+        </p:txBody>
+      </p:sp>
+      <p:sp>
+        <p:nvSpPr>
+          <p:cNvPr id="38" name="Rounded Rectangle 37"/>
           <p:cNvSpPr/>
           <p:nvPr/>
         </p:nvSpPr>
         <p:spPr>
           <a:xfrm>
-            <a:off x="6199632" y="3246120"/>
-            <a:ext cx="5742432" cy="1993392"/>
-          </a:xfrm>
-          <a:prstGeom prst="roundRect">
-            <a:avLst>
-              <a:gd name="adj" fmla="val 8000"/>
-            </a:avLst>
-          </a:prstGeom>
-          <a:solidFill>
-            <a:srgbClr val="F5F7FA"/>
-          </a:solidFill>
-          <a:ln w="6350">
-            <a:solidFill>
-              <a:srgbClr val="1F77B4"/>
-            </a:solidFill>
-          </a:ln>
-        </p:spPr>
-        <p:style>
-          <a:lnRef idx="1">
-            <a:schemeClr val="accent1"/>
-          </a:lnRef>
-          <a:fillRef idx="3">
-            <a:schemeClr val="accent1"/>
-          </a:fillRef>
-          <a:effectRef idx="2">
-            <a:schemeClr val="accent1"/>
-          </a:effectRef>
-          <a:fontRef idx="minor">
-            <a:schemeClr val="lt1"/>
-          </a:fontRef>
-        </p:style>
-        <p:txBody>
-          <a:bodyPr rtlCol="0" anchor="ctr"/>
-          <a:lstStyle/>
-          <a:p>
-            <a:pPr algn="ctr"/>
-          </a:p>
-        </p:txBody>
-      </p:sp>
-      <p:sp>
-        <p:nvSpPr>
-          <p:cNvPr id="20" name="TextBox 19"/>
-          <p:cNvSpPr txBox="1"/>
-          <p:nvPr/>
-        </p:nvSpPr>
-        <p:spPr>
-          <a:xfrm>
-            <a:off x="6400800" y="3410712"/>
-            <a:ext cx="5349240" cy="292608"/>
-          </a:xfrm>
-          <a:prstGeom prst="rect">
-            <a:avLst/>
-          </a:prstGeom>
-          <a:noFill/>
-        </p:spPr>
-        <p:txBody>
-          <a:bodyPr wrap="square">
-            <a:spAutoFit/>
-          </a:bodyPr>
-          <a:lstStyle/>
-          <a:p>
-            <a:pPr algn="l">
-              <a:spcAft>
-                <a:spcPts val="300"/>
-              </a:spcAft>
-            </a:pPr>
-            <a:r>
-              <a:rPr sz="1200" b="1">
-                <a:solidFill>
-                  <a:srgbClr val="C9A227"/>
-                </a:solidFill>
-                <a:latin typeface="Calibri"/>
-              </a:rPr>
-              <a:t>000025-19</a:t>
-            </a:r>
-          </a:p>
-        </p:txBody>
-      </p:sp>
-      <p:sp>
-        <p:nvSpPr>
-          <p:cNvPr id="21" name="TextBox 20"/>
-          <p:cNvSpPr txBox="1"/>
-          <p:nvPr/>
-        </p:nvSpPr>
-        <p:spPr>
-          <a:xfrm>
-            <a:off x="6400800" y="3721608"/>
-            <a:ext cx="5349240" cy="640080"/>
-          </a:xfrm>
-          <a:prstGeom prst="rect">
-            <a:avLst/>
-          </a:prstGeom>
-          <a:noFill/>
-        </p:spPr>
-        <p:txBody>
-          <a:bodyPr wrap="square">
-            <a:spAutoFit/>
-          </a:bodyPr>
-          <a:lstStyle/>
-          <a:p>
-            <a:pPr algn="l">
-              <a:spcAft>
-                <a:spcPts val="300"/>
-              </a:spcAft>
-            </a:pPr>
-            <a:r>
-              <a:rPr sz="2200" b="1">
-                <a:solidFill>
-                  <a:srgbClr val="0D3B66"/>
-                </a:solidFill>
-                <a:latin typeface="Calibri"/>
-              </a:rPr>
-              <a:t>Sala de Bomba Estanque Sur</a:t>
-            </a:r>
-          </a:p>
-        </p:txBody>
-      </p:sp>
-      <p:sp>
-        <p:nvSpPr>
-          <p:cNvPr id="22" name="TextBox 21"/>
-          <p:cNvSpPr txBox="1"/>
-          <p:nvPr/>
-        </p:nvSpPr>
-        <p:spPr>
-          <a:xfrm>
-            <a:off x="6400800" y="4453128"/>
-            <a:ext cx="5349240" cy="502920"/>
-          </a:xfrm>
-          <a:prstGeom prst="rect">
-            <a:avLst/>
-          </a:prstGeom>
-          <a:noFill/>
-        </p:spPr>
-        <p:txBody>
-          <a:bodyPr wrap="square">
-            <a:spAutoFit/>
-          </a:bodyPr>
-          <a:lstStyle/>
-          <a:p>
-            <a:pPr algn="l">
-              <a:spcAft>
-                <a:spcPts val="300"/>
-              </a:spcAft>
-            </a:pPr>
-            <a:r>
-              <a:rPr sz="1400" b="0">
-                <a:solidFill>
-                  <a:srgbClr val="5A5A5A"/>
-                </a:solidFill>
-                <a:latin typeface="Calibri"/>
-              </a:rPr>
-              <a:t>Sala de bomba — estanque sur</a:t>
-            </a:r>
-          </a:p>
-        </p:txBody>
-      </p:sp>
-      <p:sp>
-        <p:nvSpPr>
-          <p:cNvPr id="23" name="Rounded Rectangle 22"/>
-          <p:cNvSpPr/>
-          <p:nvPr/>
-        </p:nvSpPr>
-        <p:spPr>
-          <a:xfrm>
-            <a:off x="256032" y="5394960"/>
-            <a:ext cx="11686032" cy="1170432"/>
+            <a:off x="201168" y="5705856"/>
+            <a:ext cx="11795760" cy="438912"/>
           </a:xfrm>
           <a:prstGeom prst="roundRect">
             <a:avLst>
@@ -4219,14 +4834,14 @@
       </p:sp>
       <p:sp>
         <p:nvSpPr>
-          <p:cNvPr id="24" name="TextBox 23"/>
+          <p:cNvPr id="39" name="TextBox 38"/>
           <p:cNvSpPr txBox="1"/>
           <p:nvPr/>
         </p:nvSpPr>
         <p:spPr>
           <a:xfrm>
-            <a:off x="438912" y="5504688"/>
-            <a:ext cx="11338560" cy="256032"/>
+            <a:off x="329184" y="5779008"/>
+            <a:ext cx="11539728" cy="310896"/>
           </a:xfrm>
           <a:prstGeom prst="rect">
             <a:avLst/>
@@ -4245,27 +4860,27 @@
               </a:spcAft>
             </a:pPr>
             <a:r>
-              <a:rPr sz="1100" b="1">
-                <a:solidFill>
-                  <a:srgbClr val="C9A227"/>
+              <a:rPr sz="1100" b="0">
+                <a:solidFill>
+                  <a:srgbClr val="0D3B66"/>
                 </a:solidFill>
                 <a:latin typeface="Calibri"/>
               </a:rPr>
-              <a:t>RECINTO</a:t>
-            </a:r>
-          </a:p>
-        </p:txBody>
-      </p:sp>
-      <p:sp>
-        <p:nvSpPr>
-          <p:cNvPr id="25" name="TextBox 24"/>
+              <a:t>Recepción 20/10/2025  ·  Capacitación 18/02/2025  ·  medioambiente.dcl@parauco.com  ·  Sala de monitores MAE  ·  Sergio Fuenzalida — Analista Gestión Ambiental</a:t>
+            </a:r>
+          </a:p>
+        </p:txBody>
+      </p:sp>
+      <p:sp>
+        <p:nvSpPr>
+          <p:cNvPr id="40" name="TextBox 39"/>
           <p:cNvSpPr txBox="1"/>
           <p:nvPr/>
         </p:nvSpPr>
         <p:spPr>
           <a:xfrm>
-            <a:off x="438912" y="5779008"/>
-            <a:ext cx="11338560" cy="658368"/>
+            <a:off x="256032" y="6181344"/>
+            <a:ext cx="11704320" cy="566928"/>
           </a:xfrm>
           <a:prstGeom prst="rect">
             <a:avLst/>
@@ -4284,13 +4899,29 @@
               </a:spcAft>
             </a:pPr>
             <a:r>
-              <a:rPr sz="1300" b="0">
+              <a:rPr sz="1200" b="0">
                 <a:solidFill>
                   <a:srgbClr val="0D3B66"/>
                 </a:solidFill>
                 <a:latin typeface="Calibri"/>
               </a:rPr>
-              <a:t>Recepción 20/10/2025  ·  Capacitación 18/02/2025  ·  Usuarios: medioambiente.dcl@parauco.com  ·  Sala de monitores MAE  ·  Sergio Fuenzalida — Analista Gestión Ambiental</a:t>
+              <a:t>Mayo 5.107   ·   Junio 3.179   ·   Julio 3.074   ·   Agosto 1–17: 1.701   ·   proy. ago 3.101 m³.</a:t>
+            </a:r>
+          </a:p>
+          <a:p>
+            <a:pPr algn="l">
+              <a:spcAft>
+                <a:spcPts val="300"/>
+              </a:spcAft>
+            </a:pPr>
+            <a:r>
+              <a:rPr sz="1100" b="0">
+                <a:solidFill>
+                  <a:srgbClr val="5A5A5A"/>
+                </a:solidFill>
+                <a:latin typeface="Calibri"/>
+              </a:rPr>
+              <a:t>Mayo cierra más alto por Estanque Sur, antes de la reparación del 10/06.</a:t>
             </a:r>
           </a:p>
         </p:txBody>
@@ -4457,7 +5088,7 @@
                 </a:solidFill>
                 <a:latin typeface="Calibri"/>
               </a:rPr>
-              <a:t>MAE  ·  2. Consumo mensualizado</a:t>
+              <a:t>MAE  ·  Hallazgos</a:t>
             </a:r>
           </a:p>
         </p:txBody>
@@ -4496,7 +5127,7 @@
                 </a:solidFill>
                 <a:latin typeface="Calibri"/>
               </a:rPr>
-              <a:t>Suma de los 4 puntos WES   |   01/05/2026 – 17/08/2026   |   Agosto: a la fecha vs proyección al 31</a:t>
+              <a:t>Estanque Sur: reparación de presostatos (10/06)  ·  Estanque Norte: control nocturno</a:t>
             </a:r>
           </a:p>
         </p:txBody>
@@ -4509,8 +5140,133 @@
         </p:nvSpPr>
         <p:spPr>
           <a:xfrm>
-            <a:off x="201168" y="1024128"/>
-            <a:ext cx="7973568" cy="4617720"/>
+            <a:off x="201168" y="987552"/>
+            <a:ext cx="11777472" cy="1170432"/>
+          </a:xfrm>
+          <a:prstGeom prst="roundRect">
+            <a:avLst>
+              <a:gd name="adj" fmla="val 8000"/>
+            </a:avLst>
+          </a:prstGeom>
+          <a:solidFill>
+            <a:srgbClr val="FFF9EB"/>
+          </a:solidFill>
+          <a:ln w="6350">
+            <a:solidFill>
+              <a:srgbClr val="C9A227"/>
+            </a:solidFill>
+          </a:ln>
+        </p:spPr>
+        <p:style>
+          <a:lnRef idx="1">
+            <a:schemeClr val="accent1"/>
+          </a:lnRef>
+          <a:fillRef idx="3">
+            <a:schemeClr val="accent1"/>
+          </a:fillRef>
+          <a:effectRef idx="2">
+            <a:schemeClr val="accent1"/>
+          </a:effectRef>
+          <a:fontRef idx="minor">
+            <a:schemeClr val="lt1"/>
+          </a:fontRef>
+        </p:style>
+        <p:txBody>
+          <a:bodyPr rtlCol="0" anchor="ctr"/>
+          <a:lstStyle/>
+          <a:p>
+            <a:pPr algn="ctr"/>
+          </a:p>
+        </p:txBody>
+      </p:sp>
+      <p:sp>
+        <p:nvSpPr>
+          <p:cNvPr id="8" name="TextBox 7"/>
+          <p:cNvSpPr txBox="1"/>
+          <p:nvPr/>
+        </p:nvSpPr>
+        <p:spPr>
+          <a:xfrm>
+            <a:off x="365760" y="1042415"/>
+            <a:ext cx="11475720" cy="237744"/>
+          </a:xfrm>
+          <a:prstGeom prst="rect">
+            <a:avLst/>
+          </a:prstGeom>
+          <a:noFill/>
+        </p:spPr>
+        <p:txBody>
+          <a:bodyPr wrap="square">
+            <a:spAutoFit/>
+          </a:bodyPr>
+          <a:lstStyle/>
+          <a:p>
+            <a:pPr algn="l">
+              <a:spcAft>
+                <a:spcPts val="300"/>
+              </a:spcAft>
+            </a:pPr>
+            <a:r>
+              <a:rPr sz="1100" b="1">
+                <a:solidFill>
+                  <a:srgbClr val="C9A227"/>
+                </a:solidFill>
+                <a:latin typeface="Calibri"/>
+              </a:rPr>
+              <a:t>ESTANQUE SUR  ·  PRESÓSTATOS</a:t>
+            </a:r>
+          </a:p>
+        </p:txBody>
+      </p:sp>
+      <p:sp>
+        <p:nvSpPr>
+          <p:cNvPr id="9" name="TextBox 8"/>
+          <p:cNvSpPr txBox="1"/>
+          <p:nvPr/>
+        </p:nvSpPr>
+        <p:spPr>
+          <a:xfrm>
+            <a:off x="365760" y="1280160"/>
+            <a:ext cx="11475720" cy="804672"/>
+          </a:xfrm>
+          <a:prstGeom prst="rect">
+            <a:avLst/>
+          </a:prstGeom>
+          <a:noFill/>
+        </p:spPr>
+        <p:txBody>
+          <a:bodyPr wrap="square">
+            <a:spAutoFit/>
+          </a:bodyPr>
+          <a:lstStyle/>
+          <a:p>
+            <a:pPr algn="l">
+              <a:spcAft>
+                <a:spcPts val="300"/>
+              </a:spcAft>
+            </a:pPr>
+            <a:r>
+              <a:rPr sz="1200" b="0">
+                <a:solidFill>
+                  <a:srgbClr val="0D3B66"/>
+                </a:solidFill>
+                <a:latin typeface="Calibri"/>
+              </a:rPr>
+              <a:t>El 10/06 se repararon los presostatos. El estanque venía en 89 m³/día (mayo–9/jun) y ese día ya marca 39 m³. Desde el 11/06 se sostiene en 28 m³/día (−61 m³/día, 68%). A $1.400/m³: $84.897/día  ·  $2.546.923/mes  ·  acumulado 11/06–17/08: $5.688.128 (4.063 m³ en 67 días).</a:t>
+            </a:r>
+          </a:p>
+        </p:txBody>
+      </p:sp>
+      <p:sp>
+        <p:nvSpPr>
+          <p:cNvPr id="10" name="Rounded Rectangle 9"/>
+          <p:cNvSpPr/>
+          <p:nvPr/>
+        </p:nvSpPr>
+        <p:spPr>
+          <a:xfrm>
+            <a:off x="201168" y="2249424"/>
+            <a:ext cx="5285232" cy="3456432"/>
           </a:xfrm>
           <a:prstGeom prst="roundRect">
             <a:avLst>
@@ -4546,9 +5302,48 @@
           </a:p>
         </p:txBody>
       </p:sp>
+      <p:sp>
+        <p:nvSpPr>
+          <p:cNvPr id="11" name="TextBox 10"/>
+          <p:cNvSpPr txBox="1"/>
+          <p:nvPr/>
+        </p:nvSpPr>
+        <p:spPr>
+          <a:xfrm>
+            <a:off x="329184" y="2304288"/>
+            <a:ext cx="5029200" cy="237744"/>
+          </a:xfrm>
+          <a:prstGeom prst="rect">
+            <a:avLst/>
+          </a:prstGeom>
+          <a:noFill/>
+        </p:spPr>
+        <p:txBody>
+          <a:bodyPr wrap="square">
+            <a:spAutoFit/>
+          </a:bodyPr>
+          <a:lstStyle/>
+          <a:p>
+            <a:pPr algn="l">
+              <a:spcAft>
+                <a:spcPts val="300"/>
+              </a:spcAft>
+            </a:pPr>
+            <a:r>
+              <a:rPr sz="1100" b="1">
+                <a:solidFill>
+                  <a:srgbClr val="1F77B4"/>
+                </a:solidFill>
+                <a:latin typeface="Calibri"/>
+              </a:rPr>
+              <a:t>CONTROLES NOCTURNOS — noche típica antes vs con control</a:t>
+            </a:r>
+          </a:p>
+        </p:txBody>
+      </p:sp>
       <p:pic>
         <p:nvPicPr>
-          <p:cNvPr id="8" name="Picture 7" descr="mae_mensual_may_ago.png"/>
+          <p:cNvPr id="12" name="Picture 11" descr="mae_controles_nocturnos.png"/>
           <p:cNvPicPr>
             <a:picLocks noChangeAspect="1"/>
           </p:cNvPicPr>
@@ -4562,8 +5357,8 @@
         </p:blipFill>
         <p:spPr>
           <a:xfrm>
-            <a:off x="347472" y="1115568"/>
-            <a:ext cx="7680960" cy="3759628"/>
+            <a:off x="329184" y="2560320"/>
+            <a:ext cx="5010912" cy="2926080"/>
           </a:xfrm>
           <a:prstGeom prst="rect">
             <a:avLst/>
@@ -4572,14 +5367,14 @@
       </p:pic>
       <p:sp>
         <p:nvSpPr>
-          <p:cNvPr id="9" name="Rounded Rectangle 8"/>
+          <p:cNvPr id="13" name="Rounded Rectangle 12"/>
           <p:cNvSpPr/>
           <p:nvPr/>
         </p:nvSpPr>
         <p:spPr>
           <a:xfrm>
-            <a:off x="8302752" y="1024128"/>
-            <a:ext cx="3675887" cy="4617720"/>
+            <a:off x="5614416" y="2249424"/>
+            <a:ext cx="6364224" cy="3456432"/>
           </a:xfrm>
           <a:prstGeom prst="roundRect">
             <a:avLst>
@@ -4587,12 +5382,10 @@
             </a:avLst>
           </a:prstGeom>
           <a:solidFill>
-            <a:srgbClr val="FFFFFF"/>
+            <a:srgbClr val="F5F7FA"/>
           </a:solidFill>
-          <a:ln w="6350">
-            <a:solidFill>
-              <a:srgbClr val="1F77B4"/>
-            </a:solidFill>
+          <a:ln>
+            <a:noFill/>
           </a:ln>
         </p:spPr>
         <p:style>
@@ -4619,14 +5412,14 @@
       </p:sp>
       <p:sp>
         <p:nvSpPr>
-          <p:cNvPr id="10" name="TextBox 9"/>
+          <p:cNvPr id="14" name="TextBox 13"/>
           <p:cNvSpPr txBox="1"/>
           <p:nvPr/>
         </p:nvSpPr>
         <p:spPr>
           <a:xfrm>
-            <a:off x="8430768" y="1115568"/>
-            <a:ext cx="3419856" cy="256032"/>
+            <a:off x="5742432" y="2304288"/>
+            <a:ext cx="6108192" cy="237744"/>
           </a:xfrm>
           <a:prstGeom prst="rect">
             <a:avLst/>
@@ -4651,21 +5444,45 @@
                 </a:solidFill>
                 <a:latin typeface="Calibri"/>
               </a:rPr>
-              <a:t>JULIO · último mes cerrado</a:t>
-            </a:r>
-          </a:p>
-        </p:txBody>
-      </p:sp>
-      <p:sp>
-        <p:nvSpPr>
-          <p:cNvPr id="11" name="TextBox 10"/>
+              <a:t>ESTANQUE SUR — m³/día y costo evitado</a:t>
+            </a:r>
+          </a:p>
+        </p:txBody>
+      </p:sp>
+      <p:pic>
+        <p:nvPicPr>
+          <p:cNvPr id="15" name="Picture 14" descr="mae_sur_diario_presostatos.png"/>
+          <p:cNvPicPr>
+            <a:picLocks noChangeAspect="1"/>
+          </p:cNvPicPr>
+          <p:nvPr/>
+        </p:nvPicPr>
+        <p:blipFill>
+          <a:blip r:embed="rId4"/>
+          <a:stretch>
+            <a:fillRect/>
+          </a:stretch>
+        </p:blipFill>
+        <p:spPr>
+          <a:xfrm>
+            <a:off x="5742432" y="2560320"/>
+            <a:ext cx="6108192" cy="2926080"/>
+          </a:xfrm>
+          <a:prstGeom prst="rect">
+            <a:avLst/>
+          </a:prstGeom>
+        </p:spPr>
+      </p:pic>
+      <p:sp>
+        <p:nvSpPr>
+          <p:cNvPr id="16" name="TextBox 15"/>
           <p:cNvSpPr txBox="1"/>
           <p:nvPr/>
         </p:nvSpPr>
         <p:spPr>
           <a:xfrm>
-            <a:off x="8430768" y="1371600"/>
-            <a:ext cx="3419856" cy="566928"/>
+            <a:off x="256032" y="5742432"/>
+            <a:ext cx="11704320" cy="1024128"/>
           </a:xfrm>
           <a:prstGeom prst="rect">
             <a:avLst/>
@@ -4684,85 +5501,15 @@
               </a:spcAft>
             </a:pPr>
             <a:r>
-              <a:rPr sz="1300" b="0">
-                <a:solidFill>
-                  <a:srgbClr val="5A5A5A"/>
+              <a:rPr sz="1200" b="0">
+                <a:solidFill>
+                  <a:srgbClr val="0D3B66"/>
                 </a:solidFill>
                 <a:latin typeface="Calibri"/>
               </a:rPr>
-              <a:t>El recinto sumó 3.074 m³. Peso de cada equipo en el total:</a:t>
-            </a:r>
-          </a:p>
-        </p:txBody>
-      </p:sp>
-      <p:sp>
-        <p:nvSpPr>
-          <p:cNvPr id="12" name="Rounded Rectangle 11"/>
-          <p:cNvSpPr/>
-          <p:nvPr/>
-        </p:nvSpPr>
-        <p:spPr>
-          <a:xfrm>
-            <a:off x="8430768" y="2011680"/>
-            <a:ext cx="3419856" cy="804672"/>
-          </a:xfrm>
-          <a:prstGeom prst="roundRect">
-            <a:avLst>
-              <a:gd name="adj" fmla="val 8000"/>
-            </a:avLst>
-          </a:prstGeom>
-          <a:solidFill>
-            <a:srgbClr val="F5F7FA"/>
-          </a:solidFill>
-          <a:ln w="6350">
-            <a:solidFill>
-              <a:srgbClr val="C45C26"/>
-            </a:solidFill>
-          </a:ln>
-        </p:spPr>
-        <p:style>
-          <a:lnRef idx="1">
-            <a:schemeClr val="accent1"/>
-          </a:lnRef>
-          <a:fillRef idx="3">
-            <a:schemeClr val="accent1"/>
-          </a:fillRef>
-          <a:effectRef idx="2">
-            <a:schemeClr val="accent1"/>
-          </a:effectRef>
-          <a:fontRef idx="minor">
-            <a:schemeClr val="lt1"/>
-          </a:fontRef>
-        </p:style>
-        <p:txBody>
-          <a:bodyPr rtlCol="0" anchor="ctr"/>
-          <a:lstStyle/>
-          <a:p>
-            <a:pPr algn="ctr"/>
-          </a:p>
-        </p:txBody>
-      </p:sp>
-      <p:sp>
-        <p:nvSpPr>
-          <p:cNvPr id="13" name="TextBox 12"/>
-          <p:cNvSpPr txBox="1"/>
-          <p:nvPr/>
-        </p:nvSpPr>
-        <p:spPr>
-          <a:xfrm>
-            <a:off x="8558784" y="2084832"/>
-            <a:ext cx="3163824" cy="256032"/>
-          </a:xfrm>
-          <a:prstGeom prst="rect">
-            <a:avLst/>
-          </a:prstGeom>
-          <a:noFill/>
-        </p:spPr>
-        <p:txBody>
-          <a:bodyPr wrap="square">
-            <a:spAutoFit/>
-          </a:bodyPr>
-          <a:lstStyle/>
+              <a:t>Estanque Norte (control 05/08): noche típica 4,8 → 1,1 m³. Ahorro 3,7 m³/noche ($5.194/noche · $155.820/mes). En 13 noches: 48 m³ = $67.522 (tarifa $1.400/m³).</a:t>
+            </a:r>
+          </a:p>
           <a:p>
             <a:pPr algn="l">
               <a:spcAft>
@@ -4770,38 +5517,15 @@
               </a:spcAft>
             </a:pPr>
             <a:r>
-              <a:rPr sz="1300" b="1">
-                <a:solidFill>
-                  <a:srgbClr val="C45C26"/>
+              <a:rPr sz="1200" b="0">
+                <a:solidFill>
+                  <a:srgbClr val="0D3B66"/>
                 </a:solidFill>
                 <a:latin typeface="Calibri"/>
               </a:rPr>
-              <a:t>Pizza Hut</a:t>
-            </a:r>
-          </a:p>
-        </p:txBody>
-      </p:sp>
-      <p:sp>
-        <p:nvSpPr>
-          <p:cNvPr id="14" name="TextBox 13"/>
-          <p:cNvSpPr txBox="1"/>
-          <p:nvPr/>
-        </p:nvSpPr>
-        <p:spPr>
-          <a:xfrm>
-            <a:off x="8558784" y="2359152"/>
-            <a:ext cx="3163824" cy="365760"/>
-          </a:xfrm>
-          <a:prstGeom prst="rect">
-            <a:avLst/>
-          </a:prstGeom>
-          <a:noFill/>
-        </p:spPr>
-        <p:txBody>
-          <a:bodyPr wrap="square">
-            <a:spAutoFit/>
-          </a:bodyPr>
-          <a:lstStyle/>
+              <a:t>Pizza Hut (control 01/07): noche típica 0,1 → 0 m³.</a:t>
+            </a:r>
+          </a:p>
           <a:p>
             <a:pPr algn="l">
               <a:spcAft>
@@ -4809,85 +5533,15 @@
               </a:spcAft>
             </a:pPr>
             <a:r>
-              <a:rPr sz="1800" b="1">
+              <a:rPr sz="1200" b="0">
                 <a:solidFill>
                   <a:srgbClr val="0D3B66"/>
                 </a:solidFill>
                 <a:latin typeface="Calibri"/>
               </a:rPr>
-              <a:t>1.169 m³    38 %</a:t>
-            </a:r>
-          </a:p>
-        </p:txBody>
-      </p:sp>
-      <p:sp>
-        <p:nvSpPr>
-          <p:cNvPr id="15" name="Rounded Rectangle 14"/>
-          <p:cNvSpPr/>
-          <p:nvPr/>
-        </p:nvSpPr>
-        <p:spPr>
-          <a:xfrm>
-            <a:off x="8430768" y="2889504"/>
-            <a:ext cx="3419856" cy="804672"/>
-          </a:xfrm>
-          <a:prstGeom prst="roundRect">
-            <a:avLst>
-              <a:gd name="adj" fmla="val 8000"/>
-            </a:avLst>
-          </a:prstGeom>
-          <a:solidFill>
-            <a:srgbClr val="F5F7FA"/>
-          </a:solidFill>
-          <a:ln w="6350">
-            <a:solidFill>
-              <a:srgbClr val="0D3B66"/>
-            </a:solidFill>
-          </a:ln>
-        </p:spPr>
-        <p:style>
-          <a:lnRef idx="1">
-            <a:schemeClr val="accent1"/>
-          </a:lnRef>
-          <a:fillRef idx="3">
-            <a:schemeClr val="accent1"/>
-          </a:fillRef>
-          <a:effectRef idx="2">
-            <a:schemeClr val="accent1"/>
-          </a:effectRef>
-          <a:fontRef idx="minor">
-            <a:schemeClr val="lt1"/>
-          </a:fontRef>
-        </p:style>
-        <p:txBody>
-          <a:bodyPr rtlCol="0" anchor="ctr"/>
-          <a:lstStyle/>
-          <a:p>
-            <a:pPr algn="ctr"/>
-          </a:p>
-        </p:txBody>
-      </p:sp>
-      <p:sp>
-        <p:nvSpPr>
-          <p:cNvPr id="16" name="TextBox 15"/>
-          <p:cNvSpPr txBox="1"/>
-          <p:nvPr/>
-        </p:nvSpPr>
-        <p:spPr>
-          <a:xfrm>
-            <a:off x="8558784" y="2962656"/>
-            <a:ext cx="3163824" cy="256032"/>
-          </a:xfrm>
-          <a:prstGeom prst="rect">
-            <a:avLst/>
-          </a:prstGeom>
-          <a:noFill/>
-        </p:spPr>
-        <p:txBody>
-          <a:bodyPr wrap="square">
-            <a:spAutoFit/>
-          </a:bodyPr>
-          <a:lstStyle/>
+              <a:t>Estanque Sur: corte on/off a cargo de mantención nocturna.</a:t>
+            </a:r>
+          </a:p>
           <a:p>
             <a:pPr algn="l">
               <a:spcAft>
@@ -4895,357 +5549,13 @@
               </a:spcAft>
             </a:pPr>
             <a:r>
-              <a:rPr sz="1300" b="1">
+              <a:rPr sz="1200" b="0">
                 <a:solidFill>
                   <a:srgbClr val="0D3B66"/>
                 </a:solidFill>
                 <a:latin typeface="Calibri"/>
               </a:rPr>
-              <a:t>Estanque Norte</a:t>
-            </a:r>
-          </a:p>
-        </p:txBody>
-      </p:sp>
-      <p:sp>
-        <p:nvSpPr>
-          <p:cNvPr id="17" name="TextBox 16"/>
-          <p:cNvSpPr txBox="1"/>
-          <p:nvPr/>
-        </p:nvSpPr>
-        <p:spPr>
-          <a:xfrm>
-            <a:off x="8558784" y="3236976"/>
-            <a:ext cx="3163824" cy="365760"/>
-          </a:xfrm>
-          <a:prstGeom prst="rect">
-            <a:avLst/>
-          </a:prstGeom>
-          <a:noFill/>
-        </p:spPr>
-        <p:txBody>
-          <a:bodyPr wrap="square">
-            <a:spAutoFit/>
-          </a:bodyPr>
-          <a:lstStyle/>
-          <a:p>
-            <a:pPr algn="l">
-              <a:spcAft>
-                <a:spcPts val="300"/>
-              </a:spcAft>
-            </a:pPr>
-            <a:r>
-              <a:rPr sz="1800" b="1">
-                <a:solidFill>
-                  <a:srgbClr val="0D3B66"/>
-                </a:solidFill>
-                <a:latin typeface="Calibri"/>
-              </a:rPr>
-              <a:t>886 m³    29 %</a:t>
-            </a:r>
-          </a:p>
-        </p:txBody>
-      </p:sp>
-      <p:sp>
-        <p:nvSpPr>
-          <p:cNvPr id="18" name="Rounded Rectangle 17"/>
-          <p:cNvSpPr/>
-          <p:nvPr/>
-        </p:nvSpPr>
-        <p:spPr>
-          <a:xfrm>
-            <a:off x="8430768" y="3767328"/>
-            <a:ext cx="3419856" cy="804672"/>
-          </a:xfrm>
-          <a:prstGeom prst="roundRect">
-            <a:avLst>
-              <a:gd name="adj" fmla="val 8000"/>
-            </a:avLst>
-          </a:prstGeom>
-          <a:solidFill>
-            <a:srgbClr val="F5F7FA"/>
-          </a:solidFill>
-          <a:ln w="6350">
-            <a:solidFill>
-              <a:srgbClr val="1F77B4"/>
-            </a:solidFill>
-          </a:ln>
-        </p:spPr>
-        <p:style>
-          <a:lnRef idx="1">
-            <a:schemeClr val="accent1"/>
-          </a:lnRef>
-          <a:fillRef idx="3">
-            <a:schemeClr val="accent1"/>
-          </a:fillRef>
-          <a:effectRef idx="2">
-            <a:schemeClr val="accent1"/>
-          </a:effectRef>
-          <a:fontRef idx="minor">
-            <a:schemeClr val="lt1"/>
-          </a:fontRef>
-        </p:style>
-        <p:txBody>
-          <a:bodyPr rtlCol="0" anchor="ctr"/>
-          <a:lstStyle/>
-          <a:p>
-            <a:pPr algn="ctr"/>
-          </a:p>
-        </p:txBody>
-      </p:sp>
-      <p:sp>
-        <p:nvSpPr>
-          <p:cNvPr id="19" name="TextBox 18"/>
-          <p:cNvSpPr txBox="1"/>
-          <p:nvPr/>
-        </p:nvSpPr>
-        <p:spPr>
-          <a:xfrm>
-            <a:off x="8558784" y="3840480"/>
-            <a:ext cx="3163824" cy="256032"/>
-          </a:xfrm>
-          <a:prstGeom prst="rect">
-            <a:avLst/>
-          </a:prstGeom>
-          <a:noFill/>
-        </p:spPr>
-        <p:txBody>
-          <a:bodyPr wrap="square">
-            <a:spAutoFit/>
-          </a:bodyPr>
-          <a:lstStyle/>
-          <a:p>
-            <a:pPr algn="l">
-              <a:spcAft>
-                <a:spcPts val="300"/>
-              </a:spcAft>
-            </a:pPr>
-            <a:r>
-              <a:rPr sz="1300" b="1">
-                <a:solidFill>
-                  <a:srgbClr val="1F77B4"/>
-                </a:solidFill>
-                <a:latin typeface="Calibri"/>
-              </a:rPr>
-              <a:t>Estanque Sur</a:t>
-            </a:r>
-          </a:p>
-        </p:txBody>
-      </p:sp>
-      <p:sp>
-        <p:nvSpPr>
-          <p:cNvPr id="20" name="TextBox 19"/>
-          <p:cNvSpPr txBox="1"/>
-          <p:nvPr/>
-        </p:nvSpPr>
-        <p:spPr>
-          <a:xfrm>
-            <a:off x="8558784" y="4114800"/>
-            <a:ext cx="3163824" cy="365760"/>
-          </a:xfrm>
-          <a:prstGeom prst="rect">
-            <a:avLst/>
-          </a:prstGeom>
-          <a:noFill/>
-        </p:spPr>
-        <p:txBody>
-          <a:bodyPr wrap="square">
-            <a:spAutoFit/>
-          </a:bodyPr>
-          <a:lstStyle/>
-          <a:p>
-            <a:pPr algn="l">
-              <a:spcAft>
-                <a:spcPts val="300"/>
-              </a:spcAft>
-            </a:pPr>
-            <a:r>
-              <a:rPr sz="1800" b="1">
-                <a:solidFill>
-                  <a:srgbClr val="0D3B66"/>
-                </a:solidFill>
-                <a:latin typeface="Calibri"/>
-              </a:rPr>
-              <a:t>802 m³    26 %</a:t>
-            </a:r>
-          </a:p>
-        </p:txBody>
-      </p:sp>
-      <p:sp>
-        <p:nvSpPr>
-          <p:cNvPr id="21" name="Rounded Rectangle 20"/>
-          <p:cNvSpPr/>
-          <p:nvPr/>
-        </p:nvSpPr>
-        <p:spPr>
-          <a:xfrm>
-            <a:off x="8430768" y="4645152"/>
-            <a:ext cx="3419856" cy="804672"/>
-          </a:xfrm>
-          <a:prstGeom prst="roundRect">
-            <a:avLst>
-              <a:gd name="adj" fmla="val 8000"/>
-            </a:avLst>
-          </a:prstGeom>
-          <a:solidFill>
-            <a:srgbClr val="F5F7FA"/>
-          </a:solidFill>
-          <a:ln w="6350">
-            <a:solidFill>
-              <a:srgbClr val="7BA3C9"/>
-            </a:solidFill>
-          </a:ln>
-        </p:spPr>
-        <p:style>
-          <a:lnRef idx="1">
-            <a:schemeClr val="accent1"/>
-          </a:lnRef>
-          <a:fillRef idx="3">
-            <a:schemeClr val="accent1"/>
-          </a:fillRef>
-          <a:effectRef idx="2">
-            <a:schemeClr val="accent1"/>
-          </a:effectRef>
-          <a:fontRef idx="minor">
-            <a:schemeClr val="lt1"/>
-          </a:fontRef>
-        </p:style>
-        <p:txBody>
-          <a:bodyPr rtlCol="0" anchor="ctr"/>
-          <a:lstStyle/>
-          <a:p>
-            <a:pPr algn="ctr"/>
-          </a:p>
-        </p:txBody>
-      </p:sp>
-      <p:sp>
-        <p:nvSpPr>
-          <p:cNvPr id="22" name="TextBox 21"/>
-          <p:cNvSpPr txBox="1"/>
-          <p:nvPr/>
-        </p:nvSpPr>
-        <p:spPr>
-          <a:xfrm>
-            <a:off x="8558784" y="4718304"/>
-            <a:ext cx="3163824" cy="256032"/>
-          </a:xfrm>
-          <a:prstGeom prst="rect">
-            <a:avLst/>
-          </a:prstGeom>
-          <a:noFill/>
-        </p:spPr>
-        <p:txBody>
-          <a:bodyPr wrap="square">
-            <a:spAutoFit/>
-          </a:bodyPr>
-          <a:lstStyle/>
-          <a:p>
-            <a:pPr algn="l">
-              <a:spcAft>
-                <a:spcPts val="300"/>
-              </a:spcAft>
-            </a:pPr>
-            <a:r>
-              <a:rPr sz="1300" b="1">
-                <a:solidFill>
-                  <a:srgbClr val="7BA3C9"/>
-                </a:solidFill>
-                <a:latin typeface="Calibri"/>
-              </a:rPr>
-              <a:t>Baños Públicos</a:t>
-            </a:r>
-          </a:p>
-        </p:txBody>
-      </p:sp>
-      <p:sp>
-        <p:nvSpPr>
-          <p:cNvPr id="23" name="TextBox 22"/>
-          <p:cNvSpPr txBox="1"/>
-          <p:nvPr/>
-        </p:nvSpPr>
-        <p:spPr>
-          <a:xfrm>
-            <a:off x="8558784" y="4992624"/>
-            <a:ext cx="3163824" cy="365760"/>
-          </a:xfrm>
-          <a:prstGeom prst="rect">
-            <a:avLst/>
-          </a:prstGeom>
-          <a:noFill/>
-        </p:spPr>
-        <p:txBody>
-          <a:bodyPr wrap="square">
-            <a:spAutoFit/>
-          </a:bodyPr>
-          <a:lstStyle/>
-          <a:p>
-            <a:pPr algn="l">
-              <a:spcAft>
-                <a:spcPts val="300"/>
-              </a:spcAft>
-            </a:pPr>
-            <a:r>
-              <a:rPr sz="1800" b="1">
-                <a:solidFill>
-                  <a:srgbClr val="0D3B66"/>
-                </a:solidFill>
-                <a:latin typeface="Calibri"/>
-              </a:rPr>
-              <a:t>217 m³    7 %</a:t>
-            </a:r>
-          </a:p>
-        </p:txBody>
-      </p:sp>
-      <p:sp>
-        <p:nvSpPr>
-          <p:cNvPr id="24" name="TextBox 23"/>
-          <p:cNvSpPr txBox="1"/>
-          <p:nvPr/>
-        </p:nvSpPr>
-        <p:spPr>
-          <a:xfrm>
-            <a:off x="256032" y="5742432"/>
-            <a:ext cx="11887200" cy="960120"/>
-          </a:xfrm>
-          <a:prstGeom prst="rect">
-            <a:avLst/>
-          </a:prstGeom>
-          <a:noFill/>
-        </p:spPr>
-        <p:txBody>
-          <a:bodyPr wrap="square">
-            <a:spAutoFit/>
-          </a:bodyPr>
-          <a:lstStyle/>
-          <a:p>
-            <a:pPr algn="l">
-              <a:spcAft>
-                <a:spcPts val="300"/>
-              </a:spcAft>
-            </a:pPr>
-            <a:r>
-              <a:rPr sz="1300" b="0">
-                <a:solidFill>
-                  <a:srgbClr val="0D3B66"/>
-                </a:solidFill>
-                <a:latin typeface="Calibri"/>
-              </a:rPr>
-              <a:t>Mayo 5.107 m³   ·   Junio 3.179 m³   ·   Julio 3.074 m³   ·   Agosto 1–17: 1.701 m³   ·   Proyección agosto: 3.101 m³ (100 m³/día × 31).</a:t>
-            </a:r>
-          </a:p>
-          <a:p>
-            <a:pPr algn="l">
-              <a:spcAft>
-                <a:spcPts val="300"/>
-              </a:spcAft>
-            </a:pPr>
-            <a:r>
-              <a:rPr sz="1200" b="0">
-                <a:solidFill>
-                  <a:srgbClr val="5A5A5A"/>
-                </a:solidFill>
-                <a:latin typeface="Calibri"/>
-              </a:rPr>
-              <a:t>Dorado = lo que agosto ya lleva. Tramo claro = proyección del resto del mes. Mayo cierra más alto por Estanque Sur, antes de la reparación del 10/06.</a:t>
+              <a:t>Baños Guardias: control instalado; no está solicitado el uso.</a:t>
             </a:r>
           </a:p>
         </p:txBody>
@@ -5259,640 +5569,6 @@
 </file>
 
 <file path=ppt/slides/slide4.xml><?xml version="1.0" encoding="utf-8"?>
-<p:sld xmlns:a="http://schemas.openxmlformats.org/drawingml/2006/main" xmlns:p="http://schemas.openxmlformats.org/presentationml/2006/main" xmlns:r="http://schemas.openxmlformats.org/officeDocument/2006/relationships">
-  <p:cSld>
-    <p:spTree>
-      <p:nvGrpSpPr>
-        <p:cNvPr id="1" name=""/>
-        <p:cNvGrpSpPr/>
-        <p:nvPr/>
-      </p:nvGrpSpPr>
-      <p:grpSpPr/>
-      <p:sp>
-        <p:nvSpPr>
-          <p:cNvPr id="2" name="Rectangle 1"/>
-          <p:cNvSpPr/>
-          <p:nvPr/>
-        </p:nvSpPr>
-        <p:spPr>
-          <a:xfrm>
-            <a:off x="0" y="0"/>
-            <a:ext cx="12191695" cy="841248"/>
-          </a:xfrm>
-          <a:prstGeom prst="rect">
-            <a:avLst/>
-          </a:prstGeom>
-          <a:solidFill>
-            <a:srgbClr val="0D3B66"/>
-          </a:solidFill>
-          <a:ln>
-            <a:noFill/>
-          </a:ln>
-        </p:spPr>
-        <p:style>
-          <a:lnRef idx="1">
-            <a:schemeClr val="accent1"/>
-          </a:lnRef>
-          <a:fillRef idx="3">
-            <a:schemeClr val="accent1"/>
-          </a:fillRef>
-          <a:effectRef idx="2">
-            <a:schemeClr val="accent1"/>
-          </a:effectRef>
-          <a:fontRef idx="minor">
-            <a:schemeClr val="lt1"/>
-          </a:fontRef>
-        </p:style>
-        <p:txBody>
-          <a:bodyPr rtlCol="0" anchor="ctr"/>
-          <a:lstStyle/>
-          <a:p>
-            <a:pPr algn="ctr"/>
-          </a:p>
-        </p:txBody>
-      </p:sp>
-      <p:sp>
-        <p:nvSpPr>
-          <p:cNvPr id="3" name="Rectangle 2"/>
-          <p:cNvSpPr/>
-          <p:nvPr/>
-        </p:nvSpPr>
-        <p:spPr>
-          <a:xfrm>
-            <a:off x="0" y="841248"/>
-            <a:ext cx="12191695" cy="54864"/>
-          </a:xfrm>
-          <a:prstGeom prst="rect">
-            <a:avLst/>
-          </a:prstGeom>
-          <a:solidFill>
-            <a:srgbClr val="C9A227"/>
-          </a:solidFill>
-          <a:ln>
-            <a:noFill/>
-          </a:ln>
-        </p:spPr>
-        <p:style>
-          <a:lnRef idx="1">
-            <a:schemeClr val="accent1"/>
-          </a:lnRef>
-          <a:fillRef idx="3">
-            <a:schemeClr val="accent1"/>
-          </a:fillRef>
-          <a:effectRef idx="2">
-            <a:schemeClr val="accent1"/>
-          </a:effectRef>
-          <a:fontRef idx="minor">
-            <a:schemeClr val="lt1"/>
-          </a:fontRef>
-        </p:style>
-        <p:txBody>
-          <a:bodyPr rtlCol="0" anchor="ctr"/>
-          <a:lstStyle/>
-          <a:p>
-            <a:pPr algn="ctr"/>
-          </a:p>
-        </p:txBody>
-      </p:sp>
-      <p:pic>
-        <p:nvPicPr>
-          <p:cNvPr id="4" name="Picture 3" descr="logo wes.bmp"/>
-          <p:cNvPicPr>
-            <a:picLocks noChangeAspect="1"/>
-          </p:cNvPicPr>
-          <p:nvPr/>
-        </p:nvPicPr>
-        <p:blipFill>
-          <a:blip r:embed="rId2"/>
-          <a:stretch>
-            <a:fillRect/>
-          </a:stretch>
-        </p:blipFill>
-        <p:spPr>
-          <a:xfrm>
-            <a:off x="10835640" y="146304"/>
-            <a:ext cx="1143000" cy="253401"/>
-          </a:xfrm>
-          <a:prstGeom prst="rect">
-            <a:avLst/>
-          </a:prstGeom>
-        </p:spPr>
-      </p:pic>
-      <p:sp>
-        <p:nvSpPr>
-          <p:cNvPr id="5" name="TextBox 4"/>
-          <p:cNvSpPr txBox="1"/>
-          <p:nvPr/>
-        </p:nvSpPr>
-        <p:spPr>
-          <a:xfrm>
-            <a:off x="256032" y="109728"/>
-            <a:ext cx="10607040" cy="384048"/>
-          </a:xfrm>
-          <a:prstGeom prst="rect">
-            <a:avLst/>
-          </a:prstGeom>
-          <a:noFill/>
-        </p:spPr>
-        <p:txBody>
-          <a:bodyPr wrap="square">
-            <a:spAutoFit/>
-          </a:bodyPr>
-          <a:lstStyle/>
-          <a:p>
-            <a:pPr algn="l">
-              <a:spcAft>
-                <a:spcPts val="300"/>
-              </a:spcAft>
-            </a:pPr>
-            <a:r>
-              <a:rPr sz="2000" b="1">
-                <a:solidFill>
-                  <a:srgbClr val="FFFFFF"/>
-                </a:solidFill>
-                <a:latin typeface="Calibri"/>
-              </a:rPr>
-              <a:t>MAE  ·  3. Hallazgos</a:t>
-            </a:r>
-          </a:p>
-        </p:txBody>
-      </p:sp>
-      <p:sp>
-        <p:nvSpPr>
-          <p:cNvPr id="6" name="TextBox 5"/>
-          <p:cNvSpPr txBox="1"/>
-          <p:nvPr/>
-        </p:nvSpPr>
-        <p:spPr>
-          <a:xfrm>
-            <a:off x="256032" y="457200"/>
-            <a:ext cx="10607040" cy="329184"/>
-          </a:xfrm>
-          <a:prstGeom prst="rect">
-            <a:avLst/>
-          </a:prstGeom>
-          <a:noFill/>
-        </p:spPr>
-        <p:txBody>
-          <a:bodyPr wrap="square">
-            <a:spAutoFit/>
-          </a:bodyPr>
-          <a:lstStyle/>
-          <a:p>
-            <a:pPr algn="l">
-              <a:spcAft>
-                <a:spcPts val="300"/>
-              </a:spcAft>
-            </a:pPr>
-            <a:r>
-              <a:rPr sz="1100" b="0">
-                <a:solidFill>
-                  <a:srgbClr val="DCE6F0"/>
-                </a:solidFill>
-                <a:latin typeface="Calibri"/>
-              </a:rPr>
-              <a:t>Estanque Sur: reparación de presostatos (10/06)  ·  Estanque Norte: control nocturno</a:t>
-            </a:r>
-          </a:p>
-        </p:txBody>
-      </p:sp>
-      <p:sp>
-        <p:nvSpPr>
-          <p:cNvPr id="7" name="Rounded Rectangle 6"/>
-          <p:cNvSpPr/>
-          <p:nvPr/>
-        </p:nvSpPr>
-        <p:spPr>
-          <a:xfrm>
-            <a:off x="201168" y="987552"/>
-            <a:ext cx="11777472" cy="1170432"/>
-          </a:xfrm>
-          <a:prstGeom prst="roundRect">
-            <a:avLst>
-              <a:gd name="adj" fmla="val 8000"/>
-            </a:avLst>
-          </a:prstGeom>
-          <a:solidFill>
-            <a:srgbClr val="FFF9EB"/>
-          </a:solidFill>
-          <a:ln w="6350">
-            <a:solidFill>
-              <a:srgbClr val="C9A227"/>
-            </a:solidFill>
-          </a:ln>
-        </p:spPr>
-        <p:style>
-          <a:lnRef idx="1">
-            <a:schemeClr val="accent1"/>
-          </a:lnRef>
-          <a:fillRef idx="3">
-            <a:schemeClr val="accent1"/>
-          </a:fillRef>
-          <a:effectRef idx="2">
-            <a:schemeClr val="accent1"/>
-          </a:effectRef>
-          <a:fontRef idx="minor">
-            <a:schemeClr val="lt1"/>
-          </a:fontRef>
-        </p:style>
-        <p:txBody>
-          <a:bodyPr rtlCol="0" anchor="ctr"/>
-          <a:lstStyle/>
-          <a:p>
-            <a:pPr algn="ctr"/>
-          </a:p>
-        </p:txBody>
-      </p:sp>
-      <p:sp>
-        <p:nvSpPr>
-          <p:cNvPr id="8" name="TextBox 7"/>
-          <p:cNvSpPr txBox="1"/>
-          <p:nvPr/>
-        </p:nvSpPr>
-        <p:spPr>
-          <a:xfrm>
-            <a:off x="365760" y="1042415"/>
-            <a:ext cx="11475720" cy="237744"/>
-          </a:xfrm>
-          <a:prstGeom prst="rect">
-            <a:avLst/>
-          </a:prstGeom>
-          <a:noFill/>
-        </p:spPr>
-        <p:txBody>
-          <a:bodyPr wrap="square">
-            <a:spAutoFit/>
-          </a:bodyPr>
-          <a:lstStyle/>
-          <a:p>
-            <a:pPr algn="l">
-              <a:spcAft>
-                <a:spcPts val="300"/>
-              </a:spcAft>
-            </a:pPr>
-            <a:r>
-              <a:rPr sz="1100" b="1">
-                <a:solidFill>
-                  <a:srgbClr val="C9A227"/>
-                </a:solidFill>
-                <a:latin typeface="Calibri"/>
-              </a:rPr>
-              <a:t>ESTANQUE SUR  ·  PRESÓSTATOS</a:t>
-            </a:r>
-          </a:p>
-        </p:txBody>
-      </p:sp>
-      <p:sp>
-        <p:nvSpPr>
-          <p:cNvPr id="9" name="TextBox 8"/>
-          <p:cNvSpPr txBox="1"/>
-          <p:nvPr/>
-        </p:nvSpPr>
-        <p:spPr>
-          <a:xfrm>
-            <a:off x="365760" y="1280160"/>
-            <a:ext cx="11475720" cy="804672"/>
-          </a:xfrm>
-          <a:prstGeom prst="rect">
-            <a:avLst/>
-          </a:prstGeom>
-          <a:noFill/>
-        </p:spPr>
-        <p:txBody>
-          <a:bodyPr wrap="square">
-            <a:spAutoFit/>
-          </a:bodyPr>
-          <a:lstStyle/>
-          <a:p>
-            <a:pPr algn="l">
-              <a:spcAft>
-                <a:spcPts val="300"/>
-              </a:spcAft>
-            </a:pPr>
-            <a:r>
-              <a:rPr sz="1200" b="0">
-                <a:solidFill>
-                  <a:srgbClr val="0D3B66"/>
-                </a:solidFill>
-                <a:latin typeface="Calibri"/>
-              </a:rPr>
-              <a:t>El 10/06 se repararon los presostatos. El estanque venía en 89 m³/día (mayo–9/jun) y ese día ya marca 39 m³. Desde el 11/06 se sostiene en 28 m³/día (−61 m³/día, 68%). A $1.400/m³: $84.897/día  ·  $2.546.923/mes  ·  acumulado 11/06–17/08: $5.688.128 (4.063 m³ en 67 días).</a:t>
-            </a:r>
-          </a:p>
-        </p:txBody>
-      </p:sp>
-      <p:sp>
-        <p:nvSpPr>
-          <p:cNvPr id="10" name="Rounded Rectangle 9"/>
-          <p:cNvSpPr/>
-          <p:nvPr/>
-        </p:nvSpPr>
-        <p:spPr>
-          <a:xfrm>
-            <a:off x="201168" y="2249424"/>
-            <a:ext cx="5285232" cy="3456432"/>
-          </a:xfrm>
-          <a:prstGeom prst="roundRect">
-            <a:avLst>
-              <a:gd name="adj" fmla="val 8000"/>
-            </a:avLst>
-          </a:prstGeom>
-          <a:solidFill>
-            <a:srgbClr val="F5F7FA"/>
-          </a:solidFill>
-          <a:ln>
-            <a:noFill/>
-          </a:ln>
-        </p:spPr>
-        <p:style>
-          <a:lnRef idx="1">
-            <a:schemeClr val="accent1"/>
-          </a:lnRef>
-          <a:fillRef idx="3">
-            <a:schemeClr val="accent1"/>
-          </a:fillRef>
-          <a:effectRef idx="2">
-            <a:schemeClr val="accent1"/>
-          </a:effectRef>
-          <a:fontRef idx="minor">
-            <a:schemeClr val="lt1"/>
-          </a:fontRef>
-        </p:style>
-        <p:txBody>
-          <a:bodyPr rtlCol="0" anchor="ctr"/>
-          <a:lstStyle/>
-          <a:p>
-            <a:pPr algn="ctr"/>
-          </a:p>
-        </p:txBody>
-      </p:sp>
-      <p:sp>
-        <p:nvSpPr>
-          <p:cNvPr id="11" name="TextBox 10"/>
-          <p:cNvSpPr txBox="1"/>
-          <p:nvPr/>
-        </p:nvSpPr>
-        <p:spPr>
-          <a:xfrm>
-            <a:off x="329184" y="2304288"/>
-            <a:ext cx="5029200" cy="237744"/>
-          </a:xfrm>
-          <a:prstGeom prst="rect">
-            <a:avLst/>
-          </a:prstGeom>
-          <a:noFill/>
-        </p:spPr>
-        <p:txBody>
-          <a:bodyPr wrap="square">
-            <a:spAutoFit/>
-          </a:bodyPr>
-          <a:lstStyle/>
-          <a:p>
-            <a:pPr algn="l">
-              <a:spcAft>
-                <a:spcPts val="300"/>
-              </a:spcAft>
-            </a:pPr>
-            <a:r>
-              <a:rPr sz="1100" b="1">
-                <a:solidFill>
-                  <a:srgbClr val="1F77B4"/>
-                </a:solidFill>
-                <a:latin typeface="Calibri"/>
-              </a:rPr>
-              <a:t>CONTROLES NOCTURNOS — noche típica antes vs con control</a:t>
-            </a:r>
-          </a:p>
-        </p:txBody>
-      </p:sp>
-      <p:pic>
-        <p:nvPicPr>
-          <p:cNvPr id="12" name="Picture 11" descr="mae_controles_nocturnos.png"/>
-          <p:cNvPicPr>
-            <a:picLocks noChangeAspect="1"/>
-          </p:cNvPicPr>
-          <p:nvPr/>
-        </p:nvPicPr>
-        <p:blipFill>
-          <a:blip r:embed="rId3"/>
-          <a:stretch>
-            <a:fillRect/>
-          </a:stretch>
-        </p:blipFill>
-        <p:spPr>
-          <a:xfrm>
-            <a:off x="329184" y="2560320"/>
-            <a:ext cx="5010912" cy="2926080"/>
-          </a:xfrm>
-          <a:prstGeom prst="rect">
-            <a:avLst/>
-          </a:prstGeom>
-        </p:spPr>
-      </p:pic>
-      <p:sp>
-        <p:nvSpPr>
-          <p:cNvPr id="13" name="Rounded Rectangle 12"/>
-          <p:cNvSpPr/>
-          <p:nvPr/>
-        </p:nvSpPr>
-        <p:spPr>
-          <a:xfrm>
-            <a:off x="5614416" y="2249424"/>
-            <a:ext cx="6364224" cy="3456432"/>
-          </a:xfrm>
-          <a:prstGeom prst="roundRect">
-            <a:avLst>
-              <a:gd name="adj" fmla="val 8000"/>
-            </a:avLst>
-          </a:prstGeom>
-          <a:solidFill>
-            <a:srgbClr val="F5F7FA"/>
-          </a:solidFill>
-          <a:ln>
-            <a:noFill/>
-          </a:ln>
-        </p:spPr>
-        <p:style>
-          <a:lnRef idx="1">
-            <a:schemeClr val="accent1"/>
-          </a:lnRef>
-          <a:fillRef idx="3">
-            <a:schemeClr val="accent1"/>
-          </a:fillRef>
-          <a:effectRef idx="2">
-            <a:schemeClr val="accent1"/>
-          </a:effectRef>
-          <a:fontRef idx="minor">
-            <a:schemeClr val="lt1"/>
-          </a:fontRef>
-        </p:style>
-        <p:txBody>
-          <a:bodyPr rtlCol="0" anchor="ctr"/>
-          <a:lstStyle/>
-          <a:p>
-            <a:pPr algn="ctr"/>
-          </a:p>
-        </p:txBody>
-      </p:sp>
-      <p:sp>
-        <p:nvSpPr>
-          <p:cNvPr id="14" name="TextBox 13"/>
-          <p:cNvSpPr txBox="1"/>
-          <p:nvPr/>
-        </p:nvSpPr>
-        <p:spPr>
-          <a:xfrm>
-            <a:off x="5742432" y="2304288"/>
-            <a:ext cx="6108192" cy="237744"/>
-          </a:xfrm>
-          <a:prstGeom prst="rect">
-            <a:avLst/>
-          </a:prstGeom>
-          <a:noFill/>
-        </p:spPr>
-        <p:txBody>
-          <a:bodyPr wrap="square">
-            <a:spAutoFit/>
-          </a:bodyPr>
-          <a:lstStyle/>
-          <a:p>
-            <a:pPr algn="l">
-              <a:spcAft>
-                <a:spcPts val="300"/>
-              </a:spcAft>
-            </a:pPr>
-            <a:r>
-              <a:rPr sz="1100" b="1">
-                <a:solidFill>
-                  <a:srgbClr val="1F77B4"/>
-                </a:solidFill>
-                <a:latin typeface="Calibri"/>
-              </a:rPr>
-              <a:t>ESTANQUE SUR — m³/día y costo evitado</a:t>
-            </a:r>
-          </a:p>
-        </p:txBody>
-      </p:sp>
-      <p:pic>
-        <p:nvPicPr>
-          <p:cNvPr id="15" name="Picture 14" descr="mae_sur_diario_presostatos.png"/>
-          <p:cNvPicPr>
-            <a:picLocks noChangeAspect="1"/>
-          </p:cNvPicPr>
-          <p:nvPr/>
-        </p:nvPicPr>
-        <p:blipFill>
-          <a:blip r:embed="rId4"/>
-          <a:stretch>
-            <a:fillRect/>
-          </a:stretch>
-        </p:blipFill>
-        <p:spPr>
-          <a:xfrm>
-            <a:off x="5742432" y="2560320"/>
-            <a:ext cx="6108192" cy="2926080"/>
-          </a:xfrm>
-          <a:prstGeom prst="rect">
-            <a:avLst/>
-          </a:prstGeom>
-        </p:spPr>
-      </p:pic>
-      <p:sp>
-        <p:nvSpPr>
-          <p:cNvPr id="16" name="TextBox 15"/>
-          <p:cNvSpPr txBox="1"/>
-          <p:nvPr/>
-        </p:nvSpPr>
-        <p:spPr>
-          <a:xfrm>
-            <a:off x="256032" y="5742432"/>
-            <a:ext cx="11704320" cy="1024128"/>
-          </a:xfrm>
-          <a:prstGeom prst="rect">
-            <a:avLst/>
-          </a:prstGeom>
-          <a:noFill/>
-        </p:spPr>
-        <p:txBody>
-          <a:bodyPr wrap="square">
-            <a:spAutoFit/>
-          </a:bodyPr>
-          <a:lstStyle/>
-          <a:p>
-            <a:pPr algn="l">
-              <a:spcAft>
-                <a:spcPts val="300"/>
-              </a:spcAft>
-            </a:pPr>
-            <a:r>
-              <a:rPr sz="1200" b="0">
-                <a:solidFill>
-                  <a:srgbClr val="0D3B66"/>
-                </a:solidFill>
-                <a:latin typeface="Calibri"/>
-              </a:rPr>
-              <a:t>Estanque Norte (control 05/08): noche típica 4,8 → 1,1 m³. Ahorro 3,7 m³/noche ($5.194/noche · $155.820/mes). En 13 noches: 48 m³ = $67.522 (tarifa $1.400/m³).</a:t>
-            </a:r>
-          </a:p>
-          <a:p>
-            <a:pPr algn="l">
-              <a:spcAft>
-                <a:spcPts val="300"/>
-              </a:spcAft>
-            </a:pPr>
-            <a:r>
-              <a:rPr sz="1200" b="0">
-                <a:solidFill>
-                  <a:srgbClr val="0D3B66"/>
-                </a:solidFill>
-                <a:latin typeface="Calibri"/>
-              </a:rPr>
-              <a:t>Pizza Hut (control 01/07): noche típica 0,1 → 0 m³.</a:t>
-            </a:r>
-          </a:p>
-          <a:p>
-            <a:pPr algn="l">
-              <a:spcAft>
-                <a:spcPts val="300"/>
-              </a:spcAft>
-            </a:pPr>
-            <a:r>
-              <a:rPr sz="1200" b="0">
-                <a:solidFill>
-                  <a:srgbClr val="0D3B66"/>
-                </a:solidFill>
-                <a:latin typeface="Calibri"/>
-              </a:rPr>
-              <a:t>Estanque Sur: corte on/off a cargo de mantención nocturna.</a:t>
-            </a:r>
-          </a:p>
-          <a:p>
-            <a:pPr algn="l">
-              <a:spcAft>
-                <a:spcPts val="300"/>
-              </a:spcAft>
-            </a:pPr>
-            <a:r>
-              <a:rPr sz="1200" b="0">
-                <a:solidFill>
-                  <a:srgbClr val="0D3B66"/>
-                </a:solidFill>
-                <a:latin typeface="Calibri"/>
-              </a:rPr>
-              <a:t>Baños Guardias: control instalado; no está solicitado el uso.</a:t>
-            </a:r>
-          </a:p>
-        </p:txBody>
-      </p:sp>
-    </p:spTree>
-  </p:cSld>
-  <p:clrMapOvr>
-    <a:masterClrMapping/>
-  </p:clrMapOvr>
-</p:sld>
-</file>
-
-<file path=ppt/slides/slide5.xml><?xml version="1.0" encoding="utf-8"?>
 <p:sld xmlns:a="http://schemas.openxmlformats.org/drawingml/2006/main" xmlns:p="http://schemas.openxmlformats.org/presentationml/2006/main" xmlns:r="http://schemas.openxmlformats.org/officeDocument/2006/relationships">
   <p:cSld>
     <p:spTree>

</xml_diff>

<commit_message>
Fix monthly-chart August labels and drop CUR May after anillo change
Move the August projection off the last bar so it no longer sits on the legend. Curauma starts at June (anillos from 19/05). Kennedy caption states 27, 35 and 36 are not summed.

Co-authored-by: anibaloperacionesWes <anibaloperacionesWes@users.noreply.github.com>
</commit_message>
<xml_diff>
--- a/reports/Parque_Arauco/TMP_7MALLS/entrega_diego_anibal/Recorrido_ejecutivo_PA_MAE_20260817.pptx
+++ b/reports/Parque_Arauco/TMP_7MALLS/entrega_diego_anibal/Recorrido_ejecutivo_PA_MAE_20260817.pptx
@@ -4158,7 +4158,7 @@
         <p:spPr>
           <a:xfrm>
             <a:off x="329184" y="1865376"/>
-            <a:ext cx="7717536" cy="3777531"/>
+            <a:ext cx="7717536" cy="3889192"/>
           </a:xfrm>
           <a:prstGeom prst="rect">
             <a:avLst/>
@@ -6575,7 +6575,7 @@
         <p:spPr>
           <a:xfrm>
             <a:off x="329184" y="1865376"/>
-            <a:ext cx="7717536" cy="3777531"/>
+            <a:ext cx="7717536" cy="3884121"/>
           </a:xfrm>
           <a:prstGeom prst="rect">
             <a:avLst/>
@@ -8030,7 +8030,7 @@
         <p:spPr>
           <a:xfrm>
             <a:off x="329184" y="1865376"/>
-            <a:ext cx="7717536" cy="3777531"/>
+            <a:ext cx="7717536" cy="3889192"/>
           </a:xfrm>
           <a:prstGeom prst="rect">
             <a:avLst/>
@@ -9149,7 +9149,7 @@
         <p:spPr>
           <a:xfrm>
             <a:off x="329184" y="1865376"/>
-            <a:ext cx="7717536" cy="3777531"/>
+            <a:ext cx="7717536" cy="3889192"/>
           </a:xfrm>
           <a:prstGeom prst="rect">
             <a:avLst/>
@@ -10190,7 +10190,7 @@
         <p:spPr>
           <a:xfrm>
             <a:off x="329184" y="1865376"/>
-            <a:ext cx="7717536" cy="3777531"/>
+            <a:ext cx="7717536" cy="3889192"/>
           </a:xfrm>
           <a:prstGeom prst="rect">
             <a:avLst/>
@@ -11231,7 +11231,7 @@
         <p:spPr>
           <a:xfrm>
             <a:off x="329184" y="1865376"/>
-            <a:ext cx="7717536" cy="3777531"/>
+            <a:ext cx="7717536" cy="3889192"/>
           </a:xfrm>
           <a:prstGeom prst="rect">
             <a:avLst/>
@@ -11733,7 +11733,7 @@
                 </a:solidFill>
                 <a:latin typeface="Calibri"/>
               </a:rPr>
-              <a:t>Mayo 31.150   ·   Junio 664   ·   Julio 618   ·   Agosto 1–17: 366   ·   proy. ago 667 m³.</a:t>
+              <a:t>Junio 664   ·   Julio 618   ·   Agosto 1–17: 366   ·   proy. ago 667 m³.</a:t>
             </a:r>
           </a:p>
           <a:p>
@@ -11749,7 +11749,7 @@
                 </a:solidFill>
                 <a:latin typeface="Calibri"/>
               </a:rPr>
-              <a:t>Anillo Norte y Anillo Sur cubren el recinto.</a:t>
+              <a:t>Cambio de monitoreo: se dejó Baños y Matriz Principal. Anillo Norte y Sur con lectura correcta desde el 19/05 (mayo no se grafica).</a:t>
             </a:r>
           </a:p>
         </p:txBody>
@@ -12897,7 +12897,7 @@
         <p:spPr>
           <a:xfrm>
             <a:off x="329184" y="2340864"/>
-            <a:ext cx="7717536" cy="3777531"/>
+            <a:ext cx="7717536" cy="3904585"/>
           </a:xfrm>
           <a:prstGeom prst="rect">
             <a:avLst/>
@@ -14040,7 +14040,7 @@
                 </a:solidFill>
                 <a:latin typeface="Calibri"/>
               </a:rPr>
-              <a:t>Totales de cabecera. DL, Bazar y Kennedy no se suman (doble conteo).</a:t>
+              <a:t>No se suman 000025-27 (Distrito de Lujo) ni 35 y 36 (subdivisión de Sandía Antigua).</a:t>
             </a:r>
           </a:p>
         </p:txBody>

</xml_diff>

<commit_message>
Rebuild PAK chain slide with July nights and spaced chips
Keep the 10/08 hourly profile and replace the August madrugada
series with the full July month. Drop the unused August chart.

Co-authored-by: anibaloperacionesWes <anibaloperacionesWes@users.noreply.github.com>
</commit_message>
<xml_diff>
--- a/reports/Parque_Arauco/TMP_7MALLS/entrega_diego_anibal/Recorrido_ejecutivo_PA_MAE_20260817.pptx
+++ b/reports/Parque_Arauco/TMP_7MALLS/entrega_diego_anibal/Recorrido_ejecutivo_PA_MAE_20260817.pptx
@@ -3514,7 +3514,7 @@
                 </a:solidFill>
                 <a:latin typeface="Calibri"/>
               </a:rPr>
-              <a:t>22 + 28 alimentan 000025-27  ·  27 se divide en 35 y 36  ·  no entran a cabecera</a:t>
+              <a:t>Sandía Antigua y Sandía Nueva alimentan Distrito de Lujo  ·  se divide en Bazar Gourmet y DL Kennedy</a:t>
             </a:r>
           </a:p>
         </p:txBody>
@@ -3528,7 +3528,7 @@
         <p:spPr>
           <a:xfrm>
             <a:off x="201168" y="987552"/>
-            <a:ext cx="11777472" cy="713232"/>
+            <a:ext cx="11777472" cy="512064"/>
           </a:xfrm>
           <a:prstGeom prst="roundRect">
             <a:avLst>
@@ -3575,7 +3575,7 @@
         <p:spPr>
           <a:xfrm>
             <a:off x="365760" y="1042415"/>
-            <a:ext cx="11475720" cy="603504"/>
+            <a:ext cx="11475720" cy="402336"/>
           </a:xfrm>
           <a:prstGeom prst="rect">
             <a:avLst/>
@@ -3600,7 +3600,7 @@
                 </a:solidFill>
                 <a:latin typeface="Calibri"/>
               </a:rPr>
-              <a:t>Sandía Antigua (000025-22) y Sandía Nueva (000025-28) alimentan 000025-27 (Distrito de Lujo). Desde 27 el caudal se divide en 000025-35 (Bazar Gourmet) y 000025-36 (DL Kennedy). Por eso 27, 35 y 36 no se suman a la cabecera: sería doble conteo.</a:t>
+              <a:t>Sandía Antigua y Sandía Nueva alimentan Distrito de Lujo. Desde ahí el caudal se divide en Bazar Gourmet y DL Kennedy. Por eso esos tres puntos no se suman a la cabecera: sería doble conteo.</a:t>
             </a:r>
           </a:p>
         </p:txBody>
@@ -3613,8 +3613,8 @@
         </p:nvSpPr>
         <p:spPr>
           <a:xfrm>
-            <a:off x="201168" y="1792224"/>
-            <a:ext cx="1975104" cy="530352"/>
+            <a:off x="201168" y="1591056"/>
+            <a:ext cx="1938528" cy="457200"/>
           </a:xfrm>
           <a:prstGeom prst="roundRect">
             <a:avLst>
@@ -3660,66 +3660,27 @@
         </p:nvSpPr>
         <p:spPr>
           <a:xfrm>
-            <a:off x="274320" y="1810512"/>
-            <a:ext cx="1828800" cy="164592"/>
-          </a:xfrm>
-          <a:prstGeom prst="rect">
-            <a:avLst/>
-          </a:prstGeom>
-          <a:noFill/>
-        </p:spPr>
-        <p:txBody>
-          <a:bodyPr wrap="square">
-            <a:spAutoFit/>
-          </a:bodyPr>
-          <a:lstStyle/>
-          <a:p>
-            <a:pPr algn="l">
-              <a:spcAft>
-                <a:spcPts val="300"/>
-              </a:spcAft>
-            </a:pPr>
-            <a:r>
-              <a:rPr sz="900" b="1">
-                <a:solidFill>
-                  <a:srgbClr val="C9A227"/>
-                </a:solidFill>
-                <a:latin typeface="Calibri"/>
-              </a:rPr>
-              <a:t>000025-22</a:t>
-            </a:r>
-          </a:p>
-        </p:txBody>
-      </p:sp>
-      <p:sp>
-        <p:nvSpPr>
-          <p:cNvPr id="11" name="TextBox 10"/>
-          <p:cNvSpPr txBox="1"/>
-          <p:nvPr/>
-        </p:nvSpPr>
-        <p:spPr>
-          <a:xfrm>
-            <a:off x="274320" y="1993392"/>
-            <a:ext cx="1828800" cy="274320"/>
-          </a:xfrm>
-          <a:prstGeom prst="rect">
-            <a:avLst/>
-          </a:prstGeom>
-          <a:noFill/>
-        </p:spPr>
-        <p:txBody>
-          <a:bodyPr wrap="square">
-            <a:spAutoFit/>
-          </a:bodyPr>
-          <a:lstStyle/>
-          <a:p>
-            <a:pPr algn="l">
-              <a:spcAft>
-                <a:spcPts val="300"/>
-              </a:spcAft>
-            </a:pPr>
-            <a:r>
-              <a:rPr sz="1100" b="1">
+            <a:off x="274320" y="1700784"/>
+            <a:ext cx="1792224" cy="256032"/>
+          </a:xfrm>
+          <a:prstGeom prst="rect">
+            <a:avLst/>
+          </a:prstGeom>
+          <a:noFill/>
+        </p:spPr>
+        <p:txBody>
+          <a:bodyPr wrap="square">
+            <a:spAutoFit/>
+          </a:bodyPr>
+          <a:lstStyle/>
+          <a:p>
+            <a:pPr algn="ctr">
+              <a:spcAft>
+                <a:spcPts val="300"/>
+              </a:spcAft>
+            </a:pPr>
+            <a:r>
+              <a:rPr sz="1200" b="1">
                 <a:solidFill>
                   <a:srgbClr val="0D3B66"/>
                 </a:solidFill>
@@ -3732,14 +3693,14 @@
       </p:sp>
       <p:sp>
         <p:nvSpPr>
-          <p:cNvPr id="12" name="Rounded Rectangle 11"/>
+          <p:cNvPr id="11" name="Rounded Rectangle 10"/>
           <p:cNvSpPr/>
           <p:nvPr/>
         </p:nvSpPr>
         <p:spPr>
           <a:xfrm>
-            <a:off x="2267712" y="1792224"/>
-            <a:ext cx="1975104" cy="530352"/>
+            <a:off x="2468880" y="1591056"/>
+            <a:ext cx="1938528" cy="457200"/>
           </a:xfrm>
           <a:prstGeom prst="roundRect">
             <a:avLst>
@@ -3779,72 +3740,33 @@
       </p:sp>
       <p:sp>
         <p:nvSpPr>
-          <p:cNvPr id="13" name="TextBox 12"/>
-          <p:cNvSpPr txBox="1"/>
-          <p:nvPr/>
-        </p:nvSpPr>
-        <p:spPr>
-          <a:xfrm>
-            <a:off x="2340864" y="1810512"/>
-            <a:ext cx="1828800" cy="164592"/>
-          </a:xfrm>
-          <a:prstGeom prst="rect">
-            <a:avLst/>
-          </a:prstGeom>
-          <a:noFill/>
-        </p:spPr>
-        <p:txBody>
-          <a:bodyPr wrap="square">
-            <a:spAutoFit/>
-          </a:bodyPr>
-          <a:lstStyle/>
-          <a:p>
-            <a:pPr algn="l">
-              <a:spcAft>
-                <a:spcPts val="300"/>
-              </a:spcAft>
-            </a:pPr>
-            <a:r>
-              <a:rPr sz="900" b="1">
-                <a:solidFill>
-                  <a:srgbClr val="C9A227"/>
-                </a:solidFill>
-                <a:latin typeface="Calibri"/>
-              </a:rPr>
-              <a:t>000025-28</a:t>
-            </a:r>
-          </a:p>
-        </p:txBody>
-      </p:sp>
-      <p:sp>
-        <p:nvSpPr>
-          <p:cNvPr id="14" name="TextBox 13"/>
-          <p:cNvSpPr txBox="1"/>
-          <p:nvPr/>
-        </p:nvSpPr>
-        <p:spPr>
-          <a:xfrm>
-            <a:off x="2340864" y="1993392"/>
-            <a:ext cx="1828800" cy="274320"/>
-          </a:xfrm>
-          <a:prstGeom prst="rect">
-            <a:avLst/>
-          </a:prstGeom>
-          <a:noFill/>
-        </p:spPr>
-        <p:txBody>
-          <a:bodyPr wrap="square">
-            <a:spAutoFit/>
-          </a:bodyPr>
-          <a:lstStyle/>
-          <a:p>
-            <a:pPr algn="l">
-              <a:spcAft>
-                <a:spcPts val="300"/>
-              </a:spcAft>
-            </a:pPr>
-            <a:r>
-              <a:rPr sz="1100" b="1">
+          <p:cNvPr id="12" name="TextBox 11"/>
+          <p:cNvSpPr txBox="1"/>
+          <p:nvPr/>
+        </p:nvSpPr>
+        <p:spPr>
+          <a:xfrm>
+            <a:off x="2542032" y="1700784"/>
+            <a:ext cx="1792224" cy="256032"/>
+          </a:xfrm>
+          <a:prstGeom prst="rect">
+            <a:avLst/>
+          </a:prstGeom>
+          <a:noFill/>
+        </p:spPr>
+        <p:txBody>
+          <a:bodyPr wrap="square">
+            <a:spAutoFit/>
+          </a:bodyPr>
+          <a:lstStyle/>
+          <a:p>
+            <a:pPr algn="ctr">
+              <a:spcAft>
+                <a:spcPts val="300"/>
+              </a:spcAft>
+            </a:pPr>
+            <a:r>
+              <a:rPr sz="1200" b="1">
                 <a:solidFill>
                   <a:srgbClr val="0D3B66"/>
                 </a:solidFill>
@@ -3857,14 +3779,14 @@
       </p:sp>
       <p:sp>
         <p:nvSpPr>
-          <p:cNvPr id="15" name="Rounded Rectangle 14"/>
+          <p:cNvPr id="13" name="Rounded Rectangle 12"/>
           <p:cNvSpPr/>
           <p:nvPr/>
         </p:nvSpPr>
         <p:spPr>
           <a:xfrm>
-            <a:off x="4736592" y="1792224"/>
-            <a:ext cx="1975104" cy="530352"/>
+            <a:off x="4864608" y="1591056"/>
+            <a:ext cx="2194560" cy="457200"/>
           </a:xfrm>
           <a:prstGeom prst="roundRect">
             <a:avLst>
@@ -3904,92 +3826,53 @@
       </p:sp>
       <p:sp>
         <p:nvSpPr>
-          <p:cNvPr id="16" name="TextBox 15"/>
-          <p:cNvSpPr txBox="1"/>
-          <p:nvPr/>
-        </p:nvSpPr>
-        <p:spPr>
-          <a:xfrm>
-            <a:off x="4809744" y="1810512"/>
-            <a:ext cx="1828800" cy="164592"/>
-          </a:xfrm>
-          <a:prstGeom prst="rect">
-            <a:avLst/>
-          </a:prstGeom>
-          <a:noFill/>
-        </p:spPr>
-        <p:txBody>
-          <a:bodyPr wrap="square">
-            <a:spAutoFit/>
-          </a:bodyPr>
-          <a:lstStyle/>
-          <a:p>
-            <a:pPr algn="l">
-              <a:spcAft>
-                <a:spcPts val="300"/>
-              </a:spcAft>
-            </a:pPr>
-            <a:r>
-              <a:rPr sz="900" b="1">
-                <a:solidFill>
-                  <a:srgbClr val="C9A227"/>
-                </a:solidFill>
-                <a:latin typeface="Calibri"/>
-              </a:rPr>
-              <a:t>000025-27</a:t>
-            </a:r>
-          </a:p>
-        </p:txBody>
-      </p:sp>
-      <p:sp>
-        <p:nvSpPr>
-          <p:cNvPr id="17" name="TextBox 16"/>
-          <p:cNvSpPr txBox="1"/>
-          <p:nvPr/>
-        </p:nvSpPr>
-        <p:spPr>
-          <a:xfrm>
-            <a:off x="4809744" y="1993392"/>
-            <a:ext cx="1828800" cy="274320"/>
-          </a:xfrm>
-          <a:prstGeom prst="rect">
-            <a:avLst/>
-          </a:prstGeom>
-          <a:noFill/>
-        </p:spPr>
-        <p:txBody>
-          <a:bodyPr wrap="square">
-            <a:spAutoFit/>
-          </a:bodyPr>
-          <a:lstStyle/>
-          <a:p>
-            <a:pPr algn="l">
-              <a:spcAft>
-                <a:spcPts val="300"/>
-              </a:spcAft>
-            </a:pPr>
-            <a:r>
-              <a:rPr sz="1100" b="1">
+          <p:cNvPr id="14" name="TextBox 13"/>
+          <p:cNvSpPr txBox="1"/>
+          <p:nvPr/>
+        </p:nvSpPr>
+        <p:spPr>
+          <a:xfrm>
+            <a:off x="4937760" y="1700784"/>
+            <a:ext cx="2048255" cy="256032"/>
+          </a:xfrm>
+          <a:prstGeom prst="rect">
+            <a:avLst/>
+          </a:prstGeom>
+          <a:noFill/>
+        </p:spPr>
+        <p:txBody>
+          <a:bodyPr wrap="square">
+            <a:spAutoFit/>
+          </a:bodyPr>
+          <a:lstStyle/>
+          <a:p>
+            <a:pPr algn="ctr">
+              <a:spcAft>
+                <a:spcPts val="300"/>
+              </a:spcAft>
+            </a:pPr>
+            <a:r>
+              <a:rPr sz="1200" b="1">
                 <a:solidFill>
                   <a:srgbClr val="0D3B66"/>
                 </a:solidFill>
                 <a:latin typeface="Calibri"/>
               </a:rPr>
-              <a:t>Distrito Lujo  ·  tronco</a:t>
-            </a:r>
-          </a:p>
-        </p:txBody>
-      </p:sp>
-      <p:sp>
-        <p:nvSpPr>
-          <p:cNvPr id="18" name="Rounded Rectangle 17"/>
+              <a:t>Distrito de Lujo</a:t>
+            </a:r>
+          </a:p>
+        </p:txBody>
+      </p:sp>
+      <p:sp>
+        <p:nvSpPr>
+          <p:cNvPr id="15" name="Rounded Rectangle 14"/>
           <p:cNvSpPr/>
           <p:nvPr/>
         </p:nvSpPr>
         <p:spPr>
           <a:xfrm>
-            <a:off x="7717536" y="1792224"/>
-            <a:ext cx="1975104" cy="530352"/>
+            <a:off x="7516368" y="1591056"/>
+            <a:ext cx="1938528" cy="457200"/>
           </a:xfrm>
           <a:prstGeom prst="roundRect">
             <a:avLst>
@@ -4029,72 +3912,33 @@
       </p:sp>
       <p:sp>
         <p:nvSpPr>
-          <p:cNvPr id="19" name="TextBox 18"/>
-          <p:cNvSpPr txBox="1"/>
-          <p:nvPr/>
-        </p:nvSpPr>
-        <p:spPr>
-          <a:xfrm>
-            <a:off x="7790688" y="1810512"/>
-            <a:ext cx="1828800" cy="164592"/>
-          </a:xfrm>
-          <a:prstGeom prst="rect">
-            <a:avLst/>
-          </a:prstGeom>
-          <a:noFill/>
-        </p:spPr>
-        <p:txBody>
-          <a:bodyPr wrap="square">
-            <a:spAutoFit/>
-          </a:bodyPr>
-          <a:lstStyle/>
-          <a:p>
-            <a:pPr algn="l">
-              <a:spcAft>
-                <a:spcPts val="300"/>
-              </a:spcAft>
-            </a:pPr>
-            <a:r>
-              <a:rPr sz="900" b="1">
-                <a:solidFill>
-                  <a:srgbClr val="C9A227"/>
-                </a:solidFill>
-                <a:latin typeface="Calibri"/>
-              </a:rPr>
-              <a:t>000025-35</a:t>
-            </a:r>
-          </a:p>
-        </p:txBody>
-      </p:sp>
-      <p:sp>
-        <p:nvSpPr>
-          <p:cNvPr id="20" name="TextBox 19"/>
-          <p:cNvSpPr txBox="1"/>
-          <p:nvPr/>
-        </p:nvSpPr>
-        <p:spPr>
-          <a:xfrm>
-            <a:off x="7790688" y="1993392"/>
-            <a:ext cx="1828800" cy="274320"/>
-          </a:xfrm>
-          <a:prstGeom prst="rect">
-            <a:avLst/>
-          </a:prstGeom>
-          <a:noFill/>
-        </p:spPr>
-        <p:txBody>
-          <a:bodyPr wrap="square">
-            <a:spAutoFit/>
-          </a:bodyPr>
-          <a:lstStyle/>
-          <a:p>
-            <a:pPr algn="l">
-              <a:spcAft>
-                <a:spcPts val="300"/>
-              </a:spcAft>
-            </a:pPr>
-            <a:r>
-              <a:rPr sz="1100" b="1">
+          <p:cNvPr id="16" name="TextBox 15"/>
+          <p:cNvSpPr txBox="1"/>
+          <p:nvPr/>
+        </p:nvSpPr>
+        <p:spPr>
+          <a:xfrm>
+            <a:off x="7589520" y="1700784"/>
+            <a:ext cx="1792224" cy="256032"/>
+          </a:xfrm>
+          <a:prstGeom prst="rect">
+            <a:avLst/>
+          </a:prstGeom>
+          <a:noFill/>
+        </p:spPr>
+        <p:txBody>
+          <a:bodyPr wrap="square">
+            <a:spAutoFit/>
+          </a:bodyPr>
+          <a:lstStyle/>
+          <a:p>
+            <a:pPr algn="ctr">
+              <a:spcAft>
+                <a:spcPts val="300"/>
+              </a:spcAft>
+            </a:pPr>
+            <a:r>
+              <a:rPr sz="1200" b="1">
                 <a:solidFill>
                   <a:srgbClr val="0D3B66"/>
                 </a:solidFill>
@@ -4107,14 +3951,14 @@
       </p:sp>
       <p:sp>
         <p:nvSpPr>
-          <p:cNvPr id="21" name="Rounded Rectangle 20"/>
+          <p:cNvPr id="17" name="Rounded Rectangle 16"/>
           <p:cNvSpPr/>
           <p:nvPr/>
         </p:nvSpPr>
         <p:spPr>
           <a:xfrm>
-            <a:off x="9784080" y="1792224"/>
-            <a:ext cx="1975104" cy="530352"/>
+            <a:off x="9546336" y="1591056"/>
+            <a:ext cx="1938528" cy="457200"/>
           </a:xfrm>
           <a:prstGeom prst="roundRect">
             <a:avLst>
@@ -4154,92 +3998,92 @@
       </p:sp>
       <p:sp>
         <p:nvSpPr>
-          <p:cNvPr id="22" name="TextBox 21"/>
-          <p:cNvSpPr txBox="1"/>
-          <p:nvPr/>
-        </p:nvSpPr>
-        <p:spPr>
-          <a:xfrm>
-            <a:off x="9857232" y="1810512"/>
-            <a:ext cx="1828800" cy="164592"/>
-          </a:xfrm>
-          <a:prstGeom prst="rect">
-            <a:avLst/>
-          </a:prstGeom>
-          <a:noFill/>
-        </p:spPr>
-        <p:txBody>
-          <a:bodyPr wrap="square">
-            <a:spAutoFit/>
-          </a:bodyPr>
-          <a:lstStyle/>
-          <a:p>
-            <a:pPr algn="l">
-              <a:spcAft>
-                <a:spcPts val="300"/>
-              </a:spcAft>
-            </a:pPr>
-            <a:r>
-              <a:rPr sz="900" b="1">
+          <p:cNvPr id="18" name="TextBox 17"/>
+          <p:cNvSpPr txBox="1"/>
+          <p:nvPr/>
+        </p:nvSpPr>
+        <p:spPr>
+          <a:xfrm>
+            <a:off x="9619488" y="1700784"/>
+            <a:ext cx="1792224" cy="256032"/>
+          </a:xfrm>
+          <a:prstGeom prst="rect">
+            <a:avLst/>
+          </a:prstGeom>
+          <a:noFill/>
+        </p:spPr>
+        <p:txBody>
+          <a:bodyPr wrap="square">
+            <a:spAutoFit/>
+          </a:bodyPr>
+          <a:lstStyle/>
+          <a:p>
+            <a:pPr algn="ctr">
+              <a:spcAft>
+                <a:spcPts val="300"/>
+              </a:spcAft>
+            </a:pPr>
+            <a:r>
+              <a:rPr sz="1200" b="1">
+                <a:solidFill>
+                  <a:srgbClr val="0D3B66"/>
+                </a:solidFill>
+                <a:latin typeface="Calibri"/>
+              </a:rPr>
+              <a:t>DL Kennedy</a:t>
+            </a:r>
+          </a:p>
+        </p:txBody>
+      </p:sp>
+      <p:sp>
+        <p:nvSpPr>
+          <p:cNvPr id="19" name="TextBox 18"/>
+          <p:cNvSpPr txBox="1"/>
+          <p:nvPr/>
+        </p:nvSpPr>
+        <p:spPr>
+          <a:xfrm>
+            <a:off x="2139696" y="1664208"/>
+            <a:ext cx="329184" cy="310896"/>
+          </a:xfrm>
+          <a:prstGeom prst="rect">
+            <a:avLst/>
+          </a:prstGeom>
+          <a:noFill/>
+        </p:spPr>
+        <p:txBody>
+          <a:bodyPr wrap="square">
+            <a:spAutoFit/>
+          </a:bodyPr>
+          <a:lstStyle/>
+          <a:p>
+            <a:pPr algn="ctr">
+              <a:spcAft>
+                <a:spcPts val="300"/>
+              </a:spcAft>
+            </a:pPr>
+            <a:r>
+              <a:rPr sz="1600" b="1">
                 <a:solidFill>
                   <a:srgbClr val="C9A227"/>
                 </a:solidFill>
                 <a:latin typeface="Calibri"/>
               </a:rPr>
-              <a:t>000025-36</a:t>
-            </a:r>
-          </a:p>
-        </p:txBody>
-      </p:sp>
-      <p:sp>
-        <p:nvSpPr>
-          <p:cNvPr id="23" name="TextBox 22"/>
-          <p:cNvSpPr txBox="1"/>
-          <p:nvPr/>
-        </p:nvSpPr>
-        <p:spPr>
-          <a:xfrm>
-            <a:off x="9857232" y="1993392"/>
-            <a:ext cx="1828800" cy="274320"/>
-          </a:xfrm>
-          <a:prstGeom prst="rect">
-            <a:avLst/>
-          </a:prstGeom>
-          <a:noFill/>
-        </p:spPr>
-        <p:txBody>
-          <a:bodyPr wrap="square">
-            <a:spAutoFit/>
-          </a:bodyPr>
-          <a:lstStyle/>
-          <a:p>
-            <a:pPr algn="l">
-              <a:spcAft>
-                <a:spcPts val="300"/>
-              </a:spcAft>
-            </a:pPr>
-            <a:r>
-              <a:rPr sz="1100" b="1">
-                <a:solidFill>
-                  <a:srgbClr val="0D3B66"/>
-                </a:solidFill>
-                <a:latin typeface="Calibri"/>
-              </a:rPr>
-              <a:t>DL Kennedy</a:t>
-            </a:r>
-          </a:p>
-        </p:txBody>
-      </p:sp>
-      <p:sp>
-        <p:nvSpPr>
-          <p:cNvPr id="24" name="TextBox 23"/>
-          <p:cNvSpPr txBox="1"/>
-          <p:nvPr/>
-        </p:nvSpPr>
-        <p:spPr>
-          <a:xfrm>
-            <a:off x="2103120" y="1920240"/>
-            <a:ext cx="201168" cy="256032"/>
+              <a:t>+</a:t>
+            </a:r>
+          </a:p>
+        </p:txBody>
+      </p:sp>
+      <p:sp>
+        <p:nvSpPr>
+          <p:cNvPr id="20" name="TextBox 19"/>
+          <p:cNvSpPr txBox="1"/>
+          <p:nvPr/>
+        </p:nvSpPr>
+        <p:spPr>
+          <a:xfrm>
+            <a:off x="4407408" y="1664208"/>
+            <a:ext cx="457200" cy="310896"/>
           </a:xfrm>
           <a:prstGeom prst="rect">
             <a:avLst/>
@@ -4258,27 +4102,27 @@
               </a:spcAft>
             </a:pPr>
             <a:r>
-              <a:rPr sz="1600" b="1">
+              <a:rPr sz="1800" b="1">
                 <a:solidFill>
                   <a:srgbClr val="C9A227"/>
                 </a:solidFill>
                 <a:latin typeface="Calibri"/>
               </a:rPr>
-              <a:t>+</a:t>
-            </a:r>
-          </a:p>
-        </p:txBody>
-      </p:sp>
-      <p:sp>
-        <p:nvSpPr>
-          <p:cNvPr id="25" name="TextBox 24"/>
-          <p:cNvSpPr txBox="1"/>
-          <p:nvPr/>
-        </p:nvSpPr>
-        <p:spPr>
-          <a:xfrm>
-            <a:off x="4242816" y="1920240"/>
-            <a:ext cx="493776" cy="256032"/>
+              <a:t>→</a:t>
+            </a:r>
+          </a:p>
+        </p:txBody>
+      </p:sp>
+      <p:sp>
+        <p:nvSpPr>
+          <p:cNvPr id="21" name="TextBox 20"/>
+          <p:cNvSpPr txBox="1"/>
+          <p:nvPr/>
+        </p:nvSpPr>
+        <p:spPr>
+          <a:xfrm>
+            <a:off x="7059168" y="1664208"/>
+            <a:ext cx="457200" cy="310896"/>
           </a:xfrm>
           <a:prstGeom prst="rect">
             <a:avLst/>
@@ -4310,53 +4154,14 @@
       </p:sp>
       <p:sp>
         <p:nvSpPr>
-          <p:cNvPr id="26" name="TextBox 25"/>
-          <p:cNvSpPr txBox="1"/>
-          <p:nvPr/>
-        </p:nvSpPr>
-        <p:spPr>
-          <a:xfrm>
-            <a:off x="7223760" y="1920240"/>
-            <a:ext cx="493776" cy="256032"/>
-          </a:xfrm>
-          <a:prstGeom prst="rect">
-            <a:avLst/>
-          </a:prstGeom>
-          <a:noFill/>
-        </p:spPr>
-        <p:txBody>
-          <a:bodyPr wrap="square">
-            <a:spAutoFit/>
-          </a:bodyPr>
-          <a:lstStyle/>
-          <a:p>
-            <a:pPr algn="ctr">
-              <a:spcAft>
-                <a:spcPts val="300"/>
-              </a:spcAft>
-            </a:pPr>
-            <a:r>
-              <a:rPr sz="1800" b="1">
-                <a:solidFill>
-                  <a:srgbClr val="C9A227"/>
-                </a:solidFill>
-                <a:latin typeface="Calibri"/>
-              </a:rPr>
-              <a:t>→</a:t>
-            </a:r>
-          </a:p>
-        </p:txBody>
-      </p:sp>
-      <p:sp>
-        <p:nvSpPr>
-          <p:cNvPr id="27" name="Rounded Rectangle 26"/>
+          <p:cNvPr id="22" name="Rounded Rectangle 21"/>
           <p:cNvSpPr/>
           <p:nvPr/>
         </p:nvSpPr>
         <p:spPr>
           <a:xfrm>
-            <a:off x="201168" y="2432304"/>
-            <a:ext cx="5833872" cy="3108960"/>
+            <a:off x="201168" y="2157984"/>
+            <a:ext cx="5833872" cy="3383280"/>
           </a:xfrm>
           <a:prstGeom prst="roundRect">
             <a:avLst>
@@ -4394,13 +4199,13 @@
       </p:sp>
       <p:sp>
         <p:nvSpPr>
-          <p:cNvPr id="28" name="TextBox 27"/>
-          <p:cNvSpPr txBox="1"/>
-          <p:nvPr/>
-        </p:nvSpPr>
-        <p:spPr>
-          <a:xfrm>
-            <a:off x="329184" y="2468880"/>
+          <p:cNvPr id="23" name="TextBox 22"/>
+          <p:cNvSpPr txBox="1"/>
+          <p:nvPr/>
+        </p:nvSpPr>
+        <p:spPr>
+          <a:xfrm>
+            <a:off x="329184" y="2194560"/>
             <a:ext cx="5577840" cy="201168"/>
           </a:xfrm>
           <a:prstGeom prst="rect">
@@ -4433,7 +4238,7 @@
       </p:sp>
       <p:pic>
         <p:nvPicPr>
-          <p:cNvPr id="29" name="Picture 28" descr="pak_cadena_perfil_20260810.png"/>
+          <p:cNvPr id="24" name="Picture 23" descr="pak_cadena_perfil_20260810.png"/>
           <p:cNvPicPr>
             <a:picLocks noChangeAspect="1"/>
           </p:cNvPicPr>
@@ -4447,7 +4252,7 @@
         </p:blipFill>
         <p:spPr>
           <a:xfrm>
-            <a:off x="292608" y="2809776"/>
+            <a:off x="292608" y="2672616"/>
             <a:ext cx="5650992" cy="2518606"/>
           </a:xfrm>
           <a:prstGeom prst="rect">
@@ -4457,14 +4262,14 @@
       </p:pic>
       <p:sp>
         <p:nvSpPr>
-          <p:cNvPr id="30" name="Rounded Rectangle 29"/>
+          <p:cNvPr id="25" name="Rounded Rectangle 24"/>
           <p:cNvSpPr/>
           <p:nvPr/>
         </p:nvSpPr>
         <p:spPr>
           <a:xfrm>
-            <a:off x="6163056" y="2432304"/>
-            <a:ext cx="5815584" cy="3108960"/>
+            <a:off x="6163056" y="2157984"/>
+            <a:ext cx="5815584" cy="3383280"/>
           </a:xfrm>
           <a:prstGeom prst="roundRect">
             <a:avLst>
@@ -4502,13 +4307,13 @@
       </p:sp>
       <p:sp>
         <p:nvSpPr>
-          <p:cNvPr id="31" name="TextBox 30"/>
-          <p:cNvSpPr txBox="1"/>
-          <p:nvPr/>
-        </p:nvSpPr>
-        <p:spPr>
-          <a:xfrm>
-            <a:off x="6291072" y="2468880"/>
+          <p:cNvPr id="26" name="TextBox 25"/>
+          <p:cNvSpPr txBox="1"/>
+          <p:nvPr/>
+        </p:nvSpPr>
+        <p:spPr>
+          <a:xfrm>
+            <a:off x="6291072" y="2194560"/>
             <a:ext cx="5559552" cy="201168"/>
           </a:xfrm>
           <a:prstGeom prst="rect">
@@ -4534,14 +4339,14 @@
                 </a:solidFill>
                 <a:latin typeface="Calibri"/>
               </a:rPr>
-              <a:t>Agosto · m³ de madrugada (00:00–06:00)</a:t>
+              <a:t>Julio · m³ de madrugada (00:00–06:00)</a:t>
             </a:r>
           </a:p>
         </p:txBody>
       </p:sp>
       <p:pic>
         <p:nvPicPr>
-          <p:cNvPr id="32" name="Picture 31" descr="pak_cadena_noches_ago.png"/>
+          <p:cNvPr id="27" name="Picture 26" descr="pak_cadena_noches_jul.png"/>
           <p:cNvPicPr>
             <a:picLocks noChangeAspect="1"/>
           </p:cNvPicPr>
@@ -4555,7 +4360,7 @@
         </p:blipFill>
         <p:spPr>
           <a:xfrm>
-            <a:off x="6254496" y="2813851"/>
+            <a:off x="6254496" y="2676691"/>
             <a:ext cx="5632704" cy="2510456"/>
           </a:xfrm>
           <a:prstGeom prst="rect">
@@ -4565,7 +4370,7 @@
       </p:pic>
       <p:sp>
         <p:nvSpPr>
-          <p:cNvPr id="33" name="Rounded Rectangle 32"/>
+          <p:cNvPr id="28" name="Rounded Rectangle 27"/>
           <p:cNvSpPr/>
           <p:nvPr/>
         </p:nvSpPr>
@@ -4612,7 +4417,7 @@
       </p:sp>
       <p:sp>
         <p:nvSpPr>
-          <p:cNvPr id="34" name="TextBox 33"/>
+          <p:cNvPr id="29" name="TextBox 28"/>
           <p:cNvSpPr txBox="1"/>
           <p:nvPr/>
         </p:nvSpPr>
@@ -4644,7 +4449,7 @@
                 </a:solidFill>
                 <a:latin typeface="Calibri"/>
               </a:rPr>
-              <a:t>10/08 noche 00–06: Distrito de Lujo 41,2 m³  ·  Bazar 28,2 m³  ·  DL Kennedy 0,9 m³. Julio: 27 = 9.669 m³  ·  35 = 6.256 m³  ·  36 = 503 m³.</a:t>
+              <a:t>Julio (31 noches): Distrito de Lujo mediana 42,6 m³  ·  Bazar Gourmet 28,7 m³  ·  DL Kennedy 1,3 m³. Ejemplo 10/08 00–06: Distrito de Lujo 41,2 m³  ·  Bazar 28,2 m³  ·  DL Kennedy 0,9 m³.</a:t>
             </a:r>
           </a:p>
           <a:p>
@@ -4660,7 +4465,7 @@
                 </a:solidFill>
                 <a:latin typeface="Calibri"/>
               </a:rPr>
-              <a:t>Propuesta: instalar control nocturno en 000025-27 (tronco). De madrugada, Bazar (35) sigue a 27 y DL Kennedy (36) queda residual. Cortar 27 corta el caudal de noche del Distrito de Lujo.</a:t>
+              <a:t>Propuesta: instalar control nocturno en Distrito de Lujo (tronco). De madrugada, Bazar Gourmet sigue al tronco y DL Kennedy queda residual. Cortar el tronco corta el caudal de noche del Distrito de Lujo.</a:t>
             </a:r>
           </a:p>
         </p:txBody>
@@ -4926,8 +4731,8 @@
         </p:nvSpPr>
         <p:spPr>
           <a:xfrm>
-            <a:off x="274320" y="1051560"/>
-            <a:ext cx="2766060" cy="164592"/>
+            <a:off x="274320" y="1060704"/>
+            <a:ext cx="2766060" cy="146304"/>
           </a:xfrm>
           <a:prstGeom prst="rect">
             <a:avLst/>
@@ -5004,7 +4809,7 @@
         </p:nvSpPr>
         <p:spPr>
           <a:xfrm>
-            <a:off x="274320" y="1499616"/>
+            <a:off x="274320" y="1481328"/>
             <a:ext cx="2766060" cy="164592"/>
           </a:xfrm>
           <a:prstGeom prst="rect">
@@ -5090,8 +4895,8 @@
         </p:nvSpPr>
         <p:spPr>
           <a:xfrm>
-            <a:off x="3241548" y="1051560"/>
-            <a:ext cx="2766060" cy="164592"/>
+            <a:off x="3241548" y="1060704"/>
+            <a:ext cx="2766060" cy="146304"/>
           </a:xfrm>
           <a:prstGeom prst="rect">
             <a:avLst/>
@@ -5215,8 +5020,8 @@
         </p:nvSpPr>
         <p:spPr>
           <a:xfrm>
-            <a:off x="6208776" y="1051560"/>
-            <a:ext cx="2766060" cy="164592"/>
+            <a:off x="6208776" y="1060704"/>
+            <a:ext cx="2766060" cy="146304"/>
           </a:xfrm>
           <a:prstGeom prst="rect">
             <a:avLst/>
@@ -5293,7 +5098,7 @@
         </p:nvSpPr>
         <p:spPr>
           <a:xfrm>
-            <a:off x="6208776" y="1499616"/>
+            <a:off x="6208776" y="1481328"/>
             <a:ext cx="2766060" cy="164592"/>
           </a:xfrm>
           <a:prstGeom prst="rect">
@@ -5379,8 +5184,8 @@
         </p:nvSpPr>
         <p:spPr>
           <a:xfrm>
-            <a:off x="9176004" y="1051560"/>
-            <a:ext cx="2766060" cy="164592"/>
+            <a:off x="9176004" y="1060704"/>
+            <a:ext cx="2766060" cy="146304"/>
           </a:xfrm>
           <a:prstGeom prst="rect">
             <a:avLst/>
@@ -7179,8 +6984,8 @@
         </p:nvSpPr>
         <p:spPr>
           <a:xfrm>
-            <a:off x="274320" y="1051560"/>
-            <a:ext cx="2172614" cy="164592"/>
+            <a:off x="274320" y="1060704"/>
+            <a:ext cx="2172614" cy="146304"/>
           </a:xfrm>
           <a:prstGeom prst="rect">
             <a:avLst/>
@@ -7304,8 +7109,8 @@
         </p:nvSpPr>
         <p:spPr>
           <a:xfrm>
-            <a:off x="2648102" y="1051560"/>
-            <a:ext cx="2172614" cy="164592"/>
+            <a:off x="2648102" y="1060704"/>
+            <a:ext cx="2172614" cy="146304"/>
           </a:xfrm>
           <a:prstGeom prst="rect">
             <a:avLst/>
@@ -7429,8 +7234,8 @@
         </p:nvSpPr>
         <p:spPr>
           <a:xfrm>
-            <a:off x="5021884" y="1051560"/>
-            <a:ext cx="2172614" cy="164592"/>
+            <a:off x="5021884" y="1060704"/>
+            <a:ext cx="2172614" cy="146304"/>
           </a:xfrm>
           <a:prstGeom prst="rect">
             <a:avLst/>
@@ -7507,7 +7312,7 @@
         </p:nvSpPr>
         <p:spPr>
           <a:xfrm>
-            <a:off x="5021884" y="1499616"/>
+            <a:off x="5021884" y="1481328"/>
             <a:ext cx="2172614" cy="164592"/>
           </a:xfrm>
           <a:prstGeom prst="rect">
@@ -7593,8 +7398,8 @@
         </p:nvSpPr>
         <p:spPr>
           <a:xfrm>
-            <a:off x="7395667" y="1051560"/>
-            <a:ext cx="2172614" cy="164592"/>
+            <a:off x="7395667" y="1060704"/>
+            <a:ext cx="2172614" cy="146304"/>
           </a:xfrm>
           <a:prstGeom prst="rect">
             <a:avLst/>
@@ -7671,7 +7476,7 @@
         </p:nvSpPr>
         <p:spPr>
           <a:xfrm>
-            <a:off x="7395667" y="1499616"/>
+            <a:off x="7395667" y="1481328"/>
             <a:ext cx="2172614" cy="164592"/>
           </a:xfrm>
           <a:prstGeom prst="rect">
@@ -7757,8 +7562,8 @@
         </p:nvSpPr>
         <p:spPr>
           <a:xfrm>
-            <a:off x="9769449" y="1051560"/>
-            <a:ext cx="2172614" cy="164592"/>
+            <a:off x="9769449" y="1060704"/>
+            <a:ext cx="2172614" cy="146304"/>
           </a:xfrm>
           <a:prstGeom prst="rect">
             <a:avLst/>
@@ -7835,7 +7640,7 @@
         </p:nvSpPr>
         <p:spPr>
           <a:xfrm>
-            <a:off x="9769449" y="1499616"/>
+            <a:off x="9769449" y="1481328"/>
             <a:ext cx="2172614" cy="164592"/>
           </a:xfrm>
           <a:prstGeom prst="rect">
@@ -9087,8 +8892,8 @@
         </p:nvSpPr>
         <p:spPr>
           <a:xfrm>
-            <a:off x="274320" y="1051560"/>
-            <a:ext cx="5733288" cy="164592"/>
+            <a:off x="274320" y="1060704"/>
+            <a:ext cx="5733288" cy="146304"/>
           </a:xfrm>
           <a:prstGeom prst="rect">
             <a:avLst/>
@@ -9212,8 +9017,8 @@
         </p:nvSpPr>
         <p:spPr>
           <a:xfrm>
-            <a:off x="6208776" y="1051560"/>
-            <a:ext cx="5733288" cy="164592"/>
+            <a:off x="6208776" y="1060704"/>
+            <a:ext cx="5733288" cy="146304"/>
           </a:xfrm>
           <a:prstGeom prst="rect">
             <a:avLst/>
@@ -9290,7 +9095,7 @@
         </p:nvSpPr>
         <p:spPr>
           <a:xfrm>
-            <a:off x="6208776" y="1499616"/>
+            <a:off x="6208776" y="1481328"/>
             <a:ext cx="5733288" cy="164592"/>
           </a:xfrm>
           <a:prstGeom prst="rect">
@@ -10167,8 +9972,8 @@
         </p:nvSpPr>
         <p:spPr>
           <a:xfrm>
-            <a:off x="274320" y="1051560"/>
-            <a:ext cx="5733288" cy="164592"/>
+            <a:off x="274320" y="1060704"/>
+            <a:ext cx="5733288" cy="146304"/>
           </a:xfrm>
           <a:prstGeom prst="rect">
             <a:avLst/>
@@ -10292,8 +10097,8 @@
         </p:nvSpPr>
         <p:spPr>
           <a:xfrm>
-            <a:off x="6208776" y="1051560"/>
-            <a:ext cx="5733288" cy="164592"/>
+            <a:off x="6208776" y="1060704"/>
+            <a:ext cx="5733288" cy="146304"/>
           </a:xfrm>
           <a:prstGeom prst="rect">
             <a:avLst/>
@@ -10370,7 +10175,7 @@
         </p:nvSpPr>
         <p:spPr>
           <a:xfrm>
-            <a:off x="6208776" y="1499616"/>
+            <a:off x="6208776" y="1481328"/>
             <a:ext cx="5733288" cy="164592"/>
           </a:xfrm>
           <a:prstGeom prst="rect">
@@ -11247,8 +11052,8 @@
         </p:nvSpPr>
         <p:spPr>
           <a:xfrm>
-            <a:off x="274320" y="1051560"/>
-            <a:ext cx="5733288" cy="164592"/>
+            <a:off x="274320" y="1060704"/>
+            <a:ext cx="5733288" cy="146304"/>
           </a:xfrm>
           <a:prstGeom prst="rect">
             <a:avLst/>
@@ -11372,8 +11177,8 @@
         </p:nvSpPr>
         <p:spPr>
           <a:xfrm>
-            <a:off x="6208776" y="1051560"/>
-            <a:ext cx="5733288" cy="164592"/>
+            <a:off x="6208776" y="1060704"/>
+            <a:ext cx="5733288" cy="146304"/>
           </a:xfrm>
           <a:prstGeom prst="rect">
             <a:avLst/>
@@ -12288,8 +12093,8 @@
         </p:nvSpPr>
         <p:spPr>
           <a:xfrm>
-            <a:off x="274320" y="1051560"/>
-            <a:ext cx="5733288" cy="164592"/>
+            <a:off x="274320" y="1060704"/>
+            <a:ext cx="5733288" cy="146304"/>
           </a:xfrm>
           <a:prstGeom prst="rect">
             <a:avLst/>
@@ -12413,8 +12218,8 @@
         </p:nvSpPr>
         <p:spPr>
           <a:xfrm>
-            <a:off x="6208776" y="1051560"/>
-            <a:ext cx="5733288" cy="164592"/>
+            <a:off x="6208776" y="1060704"/>
+            <a:ext cx="5733288" cy="146304"/>
           </a:xfrm>
           <a:prstGeom prst="rect">
             <a:avLst/>
@@ -13283,7 +13088,7 @@
         <p:spPr>
           <a:xfrm>
             <a:off x="201168" y="1024128"/>
-            <a:ext cx="2300630" cy="566928"/>
+            <a:ext cx="2286000" cy="621792"/>
           </a:xfrm>
           <a:prstGeom prst="roundRect">
             <a:avLst>
@@ -13329,8 +13134,8 @@
         </p:nvSpPr>
         <p:spPr>
           <a:xfrm>
-            <a:off x="274320" y="1051560"/>
-            <a:ext cx="2172614" cy="164592"/>
+            <a:off x="274320" y="1060704"/>
+            <a:ext cx="2157984" cy="146304"/>
           </a:xfrm>
           <a:prstGeom prst="rect">
             <a:avLst/>
@@ -13368,8 +13173,8 @@
         </p:nvSpPr>
         <p:spPr>
           <a:xfrm>
-            <a:off x="274320" y="1207008"/>
-            <a:ext cx="2172614" cy="201168"/>
+            <a:off x="274320" y="1225296"/>
+            <a:ext cx="2157984" cy="201168"/>
           </a:xfrm>
           <a:prstGeom prst="rect">
             <a:avLst/>
@@ -13407,8 +13212,8 @@
         </p:nvSpPr>
         <p:spPr>
           <a:xfrm>
-            <a:off x="2574950" y="1024128"/>
-            <a:ext cx="2300630" cy="566928"/>
+            <a:off x="2578608" y="1024128"/>
+            <a:ext cx="2286000" cy="621792"/>
           </a:xfrm>
           <a:prstGeom prst="roundRect">
             <a:avLst>
@@ -13454,8 +13259,8 @@
         </p:nvSpPr>
         <p:spPr>
           <a:xfrm>
-            <a:off x="2648102" y="1051560"/>
-            <a:ext cx="2172614" cy="164592"/>
+            <a:off x="2651760" y="1060704"/>
+            <a:ext cx="2157984" cy="146304"/>
           </a:xfrm>
           <a:prstGeom prst="rect">
             <a:avLst/>
@@ -13493,8 +13298,8 @@
         </p:nvSpPr>
         <p:spPr>
           <a:xfrm>
-            <a:off x="2648102" y="1207008"/>
-            <a:ext cx="2172614" cy="201168"/>
+            <a:off x="2651760" y="1225296"/>
+            <a:ext cx="2157984" cy="201168"/>
           </a:xfrm>
           <a:prstGeom prst="rect">
             <a:avLst/>
@@ -13532,8 +13337,8 @@
         </p:nvSpPr>
         <p:spPr>
           <a:xfrm>
-            <a:off x="4948732" y="1024128"/>
-            <a:ext cx="2300630" cy="566928"/>
+            <a:off x="4956048" y="1024128"/>
+            <a:ext cx="2286000" cy="621792"/>
           </a:xfrm>
           <a:prstGeom prst="roundRect">
             <a:avLst>
@@ -13579,8 +13384,8 @@
         </p:nvSpPr>
         <p:spPr>
           <a:xfrm>
-            <a:off x="5021884" y="1051560"/>
-            <a:ext cx="2172614" cy="164592"/>
+            <a:off x="5029200" y="1060704"/>
+            <a:ext cx="2157984" cy="146304"/>
           </a:xfrm>
           <a:prstGeom prst="rect">
             <a:avLst/>
@@ -13618,8 +13423,8 @@
         </p:nvSpPr>
         <p:spPr>
           <a:xfrm>
-            <a:off x="5021884" y="1207008"/>
-            <a:ext cx="2172614" cy="201168"/>
+            <a:off x="5029200" y="1225296"/>
+            <a:ext cx="2157984" cy="201168"/>
           </a:xfrm>
           <a:prstGeom prst="rect">
             <a:avLst/>
@@ -13657,8 +13462,8 @@
         </p:nvSpPr>
         <p:spPr>
           <a:xfrm>
-            <a:off x="5021884" y="1408176"/>
-            <a:ext cx="2172614" cy="164592"/>
+            <a:off x="5029200" y="1444752"/>
+            <a:ext cx="2157984" cy="164592"/>
           </a:xfrm>
           <a:prstGeom prst="rect">
             <a:avLst/>
@@ -13696,8 +13501,8 @@
         </p:nvSpPr>
         <p:spPr>
           <a:xfrm>
-            <a:off x="7322515" y="1024128"/>
-            <a:ext cx="2300630" cy="566928"/>
+            <a:off x="7333488" y="1024128"/>
+            <a:ext cx="2286000" cy="621792"/>
           </a:xfrm>
           <a:prstGeom prst="roundRect">
             <a:avLst>
@@ -13743,8 +13548,8 @@
         </p:nvSpPr>
         <p:spPr>
           <a:xfrm>
-            <a:off x="7395667" y="1051560"/>
-            <a:ext cx="2172614" cy="164592"/>
+            <a:off x="7406640" y="1060704"/>
+            <a:ext cx="2157984" cy="146304"/>
           </a:xfrm>
           <a:prstGeom prst="rect">
             <a:avLst/>
@@ -13782,8 +13587,8 @@
         </p:nvSpPr>
         <p:spPr>
           <a:xfrm>
-            <a:off x="7395667" y="1207008"/>
-            <a:ext cx="2172614" cy="201168"/>
+            <a:off x="7406640" y="1225296"/>
+            <a:ext cx="2157984" cy="201168"/>
           </a:xfrm>
           <a:prstGeom prst="rect">
             <a:avLst/>
@@ -13821,8 +13626,8 @@
         </p:nvSpPr>
         <p:spPr>
           <a:xfrm>
-            <a:off x="7395667" y="1408176"/>
-            <a:ext cx="2172614" cy="164592"/>
+            <a:off x="7406640" y="1444752"/>
+            <a:ext cx="2157984" cy="164592"/>
           </a:xfrm>
           <a:prstGeom prst="rect">
             <a:avLst/>
@@ -13860,8 +13665,8 @@
         </p:nvSpPr>
         <p:spPr>
           <a:xfrm>
-            <a:off x="9696297" y="1024128"/>
-            <a:ext cx="2300630" cy="566928"/>
+            <a:off x="9710928" y="1024128"/>
+            <a:ext cx="2286000" cy="621792"/>
           </a:xfrm>
           <a:prstGeom prst="roundRect">
             <a:avLst>
@@ -13907,8 +13712,8 @@
         </p:nvSpPr>
         <p:spPr>
           <a:xfrm>
-            <a:off x="9769449" y="1051560"/>
-            <a:ext cx="2172614" cy="164592"/>
+            <a:off x="9784080" y="1060704"/>
+            <a:ext cx="2157984" cy="146304"/>
           </a:xfrm>
           <a:prstGeom prst="rect">
             <a:avLst/>
@@ -13946,8 +13751,8 @@
         </p:nvSpPr>
         <p:spPr>
           <a:xfrm>
-            <a:off x="9769449" y="1207008"/>
-            <a:ext cx="2172614" cy="201168"/>
+            <a:off x="9784080" y="1225296"/>
+            <a:ext cx="2157984" cy="201168"/>
           </a:xfrm>
           <a:prstGeom prst="rect">
             <a:avLst/>
@@ -13985,8 +13790,8 @@
         </p:nvSpPr>
         <p:spPr>
           <a:xfrm>
-            <a:off x="201168" y="1636776"/>
-            <a:ext cx="2300630" cy="566928"/>
+            <a:off x="201168" y="1719072"/>
+            <a:ext cx="2286000" cy="621792"/>
           </a:xfrm>
           <a:prstGeom prst="roundRect">
             <a:avLst>
@@ -14032,8 +13837,8 @@
         </p:nvSpPr>
         <p:spPr>
           <a:xfrm>
-            <a:off x="274320" y="1664208"/>
-            <a:ext cx="2172614" cy="164592"/>
+            <a:off x="274320" y="1755648"/>
+            <a:ext cx="2157984" cy="146304"/>
           </a:xfrm>
           <a:prstGeom prst="rect">
             <a:avLst/>
@@ -14071,8 +13876,8 @@
         </p:nvSpPr>
         <p:spPr>
           <a:xfrm>
-            <a:off x="274320" y="1819656"/>
-            <a:ext cx="2172614" cy="201168"/>
+            <a:off x="274320" y="1920240"/>
+            <a:ext cx="2157984" cy="201168"/>
           </a:xfrm>
           <a:prstGeom prst="rect">
             <a:avLst/>
@@ -14110,8 +13915,8 @@
         </p:nvSpPr>
         <p:spPr>
           <a:xfrm>
-            <a:off x="2574950" y="1636776"/>
-            <a:ext cx="2300630" cy="566928"/>
+            <a:off x="2578608" y="1719072"/>
+            <a:ext cx="2286000" cy="621792"/>
           </a:xfrm>
           <a:prstGeom prst="roundRect">
             <a:avLst>
@@ -14157,8 +13962,8 @@
         </p:nvSpPr>
         <p:spPr>
           <a:xfrm>
-            <a:off x="2648102" y="1664208"/>
-            <a:ext cx="2172614" cy="164592"/>
+            <a:off x="2651760" y="1755648"/>
+            <a:ext cx="2157984" cy="146304"/>
           </a:xfrm>
           <a:prstGeom prst="rect">
             <a:avLst/>
@@ -14196,8 +14001,8 @@
         </p:nvSpPr>
         <p:spPr>
           <a:xfrm>
-            <a:off x="2648102" y="1819656"/>
-            <a:ext cx="2172614" cy="201168"/>
+            <a:off x="2651760" y="1920240"/>
+            <a:ext cx="2157984" cy="201168"/>
           </a:xfrm>
           <a:prstGeom prst="rect">
             <a:avLst/>
@@ -14235,8 +14040,8 @@
         </p:nvSpPr>
         <p:spPr>
           <a:xfrm>
-            <a:off x="4948732" y="1636776"/>
-            <a:ext cx="2300630" cy="566928"/>
+            <a:off x="4956048" y="1719072"/>
+            <a:ext cx="2286000" cy="621792"/>
           </a:xfrm>
           <a:prstGeom prst="roundRect">
             <a:avLst>
@@ -14282,8 +14087,8 @@
         </p:nvSpPr>
         <p:spPr>
           <a:xfrm>
-            <a:off x="5021884" y="1664208"/>
-            <a:ext cx="2172614" cy="164592"/>
+            <a:off x="5029200" y="1755648"/>
+            <a:ext cx="2157984" cy="146304"/>
           </a:xfrm>
           <a:prstGeom prst="rect">
             <a:avLst/>
@@ -14321,8 +14126,8 @@
         </p:nvSpPr>
         <p:spPr>
           <a:xfrm>
-            <a:off x="5021884" y="1819656"/>
-            <a:ext cx="2172614" cy="201168"/>
+            <a:off x="5029200" y="1920240"/>
+            <a:ext cx="2157984" cy="201168"/>
           </a:xfrm>
           <a:prstGeom prst="rect">
             <a:avLst/>
@@ -14360,8 +14165,8 @@
         </p:nvSpPr>
         <p:spPr>
           <a:xfrm>
-            <a:off x="5021884" y="2020824"/>
-            <a:ext cx="2172614" cy="164592"/>
+            <a:off x="5029200" y="2139696"/>
+            <a:ext cx="2157984" cy="164592"/>
           </a:xfrm>
           <a:prstGeom prst="rect">
             <a:avLst/>
@@ -14399,8 +14204,8 @@
         </p:nvSpPr>
         <p:spPr>
           <a:xfrm>
-            <a:off x="7322515" y="1636776"/>
-            <a:ext cx="2300630" cy="566928"/>
+            <a:off x="7333488" y="1719072"/>
+            <a:ext cx="2286000" cy="621792"/>
           </a:xfrm>
           <a:prstGeom prst="roundRect">
             <a:avLst>
@@ -14446,8 +14251,8 @@
         </p:nvSpPr>
         <p:spPr>
           <a:xfrm>
-            <a:off x="7395667" y="1664208"/>
-            <a:ext cx="2172614" cy="164592"/>
+            <a:off x="7406640" y="1755648"/>
+            <a:ext cx="2157984" cy="146304"/>
           </a:xfrm>
           <a:prstGeom prst="rect">
             <a:avLst/>
@@ -14485,8 +14290,8 @@
         </p:nvSpPr>
         <p:spPr>
           <a:xfrm>
-            <a:off x="7395667" y="1819656"/>
-            <a:ext cx="2172614" cy="201168"/>
+            <a:off x="7406640" y="1920240"/>
+            <a:ext cx="2157984" cy="201168"/>
           </a:xfrm>
           <a:prstGeom prst="rect">
             <a:avLst/>
@@ -14524,8 +14329,8 @@
         </p:nvSpPr>
         <p:spPr>
           <a:xfrm>
-            <a:off x="7395667" y="2020824"/>
-            <a:ext cx="2172614" cy="164592"/>
+            <a:off x="7406640" y="2139696"/>
+            <a:ext cx="2157984" cy="164592"/>
           </a:xfrm>
           <a:prstGeom prst="rect">
             <a:avLst/>
@@ -14563,8 +14368,8 @@
         </p:nvSpPr>
         <p:spPr>
           <a:xfrm>
-            <a:off x="9696297" y="1636776"/>
-            <a:ext cx="2300630" cy="566928"/>
+            <a:off x="9710928" y="1719072"/>
+            <a:ext cx="2286000" cy="621792"/>
           </a:xfrm>
           <a:prstGeom prst="roundRect">
             <a:avLst>
@@ -14610,8 +14415,8 @@
         </p:nvSpPr>
         <p:spPr>
           <a:xfrm>
-            <a:off x="9769449" y="1664208"/>
-            <a:ext cx="2172614" cy="164592"/>
+            <a:off x="9784080" y="1755648"/>
+            <a:ext cx="2157984" cy="146304"/>
           </a:xfrm>
           <a:prstGeom prst="rect">
             <a:avLst/>
@@ -14649,8 +14454,8 @@
         </p:nvSpPr>
         <p:spPr>
           <a:xfrm>
-            <a:off x="9769449" y="1819656"/>
-            <a:ext cx="2172614" cy="201168"/>
+            <a:off x="9784080" y="1920240"/>
+            <a:ext cx="2157984" cy="201168"/>
           </a:xfrm>
           <a:prstGeom prst="rect">
             <a:avLst/>
@@ -14688,8 +14493,8 @@
         </p:nvSpPr>
         <p:spPr>
           <a:xfrm>
-            <a:off x="9769449" y="2020824"/>
-            <a:ext cx="2172614" cy="164592"/>
+            <a:off x="9784080" y="2139696"/>
+            <a:ext cx="2157984" cy="164592"/>
           </a:xfrm>
           <a:prstGeom prst="rect">
             <a:avLst/>
@@ -14727,8 +14532,8 @@
         </p:nvSpPr>
         <p:spPr>
           <a:xfrm>
-            <a:off x="201168" y="2276856"/>
-            <a:ext cx="7973568" cy="3337559"/>
+            <a:off x="201168" y="2432304"/>
+            <a:ext cx="7973568" cy="3182111"/>
           </a:xfrm>
           <a:prstGeom prst="roundRect">
             <a:avLst>
@@ -14780,8 +14585,8 @@
         </p:blipFill>
         <p:spPr>
           <a:xfrm>
-            <a:off x="424627" y="2331720"/>
-            <a:ext cx="7526649" cy="3227831"/>
+            <a:off x="605863" y="2487168"/>
+            <a:ext cx="7164176" cy="3072383"/>
           </a:xfrm>
           <a:prstGeom prst="rect">
             <a:avLst/>
@@ -14796,8 +14601,8 @@
         </p:nvSpPr>
         <p:spPr>
           <a:xfrm>
-            <a:off x="8302752" y="2276856"/>
-            <a:ext cx="3675887" cy="3337559"/>
+            <a:off x="8302752" y="2432304"/>
+            <a:ext cx="3675887" cy="3182111"/>
           </a:xfrm>
           <a:prstGeom prst="roundRect">
             <a:avLst>
@@ -14843,7 +14648,7 @@
         </p:nvSpPr>
         <p:spPr>
           <a:xfrm>
-            <a:off x="8430768" y="2322576"/>
+            <a:off x="8430768" y="2478024"/>
             <a:ext cx="3419856" cy="164592"/>
           </a:xfrm>
           <a:prstGeom prst="rect">
@@ -14882,7 +14687,7 @@
         </p:nvSpPr>
         <p:spPr>
           <a:xfrm>
-            <a:off x="8430768" y="2487168"/>
+            <a:off x="8430768" y="2642616"/>
             <a:ext cx="3419856" cy="201168"/>
           </a:xfrm>
           <a:prstGeom prst="rect">
@@ -14921,8 +14726,8 @@
         </p:nvSpPr>
         <p:spPr>
           <a:xfrm>
-            <a:off x="8430768" y="2697480"/>
-            <a:ext cx="3419856" cy="369678"/>
+            <a:off x="8430768" y="2852928"/>
+            <a:ext cx="3419856" cy="347471"/>
           </a:xfrm>
           <a:prstGeom prst="roundRect">
             <a:avLst>
@@ -14968,8 +14773,8 @@
         </p:nvSpPr>
         <p:spPr>
           <a:xfrm>
-            <a:off x="8540496" y="2724912"/>
-            <a:ext cx="3200400" cy="155265"/>
+            <a:off x="8540496" y="2880360"/>
+            <a:ext cx="3200400" cy="145938"/>
           </a:xfrm>
           <a:prstGeom prst="rect">
             <a:avLst/>
@@ -15007,8 +14812,8 @@
         </p:nvSpPr>
         <p:spPr>
           <a:xfrm>
-            <a:off x="8540496" y="2852745"/>
-            <a:ext cx="3200400" cy="192233"/>
+            <a:off x="8540496" y="2998866"/>
+            <a:ext cx="3200400" cy="180685"/>
           </a:xfrm>
           <a:prstGeom prst="rect">
             <a:avLst/>
@@ -15046,8 +14851,8 @@
         </p:nvSpPr>
         <p:spPr>
           <a:xfrm>
-            <a:off x="8430768" y="3103734"/>
-            <a:ext cx="3419856" cy="369678"/>
+            <a:off x="8430768" y="3236976"/>
+            <a:ext cx="3419856" cy="347471"/>
           </a:xfrm>
           <a:prstGeom prst="roundRect">
             <a:avLst>
@@ -15093,8 +14898,8 @@
         </p:nvSpPr>
         <p:spPr>
           <a:xfrm>
-            <a:off x="8540496" y="3131166"/>
-            <a:ext cx="3200400" cy="155265"/>
+            <a:off x="8540496" y="3264408"/>
+            <a:ext cx="3200400" cy="145938"/>
           </a:xfrm>
           <a:prstGeom prst="rect">
             <a:avLst/>
@@ -15132,8 +14937,8 @@
         </p:nvSpPr>
         <p:spPr>
           <a:xfrm>
-            <a:off x="8540496" y="3258999"/>
-            <a:ext cx="3200400" cy="192233"/>
+            <a:off x="8540496" y="3382914"/>
+            <a:ext cx="3200400" cy="180685"/>
           </a:xfrm>
           <a:prstGeom prst="rect">
             <a:avLst/>
@@ -15171,8 +14976,8 @@
         </p:nvSpPr>
         <p:spPr>
           <a:xfrm>
-            <a:off x="8430768" y="3509989"/>
-            <a:ext cx="3419856" cy="369678"/>
+            <a:off x="8430768" y="3621024"/>
+            <a:ext cx="3419856" cy="347471"/>
           </a:xfrm>
           <a:prstGeom prst="roundRect">
             <a:avLst>
@@ -15218,8 +15023,8 @@
         </p:nvSpPr>
         <p:spPr>
           <a:xfrm>
-            <a:off x="8540496" y="3537421"/>
-            <a:ext cx="3200400" cy="155265"/>
+            <a:off x="8540496" y="3648456"/>
+            <a:ext cx="3200400" cy="145938"/>
           </a:xfrm>
           <a:prstGeom prst="rect">
             <a:avLst/>
@@ -15257,8 +15062,8 @@
         </p:nvSpPr>
         <p:spPr>
           <a:xfrm>
-            <a:off x="8540496" y="3665254"/>
-            <a:ext cx="3200400" cy="192233"/>
+            <a:off x="8540496" y="3766962"/>
+            <a:ext cx="3200400" cy="180685"/>
           </a:xfrm>
           <a:prstGeom prst="rect">
             <a:avLst/>
@@ -15296,8 +15101,8 @@
         </p:nvSpPr>
         <p:spPr>
           <a:xfrm>
-            <a:off x="8430768" y="3916244"/>
-            <a:ext cx="3419856" cy="369678"/>
+            <a:off x="8430768" y="4005072"/>
+            <a:ext cx="3419856" cy="347471"/>
           </a:xfrm>
           <a:prstGeom prst="roundRect">
             <a:avLst>
@@ -15343,8 +15148,8 @@
         </p:nvSpPr>
         <p:spPr>
           <a:xfrm>
-            <a:off x="8540496" y="3943676"/>
-            <a:ext cx="3200400" cy="155265"/>
+            <a:off x="8540496" y="4032504"/>
+            <a:ext cx="3200400" cy="145938"/>
           </a:xfrm>
           <a:prstGeom prst="rect">
             <a:avLst/>
@@ -15382,8 +15187,8 @@
         </p:nvSpPr>
         <p:spPr>
           <a:xfrm>
-            <a:off x="8540496" y="4071509"/>
-            <a:ext cx="3200400" cy="192233"/>
+            <a:off x="8540496" y="4151010"/>
+            <a:ext cx="3200400" cy="180685"/>
           </a:xfrm>
           <a:prstGeom prst="rect">
             <a:avLst/>
@@ -15421,8 +15226,8 @@
         </p:nvSpPr>
         <p:spPr>
           <a:xfrm>
-            <a:off x="8430768" y="4322499"/>
-            <a:ext cx="3419856" cy="369678"/>
+            <a:off x="8430768" y="4389120"/>
+            <a:ext cx="3419856" cy="347471"/>
           </a:xfrm>
           <a:prstGeom prst="roundRect">
             <a:avLst>
@@ -15468,8 +15273,8 @@
         </p:nvSpPr>
         <p:spPr>
           <a:xfrm>
-            <a:off x="8540496" y="4349931"/>
-            <a:ext cx="3200400" cy="155265"/>
+            <a:off x="8540496" y="4416552"/>
+            <a:ext cx="3200400" cy="145938"/>
           </a:xfrm>
           <a:prstGeom prst="rect">
             <a:avLst/>
@@ -15507,8 +15312,8 @@
         </p:nvSpPr>
         <p:spPr>
           <a:xfrm>
-            <a:off x="8540496" y="4477764"/>
-            <a:ext cx="3200400" cy="192233"/>
+            <a:off x="8540496" y="4535058"/>
+            <a:ext cx="3200400" cy="180685"/>
           </a:xfrm>
           <a:prstGeom prst="rect">
             <a:avLst/>
@@ -15546,8 +15351,8 @@
         </p:nvSpPr>
         <p:spPr>
           <a:xfrm>
-            <a:off x="8430768" y="4728754"/>
-            <a:ext cx="3419856" cy="369678"/>
+            <a:off x="8430768" y="4773168"/>
+            <a:ext cx="3419856" cy="347471"/>
           </a:xfrm>
           <a:prstGeom prst="roundRect">
             <a:avLst>
@@ -15593,8 +15398,8 @@
         </p:nvSpPr>
         <p:spPr>
           <a:xfrm>
-            <a:off x="8540496" y="4756186"/>
-            <a:ext cx="3200400" cy="155265"/>
+            <a:off x="8540496" y="4800600"/>
+            <a:ext cx="3200400" cy="145938"/>
           </a:xfrm>
           <a:prstGeom prst="rect">
             <a:avLst/>
@@ -15632,8 +15437,8 @@
         </p:nvSpPr>
         <p:spPr>
           <a:xfrm>
-            <a:off x="8540496" y="4884019"/>
-            <a:ext cx="3200400" cy="192233"/>
+            <a:off x="8540496" y="4919106"/>
+            <a:ext cx="3200400" cy="180685"/>
           </a:xfrm>
           <a:prstGeom prst="rect">
             <a:avLst/>
@@ -15671,8 +15476,8 @@
         </p:nvSpPr>
         <p:spPr>
           <a:xfrm>
-            <a:off x="8430768" y="5135009"/>
-            <a:ext cx="3419856" cy="369678"/>
+            <a:off x="8430768" y="5157216"/>
+            <a:ext cx="3419856" cy="347471"/>
           </a:xfrm>
           <a:prstGeom prst="roundRect">
             <a:avLst>
@@ -15718,8 +15523,8 @@
         </p:nvSpPr>
         <p:spPr>
           <a:xfrm>
-            <a:off x="8540496" y="5162441"/>
-            <a:ext cx="3200400" cy="155265"/>
+            <a:off x="8540496" y="5184648"/>
+            <a:ext cx="3200400" cy="145938"/>
           </a:xfrm>
           <a:prstGeom prst="rect">
             <a:avLst/>
@@ -15757,8 +15562,8 @@
         </p:nvSpPr>
         <p:spPr>
           <a:xfrm>
-            <a:off x="8540496" y="5290274"/>
-            <a:ext cx="3200400" cy="192233"/>
+            <a:off x="8540496" y="5303154"/>
+            <a:ext cx="3200400" cy="180685"/>
           </a:xfrm>
           <a:prstGeom prst="rect">
             <a:avLst/>

</xml_diff>

<commit_message>
Note the PAK trunk volume that never reaches 35 or 36
The 10/08 night is 41.2 m³ at Distrito de Lujo vs 29.1 m³ in Bazar +
DL Kennedy. Call out the 12.1 m³ gap and that July nights stay near 13 m³.

Co-authored-by: anibaloperacionesWes <anibaloperacionesWes@users.noreply.github.com>
</commit_message>
<xml_diff>
--- a/reports/Parque_Arauco/TMP_7MALLS/entrega_diego_anibal/Recorrido_ejecutivo_PA_MAE_20260817.pptx
+++ b/reports/Parque_Arauco/TMP_7MALLS/entrega_diego_anibal/Recorrido_ejecutivo_PA_MAE_20260817.pptx
@@ -4443,29 +4443,29 @@
               </a:spcAft>
             </a:pPr>
             <a:r>
-              <a:rPr sz="1300" b="0">
+              <a:rPr sz="1200" b="0">
                 <a:solidFill>
                   <a:srgbClr val="0D3B66"/>
                 </a:solidFill>
                 <a:latin typeface="Calibri"/>
               </a:rPr>
-              <a:t>Julio (31 noches): Distrito de Lujo mediana 42,6 m³  ·  Bazar Gourmet 28,7 m³  ·  DL Kennedy 1,3 m³. Ejemplo 10/08 00–06: Distrito de Lujo 41,2 m³  ·  Bazar 28,2 m³  ·  DL Kennedy 0,9 m³.</a:t>
-            </a:r>
-          </a:p>
-          <a:p>
-            <a:pPr algn="l">
-              <a:spcAft>
-                <a:spcPts val="300"/>
-              </a:spcAft>
-            </a:pPr>
-            <a:r>
-              <a:rPr sz="1300" b="1">
+              <a:t>10/08 00–06: Distrito de Lujo 41,2 m³  ·  Bazar 28,2 + DL Kennedy 0,9 = 29,1 m³. Quedan 12,1 m³ en el tronco que no aparecen en esos dos ramales. En julio esa diferencia de madrugada es estable (mediana 13,1 m³/noche; Bazar + Kennedy cubren 71 % del tronco).</a:t>
+            </a:r>
+          </a:p>
+          <a:p>
+            <a:pPr algn="l">
+              <a:spcAft>
+                <a:spcPts val="300"/>
+              </a:spcAft>
+            </a:pPr>
+            <a:r>
+              <a:rPr sz="1200" b="1">
                 <a:solidFill>
                   <a:srgbClr val="0D3B66"/>
                 </a:solidFill>
                 <a:latin typeface="Calibri"/>
               </a:rPr>
-              <a:t>Propuesta: instalar control nocturno en Distrito de Lujo (tronco). De madrugada, Bazar Gourmet sigue al tronco y DL Kennedy queda residual. Cortar el tronco corta el caudal de noche del Distrito de Lujo.</a:t>
+              <a:t>No asignamos ese hueco a un destino: no está en Bazar ni en DL Kennedy. Propuesta: control nocturno en Distrito de Lujo (tronco). Cortar el tronco corta Bazar, DL Kennedy y también ese caudal no ramaleado.</a:t>
             </a:r>
           </a:p>
         </p:txBody>

</xml_diff>

<commit_message>
Simplify the MAM footer: Falabella is now the mall trunk
Keep the 68% Placa callout. Explain 15/08 as the known cutover,
set round thresholds from July and current Falabella, and point
the next split at the Falabella line for night use.

Co-authored-by: anibaloperacionesWes <anibaloperacionesWes@users.noreply.github.com>
</commit_message>
<xml_diff>
--- a/reports/Parque_Arauco/TMP_7MALLS/entrega_diego_anibal/Recorrido_ejecutivo_PA_MAE_20260817.pptx
+++ b/reports/Parque_Arauco/TMP_7MALLS/entrega_diego_anibal/Recorrido_ejecutivo_PA_MAE_20260817.pptx
@@ -11694,7 +11694,7 @@
                 </a:solidFill>
                 <a:latin typeface="Calibri"/>
               </a:rPr>
-              <a:t>Mayor consumo del recinto  ·  noche  ·  umbral  ·  Placa vs Falabella desde el 11/08</a:t>
+              <a:t>Cuando se inyecta Falabella, se corta Placa y el mall sale por Falabella</a:t>
             </a:r>
           </a:p>
         </p:txBody>
@@ -11708,7 +11708,7 @@
         <p:spPr>
           <a:xfrm>
             <a:off x="201168" y="987552"/>
-            <a:ext cx="11777472" cy="713232"/>
+            <a:ext cx="11777472" cy="658368"/>
           </a:xfrm>
           <a:prstGeom prst="roundRect">
             <a:avLst>
@@ -11755,32 +11755,32 @@
         <p:spPr>
           <a:xfrm>
             <a:off x="365760" y="1042415"/>
-            <a:ext cx="11475720" cy="603504"/>
-          </a:xfrm>
-          <a:prstGeom prst="rect">
-            <a:avLst/>
-          </a:prstGeom>
-          <a:noFill/>
-        </p:spPr>
-        <p:txBody>
-          <a:bodyPr wrap="square">
-            <a:spAutoFit/>
-          </a:bodyPr>
-          <a:lstStyle/>
-          <a:p>
-            <a:pPr algn="l">
-              <a:spcAft>
-                <a:spcPts val="300"/>
-              </a:spcAft>
-            </a:pPr>
-            <a:r>
-              <a:rPr sz="1300" b="0">
+            <a:ext cx="11475720" cy="548640"/>
+          </a:xfrm>
+          <a:prstGeom prst="rect">
+            <a:avLst/>
+          </a:prstGeom>
+          <a:noFill/>
+        </p:spPr>
+        <p:txBody>
+          <a:bodyPr wrap="square">
+            <a:spAutoFit/>
+          </a:bodyPr>
+          <a:lstStyle/>
+          <a:p>
+            <a:pPr algn="l">
+              <a:spcAft>
+                <a:spcPts val="300"/>
+              </a:spcAft>
+            </a:pPr>
+            <a:r>
+              <a:rPr sz="1400" b="0">
                 <a:solidFill>
                   <a:srgbClr val="0D3B66"/>
                 </a:solidFill>
                 <a:latin typeface="Calibri"/>
               </a:rPr>
-              <a:t>Placa Bancaria se lleva 68 % de julio (7.084 m³). Pasillo Técnico (26 m³) y ARROW (0,5 m³) son residuales. Propuesta: reubicar esos dos puntos para subdividir Placa y ver qué zona alimenta el volumen. En julio hubo madrugadas altas (hasta 65 m³); en agosto la noche queda ~0. Si esas noches vuelven, un control on/off en Placa tiene sentido. Hoy el mayor valor es partir el caudal diurno.</a:t>
+              <a:t>Placa Bancaria se lleva 68 % de julio (7.084 m³). Pasillo Técnico (26 m³) y ARROW (0,5 m³) casi no miden: son los puntos para reubicar y partir la línea.</a:t>
             </a:r>
           </a:p>
         </p:txBody>
@@ -11793,8 +11793,8 @@
         </p:nvSpPr>
         <p:spPr>
           <a:xfrm>
-            <a:off x="201168" y="1792224"/>
-            <a:ext cx="5833872" cy="3749039"/>
+            <a:off x="201168" y="1737360"/>
+            <a:ext cx="5833872" cy="3803904"/>
           </a:xfrm>
           <a:prstGeom prst="roundRect">
             <a:avLst>
@@ -11838,7 +11838,7 @@
         </p:nvSpPr>
         <p:spPr>
           <a:xfrm>
-            <a:off x="329184" y="1828800"/>
+            <a:off x="329184" y="1773936"/>
             <a:ext cx="5577840" cy="201168"/>
           </a:xfrm>
           <a:prstGeom prst="rect">
@@ -11864,7 +11864,7 @@
                 </a:solidFill>
                 <a:latin typeface="Calibri"/>
               </a:rPr>
-              <a:t>NOCHES DE PLACA — m³ 00:00–06:00 (jul–ago)</a:t>
+              <a:t>NOCHE 00–06  ·  mall cerrado</a:t>
             </a:r>
           </a:p>
         </p:txBody>
@@ -11885,7 +11885,7 @@
         </p:blipFill>
         <p:spPr>
           <a:xfrm>
-            <a:off x="292608" y="2489736"/>
+            <a:off x="292608" y="2462304"/>
             <a:ext cx="5650992" cy="2518606"/>
           </a:xfrm>
           <a:prstGeom prst="rect">
@@ -11901,8 +11901,8 @@
         </p:nvSpPr>
         <p:spPr>
           <a:xfrm>
-            <a:off x="6163056" y="1792224"/>
-            <a:ext cx="5815584" cy="3749039"/>
+            <a:off x="6163056" y="1737360"/>
+            <a:ext cx="5815584" cy="3803904"/>
           </a:xfrm>
           <a:prstGeom prst="roundRect">
             <a:avLst>
@@ -11946,7 +11946,7 @@
         </p:nvSpPr>
         <p:spPr>
           <a:xfrm>
-            <a:off x="6291072" y="1828800"/>
+            <a:off x="6291072" y="1773936"/>
             <a:ext cx="5559552" cy="201168"/>
           </a:xfrm>
           <a:prstGeom prst="rect">
@@ -11972,7 +11972,7 @@
                 </a:solidFill>
                 <a:latin typeface="Calibri"/>
               </a:rPr>
-              <a:t>PLACA vs FALABELLA — m³/día desde el 11/08</a:t>
+              <a:t>DESDE EL 15/08 EL MALL SALE POR FALABELLA</a:t>
             </a:r>
           </a:p>
         </p:txBody>
@@ -11993,7 +11993,7 @@
         </p:blipFill>
         <p:spPr>
           <a:xfrm>
-            <a:off x="6254496" y="2493811"/>
+            <a:off x="6254496" y="2466379"/>
             <a:ext cx="5632704" cy="2510456"/>
           </a:xfrm>
           <a:prstGeom prst="rect">
@@ -12056,49 +12056,49 @@
         </p:nvSpPr>
         <p:spPr>
           <a:xfrm>
-            <a:off x="365760" y="5669280"/>
-            <a:ext cx="11475720" cy="969264"/>
-          </a:xfrm>
-          <a:prstGeom prst="rect">
-            <a:avLst/>
-          </a:prstGeom>
-          <a:noFill/>
-        </p:spPr>
-        <p:txBody>
-          <a:bodyPr wrap="square">
-            <a:spAutoFit/>
-          </a:bodyPr>
-          <a:lstStyle/>
-          <a:p>
-            <a:pPr algn="l">
-              <a:spcAft>
-                <a:spcPts val="300"/>
-              </a:spcAft>
-            </a:pPr>
-            <a:r>
-              <a:rPr sz="1200" b="0">
+            <a:off x="365760" y="5687568"/>
+            <a:ext cx="11475720" cy="950976"/>
+          </a:xfrm>
+          <a:prstGeom prst="rect">
+            <a:avLst/>
+          </a:prstGeom>
+          <a:noFill/>
+        </p:spPr>
+        <p:txBody>
+          <a:bodyPr wrap="square">
+            <a:spAutoFit/>
+          </a:bodyPr>
+          <a:lstStyle/>
+          <a:p>
+            <a:pPr algn="l">
+              <a:spcAft>
+                <a:spcPts val="300"/>
+              </a:spcAft>
+            </a:pPr>
+            <a:r>
+              <a:rPr sz="1400" b="0">
                 <a:solidFill>
                   <a:srgbClr val="0D3B66"/>
                 </a:solidFill>
                 <a:latin typeface="Calibri"/>
               </a:rPr>
-              <a:t>Umbral a cargar: diario Placa 155 m³/día (agosto operativo × 1,25; atrapa un salto tipo junio ~410). Nocturno 15 m³ en 00–06 (julio–ago mediana 1,5 m³; el 10/08 = 0 m³). Eso marca noches tipo 3/07 o 13/07 (48–65 m³) sin spamear agosto, ya ~0. Falabella aún sin umbral fijo (2–3 semanas de baseline; sus noches desde el 12/08 sí entran al análisis).</a:t>
-            </a:r>
-          </a:p>
-          <a:p>
-            <a:pPr algn="l">
-              <a:spcAft>
-                <a:spcPts val="300"/>
-              </a:spcAft>
-            </a:pPr>
-            <a:r>
-              <a:rPr sz="1200" b="1">
+              <a:t>Desde el 15/08 Placa se fue a 0. Ya pasó: se inyecta Falabella, se corta Placa y el mall sale por Falabella.</a:t>
+            </a:r>
+          </a:p>
+          <a:p>
+            <a:pPr algn="l">
+              <a:spcAft>
+                <a:spcPts val="300"/>
+              </a:spcAft>
+            </a:pPr>
+            <a:r>
+              <a:rPr sz="1400" b="1">
                 <a:solidFill>
                   <a:srgbClr val="0D3B66"/>
                 </a:solidFill>
                 <a:latin typeface="Calibri"/>
               </a:rPr>
-              <a:t>11–14/08: Placa 105 m³/día vs Falabella 43 m³/día (Placa ~2,5 veces Falabella). 15–17/08 Placa suma 1 m³ y Falabella 327 m³: validar en terreno si Placa se cortó o dejó de medir. Prioridad: reubicar Pasillo Técnico y ARROW para subdividir Placa.</a:t>
+              <a:t>Umbrales: Placa 290 m³/día (julio andaba en 229). Falabella 140 m³/día (ahora ~112). Noche 15 m³: el mall está cerrado y esa madrugada es alta. Siguiente paso: subdividir la línea de Falabella para ver hacia dónde va el consumo de noche.</a:t>
             </a:r>
           </a:p>
         </p:txBody>

</xml_diff>

<commit_message>
Drop SI300 from the BOM night chart and keep only a threshold alert
The 00-06 series is San Ignacio 500 only. Top copy no longer says 300 has no control; the footer recommends a night threshold on 300, not on/off.

Co-authored-by: anibaloperacionesWes <anibaloperacionesWes@users.noreply.github.com>
</commit_message>
<xml_diff>
--- a/reports/Parque_Arauco/TMP_7MALLS/entrega_diego_anibal/Recorrido_ejecutivo_PA_MAE_20260817.pptx
+++ b/reports/Parque_Arauco/TMP_7MALLS/entrega_diego_anibal/Recorrido_ejecutivo_PA_MAE_20260817.pptx
@@ -17244,7 +17244,7 @@
                 </a:solidFill>
                 <a:latin typeface="Calibri"/>
               </a:rPr>
-              <a:t>San Ignacio 500 se lleva 79 % de julio. Control on/off operativo desde el 17/07: la madrugada pasó de 32 a 2 m³ (el 15/07 eran 36 m³) y se sostiene hasta hoy. San Ignacio 300 sigue sin control.</a:t>
+              <a:t>San Ignacio 500 se lleva 79 % de julio. Control on/off operativo desde el 17/07: la madrugada pasó de 32 a 2 m³ (el 15/07 eran 36 m³) y se sostiene hasta hoy.</a:t>
             </a:r>
           </a:p>
         </p:txBody>
@@ -17546,7 +17546,7 @@
                 </a:solidFill>
                 <a:latin typeface="Calibri"/>
               </a:rPr>
-              <a:t>Desde el 17/07 no hay noche alta: residual típico 2 m³ (máximo 4,4). No se lee como fuga. Umbrales a activar: San Ignacio 500 diario 145 m³/día (agosto ~115) y noche 8 m³ (avisa si el corte se cae). San Ignacio 300 noche 4 m³ (sin on/off).</a:t>
+              <a:t>Desde el 17/07 no hay noche alta: residual típico 2 m³ (máximo 4,4). No se lee como fuga. Umbrales a activar: San Ignacio 500 diario 145 m³/día (agosto ~115) y noche 8 m³ (avisa si el corte se cae). San Ignacio 300: alerta de umbral noche 4 m³.</a:t>
             </a:r>
           </a:p>
           <a:p>

</xml_diff>

<commit_message>
Project MAE Norte savings as 5 control hours times 30 days
Bottom copy now stacks Estanque Norte first: 3.7 m3 x 5 h x 30 d = 555 m3/month at $1,400/m3.

Co-authored-by: anibaloperacionesWes <anibaloperacionesWes@users.noreply.github.com>
</commit_message>
<xml_diff>
--- a/reports/Parque_Arauco/TMP_7MALLS/entrega_diego_anibal/Recorrido_ejecutivo_PA_MAE_20260817.pptx
+++ b/reports/Parque_Arauco/TMP_7MALLS/entrega_diego_anibal/Recorrido_ejecutivo_PA_MAE_20260817.pptx
@@ -12871,45 +12871,29 @@
               </a:spcAft>
             </a:pPr>
             <a:r>
+              <a:rPr sz="1200" b="1">
+                <a:solidFill>
+                  <a:srgbClr val="0D3B66"/>
+                </a:solidFill>
+                <a:latin typeface="Calibri"/>
+              </a:rPr>
+              <a:t>Estanque Norte (control 05/08, 00:00–05:00): noche típica 4,8 → 1,1 m³, ahorro 3,7 m³. × 5 h de control × 30 días = 555 m³/mes = $777.000/mes (tarifa $1.400/m³). Es el que más ahorra de los controles MAE.</a:t>
+            </a:r>
+          </a:p>
+          <a:p>
+            <a:pPr algn="l">
+              <a:spcAft>
+                <a:spcPts val="300"/>
+              </a:spcAft>
+            </a:pPr>
+            <a:r>
               <a:rPr sz="1200" b="0">
                 <a:solidFill>
                   <a:srgbClr val="0D3B66"/>
                 </a:solidFill>
                 <a:latin typeface="Calibri"/>
               </a:rPr>
-              <a:t>Estanque Norte (control 05/08): noche típica 4,8 → 1,1 m³. Ahorro 3,7 m³/noche ($5.194/noche · $155.820/mes). En 13 noches: 48 m³ = $67.522 (tarifa $1.400/m³).</a:t>
-            </a:r>
-          </a:p>
-          <a:p>
-            <a:pPr algn="l">
-              <a:spcAft>
-                <a:spcPts val="300"/>
-              </a:spcAft>
-            </a:pPr>
-            <a:r>
-              <a:rPr sz="1200" b="0">
-                <a:solidFill>
-                  <a:srgbClr val="0D3B66"/>
-                </a:solidFill>
-                <a:latin typeface="Calibri"/>
-              </a:rPr>
-              <a:t>Pizza Hut (control 01/07): noche típica 0,1 → 0 m³.</a:t>
-            </a:r>
-          </a:p>
-          <a:p>
-            <a:pPr algn="l">
-              <a:spcAft>
-                <a:spcPts val="300"/>
-              </a:spcAft>
-            </a:pPr>
-            <a:r>
-              <a:rPr sz="1200" b="0">
-                <a:solidFill>
-                  <a:srgbClr val="0D3B66"/>
-                </a:solidFill>
-                <a:latin typeface="Calibri"/>
-              </a:rPr>
-              <a:t>Estanque Sur: corte on/off a cargo de mantención nocturna.</a:t>
+              <a:t>Pizza Hut (control 01/07): noche típica 0,1 → 0 m³. Estanque Sur: corte on/off a cargo de mantención nocturna.</a:t>
             </a:r>
           </a:p>
           <a:p>

</xml_diff>

<commit_message>
Move MAE Norte savings to the top findings box and drop node IDs from chips
Put the 4,8 → 1,1 m³ / 555 m³/mes / $777.000/mes calculation in the gold MAE hallazgos callout. Show point names only (no 000025-xx) on chips, PAK notes, and captions.

Co-authored-by: anibaloperacionesWes <anibaloperacionesWes@users.noreply.github.com>
</commit_message>
<xml_diff>
--- a/reports/Parque_Arauco/TMP_7MALLS/entrega_diego_anibal/Recorrido_ejecutivo_PA_MAE_20260817.pptx
+++ b/reports/Parque_Arauco/TMP_7MALLS/entrega_diego_anibal/Recorrido_ejecutivo_PA_MAE_20260817.pptx
@@ -3579,33 +3579,33 @@
         </p:nvSpPr>
         <p:spPr>
           <a:xfrm>
-            <a:off x="274320" y="1060704"/>
-            <a:ext cx="5733288" cy="146304"/>
-          </a:xfrm>
-          <a:prstGeom prst="rect">
-            <a:avLst/>
-          </a:prstGeom>
-          <a:noFill/>
-        </p:spPr>
-        <p:txBody>
-          <a:bodyPr wrap="square">
-            <a:spAutoFit/>
-          </a:bodyPr>
-          <a:lstStyle/>
-          <a:p>
-            <a:pPr algn="l">
-              <a:spcAft>
-                <a:spcPts val="300"/>
-              </a:spcAft>
-            </a:pPr>
-            <a:r>
-              <a:rPr sz="1000" b="1">
-                <a:solidFill>
-                  <a:srgbClr val="C9A227"/>
-                </a:solidFill>
-                <a:latin typeface="Calibri"/>
-              </a:rPr>
-              <a:t>000025-11</a:t>
+            <a:off x="274320" y="1115568"/>
+            <a:ext cx="5733288" cy="292608"/>
+          </a:xfrm>
+          <a:prstGeom prst="rect">
+            <a:avLst/>
+          </a:prstGeom>
+          <a:noFill/>
+        </p:spPr>
+        <p:txBody>
+          <a:bodyPr wrap="square">
+            <a:spAutoFit/>
+          </a:bodyPr>
+          <a:lstStyle/>
+          <a:p>
+            <a:pPr algn="l">
+              <a:spcAft>
+                <a:spcPts val="300"/>
+              </a:spcAft>
+            </a:pPr>
+            <a:r>
+              <a:rPr sz="1300" b="1">
+                <a:solidFill>
+                  <a:srgbClr val="0D3B66"/>
+                </a:solidFill>
+                <a:latin typeface="Calibri"/>
+              </a:rPr>
+              <a:t>Matriz 1° piso</a:t>
             </a:r>
           </a:p>
         </p:txBody>
@@ -3613,45 +3613,6 @@
       <p:sp>
         <p:nvSpPr>
           <p:cNvPr id="9" name="TextBox 8"/>
-          <p:cNvSpPr txBox="1"/>
-          <p:nvPr/>
-        </p:nvSpPr>
-        <p:spPr>
-          <a:xfrm>
-            <a:off x="274320" y="1243584"/>
-            <a:ext cx="5733288" cy="201168"/>
-          </a:xfrm>
-          <a:prstGeom prst="rect">
-            <a:avLst/>
-          </a:prstGeom>
-          <a:noFill/>
-        </p:spPr>
-        <p:txBody>
-          <a:bodyPr wrap="square">
-            <a:spAutoFit/>
-          </a:bodyPr>
-          <a:lstStyle/>
-          <a:p>
-            <a:pPr algn="l">
-              <a:spcAft>
-                <a:spcPts val="300"/>
-              </a:spcAft>
-            </a:pPr>
-            <a:r>
-              <a:rPr sz="1200" b="1">
-                <a:solidFill>
-                  <a:srgbClr val="0D3B66"/>
-                </a:solidFill>
-                <a:latin typeface="Calibri"/>
-              </a:rPr>
-              <a:t>Matriz 1° piso</a:t>
-            </a:r>
-          </a:p>
-        </p:txBody>
-      </p:sp>
-      <p:sp>
-        <p:nvSpPr>
-          <p:cNvPr id="10" name="TextBox 9"/>
           <p:cNvSpPr txBox="1"/>
           <p:nvPr/>
         </p:nvSpPr>
@@ -3690,7 +3651,7 @@
       </p:sp>
       <p:sp>
         <p:nvSpPr>
-          <p:cNvPr id="11" name="Rounded Rectangle 10"/>
+          <p:cNvPr id="10" name="Rounded Rectangle 9"/>
           <p:cNvSpPr/>
           <p:nvPr/>
         </p:nvSpPr>
@@ -3737,72 +3698,33 @@
       </p:sp>
       <p:sp>
         <p:nvSpPr>
-          <p:cNvPr id="12" name="TextBox 11"/>
-          <p:cNvSpPr txBox="1"/>
-          <p:nvPr/>
-        </p:nvSpPr>
-        <p:spPr>
-          <a:xfrm>
-            <a:off x="6208776" y="1060704"/>
-            <a:ext cx="5733288" cy="146304"/>
-          </a:xfrm>
-          <a:prstGeom prst="rect">
-            <a:avLst/>
-          </a:prstGeom>
-          <a:noFill/>
-        </p:spPr>
-        <p:txBody>
-          <a:bodyPr wrap="square">
-            <a:spAutoFit/>
-          </a:bodyPr>
-          <a:lstStyle/>
-          <a:p>
-            <a:pPr algn="l">
-              <a:spcAft>
-                <a:spcPts val="300"/>
-              </a:spcAft>
-            </a:pPr>
-            <a:r>
-              <a:rPr sz="1000" b="1">
-                <a:solidFill>
-                  <a:srgbClr val="C9A227"/>
-                </a:solidFill>
-                <a:latin typeface="Calibri"/>
-              </a:rPr>
-              <a:t>000025-12</a:t>
-            </a:r>
-          </a:p>
-        </p:txBody>
-      </p:sp>
-      <p:sp>
-        <p:nvSpPr>
-          <p:cNvPr id="13" name="TextBox 12"/>
-          <p:cNvSpPr txBox="1"/>
-          <p:nvPr/>
-        </p:nvSpPr>
-        <p:spPr>
-          <a:xfrm>
-            <a:off x="6208776" y="1243584"/>
-            <a:ext cx="5733288" cy="201168"/>
-          </a:xfrm>
-          <a:prstGeom prst="rect">
-            <a:avLst/>
-          </a:prstGeom>
-          <a:noFill/>
-        </p:spPr>
-        <p:txBody>
-          <a:bodyPr wrap="square">
-            <a:spAutoFit/>
-          </a:bodyPr>
-          <a:lstStyle/>
-          <a:p>
-            <a:pPr algn="l">
-              <a:spcAft>
-                <a:spcPts val="300"/>
-              </a:spcAft>
-            </a:pPr>
-            <a:r>
-              <a:rPr sz="1200" b="1">
+          <p:cNvPr id="11" name="TextBox 10"/>
+          <p:cNvSpPr txBox="1"/>
+          <p:nvPr/>
+        </p:nvSpPr>
+        <p:spPr>
+          <a:xfrm>
+            <a:off x="6208776" y="1115568"/>
+            <a:ext cx="5733288" cy="292608"/>
+          </a:xfrm>
+          <a:prstGeom prst="rect">
+            <a:avLst/>
+          </a:prstGeom>
+          <a:noFill/>
+        </p:spPr>
+        <p:txBody>
+          <a:bodyPr wrap="square">
+            <a:spAutoFit/>
+          </a:bodyPr>
+          <a:lstStyle/>
+          <a:p>
+            <a:pPr algn="l">
+              <a:spcAft>
+                <a:spcPts val="300"/>
+              </a:spcAft>
+            </a:pPr>
+            <a:r>
+              <a:rPr sz="1300" b="1">
                 <a:solidFill>
                   <a:srgbClr val="0D3B66"/>
                 </a:solidFill>
@@ -3815,7 +3737,7 @@
       </p:sp>
       <p:sp>
         <p:nvSpPr>
-          <p:cNvPr id="14" name="Rounded Rectangle 13"/>
+          <p:cNvPr id="12" name="Rounded Rectangle 11"/>
           <p:cNvSpPr/>
           <p:nvPr/>
         </p:nvSpPr>
@@ -3860,7 +3782,7 @@
       </p:sp>
       <p:pic>
         <p:nvPicPr>
-          <p:cNvPr id="15" name="Picture 14" descr="aeb_mensual_may_ago.png"/>
+          <p:cNvPr id="13" name="Picture 12" descr="aeb_mensual_may_ago.png"/>
           <p:cNvPicPr>
             <a:picLocks noChangeAspect="1"/>
           </p:cNvPicPr>
@@ -3884,7 +3806,7 @@
       </p:pic>
       <p:sp>
         <p:nvSpPr>
-          <p:cNvPr id="16" name="Rounded Rectangle 15"/>
+          <p:cNvPr id="14" name="Rounded Rectangle 13"/>
           <p:cNvSpPr/>
           <p:nvPr/>
         </p:nvSpPr>
@@ -3931,7 +3853,7 @@
       </p:sp>
       <p:sp>
         <p:nvSpPr>
-          <p:cNvPr id="17" name="TextBox 16"/>
+          <p:cNvPr id="15" name="TextBox 14"/>
           <p:cNvSpPr txBox="1"/>
           <p:nvPr/>
         </p:nvSpPr>
@@ -3970,7 +3892,7 @@
       </p:sp>
       <p:sp>
         <p:nvSpPr>
-          <p:cNvPr id="18" name="TextBox 17"/>
+          <p:cNvPr id="16" name="TextBox 15"/>
           <p:cNvSpPr txBox="1"/>
           <p:nvPr/>
         </p:nvSpPr>
@@ -4009,7 +3931,7 @@
       </p:sp>
       <p:sp>
         <p:nvSpPr>
-          <p:cNvPr id="19" name="Rounded Rectangle 18"/>
+          <p:cNvPr id="17" name="Rounded Rectangle 16"/>
           <p:cNvSpPr/>
           <p:nvPr/>
         </p:nvSpPr>
@@ -4056,7 +3978,7 @@
       </p:sp>
       <p:sp>
         <p:nvSpPr>
-          <p:cNvPr id="20" name="TextBox 19"/>
+          <p:cNvPr id="18" name="TextBox 17"/>
           <p:cNvSpPr txBox="1"/>
           <p:nvPr/>
         </p:nvSpPr>
@@ -4095,7 +4017,7 @@
       </p:sp>
       <p:sp>
         <p:nvSpPr>
-          <p:cNvPr id="21" name="TextBox 20"/>
+          <p:cNvPr id="19" name="TextBox 18"/>
           <p:cNvSpPr txBox="1"/>
           <p:nvPr/>
         </p:nvSpPr>
@@ -4134,7 +4056,7 @@
       </p:sp>
       <p:sp>
         <p:nvSpPr>
-          <p:cNvPr id="22" name="Rounded Rectangle 21"/>
+          <p:cNvPr id="20" name="Rounded Rectangle 19"/>
           <p:cNvSpPr/>
           <p:nvPr/>
         </p:nvSpPr>
@@ -4181,7 +4103,7 @@
       </p:sp>
       <p:sp>
         <p:nvSpPr>
-          <p:cNvPr id="23" name="TextBox 22"/>
+          <p:cNvPr id="21" name="TextBox 20"/>
           <p:cNvSpPr txBox="1"/>
           <p:nvPr/>
         </p:nvSpPr>
@@ -4220,7 +4142,7 @@
       </p:sp>
       <p:sp>
         <p:nvSpPr>
-          <p:cNvPr id="24" name="TextBox 23"/>
+          <p:cNvPr id="22" name="TextBox 21"/>
           <p:cNvSpPr txBox="1"/>
           <p:nvPr/>
         </p:nvSpPr>
@@ -4259,7 +4181,7 @@
       </p:sp>
       <p:sp>
         <p:nvSpPr>
-          <p:cNvPr id="25" name="Rounded Rectangle 24"/>
+          <p:cNvPr id="23" name="Rounded Rectangle 22"/>
           <p:cNvSpPr/>
           <p:nvPr/>
         </p:nvSpPr>
@@ -4306,7 +4228,7 @@
       </p:sp>
       <p:sp>
         <p:nvSpPr>
-          <p:cNvPr id="26" name="TextBox 25"/>
+          <p:cNvPr id="24" name="TextBox 23"/>
           <p:cNvSpPr txBox="1"/>
           <p:nvPr/>
         </p:nvSpPr>
@@ -4345,7 +4267,7 @@
       </p:sp>
       <p:sp>
         <p:nvSpPr>
-          <p:cNvPr id="27" name="TextBox 26"/>
+          <p:cNvPr id="25" name="TextBox 24"/>
           <p:cNvSpPr txBox="1"/>
           <p:nvPr/>
         </p:nvSpPr>
@@ -5269,66 +5191,27 @@
         </p:nvSpPr>
         <p:spPr>
           <a:xfrm>
-            <a:off x="274320" y="1060704"/>
-            <a:ext cx="5733288" cy="146304"/>
-          </a:xfrm>
-          <a:prstGeom prst="rect">
-            <a:avLst/>
-          </a:prstGeom>
-          <a:noFill/>
-        </p:spPr>
-        <p:txBody>
-          <a:bodyPr wrap="square">
-            <a:spAutoFit/>
-          </a:bodyPr>
-          <a:lstStyle/>
-          <a:p>
-            <a:pPr algn="l">
-              <a:spcAft>
-                <a:spcPts val="300"/>
-              </a:spcAft>
-            </a:pPr>
-            <a:r>
-              <a:rPr sz="1000" b="1">
-                <a:solidFill>
-                  <a:srgbClr val="C9A227"/>
-                </a:solidFill>
-                <a:latin typeface="Calibri"/>
-              </a:rPr>
-              <a:t>000025-38</a:t>
-            </a:r>
-          </a:p>
-        </p:txBody>
-      </p:sp>
-      <p:sp>
-        <p:nvSpPr>
-          <p:cNvPr id="9" name="TextBox 8"/>
-          <p:cNvSpPr txBox="1"/>
-          <p:nvPr/>
-        </p:nvSpPr>
-        <p:spPr>
-          <a:xfrm>
-            <a:off x="274320" y="1243584"/>
-            <a:ext cx="5733288" cy="201168"/>
-          </a:xfrm>
-          <a:prstGeom prst="rect">
-            <a:avLst/>
-          </a:prstGeom>
-          <a:noFill/>
-        </p:spPr>
-        <p:txBody>
-          <a:bodyPr wrap="square">
-            <a:spAutoFit/>
-          </a:bodyPr>
-          <a:lstStyle/>
-          <a:p>
-            <a:pPr algn="l">
-              <a:spcAft>
-                <a:spcPts val="300"/>
-              </a:spcAft>
-            </a:pPr>
-            <a:r>
-              <a:rPr sz="1200" b="1">
+            <a:off x="274320" y="1115568"/>
+            <a:ext cx="5733288" cy="292608"/>
+          </a:xfrm>
+          <a:prstGeom prst="rect">
+            <a:avLst/>
+          </a:prstGeom>
+          <a:noFill/>
+        </p:spPr>
+        <p:txBody>
+          <a:bodyPr wrap="square">
+            <a:spAutoFit/>
+          </a:bodyPr>
+          <a:lstStyle/>
+          <a:p>
+            <a:pPr algn="l">
+              <a:spcAft>
+                <a:spcPts val="300"/>
+              </a:spcAft>
+            </a:pPr>
+            <a:r>
+              <a:rPr sz="1300" b="1">
                 <a:solidFill>
                   <a:srgbClr val="0D3B66"/>
                 </a:solidFill>
@@ -5341,7 +5224,7 @@
       </p:sp>
       <p:sp>
         <p:nvSpPr>
-          <p:cNvPr id="10" name="Rounded Rectangle 9"/>
+          <p:cNvPr id="9" name="Rounded Rectangle 8"/>
           <p:cNvSpPr/>
           <p:nvPr/>
         </p:nvSpPr>
@@ -5388,72 +5271,33 @@
       </p:sp>
       <p:sp>
         <p:nvSpPr>
-          <p:cNvPr id="11" name="TextBox 10"/>
-          <p:cNvSpPr txBox="1"/>
-          <p:nvPr/>
-        </p:nvSpPr>
-        <p:spPr>
-          <a:xfrm>
-            <a:off x="6208776" y="1060704"/>
-            <a:ext cx="5733288" cy="146304"/>
-          </a:xfrm>
-          <a:prstGeom prst="rect">
-            <a:avLst/>
-          </a:prstGeom>
-          <a:noFill/>
-        </p:spPr>
-        <p:txBody>
-          <a:bodyPr wrap="square">
-            <a:spAutoFit/>
-          </a:bodyPr>
-          <a:lstStyle/>
-          <a:p>
-            <a:pPr algn="l">
-              <a:spcAft>
-                <a:spcPts val="300"/>
-              </a:spcAft>
-            </a:pPr>
-            <a:r>
-              <a:rPr sz="1000" b="1">
-                <a:solidFill>
-                  <a:srgbClr val="C9A227"/>
-                </a:solidFill>
-                <a:latin typeface="Calibri"/>
-              </a:rPr>
-              <a:t>000025-37</a:t>
-            </a:r>
-          </a:p>
-        </p:txBody>
-      </p:sp>
-      <p:sp>
-        <p:nvSpPr>
-          <p:cNvPr id="12" name="TextBox 11"/>
-          <p:cNvSpPr txBox="1"/>
-          <p:nvPr/>
-        </p:nvSpPr>
-        <p:spPr>
-          <a:xfrm>
-            <a:off x="6208776" y="1243584"/>
-            <a:ext cx="5733288" cy="201168"/>
-          </a:xfrm>
-          <a:prstGeom prst="rect">
-            <a:avLst/>
-          </a:prstGeom>
-          <a:noFill/>
-        </p:spPr>
-        <p:txBody>
-          <a:bodyPr wrap="square">
-            <a:spAutoFit/>
-          </a:bodyPr>
-          <a:lstStyle/>
-          <a:p>
-            <a:pPr algn="l">
-              <a:spcAft>
-                <a:spcPts val="300"/>
-              </a:spcAft>
-            </a:pPr>
-            <a:r>
-              <a:rPr sz="1200" b="1">
+          <p:cNvPr id="10" name="TextBox 9"/>
+          <p:cNvSpPr txBox="1"/>
+          <p:nvPr/>
+        </p:nvSpPr>
+        <p:spPr>
+          <a:xfrm>
+            <a:off x="6208776" y="1115568"/>
+            <a:ext cx="5733288" cy="292608"/>
+          </a:xfrm>
+          <a:prstGeom prst="rect">
+            <a:avLst/>
+          </a:prstGeom>
+          <a:noFill/>
+        </p:spPr>
+        <p:txBody>
+          <a:bodyPr wrap="square">
+            <a:spAutoFit/>
+          </a:bodyPr>
+          <a:lstStyle/>
+          <a:p>
+            <a:pPr algn="l">
+              <a:spcAft>
+                <a:spcPts val="300"/>
+              </a:spcAft>
+            </a:pPr>
+            <a:r>
+              <a:rPr sz="1300" b="1">
                 <a:solidFill>
                   <a:srgbClr val="0D3B66"/>
                 </a:solidFill>
@@ -5466,7 +5310,7 @@
       </p:sp>
       <p:sp>
         <p:nvSpPr>
-          <p:cNvPr id="13" name="Rounded Rectangle 12"/>
+          <p:cNvPr id="11" name="Rounded Rectangle 10"/>
           <p:cNvSpPr/>
           <p:nvPr/>
         </p:nvSpPr>
@@ -5511,7 +5355,7 @@
       </p:sp>
       <p:pic>
         <p:nvPicPr>
-          <p:cNvPr id="14" name="Picture 13" descr="cur_mensual_may_ago.png"/>
+          <p:cNvPr id="12" name="Picture 11" descr="cur_mensual_may_ago.png"/>
           <p:cNvPicPr>
             <a:picLocks noChangeAspect="1"/>
           </p:cNvPicPr>
@@ -5535,7 +5379,7 @@
       </p:pic>
       <p:sp>
         <p:nvSpPr>
-          <p:cNvPr id="15" name="Rounded Rectangle 14"/>
+          <p:cNvPr id="13" name="Rounded Rectangle 12"/>
           <p:cNvSpPr/>
           <p:nvPr/>
         </p:nvSpPr>
@@ -5582,7 +5426,7 @@
       </p:sp>
       <p:sp>
         <p:nvSpPr>
-          <p:cNvPr id="16" name="TextBox 15"/>
+          <p:cNvPr id="14" name="TextBox 13"/>
           <p:cNvSpPr txBox="1"/>
           <p:nvPr/>
         </p:nvSpPr>
@@ -5621,7 +5465,7 @@
       </p:sp>
       <p:sp>
         <p:nvSpPr>
-          <p:cNvPr id="17" name="TextBox 16"/>
+          <p:cNvPr id="15" name="TextBox 14"/>
           <p:cNvSpPr txBox="1"/>
           <p:nvPr/>
         </p:nvSpPr>
@@ -5660,7 +5504,7 @@
       </p:sp>
       <p:sp>
         <p:nvSpPr>
-          <p:cNvPr id="18" name="Rounded Rectangle 17"/>
+          <p:cNvPr id="16" name="Rounded Rectangle 15"/>
           <p:cNvSpPr/>
           <p:nvPr/>
         </p:nvSpPr>
@@ -5707,7 +5551,7 @@
       </p:sp>
       <p:sp>
         <p:nvSpPr>
-          <p:cNvPr id="19" name="TextBox 18"/>
+          <p:cNvPr id="17" name="TextBox 16"/>
           <p:cNvSpPr txBox="1"/>
           <p:nvPr/>
         </p:nvSpPr>
@@ -5746,7 +5590,7 @@
       </p:sp>
       <p:sp>
         <p:nvSpPr>
-          <p:cNvPr id="20" name="TextBox 19"/>
+          <p:cNvPr id="18" name="TextBox 17"/>
           <p:cNvSpPr txBox="1"/>
           <p:nvPr/>
         </p:nvSpPr>
@@ -5785,7 +5629,7 @@
       </p:sp>
       <p:sp>
         <p:nvSpPr>
-          <p:cNvPr id="21" name="Rounded Rectangle 20"/>
+          <p:cNvPr id="19" name="Rounded Rectangle 18"/>
           <p:cNvSpPr/>
           <p:nvPr/>
         </p:nvSpPr>
@@ -5832,7 +5676,7 @@
       </p:sp>
       <p:sp>
         <p:nvSpPr>
-          <p:cNvPr id="22" name="TextBox 21"/>
+          <p:cNvPr id="20" name="TextBox 19"/>
           <p:cNvSpPr txBox="1"/>
           <p:nvPr/>
         </p:nvSpPr>
@@ -5871,7 +5715,7 @@
       </p:sp>
       <p:sp>
         <p:nvSpPr>
-          <p:cNvPr id="23" name="TextBox 22"/>
+          <p:cNvPr id="21" name="TextBox 20"/>
           <p:cNvSpPr txBox="1"/>
           <p:nvPr/>
         </p:nvSpPr>
@@ -5910,7 +5754,7 @@
       </p:sp>
       <p:sp>
         <p:nvSpPr>
-          <p:cNvPr id="24" name="Rounded Rectangle 23"/>
+          <p:cNvPr id="22" name="Rounded Rectangle 21"/>
           <p:cNvSpPr/>
           <p:nvPr/>
         </p:nvSpPr>
@@ -5957,7 +5801,7 @@
       </p:sp>
       <p:sp>
         <p:nvSpPr>
-          <p:cNvPr id="25" name="TextBox 24"/>
+          <p:cNvPr id="23" name="TextBox 22"/>
           <p:cNvSpPr txBox="1"/>
           <p:nvPr/>
         </p:nvSpPr>
@@ -5996,7 +5840,7 @@
       </p:sp>
       <p:sp>
         <p:nvSpPr>
-          <p:cNvPr id="26" name="TextBox 25"/>
+          <p:cNvPr id="24" name="TextBox 23"/>
           <p:cNvSpPr txBox="1"/>
           <p:nvPr/>
         </p:nvSpPr>
@@ -6860,7 +6704,7 @@
                 </a:solidFill>
                 <a:latin typeface="Calibri"/>
               </a:rPr>
-              <a:t>Parque Arauco Kennedy   |   10 puntos WES   |   julio = cabecera (sin 27, 35 y 36)   |   01/05/2026 – 17/08/2026</a:t>
+              <a:t>Parque Arauco Kennedy   |   10 puntos WES   |   julio = cabecera (sin cadena DL)   |   01/05/2026 – 17/08/2026</a:t>
             </a:r>
           </a:p>
         </p:txBody>
@@ -6920,66 +6764,27 @@
         </p:nvSpPr>
         <p:spPr>
           <a:xfrm>
-            <a:off x="274320" y="1060704"/>
-            <a:ext cx="2157984" cy="146304"/>
-          </a:xfrm>
-          <a:prstGeom prst="rect">
-            <a:avLst/>
-          </a:prstGeom>
-          <a:noFill/>
-        </p:spPr>
-        <p:txBody>
-          <a:bodyPr wrap="square">
-            <a:spAutoFit/>
-          </a:bodyPr>
-          <a:lstStyle/>
-          <a:p>
-            <a:pPr algn="l">
-              <a:spcAft>
-                <a:spcPts val="300"/>
-              </a:spcAft>
-            </a:pPr>
-            <a:r>
-              <a:rPr sz="900" b="1">
-                <a:solidFill>
-                  <a:srgbClr val="C9A227"/>
-                </a:solidFill>
-                <a:latin typeface="Calibri"/>
-              </a:rPr>
-              <a:t>000025-20</a:t>
-            </a:r>
-          </a:p>
-        </p:txBody>
-      </p:sp>
-      <p:sp>
-        <p:nvSpPr>
-          <p:cNvPr id="9" name="TextBox 8"/>
-          <p:cNvSpPr txBox="1"/>
-          <p:nvPr/>
-        </p:nvSpPr>
-        <p:spPr>
-          <a:xfrm>
-            <a:off x="274320" y="1225296"/>
-            <a:ext cx="2157984" cy="201168"/>
-          </a:xfrm>
-          <a:prstGeom prst="rect">
-            <a:avLst/>
-          </a:prstGeom>
-          <a:noFill/>
-        </p:spPr>
-        <p:txBody>
-          <a:bodyPr wrap="square">
-            <a:spAutoFit/>
-          </a:bodyPr>
-          <a:lstStyle/>
-          <a:p>
-            <a:pPr algn="l">
-              <a:spcAft>
-                <a:spcPts val="300"/>
-              </a:spcAft>
-            </a:pPr>
-            <a:r>
-              <a:rPr sz="1100" b="1">
+            <a:off x="274320" y="1115568"/>
+            <a:ext cx="2157984" cy="292608"/>
+          </a:xfrm>
+          <a:prstGeom prst="rect">
+            <a:avLst/>
+          </a:prstGeom>
+          <a:noFill/>
+        </p:spPr>
+        <p:txBody>
+          <a:bodyPr wrap="square">
+            <a:spAutoFit/>
+          </a:bodyPr>
+          <a:lstStyle/>
+          <a:p>
+            <a:pPr algn="l">
+              <a:spcAft>
+                <a:spcPts val="300"/>
+              </a:spcAft>
+            </a:pPr>
+            <a:r>
+              <a:rPr sz="1200" b="1">
                 <a:solidFill>
                   <a:srgbClr val="0D3B66"/>
                 </a:solidFill>
@@ -6992,7 +6797,7 @@
       </p:sp>
       <p:sp>
         <p:nvSpPr>
-          <p:cNvPr id="10" name="Rounded Rectangle 9"/>
+          <p:cNvPr id="9" name="Rounded Rectangle 8"/>
           <p:cNvSpPr/>
           <p:nvPr/>
         </p:nvSpPr>
@@ -7039,72 +6844,33 @@
       </p:sp>
       <p:sp>
         <p:nvSpPr>
-          <p:cNvPr id="11" name="TextBox 10"/>
-          <p:cNvSpPr txBox="1"/>
-          <p:nvPr/>
-        </p:nvSpPr>
-        <p:spPr>
-          <a:xfrm>
-            <a:off x="2651760" y="1060704"/>
-            <a:ext cx="2157984" cy="146304"/>
-          </a:xfrm>
-          <a:prstGeom prst="rect">
-            <a:avLst/>
-          </a:prstGeom>
-          <a:noFill/>
-        </p:spPr>
-        <p:txBody>
-          <a:bodyPr wrap="square">
-            <a:spAutoFit/>
-          </a:bodyPr>
-          <a:lstStyle/>
-          <a:p>
-            <a:pPr algn="l">
-              <a:spcAft>
-                <a:spcPts val="300"/>
-              </a:spcAft>
-            </a:pPr>
-            <a:r>
-              <a:rPr sz="900" b="1">
-                <a:solidFill>
-                  <a:srgbClr val="C9A227"/>
-                </a:solidFill>
-                <a:latin typeface="Calibri"/>
-              </a:rPr>
-              <a:t>000025-21</a:t>
-            </a:r>
-          </a:p>
-        </p:txBody>
-      </p:sp>
-      <p:sp>
-        <p:nvSpPr>
-          <p:cNvPr id="12" name="TextBox 11"/>
-          <p:cNvSpPr txBox="1"/>
-          <p:nvPr/>
-        </p:nvSpPr>
-        <p:spPr>
-          <a:xfrm>
-            <a:off x="2651760" y="1225296"/>
-            <a:ext cx="2157984" cy="201168"/>
-          </a:xfrm>
-          <a:prstGeom prst="rect">
-            <a:avLst/>
-          </a:prstGeom>
-          <a:noFill/>
-        </p:spPr>
-        <p:txBody>
-          <a:bodyPr wrap="square">
-            <a:spAutoFit/>
-          </a:bodyPr>
-          <a:lstStyle/>
-          <a:p>
-            <a:pPr algn="l">
-              <a:spcAft>
-                <a:spcPts val="300"/>
-              </a:spcAft>
-            </a:pPr>
-            <a:r>
-              <a:rPr sz="1100" b="1">
+          <p:cNvPr id="10" name="TextBox 9"/>
+          <p:cNvSpPr txBox="1"/>
+          <p:nvPr/>
+        </p:nvSpPr>
+        <p:spPr>
+          <a:xfrm>
+            <a:off x="2651760" y="1115568"/>
+            <a:ext cx="2157984" cy="292608"/>
+          </a:xfrm>
+          <a:prstGeom prst="rect">
+            <a:avLst/>
+          </a:prstGeom>
+          <a:noFill/>
+        </p:spPr>
+        <p:txBody>
+          <a:bodyPr wrap="square">
+            <a:spAutoFit/>
+          </a:bodyPr>
+          <a:lstStyle/>
+          <a:p>
+            <a:pPr algn="l">
+              <a:spcAft>
+                <a:spcPts val="300"/>
+              </a:spcAft>
+            </a:pPr>
+            <a:r>
+              <a:rPr sz="1200" b="1">
                 <a:solidFill>
                   <a:srgbClr val="0D3B66"/>
                 </a:solidFill>
@@ -7117,7 +6883,7 @@
       </p:sp>
       <p:sp>
         <p:nvSpPr>
-          <p:cNvPr id="13" name="Rounded Rectangle 12"/>
+          <p:cNvPr id="11" name="Rounded Rectangle 10"/>
           <p:cNvSpPr/>
           <p:nvPr/>
         </p:nvSpPr>
@@ -7164,72 +6930,33 @@
       </p:sp>
       <p:sp>
         <p:nvSpPr>
-          <p:cNvPr id="14" name="TextBox 13"/>
-          <p:cNvSpPr txBox="1"/>
-          <p:nvPr/>
-        </p:nvSpPr>
-        <p:spPr>
-          <a:xfrm>
-            <a:off x="5029200" y="1060704"/>
-            <a:ext cx="2157984" cy="146304"/>
-          </a:xfrm>
-          <a:prstGeom prst="rect">
-            <a:avLst/>
-          </a:prstGeom>
-          <a:noFill/>
-        </p:spPr>
-        <p:txBody>
-          <a:bodyPr wrap="square">
-            <a:spAutoFit/>
-          </a:bodyPr>
-          <a:lstStyle/>
-          <a:p>
-            <a:pPr algn="l">
-              <a:spcAft>
-                <a:spcPts val="300"/>
-              </a:spcAft>
-            </a:pPr>
-            <a:r>
-              <a:rPr sz="900" b="1">
-                <a:solidFill>
-                  <a:srgbClr val="C9A227"/>
-                </a:solidFill>
-                <a:latin typeface="Calibri"/>
-              </a:rPr>
-              <a:t>000025-22</a:t>
-            </a:r>
-          </a:p>
-        </p:txBody>
-      </p:sp>
-      <p:sp>
-        <p:nvSpPr>
-          <p:cNvPr id="15" name="TextBox 14"/>
-          <p:cNvSpPr txBox="1"/>
-          <p:nvPr/>
-        </p:nvSpPr>
-        <p:spPr>
-          <a:xfrm>
-            <a:off x="5029200" y="1225296"/>
-            <a:ext cx="2157984" cy="201168"/>
-          </a:xfrm>
-          <a:prstGeom prst="rect">
-            <a:avLst/>
-          </a:prstGeom>
-          <a:noFill/>
-        </p:spPr>
-        <p:txBody>
-          <a:bodyPr wrap="square">
-            <a:spAutoFit/>
-          </a:bodyPr>
-          <a:lstStyle/>
-          <a:p>
-            <a:pPr algn="l">
-              <a:spcAft>
-                <a:spcPts val="300"/>
-              </a:spcAft>
-            </a:pPr>
-            <a:r>
-              <a:rPr sz="1100" b="1">
+          <p:cNvPr id="12" name="TextBox 11"/>
+          <p:cNvSpPr txBox="1"/>
+          <p:nvPr/>
+        </p:nvSpPr>
+        <p:spPr>
+          <a:xfrm>
+            <a:off x="5029200" y="1115568"/>
+            <a:ext cx="2157984" cy="292608"/>
+          </a:xfrm>
+          <a:prstGeom prst="rect">
+            <a:avLst/>
+          </a:prstGeom>
+          <a:noFill/>
+        </p:spPr>
+        <p:txBody>
+          <a:bodyPr wrap="square">
+            <a:spAutoFit/>
+          </a:bodyPr>
+          <a:lstStyle/>
+          <a:p>
+            <a:pPr algn="l">
+              <a:spcAft>
+                <a:spcPts val="300"/>
+              </a:spcAft>
+            </a:pPr>
+            <a:r>
+              <a:rPr sz="1200" b="1">
                 <a:solidFill>
                   <a:srgbClr val="0D3B66"/>
                 </a:solidFill>
@@ -7242,7 +6969,7 @@
       </p:sp>
       <p:sp>
         <p:nvSpPr>
-          <p:cNvPr id="16" name="TextBox 15"/>
+          <p:cNvPr id="13" name="TextBox 12"/>
           <p:cNvSpPr txBox="1"/>
           <p:nvPr/>
         </p:nvSpPr>
@@ -7274,14 +7001,14 @@
                 </a:solidFill>
                 <a:latin typeface="Calibri"/>
               </a:rPr>
-              <a:t>alimenta 27</a:t>
-            </a:r>
-          </a:p>
-        </p:txBody>
-      </p:sp>
-      <p:sp>
-        <p:nvSpPr>
-          <p:cNvPr id="17" name="Rounded Rectangle 16"/>
+              <a:t>alimenta DL</a:t>
+            </a:r>
+          </a:p>
+        </p:txBody>
+      </p:sp>
+      <p:sp>
+        <p:nvSpPr>
+          <p:cNvPr id="14" name="Rounded Rectangle 13"/>
           <p:cNvSpPr/>
           <p:nvPr/>
         </p:nvSpPr>
@@ -7328,72 +7055,33 @@
       </p:sp>
       <p:sp>
         <p:nvSpPr>
-          <p:cNvPr id="18" name="TextBox 17"/>
-          <p:cNvSpPr txBox="1"/>
-          <p:nvPr/>
-        </p:nvSpPr>
-        <p:spPr>
-          <a:xfrm>
-            <a:off x="7406640" y="1060704"/>
-            <a:ext cx="2157984" cy="146304"/>
-          </a:xfrm>
-          <a:prstGeom prst="rect">
-            <a:avLst/>
-          </a:prstGeom>
-          <a:noFill/>
-        </p:spPr>
-        <p:txBody>
-          <a:bodyPr wrap="square">
-            <a:spAutoFit/>
-          </a:bodyPr>
-          <a:lstStyle/>
-          <a:p>
-            <a:pPr algn="l">
-              <a:spcAft>
-                <a:spcPts val="300"/>
-              </a:spcAft>
-            </a:pPr>
-            <a:r>
-              <a:rPr sz="900" b="1">
-                <a:solidFill>
-                  <a:srgbClr val="C9A227"/>
-                </a:solidFill>
-                <a:latin typeface="Calibri"/>
-              </a:rPr>
-              <a:t>000025-28</a:t>
-            </a:r>
-          </a:p>
-        </p:txBody>
-      </p:sp>
-      <p:sp>
-        <p:nvSpPr>
-          <p:cNvPr id="19" name="TextBox 18"/>
-          <p:cNvSpPr txBox="1"/>
-          <p:nvPr/>
-        </p:nvSpPr>
-        <p:spPr>
-          <a:xfrm>
-            <a:off x="7406640" y="1225296"/>
-            <a:ext cx="2157984" cy="201168"/>
-          </a:xfrm>
-          <a:prstGeom prst="rect">
-            <a:avLst/>
-          </a:prstGeom>
-          <a:noFill/>
-        </p:spPr>
-        <p:txBody>
-          <a:bodyPr wrap="square">
-            <a:spAutoFit/>
-          </a:bodyPr>
-          <a:lstStyle/>
-          <a:p>
-            <a:pPr algn="l">
-              <a:spcAft>
-                <a:spcPts val="300"/>
-              </a:spcAft>
-            </a:pPr>
-            <a:r>
-              <a:rPr sz="1100" b="1">
+          <p:cNvPr id="15" name="TextBox 14"/>
+          <p:cNvSpPr txBox="1"/>
+          <p:nvPr/>
+        </p:nvSpPr>
+        <p:spPr>
+          <a:xfrm>
+            <a:off x="7406640" y="1115568"/>
+            <a:ext cx="2157984" cy="292608"/>
+          </a:xfrm>
+          <a:prstGeom prst="rect">
+            <a:avLst/>
+          </a:prstGeom>
+          <a:noFill/>
+        </p:spPr>
+        <p:txBody>
+          <a:bodyPr wrap="square">
+            <a:spAutoFit/>
+          </a:bodyPr>
+          <a:lstStyle/>
+          <a:p>
+            <a:pPr algn="l">
+              <a:spcAft>
+                <a:spcPts val="300"/>
+              </a:spcAft>
+            </a:pPr>
+            <a:r>
+              <a:rPr sz="1200" b="1">
                 <a:solidFill>
                   <a:srgbClr val="0D3B66"/>
                 </a:solidFill>
@@ -7406,7 +7094,7 @@
       </p:sp>
       <p:sp>
         <p:nvSpPr>
-          <p:cNvPr id="20" name="TextBox 19"/>
+          <p:cNvPr id="16" name="TextBox 15"/>
           <p:cNvSpPr txBox="1"/>
           <p:nvPr/>
         </p:nvSpPr>
@@ -7438,14 +7126,14 @@
                 </a:solidFill>
                 <a:latin typeface="Calibri"/>
               </a:rPr>
-              <a:t>alimenta 27</a:t>
-            </a:r>
-          </a:p>
-        </p:txBody>
-      </p:sp>
-      <p:sp>
-        <p:nvSpPr>
-          <p:cNvPr id="21" name="Rounded Rectangle 20"/>
+              <a:t>alimenta DL</a:t>
+            </a:r>
+          </a:p>
+        </p:txBody>
+      </p:sp>
+      <p:sp>
+        <p:nvSpPr>
+          <p:cNvPr id="17" name="Rounded Rectangle 16"/>
           <p:cNvSpPr/>
           <p:nvPr/>
         </p:nvSpPr>
@@ -7492,72 +7180,33 @@
       </p:sp>
       <p:sp>
         <p:nvSpPr>
-          <p:cNvPr id="22" name="TextBox 21"/>
-          <p:cNvSpPr txBox="1"/>
-          <p:nvPr/>
-        </p:nvSpPr>
-        <p:spPr>
-          <a:xfrm>
-            <a:off x="9784080" y="1060704"/>
-            <a:ext cx="2157984" cy="146304"/>
-          </a:xfrm>
-          <a:prstGeom prst="rect">
-            <a:avLst/>
-          </a:prstGeom>
-          <a:noFill/>
-        </p:spPr>
-        <p:txBody>
-          <a:bodyPr wrap="square">
-            <a:spAutoFit/>
-          </a:bodyPr>
-          <a:lstStyle/>
-          <a:p>
-            <a:pPr algn="l">
-              <a:spcAft>
-                <a:spcPts val="300"/>
-              </a:spcAft>
-            </a:pPr>
-            <a:r>
-              <a:rPr sz="900" b="1">
-                <a:solidFill>
-                  <a:srgbClr val="C9A227"/>
-                </a:solidFill>
-                <a:latin typeface="Calibri"/>
-              </a:rPr>
-              <a:t>000025-29</a:t>
-            </a:r>
-          </a:p>
-        </p:txBody>
-      </p:sp>
-      <p:sp>
-        <p:nvSpPr>
-          <p:cNvPr id="23" name="TextBox 22"/>
-          <p:cNvSpPr txBox="1"/>
-          <p:nvPr/>
-        </p:nvSpPr>
-        <p:spPr>
-          <a:xfrm>
-            <a:off x="9784080" y="1225296"/>
-            <a:ext cx="2157984" cy="201168"/>
-          </a:xfrm>
-          <a:prstGeom prst="rect">
-            <a:avLst/>
-          </a:prstGeom>
-          <a:noFill/>
-        </p:spPr>
-        <p:txBody>
-          <a:bodyPr wrap="square">
-            <a:spAutoFit/>
-          </a:bodyPr>
-          <a:lstStyle/>
-          <a:p>
-            <a:pPr algn="l">
-              <a:spcAft>
-                <a:spcPts val="300"/>
-              </a:spcAft>
-            </a:pPr>
-            <a:r>
-              <a:rPr sz="1100" b="1">
+          <p:cNvPr id="18" name="TextBox 17"/>
+          <p:cNvSpPr txBox="1"/>
+          <p:nvPr/>
+        </p:nvSpPr>
+        <p:spPr>
+          <a:xfrm>
+            <a:off x="9784080" y="1115568"/>
+            <a:ext cx="2157984" cy="292608"/>
+          </a:xfrm>
+          <a:prstGeom prst="rect">
+            <a:avLst/>
+          </a:prstGeom>
+          <a:noFill/>
+        </p:spPr>
+        <p:txBody>
+          <a:bodyPr wrap="square">
+            <a:spAutoFit/>
+          </a:bodyPr>
+          <a:lstStyle/>
+          <a:p>
+            <a:pPr algn="l">
+              <a:spcAft>
+                <a:spcPts val="300"/>
+              </a:spcAft>
+            </a:pPr>
+            <a:r>
+              <a:rPr sz="1200" b="1">
                 <a:solidFill>
                   <a:srgbClr val="0D3B66"/>
                 </a:solidFill>
@@ -7570,7 +7219,7 @@
       </p:sp>
       <p:sp>
         <p:nvSpPr>
-          <p:cNvPr id="24" name="Rounded Rectangle 23"/>
+          <p:cNvPr id="19" name="Rounded Rectangle 18"/>
           <p:cNvSpPr/>
           <p:nvPr/>
         </p:nvSpPr>
@@ -7617,72 +7266,33 @@
       </p:sp>
       <p:sp>
         <p:nvSpPr>
-          <p:cNvPr id="25" name="TextBox 24"/>
-          <p:cNvSpPr txBox="1"/>
-          <p:nvPr/>
-        </p:nvSpPr>
-        <p:spPr>
-          <a:xfrm>
-            <a:off x="274320" y="1755648"/>
-            <a:ext cx="2157984" cy="146304"/>
-          </a:xfrm>
-          <a:prstGeom prst="rect">
-            <a:avLst/>
-          </a:prstGeom>
-          <a:noFill/>
-        </p:spPr>
-        <p:txBody>
-          <a:bodyPr wrap="square">
-            <a:spAutoFit/>
-          </a:bodyPr>
-          <a:lstStyle/>
-          <a:p>
-            <a:pPr algn="l">
-              <a:spcAft>
-                <a:spcPts val="300"/>
-              </a:spcAft>
-            </a:pPr>
-            <a:r>
-              <a:rPr sz="900" b="1">
-                <a:solidFill>
-                  <a:srgbClr val="C9A227"/>
-                </a:solidFill>
-                <a:latin typeface="Calibri"/>
-              </a:rPr>
-              <a:t>000025-23</a:t>
-            </a:r>
-          </a:p>
-        </p:txBody>
-      </p:sp>
-      <p:sp>
-        <p:nvSpPr>
-          <p:cNvPr id="26" name="TextBox 25"/>
-          <p:cNvSpPr txBox="1"/>
-          <p:nvPr/>
-        </p:nvSpPr>
-        <p:spPr>
-          <a:xfrm>
-            <a:off x="274320" y="1920240"/>
-            <a:ext cx="2157984" cy="201168"/>
-          </a:xfrm>
-          <a:prstGeom prst="rect">
-            <a:avLst/>
-          </a:prstGeom>
-          <a:noFill/>
-        </p:spPr>
-        <p:txBody>
-          <a:bodyPr wrap="square">
-            <a:spAutoFit/>
-          </a:bodyPr>
-          <a:lstStyle/>
-          <a:p>
-            <a:pPr algn="l">
-              <a:spcAft>
-                <a:spcPts val="300"/>
-              </a:spcAft>
-            </a:pPr>
-            <a:r>
-              <a:rPr sz="1100" b="1">
+          <p:cNvPr id="20" name="TextBox 19"/>
+          <p:cNvSpPr txBox="1"/>
+          <p:nvPr/>
+        </p:nvSpPr>
+        <p:spPr>
+          <a:xfrm>
+            <a:off x="274320" y="1810512"/>
+            <a:ext cx="2157984" cy="292608"/>
+          </a:xfrm>
+          <a:prstGeom prst="rect">
+            <a:avLst/>
+          </a:prstGeom>
+          <a:noFill/>
+        </p:spPr>
+        <p:txBody>
+          <a:bodyPr wrap="square">
+            <a:spAutoFit/>
+          </a:bodyPr>
+          <a:lstStyle/>
+          <a:p>
+            <a:pPr algn="l">
+              <a:spcAft>
+                <a:spcPts val="300"/>
+              </a:spcAft>
+            </a:pPr>
+            <a:r>
+              <a:rPr sz="1200" b="1">
                 <a:solidFill>
                   <a:srgbClr val="0D3B66"/>
                 </a:solidFill>
@@ -7695,7 +7305,7 @@
       </p:sp>
       <p:sp>
         <p:nvSpPr>
-          <p:cNvPr id="27" name="Rounded Rectangle 26"/>
+          <p:cNvPr id="21" name="Rounded Rectangle 20"/>
           <p:cNvSpPr/>
           <p:nvPr/>
         </p:nvSpPr>
@@ -7742,72 +7352,33 @@
       </p:sp>
       <p:sp>
         <p:nvSpPr>
-          <p:cNvPr id="28" name="TextBox 27"/>
-          <p:cNvSpPr txBox="1"/>
-          <p:nvPr/>
-        </p:nvSpPr>
-        <p:spPr>
-          <a:xfrm>
-            <a:off x="2651760" y="1755648"/>
-            <a:ext cx="2157984" cy="146304"/>
-          </a:xfrm>
-          <a:prstGeom prst="rect">
-            <a:avLst/>
-          </a:prstGeom>
-          <a:noFill/>
-        </p:spPr>
-        <p:txBody>
-          <a:bodyPr wrap="square">
-            <a:spAutoFit/>
-          </a:bodyPr>
-          <a:lstStyle/>
-          <a:p>
-            <a:pPr algn="l">
-              <a:spcAft>
-                <a:spcPts val="300"/>
-              </a:spcAft>
-            </a:pPr>
-            <a:r>
-              <a:rPr sz="900" b="1">
-                <a:solidFill>
-                  <a:srgbClr val="C9A227"/>
-                </a:solidFill>
-                <a:latin typeface="Calibri"/>
-              </a:rPr>
-              <a:t>000025-24</a:t>
-            </a:r>
-          </a:p>
-        </p:txBody>
-      </p:sp>
-      <p:sp>
-        <p:nvSpPr>
-          <p:cNvPr id="29" name="TextBox 28"/>
-          <p:cNvSpPr txBox="1"/>
-          <p:nvPr/>
-        </p:nvSpPr>
-        <p:spPr>
-          <a:xfrm>
-            <a:off x="2651760" y="1920240"/>
-            <a:ext cx="2157984" cy="201168"/>
-          </a:xfrm>
-          <a:prstGeom prst="rect">
-            <a:avLst/>
-          </a:prstGeom>
-          <a:noFill/>
-        </p:spPr>
-        <p:txBody>
-          <a:bodyPr wrap="square">
-            <a:spAutoFit/>
-          </a:bodyPr>
-          <a:lstStyle/>
-          <a:p>
-            <a:pPr algn="l">
-              <a:spcAft>
-                <a:spcPts val="300"/>
-              </a:spcAft>
-            </a:pPr>
-            <a:r>
-              <a:rPr sz="1100" b="1">
+          <p:cNvPr id="22" name="TextBox 21"/>
+          <p:cNvSpPr txBox="1"/>
+          <p:nvPr/>
+        </p:nvSpPr>
+        <p:spPr>
+          <a:xfrm>
+            <a:off x="2651760" y="1810512"/>
+            <a:ext cx="2157984" cy="292608"/>
+          </a:xfrm>
+          <a:prstGeom prst="rect">
+            <a:avLst/>
+          </a:prstGeom>
+          <a:noFill/>
+        </p:spPr>
+        <p:txBody>
+          <a:bodyPr wrap="square">
+            <a:spAutoFit/>
+          </a:bodyPr>
+          <a:lstStyle/>
+          <a:p>
+            <a:pPr algn="l">
+              <a:spcAft>
+                <a:spcPts val="300"/>
+              </a:spcAft>
+            </a:pPr>
+            <a:r>
+              <a:rPr sz="1200" b="1">
                 <a:solidFill>
                   <a:srgbClr val="0D3B66"/>
                 </a:solidFill>
@@ -7820,7 +7391,7 @@
       </p:sp>
       <p:sp>
         <p:nvSpPr>
-          <p:cNvPr id="30" name="Rounded Rectangle 29"/>
+          <p:cNvPr id="23" name="Rounded Rectangle 22"/>
           <p:cNvSpPr/>
           <p:nvPr/>
         </p:nvSpPr>
@@ -7867,72 +7438,33 @@
       </p:sp>
       <p:sp>
         <p:nvSpPr>
-          <p:cNvPr id="31" name="TextBox 30"/>
-          <p:cNvSpPr txBox="1"/>
-          <p:nvPr/>
-        </p:nvSpPr>
-        <p:spPr>
-          <a:xfrm>
-            <a:off x="5029200" y="1755648"/>
-            <a:ext cx="2157984" cy="146304"/>
-          </a:xfrm>
-          <a:prstGeom prst="rect">
-            <a:avLst/>
-          </a:prstGeom>
-          <a:noFill/>
-        </p:spPr>
-        <p:txBody>
-          <a:bodyPr wrap="square">
-            <a:spAutoFit/>
-          </a:bodyPr>
-          <a:lstStyle/>
-          <a:p>
-            <a:pPr algn="l">
-              <a:spcAft>
-                <a:spcPts val="300"/>
-              </a:spcAft>
-            </a:pPr>
-            <a:r>
-              <a:rPr sz="900" b="1">
-                <a:solidFill>
-                  <a:srgbClr val="C9A227"/>
-                </a:solidFill>
-                <a:latin typeface="Calibri"/>
-              </a:rPr>
-              <a:t>000025-27</a:t>
-            </a:r>
-          </a:p>
-        </p:txBody>
-      </p:sp>
-      <p:sp>
-        <p:nvSpPr>
-          <p:cNvPr id="32" name="TextBox 31"/>
-          <p:cNvSpPr txBox="1"/>
-          <p:nvPr/>
-        </p:nvSpPr>
-        <p:spPr>
-          <a:xfrm>
-            <a:off x="5029200" y="1920240"/>
-            <a:ext cx="2157984" cy="201168"/>
-          </a:xfrm>
-          <a:prstGeom prst="rect">
-            <a:avLst/>
-          </a:prstGeom>
-          <a:noFill/>
-        </p:spPr>
-        <p:txBody>
-          <a:bodyPr wrap="square">
-            <a:spAutoFit/>
-          </a:bodyPr>
-          <a:lstStyle/>
-          <a:p>
-            <a:pPr algn="l">
-              <a:spcAft>
-                <a:spcPts val="300"/>
-              </a:spcAft>
-            </a:pPr>
-            <a:r>
-              <a:rPr sz="1100" b="1">
+          <p:cNvPr id="24" name="TextBox 23"/>
+          <p:cNvSpPr txBox="1"/>
+          <p:nvPr/>
+        </p:nvSpPr>
+        <p:spPr>
+          <a:xfrm>
+            <a:off x="5029200" y="1810512"/>
+            <a:ext cx="2157984" cy="292608"/>
+          </a:xfrm>
+          <a:prstGeom prst="rect">
+            <a:avLst/>
+          </a:prstGeom>
+          <a:noFill/>
+        </p:spPr>
+        <p:txBody>
+          <a:bodyPr wrap="square">
+            <a:spAutoFit/>
+          </a:bodyPr>
+          <a:lstStyle/>
+          <a:p>
+            <a:pPr algn="l">
+              <a:spcAft>
+                <a:spcPts val="300"/>
+              </a:spcAft>
+            </a:pPr>
+            <a:r>
+              <a:rPr sz="1200" b="1">
                 <a:solidFill>
                   <a:srgbClr val="0D3B66"/>
                 </a:solidFill>
@@ -7945,7 +7477,7 @@
       </p:sp>
       <p:sp>
         <p:nvSpPr>
-          <p:cNvPr id="33" name="TextBox 32"/>
+          <p:cNvPr id="25" name="TextBox 24"/>
           <p:cNvSpPr txBox="1"/>
           <p:nvPr/>
         </p:nvSpPr>
@@ -7984,7 +7516,7 @@
       </p:sp>
       <p:sp>
         <p:nvSpPr>
-          <p:cNvPr id="34" name="Rounded Rectangle 33"/>
+          <p:cNvPr id="26" name="Rounded Rectangle 25"/>
           <p:cNvSpPr/>
           <p:nvPr/>
         </p:nvSpPr>
@@ -8031,72 +7563,33 @@
       </p:sp>
       <p:sp>
         <p:nvSpPr>
-          <p:cNvPr id="35" name="TextBox 34"/>
-          <p:cNvSpPr txBox="1"/>
-          <p:nvPr/>
-        </p:nvSpPr>
-        <p:spPr>
-          <a:xfrm>
-            <a:off x="7406640" y="1755648"/>
-            <a:ext cx="2157984" cy="146304"/>
-          </a:xfrm>
-          <a:prstGeom prst="rect">
-            <a:avLst/>
-          </a:prstGeom>
-          <a:noFill/>
-        </p:spPr>
-        <p:txBody>
-          <a:bodyPr wrap="square">
-            <a:spAutoFit/>
-          </a:bodyPr>
-          <a:lstStyle/>
-          <a:p>
-            <a:pPr algn="l">
-              <a:spcAft>
-                <a:spcPts val="300"/>
-              </a:spcAft>
-            </a:pPr>
-            <a:r>
-              <a:rPr sz="900" b="1">
-                <a:solidFill>
-                  <a:srgbClr val="C9A227"/>
-                </a:solidFill>
-                <a:latin typeface="Calibri"/>
-              </a:rPr>
-              <a:t>000025-35</a:t>
-            </a:r>
-          </a:p>
-        </p:txBody>
-      </p:sp>
-      <p:sp>
-        <p:nvSpPr>
-          <p:cNvPr id="36" name="TextBox 35"/>
-          <p:cNvSpPr txBox="1"/>
-          <p:nvPr/>
-        </p:nvSpPr>
-        <p:spPr>
-          <a:xfrm>
-            <a:off x="7406640" y="1920240"/>
-            <a:ext cx="2157984" cy="201168"/>
-          </a:xfrm>
-          <a:prstGeom prst="rect">
-            <a:avLst/>
-          </a:prstGeom>
-          <a:noFill/>
-        </p:spPr>
-        <p:txBody>
-          <a:bodyPr wrap="square">
-            <a:spAutoFit/>
-          </a:bodyPr>
-          <a:lstStyle/>
-          <a:p>
-            <a:pPr algn="l">
-              <a:spcAft>
-                <a:spcPts val="300"/>
-              </a:spcAft>
-            </a:pPr>
-            <a:r>
-              <a:rPr sz="1100" b="1">
+          <p:cNvPr id="27" name="TextBox 26"/>
+          <p:cNvSpPr txBox="1"/>
+          <p:nvPr/>
+        </p:nvSpPr>
+        <p:spPr>
+          <a:xfrm>
+            <a:off x="7406640" y="1810512"/>
+            <a:ext cx="2157984" cy="292608"/>
+          </a:xfrm>
+          <a:prstGeom prst="rect">
+            <a:avLst/>
+          </a:prstGeom>
+          <a:noFill/>
+        </p:spPr>
+        <p:txBody>
+          <a:bodyPr wrap="square">
+            <a:spAutoFit/>
+          </a:bodyPr>
+          <a:lstStyle/>
+          <a:p>
+            <a:pPr algn="l">
+              <a:spcAft>
+                <a:spcPts val="300"/>
+              </a:spcAft>
+            </a:pPr>
+            <a:r>
+              <a:rPr sz="1200" b="1">
                 <a:solidFill>
                   <a:srgbClr val="0D3B66"/>
                 </a:solidFill>
@@ -8109,7 +7602,7 @@
       </p:sp>
       <p:sp>
         <p:nvSpPr>
-          <p:cNvPr id="37" name="TextBox 36"/>
+          <p:cNvPr id="28" name="TextBox 27"/>
           <p:cNvSpPr txBox="1"/>
           <p:nvPr/>
         </p:nvSpPr>
@@ -8141,14 +7634,14 @@
                 </a:solidFill>
                 <a:latin typeface="Calibri"/>
               </a:rPr>
-              <a:t>sale de 27</a:t>
-            </a:r>
-          </a:p>
-        </p:txBody>
-      </p:sp>
-      <p:sp>
-        <p:nvSpPr>
-          <p:cNvPr id="38" name="Rounded Rectangle 37"/>
+              <a:t>sale de DL</a:t>
+            </a:r>
+          </a:p>
+        </p:txBody>
+      </p:sp>
+      <p:sp>
+        <p:nvSpPr>
+          <p:cNvPr id="29" name="Rounded Rectangle 28"/>
           <p:cNvSpPr/>
           <p:nvPr/>
         </p:nvSpPr>
@@ -8195,72 +7688,33 @@
       </p:sp>
       <p:sp>
         <p:nvSpPr>
-          <p:cNvPr id="39" name="TextBox 38"/>
-          <p:cNvSpPr txBox="1"/>
-          <p:nvPr/>
-        </p:nvSpPr>
-        <p:spPr>
-          <a:xfrm>
-            <a:off x="9784080" y="1755648"/>
-            <a:ext cx="2157984" cy="146304"/>
-          </a:xfrm>
-          <a:prstGeom prst="rect">
-            <a:avLst/>
-          </a:prstGeom>
-          <a:noFill/>
-        </p:spPr>
-        <p:txBody>
-          <a:bodyPr wrap="square">
-            <a:spAutoFit/>
-          </a:bodyPr>
-          <a:lstStyle/>
-          <a:p>
-            <a:pPr algn="l">
-              <a:spcAft>
-                <a:spcPts val="300"/>
-              </a:spcAft>
-            </a:pPr>
-            <a:r>
-              <a:rPr sz="900" b="1">
-                <a:solidFill>
-                  <a:srgbClr val="C9A227"/>
-                </a:solidFill>
-                <a:latin typeface="Calibri"/>
-              </a:rPr>
-              <a:t>000025-36</a:t>
-            </a:r>
-          </a:p>
-        </p:txBody>
-      </p:sp>
-      <p:sp>
-        <p:nvSpPr>
-          <p:cNvPr id="40" name="TextBox 39"/>
-          <p:cNvSpPr txBox="1"/>
-          <p:nvPr/>
-        </p:nvSpPr>
-        <p:spPr>
-          <a:xfrm>
-            <a:off x="9784080" y="1920240"/>
-            <a:ext cx="2157984" cy="201168"/>
-          </a:xfrm>
-          <a:prstGeom prst="rect">
-            <a:avLst/>
-          </a:prstGeom>
-          <a:noFill/>
-        </p:spPr>
-        <p:txBody>
-          <a:bodyPr wrap="square">
-            <a:spAutoFit/>
-          </a:bodyPr>
-          <a:lstStyle/>
-          <a:p>
-            <a:pPr algn="l">
-              <a:spcAft>
-                <a:spcPts val="300"/>
-              </a:spcAft>
-            </a:pPr>
-            <a:r>
-              <a:rPr sz="1100" b="1">
+          <p:cNvPr id="30" name="TextBox 29"/>
+          <p:cNvSpPr txBox="1"/>
+          <p:nvPr/>
+        </p:nvSpPr>
+        <p:spPr>
+          <a:xfrm>
+            <a:off x="9784080" y="1810512"/>
+            <a:ext cx="2157984" cy="292608"/>
+          </a:xfrm>
+          <a:prstGeom prst="rect">
+            <a:avLst/>
+          </a:prstGeom>
+          <a:noFill/>
+        </p:spPr>
+        <p:txBody>
+          <a:bodyPr wrap="square">
+            <a:spAutoFit/>
+          </a:bodyPr>
+          <a:lstStyle/>
+          <a:p>
+            <a:pPr algn="l">
+              <a:spcAft>
+                <a:spcPts val="300"/>
+              </a:spcAft>
+            </a:pPr>
+            <a:r>
+              <a:rPr sz="1200" b="1">
                 <a:solidFill>
                   <a:srgbClr val="0D3B66"/>
                 </a:solidFill>
@@ -8273,7 +7727,7 @@
       </p:sp>
       <p:sp>
         <p:nvSpPr>
-          <p:cNvPr id="41" name="TextBox 40"/>
+          <p:cNvPr id="31" name="TextBox 30"/>
           <p:cNvSpPr txBox="1"/>
           <p:nvPr/>
         </p:nvSpPr>
@@ -8305,14 +7759,14 @@
                 </a:solidFill>
                 <a:latin typeface="Calibri"/>
               </a:rPr>
-              <a:t>sale de 27</a:t>
-            </a:r>
-          </a:p>
-        </p:txBody>
-      </p:sp>
-      <p:sp>
-        <p:nvSpPr>
-          <p:cNvPr id="42" name="Rounded Rectangle 41"/>
+              <a:t>sale de DL</a:t>
+            </a:r>
+          </a:p>
+        </p:txBody>
+      </p:sp>
+      <p:sp>
+        <p:nvSpPr>
+          <p:cNvPr id="32" name="Rounded Rectangle 31"/>
           <p:cNvSpPr/>
           <p:nvPr/>
         </p:nvSpPr>
@@ -8357,7 +7811,7 @@
       </p:sp>
       <p:pic>
         <p:nvPicPr>
-          <p:cNvPr id="43" name="Picture 42" descr="pak_mensual_may_ago.png"/>
+          <p:cNvPr id="33" name="Picture 32" descr="pak_mensual_may_ago.png"/>
           <p:cNvPicPr>
             <a:picLocks noChangeAspect="1"/>
           </p:cNvPicPr>
@@ -8381,7 +7835,7 @@
       </p:pic>
       <p:sp>
         <p:nvSpPr>
-          <p:cNvPr id="44" name="Rounded Rectangle 43"/>
+          <p:cNvPr id="34" name="Rounded Rectangle 33"/>
           <p:cNvSpPr/>
           <p:nvPr/>
         </p:nvSpPr>
@@ -8428,7 +7882,7 @@
       </p:sp>
       <p:sp>
         <p:nvSpPr>
-          <p:cNvPr id="45" name="TextBox 44"/>
+          <p:cNvPr id="35" name="TextBox 34"/>
           <p:cNvSpPr txBox="1"/>
           <p:nvPr/>
         </p:nvSpPr>
@@ -8467,7 +7921,7 @@
       </p:sp>
       <p:sp>
         <p:nvSpPr>
-          <p:cNvPr id="46" name="TextBox 45"/>
+          <p:cNvPr id="36" name="TextBox 35"/>
           <p:cNvSpPr txBox="1"/>
           <p:nvPr/>
         </p:nvSpPr>
@@ -8506,7 +7960,7 @@
       </p:sp>
       <p:sp>
         <p:nvSpPr>
-          <p:cNvPr id="47" name="Rounded Rectangle 46"/>
+          <p:cNvPr id="37" name="Rounded Rectangle 36"/>
           <p:cNvSpPr/>
           <p:nvPr/>
         </p:nvSpPr>
@@ -8553,7 +8007,7 @@
       </p:sp>
       <p:sp>
         <p:nvSpPr>
-          <p:cNvPr id="48" name="TextBox 47"/>
+          <p:cNvPr id="38" name="TextBox 37"/>
           <p:cNvSpPr txBox="1"/>
           <p:nvPr/>
         </p:nvSpPr>
@@ -8592,7 +8046,7 @@
       </p:sp>
       <p:sp>
         <p:nvSpPr>
-          <p:cNvPr id="49" name="TextBox 48"/>
+          <p:cNvPr id="39" name="TextBox 38"/>
           <p:cNvSpPr txBox="1"/>
           <p:nvPr/>
         </p:nvSpPr>
@@ -8631,7 +8085,7 @@
       </p:sp>
       <p:sp>
         <p:nvSpPr>
-          <p:cNvPr id="50" name="Rounded Rectangle 49"/>
+          <p:cNvPr id="40" name="Rounded Rectangle 39"/>
           <p:cNvSpPr/>
           <p:nvPr/>
         </p:nvSpPr>
@@ -8678,7 +8132,7 @@
       </p:sp>
       <p:sp>
         <p:nvSpPr>
-          <p:cNvPr id="51" name="TextBox 50"/>
+          <p:cNvPr id="41" name="TextBox 40"/>
           <p:cNvSpPr txBox="1"/>
           <p:nvPr/>
         </p:nvSpPr>
@@ -8717,7 +8171,7 @@
       </p:sp>
       <p:sp>
         <p:nvSpPr>
-          <p:cNvPr id="52" name="TextBox 51"/>
+          <p:cNvPr id="42" name="TextBox 41"/>
           <p:cNvSpPr txBox="1"/>
           <p:nvPr/>
         </p:nvSpPr>
@@ -8756,7 +8210,7 @@
       </p:sp>
       <p:sp>
         <p:nvSpPr>
-          <p:cNvPr id="53" name="Rounded Rectangle 52"/>
+          <p:cNvPr id="43" name="Rounded Rectangle 42"/>
           <p:cNvSpPr/>
           <p:nvPr/>
         </p:nvSpPr>
@@ -8803,7 +8257,7 @@
       </p:sp>
       <p:sp>
         <p:nvSpPr>
-          <p:cNvPr id="54" name="TextBox 53"/>
+          <p:cNvPr id="44" name="TextBox 43"/>
           <p:cNvSpPr txBox="1"/>
           <p:nvPr/>
         </p:nvSpPr>
@@ -8842,7 +8296,7 @@
       </p:sp>
       <p:sp>
         <p:nvSpPr>
-          <p:cNvPr id="55" name="TextBox 54"/>
+          <p:cNvPr id="45" name="TextBox 44"/>
           <p:cNvSpPr txBox="1"/>
           <p:nvPr/>
         </p:nvSpPr>
@@ -8881,7 +8335,7 @@
       </p:sp>
       <p:sp>
         <p:nvSpPr>
-          <p:cNvPr id="56" name="Rounded Rectangle 55"/>
+          <p:cNvPr id="46" name="Rounded Rectangle 45"/>
           <p:cNvSpPr/>
           <p:nvPr/>
         </p:nvSpPr>
@@ -8928,7 +8382,7 @@
       </p:sp>
       <p:sp>
         <p:nvSpPr>
-          <p:cNvPr id="57" name="TextBox 56"/>
+          <p:cNvPr id="47" name="TextBox 46"/>
           <p:cNvSpPr txBox="1"/>
           <p:nvPr/>
         </p:nvSpPr>
@@ -8967,7 +8421,7 @@
       </p:sp>
       <p:sp>
         <p:nvSpPr>
-          <p:cNvPr id="58" name="TextBox 57"/>
+          <p:cNvPr id="48" name="TextBox 47"/>
           <p:cNvSpPr txBox="1"/>
           <p:nvPr/>
         </p:nvSpPr>
@@ -9006,7 +8460,7 @@
       </p:sp>
       <p:sp>
         <p:nvSpPr>
-          <p:cNvPr id="59" name="Rounded Rectangle 58"/>
+          <p:cNvPr id="49" name="Rounded Rectangle 48"/>
           <p:cNvSpPr/>
           <p:nvPr/>
         </p:nvSpPr>
@@ -9053,7 +8507,7 @@
       </p:sp>
       <p:sp>
         <p:nvSpPr>
-          <p:cNvPr id="60" name="TextBox 59"/>
+          <p:cNvPr id="50" name="TextBox 49"/>
           <p:cNvSpPr txBox="1"/>
           <p:nvPr/>
         </p:nvSpPr>
@@ -9092,7 +8546,7 @@
       </p:sp>
       <p:sp>
         <p:nvSpPr>
-          <p:cNvPr id="61" name="TextBox 60"/>
+          <p:cNvPr id="51" name="TextBox 50"/>
           <p:cNvSpPr txBox="1"/>
           <p:nvPr/>
         </p:nvSpPr>
@@ -9131,7 +8585,7 @@
       </p:sp>
       <p:sp>
         <p:nvSpPr>
-          <p:cNvPr id="62" name="Rounded Rectangle 61"/>
+          <p:cNvPr id="52" name="Rounded Rectangle 51"/>
           <p:cNvSpPr/>
           <p:nvPr/>
         </p:nvSpPr>
@@ -9178,7 +8632,7 @@
       </p:sp>
       <p:sp>
         <p:nvSpPr>
-          <p:cNvPr id="63" name="TextBox 62"/>
+          <p:cNvPr id="53" name="TextBox 52"/>
           <p:cNvSpPr txBox="1"/>
           <p:nvPr/>
         </p:nvSpPr>
@@ -9217,7 +8671,7 @@
       </p:sp>
       <p:sp>
         <p:nvSpPr>
-          <p:cNvPr id="64" name="TextBox 63"/>
+          <p:cNvPr id="54" name="TextBox 53"/>
           <p:cNvSpPr txBox="1"/>
           <p:nvPr/>
         </p:nvSpPr>
@@ -9256,7 +8710,7 @@
       </p:sp>
       <p:sp>
         <p:nvSpPr>
-          <p:cNvPr id="65" name="Rounded Rectangle 64"/>
+          <p:cNvPr id="55" name="Rounded Rectangle 54"/>
           <p:cNvSpPr/>
           <p:nvPr/>
         </p:nvSpPr>
@@ -9303,7 +8757,7 @@
       </p:sp>
       <p:sp>
         <p:nvSpPr>
-          <p:cNvPr id="66" name="TextBox 65"/>
+          <p:cNvPr id="56" name="TextBox 55"/>
           <p:cNvSpPr txBox="1"/>
           <p:nvPr/>
         </p:nvSpPr>
@@ -9342,7 +8796,7 @@
       </p:sp>
       <p:sp>
         <p:nvSpPr>
-          <p:cNvPr id="67" name="TextBox 66"/>
+          <p:cNvPr id="57" name="TextBox 56"/>
           <p:cNvSpPr txBox="1"/>
           <p:nvPr/>
         </p:nvSpPr>
@@ -9381,7 +8835,7 @@
       </p:sp>
       <p:sp>
         <p:nvSpPr>
-          <p:cNvPr id="68" name="Rounded Rectangle 67"/>
+          <p:cNvPr id="58" name="Rounded Rectangle 57"/>
           <p:cNvSpPr/>
           <p:nvPr/>
         </p:nvSpPr>
@@ -9428,7 +8882,7 @@
       </p:sp>
       <p:sp>
         <p:nvSpPr>
-          <p:cNvPr id="69" name="TextBox 68"/>
+          <p:cNvPr id="59" name="TextBox 58"/>
           <p:cNvSpPr txBox="1"/>
           <p:nvPr/>
         </p:nvSpPr>
@@ -9467,7 +8921,7 @@
       </p:sp>
       <p:sp>
         <p:nvSpPr>
-          <p:cNvPr id="70" name="TextBox 69"/>
+          <p:cNvPr id="60" name="TextBox 59"/>
           <p:cNvSpPr txBox="1"/>
           <p:nvPr/>
         </p:nvSpPr>
@@ -9515,7 +8969,7 @@
                 </a:solidFill>
                 <a:latin typeface="Calibri"/>
               </a:rPr>
-              <a:t>Julio = cabecera (7 puntos). 27, 35 y 36 no se suman: cadena Sandía → DL (lámina 2).</a:t>
+              <a:t>Julio = cabecera (7 puntos). Distrito de Lujo, Bazar y DL Kennedy no se suman (lámina 2).</a:t>
             </a:r>
           </a:p>
         </p:txBody>
@@ -10938,33 +10392,33 @@
         </p:nvSpPr>
         <p:spPr>
           <a:xfrm>
-            <a:off x="274320" y="1060704"/>
-            <a:ext cx="2766060" cy="146304"/>
-          </a:xfrm>
-          <a:prstGeom prst="rect">
-            <a:avLst/>
-          </a:prstGeom>
-          <a:noFill/>
-        </p:spPr>
-        <p:txBody>
-          <a:bodyPr wrap="square">
-            <a:spAutoFit/>
-          </a:bodyPr>
-          <a:lstStyle/>
-          <a:p>
-            <a:pPr algn="l">
-              <a:spcAft>
-                <a:spcPts val="300"/>
-              </a:spcAft>
-            </a:pPr>
-            <a:r>
-              <a:rPr sz="1000" b="1">
-                <a:solidFill>
-                  <a:srgbClr val="C9A227"/>
-                </a:solidFill>
-                <a:latin typeface="Calibri"/>
-              </a:rPr>
-              <a:t>000025-01</a:t>
+            <a:off x="274320" y="1115568"/>
+            <a:ext cx="2766060" cy="292608"/>
+          </a:xfrm>
+          <a:prstGeom prst="rect">
+            <a:avLst/>
+          </a:prstGeom>
+          <a:noFill/>
+        </p:spPr>
+        <p:txBody>
+          <a:bodyPr wrap="square">
+            <a:spAutoFit/>
+          </a:bodyPr>
+          <a:lstStyle/>
+          <a:p>
+            <a:pPr algn="l">
+              <a:spcAft>
+                <a:spcPts val="300"/>
+              </a:spcAft>
+            </a:pPr>
+            <a:r>
+              <a:rPr sz="1300" b="1">
+                <a:solidFill>
+                  <a:srgbClr val="0D3B66"/>
+                </a:solidFill>
+                <a:latin typeface="Calibri"/>
+              </a:rPr>
+              <a:t>Estanque Norte</a:t>
             </a:r>
           </a:p>
         </p:txBody>
@@ -10972,45 +10426,6 @@
       <p:sp>
         <p:nvSpPr>
           <p:cNvPr id="9" name="TextBox 8"/>
-          <p:cNvSpPr txBox="1"/>
-          <p:nvPr/>
-        </p:nvSpPr>
-        <p:spPr>
-          <a:xfrm>
-            <a:off x="274320" y="1243584"/>
-            <a:ext cx="2766060" cy="201168"/>
-          </a:xfrm>
-          <a:prstGeom prst="rect">
-            <a:avLst/>
-          </a:prstGeom>
-          <a:noFill/>
-        </p:spPr>
-        <p:txBody>
-          <a:bodyPr wrap="square">
-            <a:spAutoFit/>
-          </a:bodyPr>
-          <a:lstStyle/>
-          <a:p>
-            <a:pPr algn="l">
-              <a:spcAft>
-                <a:spcPts val="300"/>
-              </a:spcAft>
-            </a:pPr>
-            <a:r>
-              <a:rPr sz="1200" b="1">
-                <a:solidFill>
-                  <a:srgbClr val="0D3B66"/>
-                </a:solidFill>
-                <a:latin typeface="Calibri"/>
-              </a:rPr>
-              <a:t>Estanque Norte</a:t>
-            </a:r>
-          </a:p>
-        </p:txBody>
-      </p:sp>
-      <p:sp>
-        <p:nvSpPr>
-          <p:cNvPr id="10" name="TextBox 9"/>
           <p:cNvSpPr txBox="1"/>
           <p:nvPr/>
         </p:nvSpPr>
@@ -11049,7 +10464,7 @@
       </p:sp>
       <p:sp>
         <p:nvSpPr>
-          <p:cNvPr id="11" name="Rounded Rectangle 10"/>
+          <p:cNvPr id="10" name="Rounded Rectangle 9"/>
           <p:cNvSpPr/>
           <p:nvPr/>
         </p:nvSpPr>
@@ -11096,72 +10511,33 @@
       </p:sp>
       <p:sp>
         <p:nvSpPr>
-          <p:cNvPr id="12" name="TextBox 11"/>
-          <p:cNvSpPr txBox="1"/>
-          <p:nvPr/>
-        </p:nvSpPr>
-        <p:spPr>
-          <a:xfrm>
-            <a:off x="3241548" y="1060704"/>
-            <a:ext cx="2766060" cy="146304"/>
-          </a:xfrm>
-          <a:prstGeom prst="rect">
-            <a:avLst/>
-          </a:prstGeom>
-          <a:noFill/>
-        </p:spPr>
-        <p:txBody>
-          <a:bodyPr wrap="square">
-            <a:spAutoFit/>
-          </a:bodyPr>
-          <a:lstStyle/>
-          <a:p>
-            <a:pPr algn="l">
-              <a:spcAft>
-                <a:spcPts val="300"/>
-              </a:spcAft>
-            </a:pPr>
-            <a:r>
-              <a:rPr sz="1000" b="1">
-                <a:solidFill>
-                  <a:srgbClr val="C9A227"/>
-                </a:solidFill>
-                <a:latin typeface="Calibri"/>
-              </a:rPr>
-              <a:t>000025-07</a:t>
-            </a:r>
-          </a:p>
-        </p:txBody>
-      </p:sp>
-      <p:sp>
-        <p:nvSpPr>
-          <p:cNvPr id="13" name="TextBox 12"/>
-          <p:cNvSpPr txBox="1"/>
-          <p:nvPr/>
-        </p:nvSpPr>
-        <p:spPr>
-          <a:xfrm>
-            <a:off x="3241548" y="1243584"/>
-            <a:ext cx="2766060" cy="201168"/>
-          </a:xfrm>
-          <a:prstGeom prst="rect">
-            <a:avLst/>
-          </a:prstGeom>
-          <a:noFill/>
-        </p:spPr>
-        <p:txBody>
-          <a:bodyPr wrap="square">
-            <a:spAutoFit/>
-          </a:bodyPr>
-          <a:lstStyle/>
-          <a:p>
-            <a:pPr algn="l">
-              <a:spcAft>
-                <a:spcPts val="300"/>
-              </a:spcAft>
-            </a:pPr>
-            <a:r>
-              <a:rPr sz="1200" b="1">
+          <p:cNvPr id="11" name="TextBox 10"/>
+          <p:cNvSpPr txBox="1"/>
+          <p:nvPr/>
+        </p:nvSpPr>
+        <p:spPr>
+          <a:xfrm>
+            <a:off x="3241548" y="1115568"/>
+            <a:ext cx="2766060" cy="292608"/>
+          </a:xfrm>
+          <a:prstGeom prst="rect">
+            <a:avLst/>
+          </a:prstGeom>
+          <a:noFill/>
+        </p:spPr>
+        <p:txBody>
+          <a:bodyPr wrap="square">
+            <a:spAutoFit/>
+          </a:bodyPr>
+          <a:lstStyle/>
+          <a:p>
+            <a:pPr algn="l">
+              <a:spcAft>
+                <a:spcPts val="300"/>
+              </a:spcAft>
+            </a:pPr>
+            <a:r>
+              <a:rPr sz="1300" b="1">
                 <a:solidFill>
                   <a:srgbClr val="0D3B66"/>
                 </a:solidFill>
@@ -11174,7 +10550,7 @@
       </p:sp>
       <p:sp>
         <p:nvSpPr>
-          <p:cNvPr id="14" name="Rounded Rectangle 13"/>
+          <p:cNvPr id="12" name="Rounded Rectangle 11"/>
           <p:cNvSpPr/>
           <p:nvPr/>
         </p:nvSpPr>
@@ -11221,72 +10597,33 @@
       </p:sp>
       <p:sp>
         <p:nvSpPr>
-          <p:cNvPr id="15" name="TextBox 14"/>
-          <p:cNvSpPr txBox="1"/>
-          <p:nvPr/>
-        </p:nvSpPr>
-        <p:spPr>
-          <a:xfrm>
-            <a:off x="6208776" y="1060704"/>
-            <a:ext cx="2766060" cy="146304"/>
-          </a:xfrm>
-          <a:prstGeom prst="rect">
-            <a:avLst/>
-          </a:prstGeom>
-          <a:noFill/>
-        </p:spPr>
-        <p:txBody>
-          <a:bodyPr wrap="square">
-            <a:spAutoFit/>
-          </a:bodyPr>
-          <a:lstStyle/>
-          <a:p>
-            <a:pPr algn="l">
-              <a:spcAft>
-                <a:spcPts val="300"/>
-              </a:spcAft>
-            </a:pPr>
-            <a:r>
-              <a:rPr sz="1000" b="1">
-                <a:solidFill>
-                  <a:srgbClr val="C9A227"/>
-                </a:solidFill>
-                <a:latin typeface="Calibri"/>
-              </a:rPr>
-              <a:t>000025-19</a:t>
-            </a:r>
-          </a:p>
-        </p:txBody>
-      </p:sp>
-      <p:sp>
-        <p:nvSpPr>
-          <p:cNvPr id="16" name="TextBox 15"/>
-          <p:cNvSpPr txBox="1"/>
-          <p:nvPr/>
-        </p:nvSpPr>
-        <p:spPr>
-          <a:xfrm>
-            <a:off x="6208776" y="1243584"/>
-            <a:ext cx="2766060" cy="201168"/>
-          </a:xfrm>
-          <a:prstGeom prst="rect">
-            <a:avLst/>
-          </a:prstGeom>
-          <a:noFill/>
-        </p:spPr>
-        <p:txBody>
-          <a:bodyPr wrap="square">
-            <a:spAutoFit/>
-          </a:bodyPr>
-          <a:lstStyle/>
-          <a:p>
-            <a:pPr algn="l">
-              <a:spcAft>
-                <a:spcPts val="300"/>
-              </a:spcAft>
-            </a:pPr>
-            <a:r>
-              <a:rPr sz="1200" b="1">
+          <p:cNvPr id="13" name="TextBox 12"/>
+          <p:cNvSpPr txBox="1"/>
+          <p:nvPr/>
+        </p:nvSpPr>
+        <p:spPr>
+          <a:xfrm>
+            <a:off x="6208776" y="1115568"/>
+            <a:ext cx="2766060" cy="292608"/>
+          </a:xfrm>
+          <a:prstGeom prst="rect">
+            <a:avLst/>
+          </a:prstGeom>
+          <a:noFill/>
+        </p:spPr>
+        <p:txBody>
+          <a:bodyPr wrap="square">
+            <a:spAutoFit/>
+          </a:bodyPr>
+          <a:lstStyle/>
+          <a:p>
+            <a:pPr algn="l">
+              <a:spcAft>
+                <a:spcPts val="300"/>
+              </a:spcAft>
+            </a:pPr>
+            <a:r>
+              <a:rPr sz="1300" b="1">
                 <a:solidFill>
                   <a:srgbClr val="0D3B66"/>
                 </a:solidFill>
@@ -11299,7 +10636,7 @@
       </p:sp>
       <p:sp>
         <p:nvSpPr>
-          <p:cNvPr id="17" name="TextBox 16"/>
+          <p:cNvPr id="14" name="TextBox 13"/>
           <p:cNvSpPr txBox="1"/>
           <p:nvPr/>
         </p:nvSpPr>
@@ -11338,7 +10675,7 @@
       </p:sp>
       <p:sp>
         <p:nvSpPr>
-          <p:cNvPr id="18" name="Rounded Rectangle 17"/>
+          <p:cNvPr id="15" name="Rounded Rectangle 14"/>
           <p:cNvSpPr/>
           <p:nvPr/>
         </p:nvSpPr>
@@ -11385,72 +10722,33 @@
       </p:sp>
       <p:sp>
         <p:nvSpPr>
-          <p:cNvPr id="19" name="TextBox 18"/>
-          <p:cNvSpPr txBox="1"/>
-          <p:nvPr/>
-        </p:nvSpPr>
-        <p:spPr>
-          <a:xfrm>
-            <a:off x="9176004" y="1060704"/>
-            <a:ext cx="2766060" cy="146304"/>
-          </a:xfrm>
-          <a:prstGeom prst="rect">
-            <a:avLst/>
-          </a:prstGeom>
-          <a:noFill/>
-        </p:spPr>
-        <p:txBody>
-          <a:bodyPr wrap="square">
-            <a:spAutoFit/>
-          </a:bodyPr>
-          <a:lstStyle/>
-          <a:p>
-            <a:pPr algn="l">
-              <a:spcAft>
-                <a:spcPts val="300"/>
-              </a:spcAft>
-            </a:pPr>
-            <a:r>
-              <a:rPr sz="1000" b="1">
-                <a:solidFill>
-                  <a:srgbClr val="C9A227"/>
-                </a:solidFill>
-                <a:latin typeface="Calibri"/>
-              </a:rPr>
-              <a:t>000025-04</a:t>
-            </a:r>
-          </a:p>
-        </p:txBody>
-      </p:sp>
-      <p:sp>
-        <p:nvSpPr>
-          <p:cNvPr id="20" name="TextBox 19"/>
-          <p:cNvSpPr txBox="1"/>
-          <p:nvPr/>
-        </p:nvSpPr>
-        <p:spPr>
-          <a:xfrm>
-            <a:off x="9176004" y="1243584"/>
-            <a:ext cx="2766060" cy="201168"/>
-          </a:xfrm>
-          <a:prstGeom prst="rect">
-            <a:avLst/>
-          </a:prstGeom>
-          <a:noFill/>
-        </p:spPr>
-        <p:txBody>
-          <a:bodyPr wrap="square">
-            <a:spAutoFit/>
-          </a:bodyPr>
-          <a:lstStyle/>
-          <a:p>
-            <a:pPr algn="l">
-              <a:spcAft>
-                <a:spcPts val="300"/>
-              </a:spcAft>
-            </a:pPr>
-            <a:r>
-              <a:rPr sz="1200" b="1">
+          <p:cNvPr id="16" name="TextBox 15"/>
+          <p:cNvSpPr txBox="1"/>
+          <p:nvPr/>
+        </p:nvSpPr>
+        <p:spPr>
+          <a:xfrm>
+            <a:off x="9176004" y="1115568"/>
+            <a:ext cx="2766060" cy="292608"/>
+          </a:xfrm>
+          <a:prstGeom prst="rect">
+            <a:avLst/>
+          </a:prstGeom>
+          <a:noFill/>
+        </p:spPr>
+        <p:txBody>
+          <a:bodyPr wrap="square">
+            <a:spAutoFit/>
+          </a:bodyPr>
+          <a:lstStyle/>
+          <a:p>
+            <a:pPr algn="l">
+              <a:spcAft>
+                <a:spcPts val="300"/>
+              </a:spcAft>
+            </a:pPr>
+            <a:r>
+              <a:rPr sz="1300" b="1">
                 <a:solidFill>
                   <a:srgbClr val="0D3B66"/>
                 </a:solidFill>
@@ -11463,7 +10761,7 @@
       </p:sp>
       <p:sp>
         <p:nvSpPr>
-          <p:cNvPr id="21" name="Rounded Rectangle 20"/>
+          <p:cNvPr id="17" name="Rounded Rectangle 16"/>
           <p:cNvSpPr/>
           <p:nvPr/>
         </p:nvSpPr>
@@ -11508,7 +10806,7 @@
       </p:sp>
       <p:pic>
         <p:nvPicPr>
-          <p:cNvPr id="22" name="Picture 21" descr="mae_mensual_may_ago.png"/>
+          <p:cNvPr id="18" name="Picture 17" descr="mae_mensual_may_ago.png"/>
           <p:cNvPicPr>
             <a:picLocks noChangeAspect="1"/>
           </p:cNvPicPr>
@@ -11532,7 +10830,7 @@
       </p:pic>
       <p:sp>
         <p:nvSpPr>
-          <p:cNvPr id="23" name="Rounded Rectangle 22"/>
+          <p:cNvPr id="19" name="Rounded Rectangle 18"/>
           <p:cNvSpPr/>
           <p:nvPr/>
         </p:nvSpPr>
@@ -11579,7 +10877,7 @@
       </p:sp>
       <p:sp>
         <p:nvSpPr>
-          <p:cNvPr id="24" name="TextBox 23"/>
+          <p:cNvPr id="20" name="TextBox 19"/>
           <p:cNvSpPr txBox="1"/>
           <p:nvPr/>
         </p:nvSpPr>
@@ -11618,7 +10916,7 @@
       </p:sp>
       <p:sp>
         <p:nvSpPr>
-          <p:cNvPr id="25" name="TextBox 24"/>
+          <p:cNvPr id="21" name="TextBox 20"/>
           <p:cNvSpPr txBox="1"/>
           <p:nvPr/>
         </p:nvSpPr>
@@ -11657,7 +10955,7 @@
       </p:sp>
       <p:sp>
         <p:nvSpPr>
-          <p:cNvPr id="26" name="Rounded Rectangle 25"/>
+          <p:cNvPr id="22" name="Rounded Rectangle 21"/>
           <p:cNvSpPr/>
           <p:nvPr/>
         </p:nvSpPr>
@@ -11704,7 +11002,7 @@
       </p:sp>
       <p:sp>
         <p:nvSpPr>
-          <p:cNvPr id="27" name="TextBox 26"/>
+          <p:cNvPr id="23" name="TextBox 22"/>
           <p:cNvSpPr txBox="1"/>
           <p:nvPr/>
         </p:nvSpPr>
@@ -11743,7 +11041,7 @@
       </p:sp>
       <p:sp>
         <p:nvSpPr>
-          <p:cNvPr id="28" name="TextBox 27"/>
+          <p:cNvPr id="24" name="TextBox 23"/>
           <p:cNvSpPr txBox="1"/>
           <p:nvPr/>
         </p:nvSpPr>
@@ -11782,7 +11080,7 @@
       </p:sp>
       <p:sp>
         <p:nvSpPr>
-          <p:cNvPr id="29" name="Rounded Rectangle 28"/>
+          <p:cNvPr id="25" name="Rounded Rectangle 24"/>
           <p:cNvSpPr/>
           <p:nvPr/>
         </p:nvSpPr>
@@ -11829,7 +11127,7 @@
       </p:sp>
       <p:sp>
         <p:nvSpPr>
-          <p:cNvPr id="30" name="TextBox 29"/>
+          <p:cNvPr id="26" name="TextBox 25"/>
           <p:cNvSpPr txBox="1"/>
           <p:nvPr/>
         </p:nvSpPr>
@@ -11868,7 +11166,7 @@
       </p:sp>
       <p:sp>
         <p:nvSpPr>
-          <p:cNvPr id="31" name="TextBox 30"/>
+          <p:cNvPr id="27" name="TextBox 26"/>
           <p:cNvSpPr txBox="1"/>
           <p:nvPr/>
         </p:nvSpPr>
@@ -11907,7 +11205,7 @@
       </p:sp>
       <p:sp>
         <p:nvSpPr>
-          <p:cNvPr id="32" name="Rounded Rectangle 31"/>
+          <p:cNvPr id="28" name="Rounded Rectangle 27"/>
           <p:cNvSpPr/>
           <p:nvPr/>
         </p:nvSpPr>
@@ -11954,7 +11252,7 @@
       </p:sp>
       <p:sp>
         <p:nvSpPr>
-          <p:cNvPr id="33" name="TextBox 32"/>
+          <p:cNvPr id="29" name="TextBox 28"/>
           <p:cNvSpPr txBox="1"/>
           <p:nvPr/>
         </p:nvSpPr>
@@ -11993,7 +11291,7 @@
       </p:sp>
       <p:sp>
         <p:nvSpPr>
-          <p:cNvPr id="34" name="TextBox 33"/>
+          <p:cNvPr id="30" name="TextBox 29"/>
           <p:cNvSpPr txBox="1"/>
           <p:nvPr/>
         </p:nvSpPr>
@@ -12032,7 +11330,7 @@
       </p:sp>
       <p:sp>
         <p:nvSpPr>
-          <p:cNvPr id="35" name="Rounded Rectangle 34"/>
+          <p:cNvPr id="31" name="Rounded Rectangle 30"/>
           <p:cNvSpPr/>
           <p:nvPr/>
         </p:nvSpPr>
@@ -12079,7 +11377,7 @@
       </p:sp>
       <p:sp>
         <p:nvSpPr>
-          <p:cNvPr id="36" name="TextBox 35"/>
+          <p:cNvPr id="32" name="TextBox 31"/>
           <p:cNvSpPr txBox="1"/>
           <p:nvPr/>
         </p:nvSpPr>
@@ -12118,7 +11416,7 @@
       </p:sp>
       <p:sp>
         <p:nvSpPr>
-          <p:cNvPr id="37" name="TextBox 36"/>
+          <p:cNvPr id="33" name="TextBox 32"/>
           <p:cNvSpPr txBox="1"/>
           <p:nvPr/>
         </p:nvSpPr>
@@ -12157,7 +11455,7 @@
       </p:sp>
       <p:sp>
         <p:nvSpPr>
-          <p:cNvPr id="38" name="Rounded Rectangle 37"/>
+          <p:cNvPr id="34" name="Rounded Rectangle 33"/>
           <p:cNvSpPr/>
           <p:nvPr/>
         </p:nvSpPr>
@@ -12204,7 +11502,7 @@
       </p:sp>
       <p:sp>
         <p:nvSpPr>
-          <p:cNvPr id="39" name="TextBox 38"/>
+          <p:cNvPr id="35" name="TextBox 34"/>
           <p:cNvSpPr txBox="1"/>
           <p:nvPr/>
         </p:nvSpPr>
@@ -12243,7 +11541,7 @@
       </p:sp>
       <p:sp>
         <p:nvSpPr>
-          <p:cNvPr id="40" name="TextBox 39"/>
+          <p:cNvPr id="36" name="TextBox 35"/>
           <p:cNvSpPr txBox="1"/>
           <p:nvPr/>
         </p:nvSpPr>
@@ -12583,7 +11881,7 @@
                 </a:solidFill>
                 <a:latin typeface="Calibri"/>
               </a:rPr>
-              <a:t>ESTANQUE SUR  ·  PRESÓSTATOS</a:t>
+              <a:t>ESTANQUE NORTE  ·  CONTROL 05/08</a:t>
             </a:r>
           </a:p>
         </p:txBody>
@@ -12616,13 +11914,13 @@
               </a:spcAft>
             </a:pPr>
             <a:r>
-              <a:rPr sz="1200" b="0">
+              <a:rPr sz="1300" b="1">
                 <a:solidFill>
                   <a:srgbClr val="0D3B66"/>
                 </a:solidFill>
                 <a:latin typeface="Calibri"/>
               </a:rPr>
-              <a:t>El 10/06 se repararon los presostatos. El estanque venía en 89 m³/día (mayo–9/jun) y ese día ya marca 39 m³. Desde el 11/06 se sostiene en 28 m³/día (−61 m³/día, 68%). A $1.400/m³: $84.897/día  ·  $2.546.923/mes  ·  acumulado 11/06–17/08: $5.688.128 (4.063 m³ en 67 días).</a:t>
+              <a:t>Estanque Norte (control 05/08, 00:00–05:00): noche típica 4,8 → 1,1 m³, ahorro 3,7 m³. × 5 h de control × 30 días = 555 m³/mes = $777.000/mes (tarifa $1.400/m³). Es el que más ahorra de los controles MAE.</a:t>
             </a:r>
           </a:p>
         </p:txBody>
@@ -12871,29 +12169,13 @@
               </a:spcAft>
             </a:pPr>
             <a:r>
-              <a:rPr sz="1200" b="1">
+              <a:rPr sz="1200" b="0">
                 <a:solidFill>
                   <a:srgbClr val="0D3B66"/>
                 </a:solidFill>
                 <a:latin typeface="Calibri"/>
               </a:rPr>
-              <a:t>Estanque Norte (control 05/08, 00:00–05:00): noche típica 4,8 → 1,1 m³, ahorro 3,7 m³. × 5 h de control × 30 días = 555 m³/mes = $777.000/mes (tarifa $1.400/m³). Es el que más ahorra de los controles MAE.</a:t>
-            </a:r>
-          </a:p>
-          <a:p>
-            <a:pPr algn="l">
-              <a:spcAft>
-                <a:spcPts val="300"/>
-              </a:spcAft>
-            </a:pPr>
-            <a:r>
-              <a:rPr sz="1200" b="0">
-                <a:solidFill>
-                  <a:srgbClr val="0D3B66"/>
-                </a:solidFill>
-                <a:latin typeface="Calibri"/>
-              </a:rPr>
-              <a:t>Pizza Hut (control 01/07): noche típica 0,1 → 0 m³. Estanque Sur: corte on/off a cargo de mantención nocturna.</a:t>
+              <a:t>Pizza Hut (control 01/07): noche típica 0,1 → 0 m³. Estanque Sur: presostatos 10/06 (−61 m³/día, $2.546.923/mes) y corte on/off de mantención nocturna.</a:t>
             </a:r>
           </a:p>
           <a:p>
@@ -13175,66 +12457,27 @@
         </p:nvSpPr>
         <p:spPr>
           <a:xfrm>
-            <a:off x="274320" y="1060704"/>
-            <a:ext cx="2172614" cy="146304"/>
-          </a:xfrm>
-          <a:prstGeom prst="rect">
-            <a:avLst/>
-          </a:prstGeom>
-          <a:noFill/>
-        </p:spPr>
-        <p:txBody>
-          <a:bodyPr wrap="square">
-            <a:spAutoFit/>
-          </a:bodyPr>
-          <a:lstStyle/>
-          <a:p>
-            <a:pPr algn="l">
-              <a:spcAft>
-                <a:spcPts val="300"/>
-              </a:spcAft>
-            </a:pPr>
-            <a:r>
-              <a:rPr sz="1000" b="1">
-                <a:solidFill>
-                  <a:srgbClr val="C9A227"/>
-                </a:solidFill>
-                <a:latin typeface="Calibri"/>
-              </a:rPr>
-              <a:t>000025-08</a:t>
-            </a:r>
-          </a:p>
-        </p:txBody>
-      </p:sp>
-      <p:sp>
-        <p:nvSpPr>
-          <p:cNvPr id="9" name="TextBox 8"/>
-          <p:cNvSpPr txBox="1"/>
-          <p:nvPr/>
-        </p:nvSpPr>
-        <p:spPr>
-          <a:xfrm>
-            <a:off x="274320" y="1243584"/>
-            <a:ext cx="2172614" cy="201168"/>
-          </a:xfrm>
-          <a:prstGeom prst="rect">
-            <a:avLst/>
-          </a:prstGeom>
-          <a:noFill/>
-        </p:spPr>
-        <p:txBody>
-          <a:bodyPr wrap="square">
-            <a:spAutoFit/>
-          </a:bodyPr>
-          <a:lstStyle/>
-          <a:p>
-            <a:pPr algn="l">
-              <a:spcAft>
-                <a:spcPts val="300"/>
-              </a:spcAft>
-            </a:pPr>
-            <a:r>
-              <a:rPr sz="1200" b="1">
+            <a:off x="274320" y="1115568"/>
+            <a:ext cx="2172614" cy="292608"/>
+          </a:xfrm>
+          <a:prstGeom prst="rect">
+            <a:avLst/>
+          </a:prstGeom>
+          <a:noFill/>
+        </p:spPr>
+        <p:txBody>
+          <a:bodyPr wrap="square">
+            <a:spAutoFit/>
+          </a:bodyPr>
+          <a:lstStyle/>
+          <a:p>
+            <a:pPr algn="l">
+              <a:spcAft>
+                <a:spcPts val="300"/>
+              </a:spcAft>
+            </a:pPr>
+            <a:r>
+              <a:rPr sz="1300" b="1">
                 <a:solidFill>
                   <a:srgbClr val="0D3B66"/>
                 </a:solidFill>
@@ -13247,7 +12490,7 @@
       </p:sp>
       <p:sp>
         <p:nvSpPr>
-          <p:cNvPr id="10" name="Rounded Rectangle 9"/>
+          <p:cNvPr id="9" name="Rounded Rectangle 8"/>
           <p:cNvSpPr/>
           <p:nvPr/>
         </p:nvSpPr>
@@ -13294,72 +12537,33 @@
       </p:sp>
       <p:sp>
         <p:nvSpPr>
-          <p:cNvPr id="11" name="TextBox 10"/>
-          <p:cNvSpPr txBox="1"/>
-          <p:nvPr/>
-        </p:nvSpPr>
-        <p:spPr>
-          <a:xfrm>
-            <a:off x="2648102" y="1060704"/>
-            <a:ext cx="2172614" cy="146304"/>
-          </a:xfrm>
-          <a:prstGeom prst="rect">
-            <a:avLst/>
-          </a:prstGeom>
-          <a:noFill/>
-        </p:spPr>
-        <p:txBody>
-          <a:bodyPr wrap="square">
-            <a:spAutoFit/>
-          </a:bodyPr>
-          <a:lstStyle/>
-          <a:p>
-            <a:pPr algn="l">
-              <a:spcAft>
-                <a:spcPts val="300"/>
-              </a:spcAft>
-            </a:pPr>
-            <a:r>
-              <a:rPr sz="1000" b="1">
-                <a:solidFill>
-                  <a:srgbClr val="C9A227"/>
-                </a:solidFill>
-                <a:latin typeface="Calibri"/>
-              </a:rPr>
-              <a:t>000025-10</a:t>
-            </a:r>
-          </a:p>
-        </p:txBody>
-      </p:sp>
-      <p:sp>
-        <p:nvSpPr>
-          <p:cNvPr id="12" name="TextBox 11"/>
-          <p:cNvSpPr txBox="1"/>
-          <p:nvPr/>
-        </p:nvSpPr>
-        <p:spPr>
-          <a:xfrm>
-            <a:off x="2648102" y="1243584"/>
-            <a:ext cx="2172614" cy="201168"/>
-          </a:xfrm>
-          <a:prstGeom prst="rect">
-            <a:avLst/>
-          </a:prstGeom>
-          <a:noFill/>
-        </p:spPr>
-        <p:txBody>
-          <a:bodyPr wrap="square">
-            <a:spAutoFit/>
-          </a:bodyPr>
-          <a:lstStyle/>
-          <a:p>
-            <a:pPr algn="l">
-              <a:spcAft>
-                <a:spcPts val="300"/>
-              </a:spcAft>
-            </a:pPr>
-            <a:r>
-              <a:rPr sz="1200" b="1">
+          <p:cNvPr id="10" name="TextBox 9"/>
+          <p:cNvSpPr txBox="1"/>
+          <p:nvPr/>
+        </p:nvSpPr>
+        <p:spPr>
+          <a:xfrm>
+            <a:off x="2648102" y="1115568"/>
+            <a:ext cx="2172614" cy="292608"/>
+          </a:xfrm>
+          <a:prstGeom prst="rect">
+            <a:avLst/>
+          </a:prstGeom>
+          <a:noFill/>
+        </p:spPr>
+        <p:txBody>
+          <a:bodyPr wrap="square">
+            <a:spAutoFit/>
+          </a:bodyPr>
+          <a:lstStyle/>
+          <a:p>
+            <a:pPr algn="l">
+              <a:spcAft>
+                <a:spcPts val="300"/>
+              </a:spcAft>
+            </a:pPr>
+            <a:r>
+              <a:rPr sz="1300" b="1">
                 <a:solidFill>
                   <a:srgbClr val="0D3B66"/>
                 </a:solidFill>
@@ -13372,7 +12576,7 @@
       </p:sp>
       <p:sp>
         <p:nvSpPr>
-          <p:cNvPr id="13" name="Rounded Rectangle 12"/>
+          <p:cNvPr id="11" name="Rounded Rectangle 10"/>
           <p:cNvSpPr/>
           <p:nvPr/>
         </p:nvSpPr>
@@ -13419,72 +12623,33 @@
       </p:sp>
       <p:sp>
         <p:nvSpPr>
-          <p:cNvPr id="14" name="TextBox 13"/>
-          <p:cNvSpPr txBox="1"/>
-          <p:nvPr/>
-        </p:nvSpPr>
-        <p:spPr>
-          <a:xfrm>
-            <a:off x="5021884" y="1060704"/>
-            <a:ext cx="2172614" cy="146304"/>
-          </a:xfrm>
-          <a:prstGeom prst="rect">
-            <a:avLst/>
-          </a:prstGeom>
-          <a:noFill/>
-        </p:spPr>
-        <p:txBody>
-          <a:bodyPr wrap="square">
-            <a:spAutoFit/>
-          </a:bodyPr>
-          <a:lstStyle/>
-          <a:p>
-            <a:pPr algn="l">
-              <a:spcAft>
-                <a:spcPts val="300"/>
-              </a:spcAft>
-            </a:pPr>
-            <a:r>
-              <a:rPr sz="1000" b="1">
-                <a:solidFill>
-                  <a:srgbClr val="C9A227"/>
-                </a:solidFill>
-                <a:latin typeface="Calibri"/>
-              </a:rPr>
-              <a:t>000025-09</a:t>
-            </a:r>
-          </a:p>
-        </p:txBody>
-      </p:sp>
-      <p:sp>
-        <p:nvSpPr>
-          <p:cNvPr id="15" name="TextBox 14"/>
-          <p:cNvSpPr txBox="1"/>
-          <p:nvPr/>
-        </p:nvSpPr>
-        <p:spPr>
-          <a:xfrm>
-            <a:off x="5021884" y="1243584"/>
-            <a:ext cx="2172614" cy="201168"/>
-          </a:xfrm>
-          <a:prstGeom prst="rect">
-            <a:avLst/>
-          </a:prstGeom>
-          <a:noFill/>
-        </p:spPr>
-        <p:txBody>
-          <a:bodyPr wrap="square">
-            <a:spAutoFit/>
-          </a:bodyPr>
-          <a:lstStyle/>
-          <a:p>
-            <a:pPr algn="l">
-              <a:spcAft>
-                <a:spcPts val="300"/>
-              </a:spcAft>
-            </a:pPr>
-            <a:r>
-              <a:rPr sz="1200" b="1">
+          <p:cNvPr id="12" name="TextBox 11"/>
+          <p:cNvSpPr txBox="1"/>
+          <p:nvPr/>
+        </p:nvSpPr>
+        <p:spPr>
+          <a:xfrm>
+            <a:off x="5021884" y="1115568"/>
+            <a:ext cx="2172614" cy="292608"/>
+          </a:xfrm>
+          <a:prstGeom prst="rect">
+            <a:avLst/>
+          </a:prstGeom>
+          <a:noFill/>
+        </p:spPr>
+        <p:txBody>
+          <a:bodyPr wrap="square">
+            <a:spAutoFit/>
+          </a:bodyPr>
+          <a:lstStyle/>
+          <a:p>
+            <a:pPr algn="l">
+              <a:spcAft>
+                <a:spcPts val="300"/>
+              </a:spcAft>
+            </a:pPr>
+            <a:r>
+              <a:rPr sz="1300" b="1">
                 <a:solidFill>
                   <a:srgbClr val="0D3B66"/>
                 </a:solidFill>
@@ -13497,7 +12662,7 @@
       </p:sp>
       <p:sp>
         <p:nvSpPr>
-          <p:cNvPr id="16" name="TextBox 15"/>
+          <p:cNvPr id="13" name="TextBox 12"/>
           <p:cNvSpPr txBox="1"/>
           <p:nvPr/>
         </p:nvSpPr>
@@ -13536,7 +12701,7 @@
       </p:sp>
       <p:sp>
         <p:nvSpPr>
-          <p:cNvPr id="17" name="Rounded Rectangle 16"/>
+          <p:cNvPr id="14" name="Rounded Rectangle 13"/>
           <p:cNvSpPr/>
           <p:nvPr/>
         </p:nvSpPr>
@@ -13583,72 +12748,33 @@
       </p:sp>
       <p:sp>
         <p:nvSpPr>
-          <p:cNvPr id="18" name="TextBox 17"/>
-          <p:cNvSpPr txBox="1"/>
-          <p:nvPr/>
-        </p:nvSpPr>
-        <p:spPr>
-          <a:xfrm>
-            <a:off x="7395667" y="1060704"/>
-            <a:ext cx="2172614" cy="146304"/>
-          </a:xfrm>
-          <a:prstGeom prst="rect">
-            <a:avLst/>
-          </a:prstGeom>
-          <a:noFill/>
-        </p:spPr>
-        <p:txBody>
-          <a:bodyPr wrap="square">
-            <a:spAutoFit/>
-          </a:bodyPr>
-          <a:lstStyle/>
-          <a:p>
-            <a:pPr algn="l">
-              <a:spcAft>
-                <a:spcPts val="300"/>
-              </a:spcAft>
-            </a:pPr>
-            <a:r>
-              <a:rPr sz="1000" b="1">
-                <a:solidFill>
-                  <a:srgbClr val="C9A227"/>
-                </a:solidFill>
-                <a:latin typeface="Calibri"/>
-              </a:rPr>
-              <a:t>000025-32</a:t>
-            </a:r>
-          </a:p>
-        </p:txBody>
-      </p:sp>
-      <p:sp>
-        <p:nvSpPr>
-          <p:cNvPr id="19" name="TextBox 18"/>
-          <p:cNvSpPr txBox="1"/>
-          <p:nvPr/>
-        </p:nvSpPr>
-        <p:spPr>
-          <a:xfrm>
-            <a:off x="7395667" y="1243584"/>
-            <a:ext cx="2172614" cy="201168"/>
-          </a:xfrm>
-          <a:prstGeom prst="rect">
-            <a:avLst/>
-          </a:prstGeom>
-          <a:noFill/>
-        </p:spPr>
-        <p:txBody>
-          <a:bodyPr wrap="square">
-            <a:spAutoFit/>
-          </a:bodyPr>
-          <a:lstStyle/>
-          <a:p>
-            <a:pPr algn="l">
-              <a:spcAft>
-                <a:spcPts val="300"/>
-              </a:spcAft>
-            </a:pPr>
-            <a:r>
-              <a:rPr sz="1200" b="1">
+          <p:cNvPr id="15" name="TextBox 14"/>
+          <p:cNvSpPr txBox="1"/>
+          <p:nvPr/>
+        </p:nvSpPr>
+        <p:spPr>
+          <a:xfrm>
+            <a:off x="7395667" y="1115568"/>
+            <a:ext cx="2172614" cy="292608"/>
+          </a:xfrm>
+          <a:prstGeom prst="rect">
+            <a:avLst/>
+          </a:prstGeom>
+          <a:noFill/>
+        </p:spPr>
+        <p:txBody>
+          <a:bodyPr wrap="square">
+            <a:spAutoFit/>
+          </a:bodyPr>
+          <a:lstStyle/>
+          <a:p>
+            <a:pPr algn="l">
+              <a:spcAft>
+                <a:spcPts val="300"/>
+              </a:spcAft>
+            </a:pPr>
+            <a:r>
+              <a:rPr sz="1300" b="1">
                 <a:solidFill>
                   <a:srgbClr val="0D3B66"/>
                 </a:solidFill>
@@ -13661,7 +12787,7 @@
       </p:sp>
       <p:sp>
         <p:nvSpPr>
-          <p:cNvPr id="20" name="TextBox 19"/>
+          <p:cNvPr id="16" name="TextBox 15"/>
           <p:cNvSpPr txBox="1"/>
           <p:nvPr/>
         </p:nvSpPr>
@@ -13700,7 +12826,7 @@
       </p:sp>
       <p:sp>
         <p:nvSpPr>
-          <p:cNvPr id="21" name="Rounded Rectangle 20"/>
+          <p:cNvPr id="17" name="Rounded Rectangle 16"/>
           <p:cNvSpPr/>
           <p:nvPr/>
         </p:nvSpPr>
@@ -13747,72 +12873,33 @@
       </p:sp>
       <p:sp>
         <p:nvSpPr>
-          <p:cNvPr id="22" name="TextBox 21"/>
-          <p:cNvSpPr txBox="1"/>
-          <p:nvPr/>
-        </p:nvSpPr>
-        <p:spPr>
-          <a:xfrm>
-            <a:off x="9769449" y="1060704"/>
-            <a:ext cx="2172614" cy="146304"/>
-          </a:xfrm>
-          <a:prstGeom prst="rect">
-            <a:avLst/>
-          </a:prstGeom>
-          <a:noFill/>
-        </p:spPr>
-        <p:txBody>
-          <a:bodyPr wrap="square">
-            <a:spAutoFit/>
-          </a:bodyPr>
-          <a:lstStyle/>
-          <a:p>
-            <a:pPr algn="l">
-              <a:spcAft>
-                <a:spcPts val="300"/>
-              </a:spcAft>
-            </a:pPr>
-            <a:r>
-              <a:rPr sz="1000" b="1">
-                <a:solidFill>
-                  <a:srgbClr val="C9A227"/>
-                </a:solidFill>
-                <a:latin typeface="Calibri"/>
-              </a:rPr>
-              <a:t>000025-33</a:t>
-            </a:r>
-          </a:p>
-        </p:txBody>
-      </p:sp>
-      <p:sp>
-        <p:nvSpPr>
-          <p:cNvPr id="23" name="TextBox 22"/>
-          <p:cNvSpPr txBox="1"/>
-          <p:nvPr/>
-        </p:nvSpPr>
-        <p:spPr>
-          <a:xfrm>
-            <a:off x="9769449" y="1243584"/>
-            <a:ext cx="2172614" cy="201168"/>
-          </a:xfrm>
-          <a:prstGeom prst="rect">
-            <a:avLst/>
-          </a:prstGeom>
-          <a:noFill/>
-        </p:spPr>
-        <p:txBody>
-          <a:bodyPr wrap="square">
-            <a:spAutoFit/>
-          </a:bodyPr>
-          <a:lstStyle/>
-          <a:p>
-            <a:pPr algn="l">
-              <a:spcAft>
-                <a:spcPts val="300"/>
-              </a:spcAft>
-            </a:pPr>
-            <a:r>
-              <a:rPr sz="1200" b="1">
+          <p:cNvPr id="18" name="TextBox 17"/>
+          <p:cNvSpPr txBox="1"/>
+          <p:nvPr/>
+        </p:nvSpPr>
+        <p:spPr>
+          <a:xfrm>
+            <a:off x="9769449" y="1115568"/>
+            <a:ext cx="2172614" cy="292608"/>
+          </a:xfrm>
+          <a:prstGeom prst="rect">
+            <a:avLst/>
+          </a:prstGeom>
+          <a:noFill/>
+        </p:spPr>
+        <p:txBody>
+          <a:bodyPr wrap="square">
+            <a:spAutoFit/>
+          </a:bodyPr>
+          <a:lstStyle/>
+          <a:p>
+            <a:pPr algn="l">
+              <a:spcAft>
+                <a:spcPts val="300"/>
+              </a:spcAft>
+            </a:pPr>
+            <a:r>
+              <a:rPr sz="1300" b="1">
                 <a:solidFill>
                   <a:srgbClr val="0D3B66"/>
                 </a:solidFill>
@@ -13825,7 +12912,7 @@
       </p:sp>
       <p:sp>
         <p:nvSpPr>
-          <p:cNvPr id="24" name="TextBox 23"/>
+          <p:cNvPr id="19" name="TextBox 18"/>
           <p:cNvSpPr txBox="1"/>
           <p:nvPr/>
         </p:nvSpPr>
@@ -13864,7 +12951,7 @@
       </p:sp>
       <p:sp>
         <p:nvSpPr>
-          <p:cNvPr id="25" name="Rounded Rectangle 24"/>
+          <p:cNvPr id="20" name="Rounded Rectangle 19"/>
           <p:cNvSpPr/>
           <p:nvPr/>
         </p:nvSpPr>
@@ -13909,7 +12996,7 @@
       </p:sp>
       <p:pic>
         <p:nvPicPr>
-          <p:cNvPr id="26" name="Picture 25" descr="mam_mensual_may_ago.png"/>
+          <p:cNvPr id="21" name="Picture 20" descr="mam_mensual_may_ago.png"/>
           <p:cNvPicPr>
             <a:picLocks noChangeAspect="1"/>
           </p:cNvPicPr>
@@ -13933,7 +13020,7 @@
       </p:pic>
       <p:sp>
         <p:nvSpPr>
-          <p:cNvPr id="27" name="Rounded Rectangle 26"/>
+          <p:cNvPr id="22" name="Rounded Rectangle 21"/>
           <p:cNvSpPr/>
           <p:nvPr/>
         </p:nvSpPr>
@@ -13980,7 +13067,7 @@
       </p:sp>
       <p:sp>
         <p:nvSpPr>
-          <p:cNvPr id="28" name="TextBox 27"/>
+          <p:cNvPr id="23" name="TextBox 22"/>
           <p:cNvSpPr txBox="1"/>
           <p:nvPr/>
         </p:nvSpPr>
@@ -14019,7 +13106,7 @@
       </p:sp>
       <p:sp>
         <p:nvSpPr>
-          <p:cNvPr id="29" name="TextBox 28"/>
+          <p:cNvPr id="24" name="TextBox 23"/>
           <p:cNvSpPr txBox="1"/>
           <p:nvPr/>
         </p:nvSpPr>
@@ -14058,7 +13145,7 @@
       </p:sp>
       <p:sp>
         <p:nvSpPr>
-          <p:cNvPr id="30" name="Rounded Rectangle 29"/>
+          <p:cNvPr id="25" name="Rounded Rectangle 24"/>
           <p:cNvSpPr/>
           <p:nvPr/>
         </p:nvSpPr>
@@ -14105,7 +13192,7 @@
       </p:sp>
       <p:sp>
         <p:nvSpPr>
-          <p:cNvPr id="31" name="TextBox 30"/>
+          <p:cNvPr id="26" name="TextBox 25"/>
           <p:cNvSpPr txBox="1"/>
           <p:nvPr/>
         </p:nvSpPr>
@@ -14144,7 +13231,7 @@
       </p:sp>
       <p:sp>
         <p:nvSpPr>
-          <p:cNvPr id="32" name="TextBox 31"/>
+          <p:cNvPr id="27" name="TextBox 26"/>
           <p:cNvSpPr txBox="1"/>
           <p:nvPr/>
         </p:nvSpPr>
@@ -14183,7 +13270,7 @@
       </p:sp>
       <p:sp>
         <p:nvSpPr>
-          <p:cNvPr id="33" name="Rounded Rectangle 32"/>
+          <p:cNvPr id="28" name="Rounded Rectangle 27"/>
           <p:cNvSpPr/>
           <p:nvPr/>
         </p:nvSpPr>
@@ -14230,7 +13317,7 @@
       </p:sp>
       <p:sp>
         <p:nvSpPr>
-          <p:cNvPr id="34" name="TextBox 33"/>
+          <p:cNvPr id="29" name="TextBox 28"/>
           <p:cNvSpPr txBox="1"/>
           <p:nvPr/>
         </p:nvSpPr>
@@ -14269,7 +13356,7 @@
       </p:sp>
       <p:sp>
         <p:nvSpPr>
-          <p:cNvPr id="35" name="TextBox 34"/>
+          <p:cNvPr id="30" name="TextBox 29"/>
           <p:cNvSpPr txBox="1"/>
           <p:nvPr/>
         </p:nvSpPr>
@@ -14308,7 +13395,7 @@
       </p:sp>
       <p:sp>
         <p:nvSpPr>
-          <p:cNvPr id="36" name="Rounded Rectangle 35"/>
+          <p:cNvPr id="31" name="Rounded Rectangle 30"/>
           <p:cNvSpPr/>
           <p:nvPr/>
         </p:nvSpPr>
@@ -14355,7 +13442,7 @@
       </p:sp>
       <p:sp>
         <p:nvSpPr>
-          <p:cNvPr id="37" name="TextBox 36"/>
+          <p:cNvPr id="32" name="TextBox 31"/>
           <p:cNvSpPr txBox="1"/>
           <p:nvPr/>
         </p:nvSpPr>
@@ -14394,7 +13481,7 @@
       </p:sp>
       <p:sp>
         <p:nvSpPr>
-          <p:cNvPr id="38" name="TextBox 37"/>
+          <p:cNvPr id="33" name="TextBox 32"/>
           <p:cNvSpPr txBox="1"/>
           <p:nvPr/>
         </p:nvSpPr>
@@ -14433,7 +13520,7 @@
       </p:sp>
       <p:sp>
         <p:nvSpPr>
-          <p:cNvPr id="39" name="Rounded Rectangle 38"/>
+          <p:cNvPr id="34" name="Rounded Rectangle 33"/>
           <p:cNvSpPr/>
           <p:nvPr/>
         </p:nvSpPr>
@@ -14480,7 +13567,7 @@
       </p:sp>
       <p:sp>
         <p:nvSpPr>
-          <p:cNvPr id="40" name="TextBox 39"/>
+          <p:cNvPr id="35" name="TextBox 34"/>
           <p:cNvSpPr txBox="1"/>
           <p:nvPr/>
         </p:nvSpPr>
@@ -14519,7 +13606,7 @@
       </p:sp>
       <p:sp>
         <p:nvSpPr>
-          <p:cNvPr id="41" name="TextBox 40"/>
+          <p:cNvPr id="36" name="TextBox 35"/>
           <p:cNvSpPr txBox="1"/>
           <p:nvPr/>
         </p:nvSpPr>
@@ -14558,7 +13645,7 @@
       </p:sp>
       <p:sp>
         <p:nvSpPr>
-          <p:cNvPr id="42" name="Rounded Rectangle 41"/>
+          <p:cNvPr id="37" name="Rounded Rectangle 36"/>
           <p:cNvSpPr/>
           <p:nvPr/>
         </p:nvSpPr>
@@ -14605,7 +13692,7 @@
       </p:sp>
       <p:sp>
         <p:nvSpPr>
-          <p:cNvPr id="43" name="TextBox 42"/>
+          <p:cNvPr id="38" name="TextBox 37"/>
           <p:cNvSpPr txBox="1"/>
           <p:nvPr/>
         </p:nvSpPr>
@@ -14644,7 +13731,7 @@
       </p:sp>
       <p:sp>
         <p:nvSpPr>
-          <p:cNvPr id="44" name="TextBox 43"/>
+          <p:cNvPr id="39" name="TextBox 38"/>
           <p:cNvSpPr txBox="1"/>
           <p:nvPr/>
         </p:nvSpPr>
@@ -14683,7 +13770,7 @@
       </p:sp>
       <p:sp>
         <p:nvSpPr>
-          <p:cNvPr id="45" name="Rounded Rectangle 44"/>
+          <p:cNvPr id="40" name="Rounded Rectangle 39"/>
           <p:cNvSpPr/>
           <p:nvPr/>
         </p:nvSpPr>
@@ -14730,7 +13817,7 @@
       </p:sp>
       <p:sp>
         <p:nvSpPr>
-          <p:cNvPr id="46" name="TextBox 45"/>
+          <p:cNvPr id="41" name="TextBox 40"/>
           <p:cNvSpPr txBox="1"/>
           <p:nvPr/>
         </p:nvSpPr>
@@ -14769,7 +13856,7 @@
       </p:sp>
       <p:sp>
         <p:nvSpPr>
-          <p:cNvPr id="47" name="TextBox 46"/>
+          <p:cNvPr id="42" name="TextBox 41"/>
           <p:cNvSpPr txBox="1"/>
           <p:nvPr/>
         </p:nvSpPr>
@@ -15693,66 +14780,27 @@
         </p:nvSpPr>
         <p:spPr>
           <a:xfrm>
-            <a:off x="274320" y="1060704"/>
-            <a:ext cx="5733288" cy="146304"/>
-          </a:xfrm>
-          <a:prstGeom prst="rect">
-            <a:avLst/>
-          </a:prstGeom>
-          <a:noFill/>
-        </p:spPr>
-        <p:txBody>
-          <a:bodyPr wrap="square">
-            <a:spAutoFit/>
-          </a:bodyPr>
-          <a:lstStyle/>
-          <a:p>
-            <a:pPr algn="l">
-              <a:spcAft>
-                <a:spcPts val="300"/>
-              </a:spcAft>
-            </a:pPr>
-            <a:r>
-              <a:rPr sz="1000" b="1">
-                <a:solidFill>
-                  <a:srgbClr val="C9A227"/>
-                </a:solidFill>
-                <a:latin typeface="Calibri"/>
-              </a:rPr>
-              <a:t>000025-13</a:t>
-            </a:r>
-          </a:p>
-        </p:txBody>
-      </p:sp>
-      <p:sp>
-        <p:nvSpPr>
-          <p:cNvPr id="9" name="TextBox 8"/>
-          <p:cNvSpPr txBox="1"/>
-          <p:nvPr/>
-        </p:nvSpPr>
-        <p:spPr>
-          <a:xfrm>
-            <a:off x="274320" y="1243584"/>
-            <a:ext cx="5733288" cy="201168"/>
-          </a:xfrm>
-          <a:prstGeom prst="rect">
-            <a:avLst/>
-          </a:prstGeom>
-          <a:noFill/>
-        </p:spPr>
-        <p:txBody>
-          <a:bodyPr wrap="square">
-            <a:spAutoFit/>
-          </a:bodyPr>
-          <a:lstStyle/>
-          <a:p>
-            <a:pPr algn="l">
-              <a:spcAft>
-                <a:spcPts val="300"/>
-              </a:spcAft>
-            </a:pPr>
-            <a:r>
-              <a:rPr sz="1200" b="1">
+            <a:off x="274320" y="1115568"/>
+            <a:ext cx="5733288" cy="292608"/>
+          </a:xfrm>
+          <a:prstGeom prst="rect">
+            <a:avLst/>
+          </a:prstGeom>
+          <a:noFill/>
+        </p:spPr>
+        <p:txBody>
+          <a:bodyPr wrap="square">
+            <a:spAutoFit/>
+          </a:bodyPr>
+          <a:lstStyle/>
+          <a:p>
+            <a:pPr algn="l">
+              <a:spcAft>
+                <a:spcPts val="300"/>
+              </a:spcAft>
+            </a:pPr>
+            <a:r>
+              <a:rPr sz="1300" b="1">
                 <a:solidFill>
                   <a:srgbClr val="0D3B66"/>
                 </a:solidFill>
@@ -15765,7 +14813,7 @@
       </p:sp>
       <p:sp>
         <p:nvSpPr>
-          <p:cNvPr id="10" name="Rounded Rectangle 9"/>
+          <p:cNvPr id="9" name="Rounded Rectangle 8"/>
           <p:cNvSpPr/>
           <p:nvPr/>
         </p:nvSpPr>
@@ -15812,85 +14860,46 @@
       </p:sp>
       <p:sp>
         <p:nvSpPr>
+          <p:cNvPr id="10" name="TextBox 9"/>
+          <p:cNvSpPr txBox="1"/>
+          <p:nvPr/>
+        </p:nvSpPr>
+        <p:spPr>
+          <a:xfrm>
+            <a:off x="6208776" y="1115568"/>
+            <a:ext cx="5733288" cy="292608"/>
+          </a:xfrm>
+          <a:prstGeom prst="rect">
+            <a:avLst/>
+          </a:prstGeom>
+          <a:noFill/>
+        </p:spPr>
+        <p:txBody>
+          <a:bodyPr wrap="square">
+            <a:spAutoFit/>
+          </a:bodyPr>
+          <a:lstStyle/>
+          <a:p>
+            <a:pPr algn="l">
+              <a:spcAft>
+                <a:spcPts val="300"/>
+              </a:spcAft>
+            </a:pPr>
+            <a:r>
+              <a:rPr sz="1300" b="1">
+                <a:solidFill>
+                  <a:srgbClr val="0D3B66"/>
+                </a:solidFill>
+                <a:latin typeface="Calibri"/>
+              </a:rPr>
+              <a:t>Alim. Baños</a:t>
+            </a:r>
+          </a:p>
+        </p:txBody>
+      </p:sp>
+      <p:sp>
+        <p:nvSpPr>
           <p:cNvPr id="11" name="TextBox 10"/>
-          <p:cNvSpPr txBox="1"/>
-          <p:nvPr/>
-        </p:nvSpPr>
-        <p:spPr>
-          <a:xfrm>
-            <a:off x="6208776" y="1060704"/>
-            <a:ext cx="5733288" cy="146304"/>
-          </a:xfrm>
-          <a:prstGeom prst="rect">
-            <a:avLst/>
-          </a:prstGeom>
-          <a:noFill/>
-        </p:spPr>
-        <p:txBody>
-          <a:bodyPr wrap="square">
-            <a:spAutoFit/>
-          </a:bodyPr>
-          <a:lstStyle/>
-          <a:p>
-            <a:pPr algn="l">
-              <a:spcAft>
-                <a:spcPts val="300"/>
-              </a:spcAft>
-            </a:pPr>
-            <a:r>
-              <a:rPr sz="1000" b="1">
-                <a:solidFill>
-                  <a:srgbClr val="C9A227"/>
-                </a:solidFill>
-                <a:latin typeface="Calibri"/>
-              </a:rPr>
-              <a:t>000025-34</a:t>
-            </a:r>
-          </a:p>
-        </p:txBody>
-      </p:sp>
-      <p:sp>
-        <p:nvSpPr>
-          <p:cNvPr id="12" name="TextBox 11"/>
-          <p:cNvSpPr txBox="1"/>
-          <p:nvPr/>
-        </p:nvSpPr>
-        <p:spPr>
-          <a:xfrm>
-            <a:off x="6208776" y="1243584"/>
-            <a:ext cx="5733288" cy="201168"/>
-          </a:xfrm>
-          <a:prstGeom prst="rect">
-            <a:avLst/>
-          </a:prstGeom>
-          <a:noFill/>
-        </p:spPr>
-        <p:txBody>
-          <a:bodyPr wrap="square">
-            <a:spAutoFit/>
-          </a:bodyPr>
-          <a:lstStyle/>
-          <a:p>
-            <a:pPr algn="l">
-              <a:spcAft>
-                <a:spcPts val="300"/>
-              </a:spcAft>
-            </a:pPr>
-            <a:r>
-              <a:rPr sz="1200" b="1">
-                <a:solidFill>
-                  <a:srgbClr val="0D3B66"/>
-                </a:solidFill>
-                <a:latin typeface="Calibri"/>
-              </a:rPr>
-              <a:t>Alim. Baños</a:t>
-            </a:r>
-          </a:p>
-        </p:txBody>
-      </p:sp>
-      <p:sp>
-        <p:nvSpPr>
-          <p:cNvPr id="13" name="TextBox 12"/>
           <p:cNvSpPr txBox="1"/>
           <p:nvPr/>
         </p:nvSpPr>
@@ -15929,7 +14938,7 @@
       </p:sp>
       <p:sp>
         <p:nvSpPr>
-          <p:cNvPr id="14" name="Rounded Rectangle 13"/>
+          <p:cNvPr id="12" name="Rounded Rectangle 11"/>
           <p:cNvSpPr/>
           <p:nvPr/>
         </p:nvSpPr>
@@ -15974,7 +14983,7 @@
       </p:sp>
       <p:pic>
         <p:nvPicPr>
-          <p:cNvPr id="15" name="Picture 14" descr="maq_mensual_may_ago.png"/>
+          <p:cNvPr id="13" name="Picture 12" descr="maq_mensual_may_ago.png"/>
           <p:cNvPicPr>
             <a:picLocks noChangeAspect="1"/>
           </p:cNvPicPr>
@@ -15998,7 +15007,7 @@
       </p:pic>
       <p:sp>
         <p:nvSpPr>
-          <p:cNvPr id="16" name="Rounded Rectangle 15"/>
+          <p:cNvPr id="14" name="Rounded Rectangle 13"/>
           <p:cNvSpPr/>
           <p:nvPr/>
         </p:nvSpPr>
@@ -16045,7 +15054,7 @@
       </p:sp>
       <p:sp>
         <p:nvSpPr>
-          <p:cNvPr id="17" name="TextBox 16"/>
+          <p:cNvPr id="15" name="TextBox 14"/>
           <p:cNvSpPr txBox="1"/>
           <p:nvPr/>
         </p:nvSpPr>
@@ -16084,7 +15093,7 @@
       </p:sp>
       <p:sp>
         <p:nvSpPr>
-          <p:cNvPr id="18" name="TextBox 17"/>
+          <p:cNvPr id="16" name="TextBox 15"/>
           <p:cNvSpPr txBox="1"/>
           <p:nvPr/>
         </p:nvSpPr>
@@ -16123,7 +15132,7 @@
       </p:sp>
       <p:sp>
         <p:nvSpPr>
-          <p:cNvPr id="19" name="Rounded Rectangle 18"/>
+          <p:cNvPr id="17" name="Rounded Rectangle 16"/>
           <p:cNvSpPr/>
           <p:nvPr/>
         </p:nvSpPr>
@@ -16170,7 +15179,7 @@
       </p:sp>
       <p:sp>
         <p:nvSpPr>
-          <p:cNvPr id="20" name="TextBox 19"/>
+          <p:cNvPr id="18" name="TextBox 17"/>
           <p:cNvSpPr txBox="1"/>
           <p:nvPr/>
         </p:nvSpPr>
@@ -16209,7 +15218,7 @@
       </p:sp>
       <p:sp>
         <p:nvSpPr>
-          <p:cNvPr id="21" name="TextBox 20"/>
+          <p:cNvPr id="19" name="TextBox 18"/>
           <p:cNvSpPr txBox="1"/>
           <p:nvPr/>
         </p:nvSpPr>
@@ -16248,7 +15257,7 @@
       </p:sp>
       <p:sp>
         <p:nvSpPr>
-          <p:cNvPr id="22" name="Rounded Rectangle 21"/>
+          <p:cNvPr id="20" name="Rounded Rectangle 19"/>
           <p:cNvSpPr/>
           <p:nvPr/>
         </p:nvSpPr>
@@ -16295,7 +15304,7 @@
       </p:sp>
       <p:sp>
         <p:nvSpPr>
-          <p:cNvPr id="23" name="TextBox 22"/>
+          <p:cNvPr id="21" name="TextBox 20"/>
           <p:cNvSpPr txBox="1"/>
           <p:nvPr/>
         </p:nvSpPr>
@@ -16334,7 +15343,7 @@
       </p:sp>
       <p:sp>
         <p:nvSpPr>
-          <p:cNvPr id="24" name="TextBox 23"/>
+          <p:cNvPr id="22" name="TextBox 21"/>
           <p:cNvSpPr txBox="1"/>
           <p:nvPr/>
         </p:nvSpPr>
@@ -16373,7 +15382,7 @@
       </p:sp>
       <p:sp>
         <p:nvSpPr>
-          <p:cNvPr id="25" name="Rounded Rectangle 24"/>
+          <p:cNvPr id="23" name="Rounded Rectangle 22"/>
           <p:cNvSpPr/>
           <p:nvPr/>
         </p:nvSpPr>
@@ -16420,7 +15429,7 @@
       </p:sp>
       <p:sp>
         <p:nvSpPr>
-          <p:cNvPr id="26" name="TextBox 25"/>
+          <p:cNvPr id="24" name="TextBox 23"/>
           <p:cNvSpPr txBox="1"/>
           <p:nvPr/>
         </p:nvSpPr>
@@ -16459,7 +15468,7 @@
       </p:sp>
       <p:sp>
         <p:nvSpPr>
-          <p:cNvPr id="27" name="TextBox 26"/>
+          <p:cNvPr id="25" name="TextBox 24"/>
           <p:cNvSpPr txBox="1"/>
           <p:nvPr/>
         </p:nvSpPr>
@@ -17383,66 +16392,27 @@
         </p:nvSpPr>
         <p:spPr>
           <a:xfrm>
-            <a:off x="274320" y="1060704"/>
-            <a:ext cx="5733288" cy="146304"/>
-          </a:xfrm>
-          <a:prstGeom prst="rect">
-            <a:avLst/>
-          </a:prstGeom>
-          <a:noFill/>
-        </p:spPr>
-        <p:txBody>
-          <a:bodyPr wrap="square">
-            <a:spAutoFit/>
-          </a:bodyPr>
-          <a:lstStyle/>
-          <a:p>
-            <a:pPr algn="l">
-              <a:spcAft>
-                <a:spcPts val="300"/>
-              </a:spcAft>
-            </a:pPr>
-            <a:r>
-              <a:rPr sz="1000" b="1">
-                <a:solidFill>
-                  <a:srgbClr val="C9A227"/>
-                </a:solidFill>
-                <a:latin typeface="Calibri"/>
-              </a:rPr>
-              <a:t>000025-18</a:t>
-            </a:r>
-          </a:p>
-        </p:txBody>
-      </p:sp>
-      <p:sp>
-        <p:nvSpPr>
-          <p:cNvPr id="9" name="TextBox 8"/>
-          <p:cNvSpPr txBox="1"/>
-          <p:nvPr/>
-        </p:nvSpPr>
-        <p:spPr>
-          <a:xfrm>
-            <a:off x="274320" y="1243584"/>
-            <a:ext cx="5733288" cy="201168"/>
-          </a:xfrm>
-          <a:prstGeom prst="rect">
-            <a:avLst/>
-          </a:prstGeom>
-          <a:noFill/>
-        </p:spPr>
-        <p:txBody>
-          <a:bodyPr wrap="square">
-            <a:spAutoFit/>
-          </a:bodyPr>
-          <a:lstStyle/>
-          <a:p>
-            <a:pPr algn="l">
-              <a:spcAft>
-                <a:spcPts val="300"/>
-              </a:spcAft>
-            </a:pPr>
-            <a:r>
-              <a:rPr sz="1200" b="1">
+            <a:off x="274320" y="1115568"/>
+            <a:ext cx="5733288" cy="292608"/>
+          </a:xfrm>
+          <a:prstGeom prst="rect">
+            <a:avLst/>
+          </a:prstGeom>
+          <a:noFill/>
+        </p:spPr>
+        <p:txBody>
+          <a:bodyPr wrap="square">
+            <a:spAutoFit/>
+          </a:bodyPr>
+          <a:lstStyle/>
+          <a:p>
+            <a:pPr algn="l">
+              <a:spcAft>
+                <a:spcPts val="300"/>
+              </a:spcAft>
+            </a:pPr>
+            <a:r>
+              <a:rPr sz="1300" b="1">
                 <a:solidFill>
                   <a:srgbClr val="0D3B66"/>
                 </a:solidFill>
@@ -17455,7 +16425,7 @@
       </p:sp>
       <p:sp>
         <p:nvSpPr>
-          <p:cNvPr id="10" name="Rounded Rectangle 9"/>
+          <p:cNvPr id="9" name="Rounded Rectangle 8"/>
           <p:cNvSpPr/>
           <p:nvPr/>
         </p:nvSpPr>
@@ -17502,85 +16472,46 @@
       </p:sp>
       <p:sp>
         <p:nvSpPr>
+          <p:cNvPr id="10" name="TextBox 9"/>
+          <p:cNvSpPr txBox="1"/>
+          <p:nvPr/>
+        </p:nvSpPr>
+        <p:spPr>
+          <a:xfrm>
+            <a:off x="6208776" y="1115568"/>
+            <a:ext cx="5733288" cy="292608"/>
+          </a:xfrm>
+          <a:prstGeom prst="rect">
+            <a:avLst/>
+          </a:prstGeom>
+          <a:noFill/>
+        </p:spPr>
+        <p:txBody>
+          <a:bodyPr wrap="square">
+            <a:spAutoFit/>
+          </a:bodyPr>
+          <a:lstStyle/>
+          <a:p>
+            <a:pPr algn="l">
+              <a:spcAft>
+                <a:spcPts val="300"/>
+              </a:spcAft>
+            </a:pPr>
+            <a:r>
+              <a:rPr sz="1300" b="1">
+                <a:solidFill>
+                  <a:srgbClr val="0D3B66"/>
+                </a:solidFill>
+                <a:latin typeface="Calibri"/>
+              </a:rPr>
+              <a:t>San Ignacio 300</a:t>
+            </a:r>
+          </a:p>
+        </p:txBody>
+      </p:sp>
+      <p:sp>
+        <p:nvSpPr>
           <p:cNvPr id="11" name="TextBox 10"/>
-          <p:cNvSpPr txBox="1"/>
-          <p:nvPr/>
-        </p:nvSpPr>
-        <p:spPr>
-          <a:xfrm>
-            <a:off x="6208776" y="1060704"/>
-            <a:ext cx="5733288" cy="146304"/>
-          </a:xfrm>
-          <a:prstGeom prst="rect">
-            <a:avLst/>
-          </a:prstGeom>
-          <a:noFill/>
-        </p:spPr>
-        <p:txBody>
-          <a:bodyPr wrap="square">
-            <a:spAutoFit/>
-          </a:bodyPr>
-          <a:lstStyle/>
-          <a:p>
-            <a:pPr algn="l">
-              <a:spcAft>
-                <a:spcPts val="300"/>
-              </a:spcAft>
-            </a:pPr>
-            <a:r>
-              <a:rPr sz="1000" b="1">
-                <a:solidFill>
-                  <a:srgbClr val="C9A227"/>
-                </a:solidFill>
-                <a:latin typeface="Calibri"/>
-              </a:rPr>
-              <a:t>000025-17</a:t>
-            </a:r>
-          </a:p>
-        </p:txBody>
-      </p:sp>
-      <p:sp>
-        <p:nvSpPr>
-          <p:cNvPr id="12" name="TextBox 11"/>
-          <p:cNvSpPr txBox="1"/>
-          <p:nvPr/>
-        </p:nvSpPr>
-        <p:spPr>
-          <a:xfrm>
-            <a:off x="6208776" y="1243584"/>
-            <a:ext cx="5733288" cy="201168"/>
-          </a:xfrm>
-          <a:prstGeom prst="rect">
-            <a:avLst/>
-          </a:prstGeom>
-          <a:noFill/>
-        </p:spPr>
-        <p:txBody>
-          <a:bodyPr wrap="square">
-            <a:spAutoFit/>
-          </a:bodyPr>
-          <a:lstStyle/>
-          <a:p>
-            <a:pPr algn="l">
-              <a:spcAft>
-                <a:spcPts val="300"/>
-              </a:spcAft>
-            </a:pPr>
-            <a:r>
-              <a:rPr sz="1200" b="1">
-                <a:solidFill>
-                  <a:srgbClr val="0D3B66"/>
-                </a:solidFill>
-                <a:latin typeface="Calibri"/>
-              </a:rPr>
-              <a:t>San Ignacio 300</a:t>
-            </a:r>
-          </a:p>
-        </p:txBody>
-      </p:sp>
-      <p:sp>
-        <p:nvSpPr>
-          <p:cNvPr id="13" name="TextBox 12"/>
           <p:cNvSpPr txBox="1"/>
           <p:nvPr/>
         </p:nvSpPr>
@@ -17619,7 +16550,7 @@
       </p:sp>
       <p:sp>
         <p:nvSpPr>
-          <p:cNvPr id="14" name="Rounded Rectangle 13"/>
+          <p:cNvPr id="12" name="Rounded Rectangle 11"/>
           <p:cNvSpPr/>
           <p:nvPr/>
         </p:nvSpPr>
@@ -17664,7 +16595,7 @@
       </p:sp>
       <p:pic>
         <p:nvPicPr>
-          <p:cNvPr id="15" name="Picture 14" descr="bom_mensual_may_ago.png"/>
+          <p:cNvPr id="13" name="Picture 12" descr="bom_mensual_may_ago.png"/>
           <p:cNvPicPr>
             <a:picLocks noChangeAspect="1"/>
           </p:cNvPicPr>
@@ -17688,7 +16619,7 @@
       </p:pic>
       <p:sp>
         <p:nvSpPr>
-          <p:cNvPr id="16" name="Rounded Rectangle 15"/>
+          <p:cNvPr id="14" name="Rounded Rectangle 13"/>
           <p:cNvSpPr/>
           <p:nvPr/>
         </p:nvSpPr>
@@ -17735,7 +16666,7 @@
       </p:sp>
       <p:sp>
         <p:nvSpPr>
-          <p:cNvPr id="17" name="TextBox 16"/>
+          <p:cNvPr id="15" name="TextBox 14"/>
           <p:cNvSpPr txBox="1"/>
           <p:nvPr/>
         </p:nvSpPr>
@@ -17774,7 +16705,7 @@
       </p:sp>
       <p:sp>
         <p:nvSpPr>
-          <p:cNvPr id="18" name="TextBox 17"/>
+          <p:cNvPr id="16" name="TextBox 15"/>
           <p:cNvSpPr txBox="1"/>
           <p:nvPr/>
         </p:nvSpPr>
@@ -17813,7 +16744,7 @@
       </p:sp>
       <p:sp>
         <p:nvSpPr>
-          <p:cNvPr id="19" name="Rounded Rectangle 18"/>
+          <p:cNvPr id="17" name="Rounded Rectangle 16"/>
           <p:cNvSpPr/>
           <p:nvPr/>
         </p:nvSpPr>
@@ -17860,7 +16791,7 @@
       </p:sp>
       <p:sp>
         <p:nvSpPr>
-          <p:cNvPr id="20" name="TextBox 19"/>
+          <p:cNvPr id="18" name="TextBox 17"/>
           <p:cNvSpPr txBox="1"/>
           <p:nvPr/>
         </p:nvSpPr>
@@ -17899,7 +16830,7 @@
       </p:sp>
       <p:sp>
         <p:nvSpPr>
-          <p:cNvPr id="21" name="TextBox 20"/>
+          <p:cNvPr id="19" name="TextBox 18"/>
           <p:cNvSpPr txBox="1"/>
           <p:nvPr/>
         </p:nvSpPr>
@@ -17938,7 +16869,7 @@
       </p:sp>
       <p:sp>
         <p:nvSpPr>
-          <p:cNvPr id="22" name="Rounded Rectangle 21"/>
+          <p:cNvPr id="20" name="Rounded Rectangle 19"/>
           <p:cNvSpPr/>
           <p:nvPr/>
         </p:nvSpPr>
@@ -17985,7 +16916,7 @@
       </p:sp>
       <p:sp>
         <p:nvSpPr>
-          <p:cNvPr id="23" name="TextBox 22"/>
+          <p:cNvPr id="21" name="TextBox 20"/>
           <p:cNvSpPr txBox="1"/>
           <p:nvPr/>
         </p:nvSpPr>
@@ -18024,7 +16955,7 @@
       </p:sp>
       <p:sp>
         <p:nvSpPr>
-          <p:cNvPr id="24" name="TextBox 23"/>
+          <p:cNvPr id="22" name="TextBox 21"/>
           <p:cNvSpPr txBox="1"/>
           <p:nvPr/>
         </p:nvSpPr>
@@ -18063,7 +16994,7 @@
       </p:sp>
       <p:sp>
         <p:nvSpPr>
-          <p:cNvPr id="25" name="Rounded Rectangle 24"/>
+          <p:cNvPr id="23" name="Rounded Rectangle 22"/>
           <p:cNvSpPr/>
           <p:nvPr/>
         </p:nvSpPr>
@@ -18110,7 +17041,7 @@
       </p:sp>
       <p:sp>
         <p:nvSpPr>
-          <p:cNvPr id="26" name="TextBox 25"/>
+          <p:cNvPr id="24" name="TextBox 23"/>
           <p:cNvSpPr txBox="1"/>
           <p:nvPr/>
         </p:nvSpPr>
@@ -18149,7 +17080,7 @@
       </p:sp>
       <p:sp>
         <p:nvSpPr>
-          <p:cNvPr id="27" name="TextBox 26"/>
+          <p:cNvPr id="25" name="TextBox 24"/>
           <p:cNvSpPr txBox="1"/>
           <p:nvPr/>
         </p:nvSpPr>

</xml_diff>

<commit_message>
Tune MAE, MAM, MAQ, BOM, AEB and PAK findings slides
Keep Norte and Sur together in MAE hallazgos. Swap MAM and BOM charts. Start MAQ nights at 01/06 with hourly floor and on/off savings. Move BOM savings under the Hallazgos callout. Project AEB night on/off savings above daily thresholds. Replace the PAK madrugada chart with Bazar vs Kennedy and quantify an on/off on the heavier ramal.

Co-authored-by: anibaloperacionesWes <anibaloperacionesWes@users.noreply.github.com>
</commit_message>
<xml_diff>
--- a/reports/Parque_Arauco/TMP_7MALLS/entrega_diego_anibal/Recorrido_ejecutivo_PA_MAE_20260817.pptx
+++ b/reports/Parque_Arauco/TMP_7MALLS/entrega_diego_anibal/Recorrido_ejecutivo_PA_MAE_20260817.pptx
@@ -4535,7 +4535,7 @@
         <p:spPr>
           <a:xfrm>
             <a:off x="201168" y="987552"/>
-            <a:ext cx="11777472" cy="658368"/>
+            <a:ext cx="11777472" cy="1005840"/>
           </a:xfrm>
           <a:prstGeom prst="roundRect">
             <a:avLst>
@@ -4581,47 +4581,102 @@
         </p:nvSpPr>
         <p:spPr>
           <a:xfrm>
-            <a:off x="365760" y="1042415"/>
-            <a:ext cx="11475720" cy="548640"/>
-          </a:xfrm>
-          <a:prstGeom prst="rect">
-            <a:avLst/>
-          </a:prstGeom>
-          <a:noFill/>
-        </p:spPr>
-        <p:txBody>
-          <a:bodyPr wrap="square">
-            <a:spAutoFit/>
-          </a:bodyPr>
-          <a:lstStyle/>
-          <a:p>
-            <a:pPr algn="l">
-              <a:spcAft>
-                <a:spcPts val="300"/>
-              </a:spcAft>
-            </a:pPr>
-            <a:r>
-              <a:rPr sz="1400" b="0">
+            <a:off x="365760" y="1024128"/>
+            <a:ext cx="11475720" cy="182880"/>
+          </a:xfrm>
+          <a:prstGeom prst="rect">
+            <a:avLst/>
+          </a:prstGeom>
+          <a:noFill/>
+        </p:spPr>
+        <p:txBody>
+          <a:bodyPr wrap="square">
+            <a:spAutoFit/>
+          </a:bodyPr>
+          <a:lstStyle/>
+          <a:p>
+            <a:pPr algn="l">
+              <a:spcAft>
+                <a:spcPts val="300"/>
+              </a:spcAft>
+            </a:pPr>
+            <a:r>
+              <a:rPr sz="1100" b="1">
+                <a:solidFill>
+                  <a:srgbClr val="C9A227"/>
+                </a:solidFill>
+                <a:latin typeface="Calibri"/>
+              </a:rPr>
+              <a:t>HALLAZGOS</a:t>
+            </a:r>
+          </a:p>
+        </p:txBody>
+      </p:sp>
+      <p:sp>
+        <p:nvSpPr>
+          <p:cNvPr id="9" name="TextBox 8"/>
+          <p:cNvSpPr txBox="1"/>
+          <p:nvPr/>
+        </p:nvSpPr>
+        <p:spPr>
+          <a:xfrm>
+            <a:off x="365760" y="1207008"/>
+            <a:ext cx="11475720" cy="731520"/>
+          </a:xfrm>
+          <a:prstGeom prst="rect">
+            <a:avLst/>
+          </a:prstGeom>
+          <a:noFill/>
+        </p:spPr>
+        <p:txBody>
+          <a:bodyPr wrap="square">
+            <a:spAutoFit/>
+          </a:bodyPr>
+          <a:lstStyle/>
+          <a:p>
+            <a:pPr algn="l">
+              <a:spcAft>
+                <a:spcPts val="300"/>
+              </a:spcAft>
+            </a:pPr>
+            <a:r>
+              <a:rPr sz="1200" b="1">
                 <a:solidFill>
                   <a:srgbClr val="0D3B66"/>
                 </a:solidFill>
                 <a:latin typeface="Calibri"/>
               </a:rPr>
-              <a:t>Matriz A.A. se desactivó el 15/05: desde ese día el recinto se lee en Matriz 1° piso y Anillo Plaza. Anillo Plaza subió (mayo 7 → junio 15 → julio 21 m³/día; pico 58 el 09/07). Agosto 13: ¿hay un trabajo en curso?</a:t>
-            </a:r>
-          </a:p>
-        </p:txBody>
-      </p:sp>
-      <p:sp>
-        <p:nvSpPr>
-          <p:cNvPr id="9" name="Rounded Rectangle 8"/>
+              <a:t>On/off 00–06: Anillo Plaza 4,3 m³/noche = $5.980/noche · $179.388/mes. Matriz 1° piso 6,8 m³/noche = $9.467/noche · $284.020/mes. Los dos: 11 m³/noche = 331 m³/mes = $463.408/mes (tarifa $1.400/m³).</a:t>
+            </a:r>
+          </a:p>
+          <a:p>
+            <a:pPr algn="l">
+              <a:spcAft>
+                <a:spcPts val="300"/>
+              </a:spcAft>
+            </a:pPr>
+            <a:r>
+              <a:rPr sz="1200" b="0">
+                <a:solidFill>
+                  <a:srgbClr val="0D3B66"/>
+                </a:solidFill>
+                <a:latin typeface="Calibri"/>
+              </a:rPr>
+              <a:t>Umbrales a activar (total del día): Anillo Plaza 22 m³/día (julio 21; el 09/07 llegó a 58). Matriz 1° piso 75 m³/día (agosto ~58 × 1,25).</a:t>
+            </a:r>
+          </a:p>
+        </p:txBody>
+      </p:sp>
+      <p:sp>
+        <p:nvSpPr>
+          <p:cNvPr id="10" name="Rounded Rectangle 9"/>
           <p:cNvSpPr/>
           <p:nvPr/>
         </p:nvSpPr>
         <p:spPr>
           <a:xfrm>
-            <a:off x="201168" y="1737360"/>
-            <a:ext cx="5833872" cy="3803904"/>
+            <a:off x="201168" y="2084831"/>
+            <a:ext cx="5833872" cy="3456432"/>
           </a:xfrm>
           <a:prstGeom prst="roundRect">
             <a:avLst>
@@ -4659,13 +4714,13 @@
       </p:sp>
       <p:sp>
         <p:nvSpPr>
-          <p:cNvPr id="10" name="TextBox 9"/>
-          <p:cNvSpPr txBox="1"/>
-          <p:nvPr/>
-        </p:nvSpPr>
-        <p:spPr>
-          <a:xfrm>
-            <a:off x="329184" y="1773936"/>
+          <p:cNvPr id="11" name="TextBox 10"/>
+          <p:cNvSpPr txBox="1"/>
+          <p:nvPr/>
+        </p:nvSpPr>
+        <p:spPr>
+          <a:xfrm>
+            <a:off x="329184" y="2121408"/>
             <a:ext cx="5577840" cy="201168"/>
           </a:xfrm>
           <a:prstGeom prst="rect">
@@ -4698,7 +4753,7 @@
       </p:sp>
       <p:pic>
         <p:nvPicPr>
-          <p:cNvPr id="11" name="Picture 10" descr="aeb_anillo_dia_noche.png"/>
+          <p:cNvPr id="12" name="Picture 11" descr="aeb_anillo_dia_noche.png"/>
           <p:cNvPicPr>
             <a:picLocks noChangeAspect="1"/>
           </p:cNvPicPr>
@@ -4712,7 +4767,7 @@
         </p:blipFill>
         <p:spPr>
           <a:xfrm>
-            <a:off x="292608" y="2462304"/>
+            <a:off x="292608" y="2636040"/>
             <a:ext cx="5650992" cy="2518606"/>
           </a:xfrm>
           <a:prstGeom prst="rect">
@@ -4722,14 +4777,14 @@
       </p:pic>
       <p:sp>
         <p:nvSpPr>
-          <p:cNvPr id="12" name="Rounded Rectangle 11"/>
+          <p:cNvPr id="13" name="Rounded Rectangle 12"/>
           <p:cNvSpPr/>
           <p:nvPr/>
         </p:nvSpPr>
         <p:spPr>
           <a:xfrm>
-            <a:off x="6163056" y="1737360"/>
-            <a:ext cx="5815584" cy="3803904"/>
+            <a:off x="6163056" y="2084831"/>
+            <a:ext cx="5815584" cy="3456432"/>
           </a:xfrm>
           <a:prstGeom prst="roundRect">
             <a:avLst>
@@ -4767,13 +4822,13 @@
       </p:sp>
       <p:sp>
         <p:nvSpPr>
-          <p:cNvPr id="13" name="TextBox 12"/>
-          <p:cNvSpPr txBox="1"/>
-          <p:nvPr/>
-        </p:nvSpPr>
-        <p:spPr>
-          <a:xfrm>
-            <a:off x="6291072" y="1773936"/>
+          <p:cNvPr id="14" name="TextBox 13"/>
+          <p:cNvSpPr txBox="1"/>
+          <p:nvPr/>
+        </p:nvSpPr>
+        <p:spPr>
+          <a:xfrm>
+            <a:off x="6291072" y="2121408"/>
             <a:ext cx="5559552" cy="201168"/>
           </a:xfrm>
           <a:prstGeom prst="rect">
@@ -4806,7 +4861,7 @@
       </p:sp>
       <p:pic>
         <p:nvPicPr>
-          <p:cNvPr id="14" name="Picture 13" descr="aeb_matriz_dia_noche.png"/>
+          <p:cNvPr id="15" name="Picture 14" descr="aeb_matriz_dia_noche.png"/>
           <p:cNvPicPr>
             <a:picLocks noChangeAspect="1"/>
           </p:cNvPicPr>
@@ -4820,7 +4875,7 @@
         </p:blipFill>
         <p:spPr>
           <a:xfrm>
-            <a:off x="6254496" y="2466379"/>
+            <a:off x="6254496" y="2640115"/>
             <a:ext cx="5632704" cy="2510456"/>
           </a:xfrm>
           <a:prstGeom prst="rect">
@@ -4830,7 +4885,7 @@
       </p:pic>
       <p:sp>
         <p:nvSpPr>
-          <p:cNvPr id="15" name="Rounded Rectangle 14"/>
+          <p:cNvPr id="16" name="Rounded Rectangle 15"/>
           <p:cNvSpPr/>
           <p:nvPr/>
         </p:nvSpPr>
@@ -4877,7 +4932,7 @@
       </p:sp>
       <p:sp>
         <p:nvSpPr>
-          <p:cNvPr id="16" name="TextBox 15"/>
+          <p:cNvPr id="17" name="TextBox 16"/>
           <p:cNvSpPr txBox="1"/>
           <p:nvPr/>
         </p:nvSpPr>
@@ -4909,23 +4964,7 @@
                 </a:solidFill>
                 <a:latin typeface="Calibri"/>
               </a:rPr>
-              <a:t>Pregunta para el recinto: el alza de Anillo Plaza (mayo 7 → julio 21 m³/día) ¿se está trabajando? Agosto baja a 13 m³/día, pero sigue sobre mayo.</a:t>
-            </a:r>
-          </a:p>
-          <a:p>
-            <a:pPr algn="l">
-              <a:spcAft>
-                <a:spcPts val="300"/>
-              </a:spcAft>
-            </a:pPr>
-            <a:r>
-              <a:rPr sz="1300" b="1">
-                <a:solidFill>
-                  <a:srgbClr val="0D3B66"/>
-                </a:solidFill>
-                <a:latin typeface="Calibri"/>
-              </a:rPr>
-              <a:t>Umbrales a activar (total del día): Anillo Plaza 22 m³/día (julio 21; el 09/07 llegó a 58). Matriz 1° piso 75 m³/día (agosto ~58 × 1,25).</a:t>
+              <a:t>Matriz A.A. se desactivó el 15/05: desde ese día el recinto se lee en Matriz 1° piso y Anillo Plaza. Anillo Plaza subió (mayo 7 → junio 15 → julio 21 m³/día; pico 58 el 09/07). Agosto 13: ¿hay un trabajo en curso?</a:t>
             </a:r>
           </a:p>
         </p:txBody>
@@ -10000,7 +10039,7 @@
                 </a:solidFill>
                 <a:latin typeface="Calibri"/>
               </a:rPr>
-              <a:t>Julio · m³ de madrugada (00:00–06:00)</a:t>
+              <a:t>NOCHE 00–06  ·  Bazar Gourmet y DL Kennedy</a:t>
             </a:r>
           </a:p>
         </p:txBody>
@@ -10110,7 +10149,7 @@
                 </a:solidFill>
                 <a:latin typeface="Calibri"/>
               </a:rPr>
-              <a:t>10/08 00–06: Distrito de Lujo 41,2 m³  ·  Bazar 28,2 + DL Kennedy 0,9 = 29,1 m³. Quedan 12,1 m³ en el tronco que no aparecen en esos dos ramales. En julio esa diferencia de madrugada es estable (mediana 13,1 m³/noche; Bazar + Kennedy cubren 71 % del tronco).</a:t>
+              <a:t>Noche típica 00–06: Bazar Gourmet 28,9 m³  ·  DL Kennedy 1,2 m³. El que más gasta de madrugada es Bazar Gourmet.</a:t>
             </a:r>
           </a:p>
           <a:p>
@@ -10126,7 +10165,7 @@
                 </a:solidFill>
                 <a:latin typeface="Calibri"/>
               </a:rPr>
-              <a:t>No asignamos ese hueco a un destino: no está en Bazar ni en DL Kennedy. Propuesta: control nocturno en Distrito de Lujo (tronco). Cortar el tronco corta Bazar, DL Kennedy y también ese caudal no ramaleado.</a:t>
+              <a:t>Propuesta: on/off 00–06 en Bazar Gourmet. 28,9 m³/noche = $40.460/noche  ·  867 m³/mes = $1.213.800/mes (tarifa $1.400/m³). DL Kennedy queda en 1,2 m³/noche.</a:t>
             </a:r>
           </a:p>
         </p:txBody>
@@ -11809,7 +11848,7 @@
         <p:spPr>
           <a:xfrm>
             <a:off x="201168" y="987552"/>
-            <a:ext cx="11777472" cy="1170432"/>
+            <a:ext cx="11777472" cy="1389888"/>
           </a:xfrm>
           <a:prstGeom prst="roundRect">
             <a:avLst>
@@ -11855,8 +11894,8 @@
         </p:nvSpPr>
         <p:spPr>
           <a:xfrm>
-            <a:off x="365760" y="1042415"/>
-            <a:ext cx="11475720" cy="237744"/>
+            <a:off x="365760" y="1024128"/>
+            <a:ext cx="11475720" cy="201168"/>
           </a:xfrm>
           <a:prstGeom prst="rect">
             <a:avLst/>
@@ -11881,7 +11920,7 @@
                 </a:solidFill>
                 <a:latin typeface="Calibri"/>
               </a:rPr>
-              <a:t>ESTANQUE NORTE  ·  CONTROL 05/08</a:t>
+              <a:t>HALLAZGOS</a:t>
             </a:r>
           </a:p>
         </p:txBody>
@@ -11894,33 +11933,49 @@
         </p:nvSpPr>
         <p:spPr>
           <a:xfrm>
-            <a:off x="365760" y="1280160"/>
-            <a:ext cx="11475720" cy="804672"/>
-          </a:xfrm>
-          <a:prstGeom prst="rect">
-            <a:avLst/>
-          </a:prstGeom>
-          <a:noFill/>
-        </p:spPr>
-        <p:txBody>
-          <a:bodyPr wrap="square">
-            <a:spAutoFit/>
-          </a:bodyPr>
-          <a:lstStyle/>
-          <a:p>
-            <a:pPr algn="l">
-              <a:spcAft>
-                <a:spcPts val="300"/>
-              </a:spcAft>
-            </a:pPr>
-            <a:r>
-              <a:rPr sz="1300" b="1">
+            <a:off x="365760" y="1225296"/>
+            <a:ext cx="11475720" cy="1097280"/>
+          </a:xfrm>
+          <a:prstGeom prst="rect">
+            <a:avLst/>
+          </a:prstGeom>
+          <a:noFill/>
+        </p:spPr>
+        <p:txBody>
+          <a:bodyPr wrap="square">
+            <a:spAutoFit/>
+          </a:bodyPr>
+          <a:lstStyle/>
+          <a:p>
+            <a:pPr algn="l">
+              <a:spcAft>
+                <a:spcPts val="300"/>
+              </a:spcAft>
+            </a:pPr>
+            <a:r>
+              <a:rPr sz="1200" b="1">
                 <a:solidFill>
                   <a:srgbClr val="0D3B66"/>
                 </a:solidFill>
                 <a:latin typeface="Calibri"/>
               </a:rPr>
               <a:t>Estanque Norte (control 05/08, 00:00–05:00): noche típica 4,8 → 1,1 m³, ahorro 3,7 m³. × 5 h de control × 30 días = 555 m³/mes = $777.000/mes (tarifa $1.400/m³). Es el que más ahorra de los controles MAE.</a:t>
+            </a:r>
+          </a:p>
+          <a:p>
+            <a:pPr algn="l">
+              <a:spcAft>
+                <a:spcPts val="300"/>
+              </a:spcAft>
+            </a:pPr>
+            <a:r>
+              <a:rPr sz="1200" b="0">
+                <a:solidFill>
+                  <a:srgbClr val="0D3B66"/>
+                </a:solidFill>
+                <a:latin typeface="Calibri"/>
+              </a:rPr>
+              <a:t>Estanque Sur: el 10/06 se repararon los presostatos. Venía en 89 m³/día (mayo–9/jun) y ese día ya marca 39 m³. Desde el 11/06 se sostiene en 28 m³/día (−61 m³/día, 68%). A $1.400/m³: $84.897/día  ·  $2.546.923/mes  ·  acumulado 11/06–17/08: $5.688.128 (4.063 m³ en 67 días).</a:t>
             </a:r>
           </a:p>
         </p:txBody>
@@ -11933,8 +11988,8 @@
         </p:nvSpPr>
         <p:spPr>
           <a:xfrm>
-            <a:off x="201168" y="2249424"/>
-            <a:ext cx="5285232" cy="3456432"/>
+            <a:off x="201168" y="2468880"/>
+            <a:ext cx="5285232" cy="3127248"/>
           </a:xfrm>
           <a:prstGeom prst="roundRect">
             <a:avLst>
@@ -11978,8 +12033,8 @@
         </p:nvSpPr>
         <p:spPr>
           <a:xfrm>
-            <a:off x="329184" y="2304288"/>
-            <a:ext cx="5029200" cy="237744"/>
+            <a:off x="329184" y="2505456"/>
+            <a:ext cx="5029200" cy="201168"/>
           </a:xfrm>
           <a:prstGeom prst="rect">
             <a:avLst/>
@@ -12025,8 +12080,8 @@
         </p:blipFill>
         <p:spPr>
           <a:xfrm>
-            <a:off x="329184" y="2560320"/>
-            <a:ext cx="5010912" cy="2926080"/>
+            <a:off x="329184" y="2724912"/>
+            <a:ext cx="5010912" cy="2761488"/>
           </a:xfrm>
           <a:prstGeom prst="rect">
             <a:avLst/>
@@ -12041,8 +12096,8 @@
         </p:nvSpPr>
         <p:spPr>
           <a:xfrm>
-            <a:off x="5614416" y="2249424"/>
-            <a:ext cx="6364224" cy="3456432"/>
+            <a:off x="5614416" y="2468880"/>
+            <a:ext cx="6364224" cy="3127248"/>
           </a:xfrm>
           <a:prstGeom prst="roundRect">
             <a:avLst>
@@ -12086,8 +12141,8 @@
         </p:nvSpPr>
         <p:spPr>
           <a:xfrm>
-            <a:off x="5742432" y="2304288"/>
-            <a:ext cx="6108192" cy="237744"/>
+            <a:off x="5742432" y="2505456"/>
+            <a:ext cx="6108192" cy="201168"/>
           </a:xfrm>
           <a:prstGeom prst="rect">
             <a:avLst/>
@@ -12133,8 +12188,8 @@
         </p:blipFill>
         <p:spPr>
           <a:xfrm>
-            <a:off x="5742432" y="2560320"/>
-            <a:ext cx="6108192" cy="2926080"/>
+            <a:off x="5742432" y="2724912"/>
+            <a:ext cx="6108192" cy="2761488"/>
           </a:xfrm>
           <a:prstGeom prst="rect">
             <a:avLst/>
@@ -12149,8 +12204,8 @@
         </p:nvSpPr>
         <p:spPr>
           <a:xfrm>
-            <a:off x="256032" y="5742432"/>
-            <a:ext cx="11704320" cy="1024128"/>
+            <a:off x="256032" y="5687568"/>
+            <a:ext cx="11704320" cy="1005840"/>
           </a:xfrm>
           <a:prstGeom prst="rect">
             <a:avLst/>
@@ -12175,7 +12230,7 @@
                 </a:solidFill>
                 <a:latin typeface="Calibri"/>
               </a:rPr>
-              <a:t>Pizza Hut (control 01/07): noche típica 0,1 → 0 m³. Estanque Sur: presostatos 10/06 (−61 m³/día, $2.546.923/mes) y corte on/off de mantención nocturna.</a:t>
+              <a:t>Pizza Hut (control 01/07): noche típica 0,1 → 0 m³.</a:t>
             </a:r>
           </a:p>
           <a:p>
@@ -14280,14 +14335,14 @@
                 </a:solidFill>
                 <a:latin typeface="Calibri"/>
               </a:rPr>
-              <a:t>NOCHE 00–06  ·  mall cerrado</a:t>
+              <a:t>DESDE EL 15/08 EL MALL SALE POR FALABELLA</a:t>
             </a:r>
           </a:p>
         </p:txBody>
       </p:sp>
       <p:pic>
         <p:nvPicPr>
-          <p:cNvPr id="11" name="Picture 10" descr="mam_placa_noches_jul_ago.png"/>
+          <p:cNvPr id="11" name="Picture 10" descr="mam_placa_vs_falabella.png"/>
           <p:cNvPicPr>
             <a:picLocks noChangeAspect="1"/>
           </p:cNvPicPr>
@@ -14388,14 +14443,14 @@
                 </a:solidFill>
                 <a:latin typeface="Calibri"/>
               </a:rPr>
-              <a:t>DESDE EL 15/08 EL MALL SALE POR FALABELLA</a:t>
+              <a:t>NOCHE 00–06  ·  mall cerrado</a:t>
             </a:r>
           </a:p>
         </p:txBody>
       </p:sp>
       <p:pic>
         <p:nvPicPr>
-          <p:cNvPr id="14" name="Picture 13" descr="mam_placa_vs_falabella.png"/>
+          <p:cNvPr id="14" name="Picture 13" descr="mam_placa_noches_jul_ago.png"/>
           <p:cNvPicPr>
             <a:picLocks noChangeAspect="1"/>
           </p:cNvPicPr>
@@ -16000,14 +16055,14 @@
                 </a:solidFill>
                 <a:latin typeface="Calibri"/>
               </a:rPr>
-              <a:t>NOCHE 00–06  ·  mall cerrado</a:t>
+              <a:t>NOCHE 00–06  ·  desde el 01/06</a:t>
             </a:r>
           </a:p>
         </p:txBody>
       </p:sp>
       <p:pic>
         <p:nvPicPr>
-          <p:cNvPr id="14" name="Picture 13" descr="maq_matriz_noches_jul_ago.png"/>
+          <p:cNvPr id="14" name="Picture 13" descr="maq_matriz_noches_jun_ago.png"/>
           <p:cNvPicPr>
             <a:picLocks noChangeAspect="1"/>
           </p:cNvPicPr>
@@ -16021,8 +16076,8 @@
         </p:blipFill>
         <p:spPr>
           <a:xfrm>
-            <a:off x="6254496" y="2466379"/>
-            <a:ext cx="5632704" cy="2510456"/>
+            <a:off x="6254496" y="2458468"/>
+            <a:ext cx="5632704" cy="2526278"/>
           </a:xfrm>
           <a:prstGeom prst="rect">
             <a:avLst/>
@@ -16104,29 +16159,29 @@
               </a:spcAft>
             </a:pPr>
             <a:r>
-              <a:rPr sz="1400" b="0">
+              <a:rPr sz="1300" b="0">
                 <a:solidFill>
                   <a:srgbClr val="0D3B66"/>
                 </a:solidFill>
                 <a:latin typeface="Calibri"/>
               </a:rPr>
-              <a:t>Umbrales: diario 240 m³/día (julio ~193). Noche 15 m³: el mall está cerrado y hoy la madrugada anda en 22 m³.</a:t>
-            </a:r>
-          </a:p>
-          <a:p>
-            <a:pPr algn="l">
-              <a:spcAft>
-                <a:spcPts val="300"/>
-              </a:spcAft>
-            </a:pPr>
-            <a:r>
-              <a:rPr sz="1400" b="1">
+              <a:t>Umbrales: diario 240 m³/día (julio ~193). Noche 15 m³. Desde el 22/06 la madrugada anda en 21,9 m³ (antes 11,2). Mínimo típico por hora 00–06: 3 m³/h.</a:t>
+            </a:r>
+          </a:p>
+          <a:p>
+            <a:pPr algn="l">
+              <a:spcAft>
+                <a:spcPts val="300"/>
+              </a:spcAft>
+            </a:pPr>
+            <a:r>
+              <a:rPr sz="1300" b="1">
                 <a:solidFill>
                   <a:srgbClr val="0D3B66"/>
                 </a:solidFill>
                 <a:latin typeface="Calibri"/>
               </a:rPr>
-              <a:t>Buena medida: poner un control on/off de madrugada en Matriz. La gráfica de la derecha lo muestra: ~22 m³/noche, unos 659 m³/mes si se corta el caudal inhábil.</a:t>
+              <a:t>On/off 00–06 en Matriz: 21,9 m³/noche = $30.688/noche  ·  658 m³/mes = $920.640/mes (tarifa $1.400/m³).</a:t>
             </a:r>
           </a:p>
         </p:txBody>
@@ -17348,7 +17403,7 @@
         <p:spPr>
           <a:xfrm>
             <a:off x="201168" y="987552"/>
-            <a:ext cx="11777472" cy="658368"/>
+            <a:ext cx="11777472" cy="1170432"/>
           </a:xfrm>
           <a:prstGeom prst="roundRect">
             <a:avLst>
@@ -17394,27 +17449,66 @@
         </p:nvSpPr>
         <p:spPr>
           <a:xfrm>
-            <a:off x="365760" y="1042415"/>
-            <a:ext cx="11475720" cy="548640"/>
-          </a:xfrm>
-          <a:prstGeom prst="rect">
-            <a:avLst/>
-          </a:prstGeom>
-          <a:noFill/>
-        </p:spPr>
-        <p:txBody>
-          <a:bodyPr wrap="square">
-            <a:spAutoFit/>
-          </a:bodyPr>
-          <a:lstStyle/>
-          <a:p>
-            <a:pPr algn="l">
-              <a:spcAft>
-                <a:spcPts val="300"/>
-              </a:spcAft>
-            </a:pPr>
-            <a:r>
-              <a:rPr sz="1400" b="0">
+            <a:off x="365760" y="1024128"/>
+            <a:ext cx="11475720" cy="182880"/>
+          </a:xfrm>
+          <a:prstGeom prst="rect">
+            <a:avLst/>
+          </a:prstGeom>
+          <a:noFill/>
+        </p:spPr>
+        <p:txBody>
+          <a:bodyPr wrap="square">
+            <a:spAutoFit/>
+          </a:bodyPr>
+          <a:lstStyle/>
+          <a:p>
+            <a:pPr algn="l">
+              <a:spcAft>
+                <a:spcPts val="300"/>
+              </a:spcAft>
+            </a:pPr>
+            <a:r>
+              <a:rPr sz="1100" b="1">
+                <a:solidFill>
+                  <a:srgbClr val="C9A227"/>
+                </a:solidFill>
+                <a:latin typeface="Calibri"/>
+              </a:rPr>
+              <a:t>HALLAZGOS</a:t>
+            </a:r>
+          </a:p>
+        </p:txBody>
+      </p:sp>
+      <p:sp>
+        <p:nvSpPr>
+          <p:cNvPr id="9" name="TextBox 8"/>
+          <p:cNvSpPr txBox="1"/>
+          <p:nvPr/>
+        </p:nvSpPr>
+        <p:spPr>
+          <a:xfrm>
+            <a:off x="365760" y="1207008"/>
+            <a:ext cx="11475720" cy="896112"/>
+          </a:xfrm>
+          <a:prstGeom prst="rect">
+            <a:avLst/>
+          </a:prstGeom>
+          <a:noFill/>
+        </p:spPr>
+        <p:txBody>
+          <a:bodyPr wrap="square">
+            <a:spAutoFit/>
+          </a:bodyPr>
+          <a:lstStyle/>
+          <a:p>
+            <a:pPr algn="l">
+              <a:spcAft>
+                <a:spcPts val="300"/>
+              </a:spcAft>
+            </a:pPr>
+            <a:r>
+              <a:rPr sz="1300" b="0">
                 <a:solidFill>
                   <a:srgbClr val="0D3B66"/>
                 </a:solidFill>
@@ -17423,18 +17517,34 @@
               <a:t>San Ignacio 500 se lleva 79 % de julio. Control on/off operativo desde el 17/07: la madrugada pasó de 32 a 2 m³ (el 15/07 eran 36 m³) y se sostiene hasta hoy.</a:t>
             </a:r>
           </a:p>
-        </p:txBody>
-      </p:sp>
-      <p:sp>
-        <p:nvSpPr>
-          <p:cNvPr id="9" name="Rounded Rectangle 8"/>
+          <a:p>
+            <a:pPr algn="l">
+              <a:spcAft>
+                <a:spcPts val="300"/>
+              </a:spcAft>
+            </a:pPr>
+            <a:r>
+              <a:rPr sz="1300" b="1">
+                <a:solidFill>
+                  <a:srgbClr val="0D3B66"/>
+                </a:solidFill>
+                <a:latin typeface="Calibri"/>
+              </a:rPr>
+              <a:t>Ahorro del corte 00–06: 29,7 m³/noche = $41.566/noche  ·  $1.246.980/mes. Acumulado 17/07–17/08 (32 noches): 950 m³ = $1.330.112 (tarifa $1.400/m³).</a:t>
+            </a:r>
+          </a:p>
+        </p:txBody>
+      </p:sp>
+      <p:sp>
+        <p:nvSpPr>
+          <p:cNvPr id="10" name="Rounded Rectangle 9"/>
           <p:cNvSpPr/>
           <p:nvPr/>
         </p:nvSpPr>
         <p:spPr>
           <a:xfrm>
-            <a:off x="201168" y="1737360"/>
-            <a:ext cx="5833872" cy="3803904"/>
+            <a:off x="201168" y="2249424"/>
+            <a:ext cx="5833872" cy="3291840"/>
           </a:xfrm>
           <a:prstGeom prst="roundRect">
             <a:avLst>
@@ -17472,13 +17582,13 @@
       </p:sp>
       <p:sp>
         <p:nvSpPr>
-          <p:cNvPr id="10" name="TextBox 9"/>
-          <p:cNvSpPr txBox="1"/>
-          <p:nvPr/>
-        </p:nvSpPr>
-        <p:spPr>
-          <a:xfrm>
-            <a:off x="329184" y="1773936"/>
+          <p:cNvPr id="11" name="TextBox 10"/>
+          <p:cNvSpPr txBox="1"/>
+          <p:nvPr/>
+        </p:nvSpPr>
+        <p:spPr>
+          <a:xfrm>
+            <a:off x="329184" y="2286000"/>
             <a:ext cx="5577840" cy="201168"/>
           </a:xfrm>
           <a:prstGeom prst="rect">
@@ -17504,14 +17614,14 @@
                 </a:solidFill>
                 <a:latin typeface="Calibri"/>
               </a:rPr>
-              <a:t>NOCHE 00–06  ·  el corte se ve y se sostiene</a:t>
+              <a:t>AHORRO  ·  noche típica antes vs con control</a:t>
             </a:r>
           </a:p>
         </p:txBody>
       </p:sp>
       <p:pic>
         <p:nvPicPr>
-          <p:cNvPr id="11" name="Picture 10" descr="bom_si500_noches_jul_ago.png"/>
+          <p:cNvPr id="12" name="Picture 11" descr="bom_si500_ahorro.png"/>
           <p:cNvPicPr>
             <a:picLocks noChangeAspect="1"/>
           </p:cNvPicPr>
@@ -17525,8 +17635,8 @@
         </p:blipFill>
         <p:spPr>
           <a:xfrm>
-            <a:off x="292608" y="2462304"/>
-            <a:ext cx="5650992" cy="2518606"/>
+            <a:off x="292608" y="2719514"/>
+            <a:ext cx="5650992" cy="2516250"/>
           </a:xfrm>
           <a:prstGeom prst="rect">
             <a:avLst/>
@@ -17535,14 +17645,14 @@
       </p:pic>
       <p:sp>
         <p:nvSpPr>
-          <p:cNvPr id="12" name="Rounded Rectangle 11"/>
+          <p:cNvPr id="13" name="Rounded Rectangle 12"/>
           <p:cNvSpPr/>
           <p:nvPr/>
         </p:nvSpPr>
         <p:spPr>
           <a:xfrm>
-            <a:off x="6163056" y="1737360"/>
-            <a:ext cx="5815584" cy="3803904"/>
+            <a:off x="6163056" y="2249424"/>
+            <a:ext cx="5815584" cy="3291840"/>
           </a:xfrm>
           <a:prstGeom prst="roundRect">
             <a:avLst>
@@ -17580,13 +17690,13 @@
       </p:sp>
       <p:sp>
         <p:nvSpPr>
-          <p:cNvPr id="13" name="TextBox 12"/>
-          <p:cNvSpPr txBox="1"/>
-          <p:nvPr/>
-        </p:nvSpPr>
-        <p:spPr>
-          <a:xfrm>
-            <a:off x="6291072" y="1773936"/>
+          <p:cNvPr id="14" name="TextBox 13"/>
+          <p:cNvSpPr txBox="1"/>
+          <p:nvPr/>
+        </p:nvSpPr>
+        <p:spPr>
+          <a:xfrm>
+            <a:off x="6291072" y="2286000"/>
             <a:ext cx="5559552" cy="201168"/>
           </a:xfrm>
           <a:prstGeom prst="rect">
@@ -17612,14 +17722,14 @@
                 </a:solidFill>
                 <a:latin typeface="Calibri"/>
               </a:rPr>
-              <a:t>AHORRO  ·  noche típica antes vs con control</a:t>
+              <a:t>NOCHE 00–06  ·  el corte se ve y se sostiene</a:t>
             </a:r>
           </a:p>
         </p:txBody>
       </p:sp>
       <p:pic>
         <p:nvPicPr>
-          <p:cNvPr id="14" name="Picture 13" descr="bom_si500_ahorro.png"/>
+          <p:cNvPr id="15" name="Picture 14" descr="bom_si500_noches_jul_ago.png"/>
           <p:cNvPicPr>
             <a:picLocks noChangeAspect="1"/>
           </p:cNvPicPr>
@@ -17633,8 +17743,8 @@
         </p:blipFill>
         <p:spPr>
           <a:xfrm>
-            <a:off x="6254496" y="2467554"/>
-            <a:ext cx="5632704" cy="2508107"/>
+            <a:off x="6254496" y="2722411"/>
+            <a:ext cx="5632704" cy="2510456"/>
           </a:xfrm>
           <a:prstGeom prst="rect">
             <a:avLst/>
@@ -17643,7 +17753,7 @@
       </p:pic>
       <p:sp>
         <p:nvSpPr>
-          <p:cNvPr id="15" name="Rounded Rectangle 14"/>
+          <p:cNvPr id="16" name="Rounded Rectangle 15"/>
           <p:cNvSpPr/>
           <p:nvPr/>
         </p:nvSpPr>
@@ -17690,7 +17800,7 @@
       </p:sp>
       <p:sp>
         <p:nvSpPr>
-          <p:cNvPr id="16" name="TextBox 15"/>
+          <p:cNvPr id="17" name="TextBox 16"/>
           <p:cNvSpPr txBox="1"/>
           <p:nvPr/>
         </p:nvSpPr>
@@ -17723,22 +17833,6 @@
                 <a:latin typeface="Calibri"/>
               </a:rPr>
               <a:t>Desde el 17/07 no hay noche alta: residual típico 2 m³ (máximo 4,4). No se lee como fuga. Umbrales a activar: San Ignacio 500 diario 145 m³/día (agosto ~115) y noche 8 m³ (avisa si el corte se cae). San Ignacio 300: alerta de umbral noche 4 m³.</a:t>
-            </a:r>
-          </a:p>
-          <a:p>
-            <a:pPr algn="l">
-              <a:spcAft>
-                <a:spcPts val="300"/>
-              </a:spcAft>
-            </a:pPr>
-            <a:r>
-              <a:rPr sz="1300" b="1">
-                <a:solidFill>
-                  <a:srgbClr val="0D3B66"/>
-                </a:solidFill>
-                <a:latin typeface="Calibri"/>
-              </a:rPr>
-              <a:t>Ahorro del corte 00–06: 29,7 m³/noche = $41.566/noche  ·  $1.246.980/mes. Acumulado 17/07–17/08 (32 noches): 950 m³ = $1.330.112 (tarifa $1.400/m³).</a:t>
             </a:r>
           </a:p>
         </p:txBody>

</xml_diff>

<commit_message>
Restore the cover and offer only 24-hour daily thresholds
Keep the original portada (fondo, recintos MAE–PAK). Title every findings callout HALLAZGOS in gold. Put daily umbrales in the upper box without dropping current findings, move the PAK on/off proposal up, and drop night thresholds from BOM and the other malls.

Co-authored-by: anibaloperacionesWes <anibaloperacionesWes@users.noreply.github.com>
</commit_message>
<xml_diff>
--- a/reports/Parque_Arauco/TMP_7MALLS/entrega_diego_anibal/Recorrido_ejecutivo_PA_MAE_20260817.pptx
+++ b/reports/Parque_Arauco/TMP_7MALLS/entrega_diego_anibal/Recorrido_ejecutivo_PA_MAE_20260817.pptx
@@ -3307,17 +3307,41 @@
               </a:spcAft>
             </a:pPr>
             <a:r>
-              <a:rPr sz="1400" b="0">
+              <a:rPr sz="1600" b="0">
                 <a:solidFill>
                   <a:srgbClr val="C9A227"/>
                 </a:solidFill>
                 <a:latin typeface="Calibri"/>
               </a:rPr>
-              <a:t>Lámina 2: MAE  ·  MAM Placa  ·  MAQ Matriz  ·  BOM SI500  ·  AEB Anillo  ·  CUR  ·  PAK cadena</a:t>
-            </a:r>
-          </a:p>
-        </p:txBody>
-      </p:sp>
+              <a:t>MAE  ·  MAM  ·  MAQ  ·  BOM  ·  AEB  ·  CUR  ·  PAK</a:t>
+            </a:r>
+          </a:p>
+        </p:txBody>
+      </p:sp>
+      <p:pic>
+        <p:nvPicPr>
+          <p:cNvPr id="7" name="Picture 6" descr="logo wes.bmp"/>
+          <p:cNvPicPr>
+            <a:picLocks noChangeAspect="1"/>
+          </p:cNvPicPr>
+          <p:nvPr/>
+        </p:nvPicPr>
+        <p:blipFill>
+          <a:blip r:embed="rId3"/>
+          <a:stretch>
+            <a:fillRect/>
+          </a:stretch>
+        </p:blipFill>
+        <p:spPr>
+          <a:xfrm>
+            <a:off x="10698480" y="6263640"/>
+            <a:ext cx="1234440" cy="273673"/>
+          </a:xfrm>
+          <a:prstGeom prst="rect">
+            <a:avLst/>
+          </a:prstGeom>
+        </p:spPr>
+      </p:pic>
     </p:spTree>
   </p:cSld>
   <p:clrMapOvr>
@@ -4621,7 +4645,7 @@
         <p:spPr>
           <a:xfrm>
             <a:off x="365760" y="1207008"/>
-            <a:ext cx="11475720" cy="731520"/>
+            <a:ext cx="11475720" cy="749808"/>
           </a:xfrm>
           <a:prstGeom prst="rect">
             <a:avLst/>
@@ -4662,7 +4686,7 @@
                 </a:solidFill>
                 <a:latin typeface="Calibri"/>
               </a:rPr>
-              <a:t>Umbrales a activar (total del día): Anillo Plaza 22 m³/día (julio 21; el 09/07 llegó a 58). Matriz 1° piso 75 m³/día (agosto ~58 × 1,25).</a:t>
+              <a:t>Umbrales a activar (total 24 h): Anillo Plaza 22 m³/día (julio 21; el 09/07 llegó a 58). Matriz 1° piso 75 m³/día (agosto ~58 × 1,25).</a:t>
             </a:r>
           </a:p>
         </p:txBody>
@@ -6147,7 +6171,7 @@
         <p:spPr>
           <a:xfrm>
             <a:off x="201168" y="987552"/>
-            <a:ext cx="11777472" cy="658368"/>
+            <a:ext cx="11777472" cy="1005840"/>
           </a:xfrm>
           <a:prstGeom prst="roundRect">
             <a:avLst>
@@ -6193,27 +6217,66 @@
         </p:nvSpPr>
         <p:spPr>
           <a:xfrm>
-            <a:off x="365760" y="1042415"/>
-            <a:ext cx="11475720" cy="548640"/>
-          </a:xfrm>
-          <a:prstGeom prst="rect">
-            <a:avLst/>
-          </a:prstGeom>
-          <a:noFill/>
-        </p:spPr>
-        <p:txBody>
-          <a:bodyPr wrap="square">
-            <a:spAutoFit/>
-          </a:bodyPr>
-          <a:lstStyle/>
-          <a:p>
-            <a:pPr algn="l">
-              <a:spcAft>
-                <a:spcPts val="300"/>
-              </a:spcAft>
-            </a:pPr>
-            <a:r>
-              <a:rPr sz="1400" b="0">
+            <a:off x="365760" y="1024128"/>
+            <a:ext cx="11475720" cy="182880"/>
+          </a:xfrm>
+          <a:prstGeom prst="rect">
+            <a:avLst/>
+          </a:prstGeom>
+          <a:noFill/>
+        </p:spPr>
+        <p:txBody>
+          <a:bodyPr wrap="square">
+            <a:spAutoFit/>
+          </a:bodyPr>
+          <a:lstStyle/>
+          <a:p>
+            <a:pPr algn="l">
+              <a:spcAft>
+                <a:spcPts val="300"/>
+              </a:spcAft>
+            </a:pPr>
+            <a:r>
+              <a:rPr sz="1100" b="1">
+                <a:solidFill>
+                  <a:srgbClr val="C9A227"/>
+                </a:solidFill>
+                <a:latin typeface="Calibri"/>
+              </a:rPr>
+              <a:t>HALLAZGOS</a:t>
+            </a:r>
+          </a:p>
+        </p:txBody>
+      </p:sp>
+      <p:sp>
+        <p:nvSpPr>
+          <p:cNvPr id="9" name="TextBox 8"/>
+          <p:cNvSpPr txBox="1"/>
+          <p:nvPr/>
+        </p:nvSpPr>
+        <p:spPr>
+          <a:xfrm>
+            <a:off x="365760" y="1207008"/>
+            <a:ext cx="11475720" cy="749808"/>
+          </a:xfrm>
+          <a:prstGeom prst="rect">
+            <a:avLst/>
+          </a:prstGeom>
+          <a:noFill/>
+        </p:spPr>
+        <p:txBody>
+          <a:bodyPr wrap="square">
+            <a:spAutoFit/>
+          </a:bodyPr>
+          <a:lstStyle/>
+          <a:p>
+            <a:pPr algn="l">
+              <a:spcAft>
+                <a:spcPts val="300"/>
+              </a:spcAft>
+            </a:pPr>
+            <a:r>
+              <a:rPr sz="1300" b="0">
                 <a:solidFill>
                   <a:srgbClr val="0D3B66"/>
                 </a:solidFill>
@@ -6222,18 +6285,34 @@
               <a:t>Anillo Sur anda un poco sobre Norte: julio 54 % vs 46 % (unos 1,5 m³/día). Los dos cubren el mall; la diferencia es chica y se sostiene.</a:t>
             </a:r>
           </a:p>
-        </p:txBody>
-      </p:sp>
-      <p:sp>
-        <p:nvSpPr>
-          <p:cNvPr id="9" name="Rounded Rectangle 8"/>
+          <a:p>
+            <a:pPr algn="l">
+              <a:spcAft>
+                <a:spcPts val="300"/>
+              </a:spcAft>
+            </a:pPr>
+            <a:r>
+              <a:rPr sz="1300" b="1">
+                <a:solidFill>
+                  <a:srgbClr val="0D3B66"/>
+                </a:solidFill>
+                <a:latin typeface="Calibri"/>
+              </a:rPr>
+              <a:t>Umbrales a activar (total 24 h): Anillo Sur 14 m³/día (junio–agosto ~11 × 1,25)  ·  Anillo Norte 13 m³/día (junio–agosto ~10 × 1,25).</a:t>
+            </a:r>
+          </a:p>
+        </p:txBody>
+      </p:sp>
+      <p:sp>
+        <p:nvSpPr>
+          <p:cNvPr id="10" name="Rounded Rectangle 9"/>
           <p:cNvSpPr/>
           <p:nvPr/>
         </p:nvSpPr>
         <p:spPr>
           <a:xfrm>
-            <a:off x="201168" y="1737360"/>
-            <a:ext cx="5833872" cy="3803904"/>
+            <a:off x="201168" y="2084831"/>
+            <a:ext cx="5833872" cy="3456432"/>
           </a:xfrm>
           <a:prstGeom prst="roundRect">
             <a:avLst>
@@ -6271,13 +6350,13 @@
       </p:sp>
       <p:sp>
         <p:nvSpPr>
-          <p:cNvPr id="10" name="TextBox 9"/>
-          <p:cNvSpPr txBox="1"/>
-          <p:nvPr/>
-        </p:nvSpPr>
-        <p:spPr>
-          <a:xfrm>
-            <a:off x="329184" y="1773936"/>
+          <p:cNvPr id="11" name="TextBox 10"/>
+          <p:cNvSpPr txBox="1"/>
+          <p:nvPr/>
+        </p:nvSpPr>
+        <p:spPr>
+          <a:xfrm>
+            <a:off x="329184" y="2121408"/>
             <a:ext cx="5577840" cy="201168"/>
           </a:xfrm>
           <a:prstGeom prst="rect">
@@ -6310,7 +6389,7 @@
       </p:sp>
       <p:pic>
         <p:nvPicPr>
-          <p:cNvPr id="11" name="Picture 10" descr="cur_noches_jun_ago.png"/>
+          <p:cNvPr id="12" name="Picture 11" descr="cur_noches_jun_ago.png"/>
           <p:cNvPicPr>
             <a:picLocks noChangeAspect="1"/>
           </p:cNvPicPr>
@@ -6324,7 +6403,7 @@
         </p:blipFill>
         <p:spPr>
           <a:xfrm>
-            <a:off x="292608" y="2462304"/>
+            <a:off x="292608" y="2636040"/>
             <a:ext cx="5650992" cy="2518606"/>
           </a:xfrm>
           <a:prstGeom prst="rect">
@@ -6334,14 +6413,14 @@
       </p:pic>
       <p:sp>
         <p:nvSpPr>
-          <p:cNvPr id="12" name="Rounded Rectangle 11"/>
+          <p:cNvPr id="13" name="Rounded Rectangle 12"/>
           <p:cNvSpPr/>
           <p:nvPr/>
         </p:nvSpPr>
         <p:spPr>
           <a:xfrm>
-            <a:off x="6163056" y="1737360"/>
-            <a:ext cx="5815584" cy="3803904"/>
+            <a:off x="6163056" y="2084831"/>
+            <a:ext cx="5815584" cy="3456432"/>
           </a:xfrm>
           <a:prstGeom prst="roundRect">
             <a:avLst>
@@ -6379,13 +6458,13 @@
       </p:sp>
       <p:sp>
         <p:nvSpPr>
-          <p:cNvPr id="13" name="TextBox 12"/>
-          <p:cNvSpPr txBox="1"/>
-          <p:nvPr/>
-        </p:nvSpPr>
-        <p:spPr>
-          <a:xfrm>
-            <a:off x="6291072" y="1773936"/>
+          <p:cNvPr id="14" name="TextBox 13"/>
+          <p:cNvSpPr txBox="1"/>
+          <p:nvPr/>
+        </p:nvSpPr>
+        <p:spPr>
+          <a:xfrm>
+            <a:off x="6291072" y="2121408"/>
             <a:ext cx="5559552" cy="201168"/>
           </a:xfrm>
           <a:prstGeom prst="rect">
@@ -6418,7 +6497,7 @@
       </p:sp>
       <p:pic>
         <p:nvPicPr>
-          <p:cNvPr id="14" name="Picture 13" descr="cur_dia_sur_norte.png"/>
+          <p:cNvPr id="15" name="Picture 14" descr="cur_dia_sur_norte.png"/>
           <p:cNvPicPr>
             <a:picLocks noChangeAspect="1"/>
           </p:cNvPicPr>
@@ -6432,7 +6511,7 @@
         </p:blipFill>
         <p:spPr>
           <a:xfrm>
-            <a:off x="6254496" y="2466379"/>
+            <a:off x="6254496" y="2640115"/>
             <a:ext cx="5632704" cy="2510456"/>
           </a:xfrm>
           <a:prstGeom prst="rect">
@@ -6442,7 +6521,7 @@
       </p:pic>
       <p:sp>
         <p:nvSpPr>
-          <p:cNvPr id="15" name="Rounded Rectangle 14"/>
+          <p:cNvPr id="16" name="Rounded Rectangle 15"/>
           <p:cNvSpPr/>
           <p:nvPr/>
         </p:nvSpPr>
@@ -6489,7 +6568,7 @@
       </p:sp>
       <p:sp>
         <p:nvSpPr>
-          <p:cNvPr id="16" name="TextBox 15"/>
+          <p:cNvPr id="17" name="TextBox 16"/>
           <p:cNvSpPr txBox="1"/>
           <p:nvPr/>
         </p:nvSpPr>
@@ -6522,22 +6601,6 @@
                 <a:latin typeface="Calibri"/>
               </a:rPr>
               <a:t>Noche típica 00–06: Sur 0,8 m³  ·  Norte 0,4 m³. La madrugada sigue el mismo patrón chico; no se lee como fuga.</a:t>
-            </a:r>
-          </a:p>
-          <a:p>
-            <a:pPr algn="l">
-              <a:spcAft>
-                <a:spcPts val="300"/>
-              </a:spcAft>
-            </a:pPr>
-            <a:r>
-              <a:rPr sz="1300" b="1">
-                <a:solidFill>
-                  <a:srgbClr val="0D3B66"/>
-                </a:solidFill>
-                <a:latin typeface="Calibri"/>
-              </a:rPr>
-              <a:t>Umbrales a activar (total del día): Anillo Sur 14 m³/día (junio–agosto ~11 × 1,25). Anillo Norte 13 m³/día (junio–agosto ~10 × 1,25).</a:t>
             </a:r>
           </a:p>
         </p:txBody>
@@ -9228,7 +9291,7 @@
         <p:spPr>
           <a:xfrm>
             <a:off x="201168" y="987552"/>
-            <a:ext cx="11777472" cy="512064"/>
+            <a:ext cx="11777472" cy="1115568"/>
           </a:xfrm>
           <a:prstGeom prst="roundRect">
             <a:avLst>
@@ -9274,27 +9337,66 @@
         </p:nvSpPr>
         <p:spPr>
           <a:xfrm>
-            <a:off x="365760" y="1042415"/>
-            <a:ext cx="11475720" cy="402336"/>
-          </a:xfrm>
-          <a:prstGeom prst="rect">
-            <a:avLst/>
-          </a:prstGeom>
-          <a:noFill/>
-        </p:spPr>
-        <p:txBody>
-          <a:bodyPr wrap="square">
-            <a:spAutoFit/>
-          </a:bodyPr>
-          <a:lstStyle/>
-          <a:p>
-            <a:pPr algn="l">
-              <a:spcAft>
-                <a:spcPts val="300"/>
-              </a:spcAft>
-            </a:pPr>
-            <a:r>
-              <a:rPr sz="1300" b="0">
+            <a:off x="365760" y="1024128"/>
+            <a:ext cx="11475720" cy="182880"/>
+          </a:xfrm>
+          <a:prstGeom prst="rect">
+            <a:avLst/>
+          </a:prstGeom>
+          <a:noFill/>
+        </p:spPr>
+        <p:txBody>
+          <a:bodyPr wrap="square">
+            <a:spAutoFit/>
+          </a:bodyPr>
+          <a:lstStyle/>
+          <a:p>
+            <a:pPr algn="l">
+              <a:spcAft>
+                <a:spcPts val="300"/>
+              </a:spcAft>
+            </a:pPr>
+            <a:r>
+              <a:rPr sz="1100" b="1">
+                <a:solidFill>
+                  <a:srgbClr val="C9A227"/>
+                </a:solidFill>
+                <a:latin typeface="Calibri"/>
+              </a:rPr>
+              <a:t>HALLAZGOS</a:t>
+            </a:r>
+          </a:p>
+        </p:txBody>
+      </p:sp>
+      <p:sp>
+        <p:nvSpPr>
+          <p:cNvPr id="9" name="TextBox 8"/>
+          <p:cNvSpPr txBox="1"/>
+          <p:nvPr/>
+        </p:nvSpPr>
+        <p:spPr>
+          <a:xfrm>
+            <a:off x="365760" y="1207008"/>
+            <a:ext cx="11475720" cy="859536"/>
+          </a:xfrm>
+          <a:prstGeom prst="rect">
+            <a:avLst/>
+          </a:prstGeom>
+          <a:noFill/>
+        </p:spPr>
+        <p:txBody>
+          <a:bodyPr wrap="square">
+            <a:spAutoFit/>
+          </a:bodyPr>
+          <a:lstStyle/>
+          <a:p>
+            <a:pPr algn="l">
+              <a:spcAft>
+                <a:spcPts val="300"/>
+              </a:spcAft>
+            </a:pPr>
+            <a:r>
+              <a:rPr sz="1200" b="0">
                 <a:solidFill>
                   <a:srgbClr val="0D3B66"/>
                 </a:solidFill>
@@ -9303,18 +9405,50 @@
               <a:t>Sandía Antigua y Sandía Nueva alimentan Distrito de Lujo. Desde ahí el caudal se divide en Bazar Gourmet y DL Kennedy. Por eso esos tres puntos no se suman a la cabecera: sería doble conteo.</a:t>
             </a:r>
           </a:p>
-        </p:txBody>
-      </p:sp>
-      <p:sp>
-        <p:nvSpPr>
-          <p:cNvPr id="9" name="Rounded Rectangle 8"/>
+          <a:p>
+            <a:pPr algn="l">
+              <a:spcAft>
+                <a:spcPts val="300"/>
+              </a:spcAft>
+            </a:pPr>
+            <a:r>
+              <a:rPr sz="1200" b="1">
+                <a:solidFill>
+                  <a:srgbClr val="0D3B66"/>
+                </a:solidFill>
+                <a:latin typeface="Calibri"/>
+              </a:rPr>
+              <a:t>Propuesta: on/off 00–06 en Bazar Gourmet (el que más gasta de noche: 28,9 m³ vs 1,2 m³). 28,9 m³/noche = $40.460/noche  ·  867 m³/mes = $1.213.800/mes (tarifa $1.400/m³).</a:t>
+            </a:r>
+          </a:p>
+          <a:p>
+            <a:pPr algn="l">
+              <a:spcAft>
+                <a:spcPts val="300"/>
+              </a:spcAft>
+            </a:pPr>
+            <a:r>
+              <a:rPr sz="1200" b="1">
+                <a:solidFill>
+                  <a:srgbClr val="0D3B66"/>
+                </a:solidFill>
+                <a:latin typeface="Calibri"/>
+              </a:rPr>
+              <a:t>Umbrales a activar (total 24 h): Distrito de Lujo 390 m³/día  ·  Bazar Gourmet 250 m³/día  ·  DL Kennedy 20 m³/día.</a:t>
+            </a:r>
+          </a:p>
+        </p:txBody>
+      </p:sp>
+      <p:sp>
+        <p:nvSpPr>
+          <p:cNvPr id="10" name="Rounded Rectangle 9"/>
           <p:cNvSpPr/>
           <p:nvPr/>
         </p:nvSpPr>
         <p:spPr>
           <a:xfrm>
-            <a:off x="201168" y="1591056"/>
-            <a:ext cx="1938528" cy="457200"/>
+            <a:off x="201168" y="2157984"/>
+            <a:ext cx="1938528" cy="384048"/>
           </a:xfrm>
           <a:prstGeom prst="roundRect">
             <a:avLst>
@@ -9354,13 +9488,13 @@
       </p:sp>
       <p:sp>
         <p:nvSpPr>
-          <p:cNvPr id="10" name="TextBox 9"/>
-          <p:cNvSpPr txBox="1"/>
-          <p:nvPr/>
-        </p:nvSpPr>
-        <p:spPr>
-          <a:xfrm>
-            <a:off x="274320" y="1700784"/>
+          <p:cNvPr id="11" name="TextBox 10"/>
+          <p:cNvSpPr txBox="1"/>
+          <p:nvPr/>
+        </p:nvSpPr>
+        <p:spPr>
+          <a:xfrm>
+            <a:off x="274320" y="2267712"/>
             <a:ext cx="1792224" cy="256032"/>
           </a:xfrm>
           <a:prstGeom prst="rect">
@@ -9393,14 +9527,14 @@
       </p:sp>
       <p:sp>
         <p:nvSpPr>
-          <p:cNvPr id="11" name="Rounded Rectangle 10"/>
+          <p:cNvPr id="12" name="Rounded Rectangle 11"/>
           <p:cNvSpPr/>
           <p:nvPr/>
         </p:nvSpPr>
         <p:spPr>
           <a:xfrm>
-            <a:off x="2468880" y="1591056"/>
-            <a:ext cx="1938528" cy="457200"/>
+            <a:off x="2468880" y="2157984"/>
+            <a:ext cx="1938528" cy="384048"/>
           </a:xfrm>
           <a:prstGeom prst="roundRect">
             <a:avLst>
@@ -9440,13 +9574,13 @@
       </p:sp>
       <p:sp>
         <p:nvSpPr>
-          <p:cNvPr id="12" name="TextBox 11"/>
-          <p:cNvSpPr txBox="1"/>
-          <p:nvPr/>
-        </p:nvSpPr>
-        <p:spPr>
-          <a:xfrm>
-            <a:off x="2542032" y="1700784"/>
+          <p:cNvPr id="13" name="TextBox 12"/>
+          <p:cNvSpPr txBox="1"/>
+          <p:nvPr/>
+        </p:nvSpPr>
+        <p:spPr>
+          <a:xfrm>
+            <a:off x="2542032" y="2267712"/>
             <a:ext cx="1792224" cy="256032"/>
           </a:xfrm>
           <a:prstGeom prst="rect">
@@ -9479,14 +9613,14 @@
       </p:sp>
       <p:sp>
         <p:nvSpPr>
-          <p:cNvPr id="13" name="Rounded Rectangle 12"/>
+          <p:cNvPr id="14" name="Rounded Rectangle 13"/>
           <p:cNvSpPr/>
           <p:nvPr/>
         </p:nvSpPr>
         <p:spPr>
           <a:xfrm>
-            <a:off x="4864608" y="1591056"/>
-            <a:ext cx="2194560" cy="457200"/>
+            <a:off x="4864608" y="2157984"/>
+            <a:ext cx="2194560" cy="384048"/>
           </a:xfrm>
           <a:prstGeom prst="roundRect">
             <a:avLst>
@@ -9526,13 +9660,13 @@
       </p:sp>
       <p:sp>
         <p:nvSpPr>
-          <p:cNvPr id="14" name="TextBox 13"/>
-          <p:cNvSpPr txBox="1"/>
-          <p:nvPr/>
-        </p:nvSpPr>
-        <p:spPr>
-          <a:xfrm>
-            <a:off x="4937760" y="1700784"/>
+          <p:cNvPr id="15" name="TextBox 14"/>
+          <p:cNvSpPr txBox="1"/>
+          <p:nvPr/>
+        </p:nvSpPr>
+        <p:spPr>
+          <a:xfrm>
+            <a:off x="4937760" y="2267712"/>
             <a:ext cx="2048255" cy="256032"/>
           </a:xfrm>
           <a:prstGeom prst="rect">
@@ -9565,14 +9699,14 @@
       </p:sp>
       <p:sp>
         <p:nvSpPr>
-          <p:cNvPr id="15" name="Rounded Rectangle 14"/>
+          <p:cNvPr id="16" name="Rounded Rectangle 15"/>
           <p:cNvSpPr/>
           <p:nvPr/>
         </p:nvSpPr>
         <p:spPr>
           <a:xfrm>
-            <a:off x="7516368" y="1591056"/>
-            <a:ext cx="1938528" cy="457200"/>
+            <a:off x="7516368" y="2157984"/>
+            <a:ext cx="1938528" cy="384048"/>
           </a:xfrm>
           <a:prstGeom prst="roundRect">
             <a:avLst>
@@ -9612,13 +9746,13 @@
       </p:sp>
       <p:sp>
         <p:nvSpPr>
-          <p:cNvPr id="16" name="TextBox 15"/>
-          <p:cNvSpPr txBox="1"/>
-          <p:nvPr/>
-        </p:nvSpPr>
-        <p:spPr>
-          <a:xfrm>
-            <a:off x="7589520" y="1700784"/>
+          <p:cNvPr id="17" name="TextBox 16"/>
+          <p:cNvSpPr txBox="1"/>
+          <p:nvPr/>
+        </p:nvSpPr>
+        <p:spPr>
+          <a:xfrm>
+            <a:off x="7589520" y="2267712"/>
             <a:ext cx="1792224" cy="256032"/>
           </a:xfrm>
           <a:prstGeom prst="rect">
@@ -9651,14 +9785,14 @@
       </p:sp>
       <p:sp>
         <p:nvSpPr>
-          <p:cNvPr id="17" name="Rounded Rectangle 16"/>
+          <p:cNvPr id="18" name="Rounded Rectangle 17"/>
           <p:cNvSpPr/>
           <p:nvPr/>
         </p:nvSpPr>
         <p:spPr>
           <a:xfrm>
-            <a:off x="9546336" y="1591056"/>
-            <a:ext cx="1938528" cy="457200"/>
+            <a:off x="9546336" y="2157984"/>
+            <a:ext cx="1938528" cy="384048"/>
           </a:xfrm>
           <a:prstGeom prst="roundRect">
             <a:avLst>
@@ -9698,13 +9832,13 @@
       </p:sp>
       <p:sp>
         <p:nvSpPr>
-          <p:cNvPr id="18" name="TextBox 17"/>
-          <p:cNvSpPr txBox="1"/>
-          <p:nvPr/>
-        </p:nvSpPr>
-        <p:spPr>
-          <a:xfrm>
-            <a:off x="9619488" y="1700784"/>
+          <p:cNvPr id="19" name="TextBox 18"/>
+          <p:cNvSpPr txBox="1"/>
+          <p:nvPr/>
+        </p:nvSpPr>
+        <p:spPr>
+          <a:xfrm>
+            <a:off x="9619488" y="2267712"/>
             <a:ext cx="1792224" cy="256032"/>
           </a:xfrm>
           <a:prstGeom prst="rect">
@@ -9737,13 +9871,13 @@
       </p:sp>
       <p:sp>
         <p:nvSpPr>
-          <p:cNvPr id="19" name="TextBox 18"/>
-          <p:cNvSpPr txBox="1"/>
-          <p:nvPr/>
-        </p:nvSpPr>
-        <p:spPr>
-          <a:xfrm>
-            <a:off x="2139696" y="1664208"/>
+          <p:cNvPr id="20" name="TextBox 19"/>
+          <p:cNvSpPr txBox="1"/>
+          <p:nvPr/>
+        </p:nvSpPr>
+        <p:spPr>
+          <a:xfrm>
+            <a:off x="2139696" y="2231136"/>
             <a:ext cx="329184" cy="310896"/>
           </a:xfrm>
           <a:prstGeom prst="rect">
@@ -9776,13 +9910,13 @@
       </p:sp>
       <p:sp>
         <p:nvSpPr>
-          <p:cNvPr id="20" name="TextBox 19"/>
-          <p:cNvSpPr txBox="1"/>
-          <p:nvPr/>
-        </p:nvSpPr>
-        <p:spPr>
-          <a:xfrm>
-            <a:off x="4407408" y="1664208"/>
+          <p:cNvPr id="21" name="TextBox 20"/>
+          <p:cNvSpPr txBox="1"/>
+          <p:nvPr/>
+        </p:nvSpPr>
+        <p:spPr>
+          <a:xfrm>
+            <a:off x="4407408" y="2231136"/>
             <a:ext cx="457200" cy="310896"/>
           </a:xfrm>
           <a:prstGeom prst="rect">
@@ -9815,13 +9949,13 @@
       </p:sp>
       <p:sp>
         <p:nvSpPr>
-          <p:cNvPr id="21" name="TextBox 20"/>
-          <p:cNvSpPr txBox="1"/>
-          <p:nvPr/>
-        </p:nvSpPr>
-        <p:spPr>
-          <a:xfrm>
-            <a:off x="7059168" y="1664208"/>
+          <p:cNvPr id="22" name="TextBox 21"/>
+          <p:cNvSpPr txBox="1"/>
+          <p:nvPr/>
+        </p:nvSpPr>
+        <p:spPr>
+          <a:xfrm>
+            <a:off x="7059168" y="2231136"/>
             <a:ext cx="457200" cy="310896"/>
           </a:xfrm>
           <a:prstGeom prst="rect">
@@ -9854,14 +9988,14 @@
       </p:sp>
       <p:sp>
         <p:nvSpPr>
-          <p:cNvPr id="22" name="Rounded Rectangle 21"/>
+          <p:cNvPr id="23" name="Rounded Rectangle 22"/>
           <p:cNvSpPr/>
           <p:nvPr/>
         </p:nvSpPr>
         <p:spPr>
           <a:xfrm>
-            <a:off x="201168" y="2157984"/>
-            <a:ext cx="5833872" cy="3383280"/>
+            <a:off x="201168" y="2596896"/>
+            <a:ext cx="5833872" cy="2944368"/>
           </a:xfrm>
           <a:prstGeom prst="roundRect">
             <a:avLst>
@@ -9899,13 +10033,13 @@
       </p:sp>
       <p:sp>
         <p:nvSpPr>
-          <p:cNvPr id="23" name="TextBox 22"/>
-          <p:cNvSpPr txBox="1"/>
-          <p:nvPr/>
-        </p:nvSpPr>
-        <p:spPr>
-          <a:xfrm>
-            <a:off x="329184" y="2194560"/>
+          <p:cNvPr id="24" name="TextBox 23"/>
+          <p:cNvSpPr txBox="1"/>
+          <p:nvPr/>
+        </p:nvSpPr>
+        <p:spPr>
+          <a:xfrm>
+            <a:off x="329184" y="2633472"/>
             <a:ext cx="5577840" cy="201168"/>
           </a:xfrm>
           <a:prstGeom prst="rect">
@@ -9938,7 +10072,7 @@
       </p:sp>
       <p:pic>
         <p:nvPicPr>
-          <p:cNvPr id="24" name="Picture 23" descr="pak_cadena_perfil_20260810.png"/>
+          <p:cNvPr id="25" name="Picture 24" descr="pak_cadena_perfil_20260810.png"/>
           <p:cNvPicPr>
             <a:picLocks noChangeAspect="1"/>
           </p:cNvPicPr>
@@ -9952,7 +10086,7 @@
         </p:blipFill>
         <p:spPr>
           <a:xfrm>
-            <a:off x="292608" y="2672616"/>
+            <a:off x="292608" y="2892072"/>
             <a:ext cx="5650992" cy="2518606"/>
           </a:xfrm>
           <a:prstGeom prst="rect">
@@ -9962,14 +10096,14 @@
       </p:pic>
       <p:sp>
         <p:nvSpPr>
-          <p:cNvPr id="25" name="Rounded Rectangle 24"/>
+          <p:cNvPr id="26" name="Rounded Rectangle 25"/>
           <p:cNvSpPr/>
           <p:nvPr/>
         </p:nvSpPr>
         <p:spPr>
           <a:xfrm>
-            <a:off x="6163056" y="2157984"/>
-            <a:ext cx="5815584" cy="3383280"/>
+            <a:off x="6163056" y="2596896"/>
+            <a:ext cx="5815584" cy="2944368"/>
           </a:xfrm>
           <a:prstGeom prst="roundRect">
             <a:avLst>
@@ -10007,13 +10141,13 @@
       </p:sp>
       <p:sp>
         <p:nvSpPr>
-          <p:cNvPr id="26" name="TextBox 25"/>
-          <p:cNvSpPr txBox="1"/>
-          <p:nvPr/>
-        </p:nvSpPr>
-        <p:spPr>
-          <a:xfrm>
-            <a:off x="6291072" y="2194560"/>
+          <p:cNvPr id="27" name="TextBox 26"/>
+          <p:cNvSpPr txBox="1"/>
+          <p:nvPr/>
+        </p:nvSpPr>
+        <p:spPr>
+          <a:xfrm>
+            <a:off x="6291072" y="2633472"/>
             <a:ext cx="5559552" cy="201168"/>
           </a:xfrm>
           <a:prstGeom prst="rect">
@@ -10046,7 +10180,7 @@
       </p:sp>
       <p:pic>
         <p:nvPicPr>
-          <p:cNvPr id="27" name="Picture 26" descr="pak_cadena_noches_jul.png"/>
+          <p:cNvPr id="28" name="Picture 27" descr="pak_cadena_noches_jul.png"/>
           <p:cNvPicPr>
             <a:picLocks noChangeAspect="1"/>
           </p:cNvPicPr>
@@ -10060,7 +10194,7 @@
         </p:blipFill>
         <p:spPr>
           <a:xfrm>
-            <a:off x="6254496" y="2676691"/>
+            <a:off x="6254496" y="2896147"/>
             <a:ext cx="5632704" cy="2510456"/>
           </a:xfrm>
           <a:prstGeom prst="rect">
@@ -10070,7 +10204,7 @@
       </p:pic>
       <p:sp>
         <p:nvSpPr>
-          <p:cNvPr id="28" name="Rounded Rectangle 27"/>
+          <p:cNvPr id="29" name="Rounded Rectangle 28"/>
           <p:cNvSpPr/>
           <p:nvPr/>
         </p:nvSpPr>
@@ -10117,7 +10251,7 @@
       </p:sp>
       <p:sp>
         <p:nvSpPr>
-          <p:cNvPr id="29" name="TextBox 28"/>
+          <p:cNvPr id="30" name="TextBox 29"/>
           <p:cNvSpPr txBox="1"/>
           <p:nvPr/>
         </p:nvSpPr>
@@ -10149,23 +10283,7 @@
                 </a:solidFill>
                 <a:latin typeface="Calibri"/>
               </a:rPr>
-              <a:t>Noche típica 00–06: Bazar Gourmet 28,9 m³  ·  DL Kennedy 1,2 m³. El que más gasta de madrugada es Bazar Gourmet.</a:t>
-            </a:r>
-          </a:p>
-          <a:p>
-            <a:pPr algn="l">
-              <a:spcAft>
-                <a:spcPts val="300"/>
-              </a:spcAft>
-            </a:pPr>
-            <a:r>
-              <a:rPr sz="1200" b="1">
-                <a:solidFill>
-                  <a:srgbClr val="0D3B66"/>
-                </a:solidFill>
-                <a:latin typeface="Calibri"/>
-              </a:rPr>
-              <a:t>Propuesta: on/off 00–06 en Bazar Gourmet. 28,9 m³/noche = $40.460/noche  ·  867 m³/mes = $1.213.800/mes (tarifa $1.400/m³). DL Kennedy queda en 1,2 m³/noche.</a:t>
+              <a:t>Noche típica 00–06: Bazar Gourmet 28,9 m³  ·  DL Kennedy 1,2 m³. DL Kennedy queda en 1,2 m³/noche.</a:t>
             </a:r>
           </a:p>
         </p:txBody>
@@ -11848,7 +11966,7 @@
         <p:spPr>
           <a:xfrm>
             <a:off x="201168" y="987552"/>
-            <a:ext cx="11777472" cy="1389888"/>
+            <a:ext cx="11777472" cy="1481328"/>
           </a:xfrm>
           <a:prstGeom prst="roundRect">
             <a:avLst>
@@ -11895,7 +12013,7 @@
         <p:spPr>
           <a:xfrm>
             <a:off x="365760" y="1024128"/>
-            <a:ext cx="11475720" cy="201168"/>
+            <a:ext cx="11475720" cy="182880"/>
           </a:xfrm>
           <a:prstGeom prst="rect">
             <a:avLst/>
@@ -11933,8 +12051,8 @@
         </p:nvSpPr>
         <p:spPr>
           <a:xfrm>
-            <a:off x="365760" y="1225296"/>
-            <a:ext cx="11475720" cy="1097280"/>
+            <a:off x="365760" y="1207008"/>
+            <a:ext cx="11475720" cy="1225296"/>
           </a:xfrm>
           <a:prstGeom prst="rect">
             <a:avLst/>
@@ -11976,6 +12094,22 @@
                 <a:latin typeface="Calibri"/>
               </a:rPr>
               <a:t>Estanque Sur: el 10/06 se repararon los presostatos. Venía en 89 m³/día (mayo–9/jun) y ese día ya marca 39 m³. Desde el 11/06 se sostiene en 28 m³/día (−61 m³/día, 68%). A $1.400/m³: $84.897/día  ·  $2.546.923/mes  ·  acumulado 11/06–17/08: $5.688.128 (4.063 m³ en 67 días).</a:t>
+            </a:r>
+          </a:p>
+          <a:p>
+            <a:pPr algn="l">
+              <a:spcAft>
+                <a:spcPts val="300"/>
+              </a:spcAft>
+            </a:pPr>
+            <a:r>
+              <a:rPr sz="1200" b="1">
+                <a:solidFill>
+                  <a:srgbClr val="0D3B66"/>
+                </a:solidFill>
+                <a:latin typeface="Calibri"/>
+              </a:rPr>
+              <a:t>Umbrales a activar (total 24 h): Estanque Norte 40 m³/día  ·  Estanque Sur 35 m³/día  ·  Pizza Hut 50 m³/día  ·  Baños Públicos 10 m³/día.</a:t>
             </a:r>
           </a:p>
         </p:txBody>
@@ -11988,8 +12122,8 @@
         </p:nvSpPr>
         <p:spPr>
           <a:xfrm>
-            <a:off x="201168" y="2468880"/>
-            <a:ext cx="5285232" cy="3127248"/>
+            <a:off x="201168" y="2560320"/>
+            <a:ext cx="5285232" cy="3035808"/>
           </a:xfrm>
           <a:prstGeom prst="roundRect">
             <a:avLst>
@@ -12033,7 +12167,7 @@
         </p:nvSpPr>
         <p:spPr>
           <a:xfrm>
-            <a:off x="329184" y="2505456"/>
+            <a:off x="329184" y="2596896"/>
             <a:ext cx="5029200" cy="201168"/>
           </a:xfrm>
           <a:prstGeom prst="rect">
@@ -12080,8 +12214,8 @@
         </p:blipFill>
         <p:spPr>
           <a:xfrm>
-            <a:off x="329184" y="2724912"/>
-            <a:ext cx="5010912" cy="2761488"/>
+            <a:off x="329184" y="2816352"/>
+            <a:ext cx="5010912" cy="2670048"/>
           </a:xfrm>
           <a:prstGeom prst="rect">
             <a:avLst/>
@@ -12096,8 +12230,8 @@
         </p:nvSpPr>
         <p:spPr>
           <a:xfrm>
-            <a:off x="5614416" y="2468880"/>
-            <a:ext cx="6364224" cy="3127248"/>
+            <a:off x="5614416" y="2560320"/>
+            <a:ext cx="6364224" cy="3035808"/>
           </a:xfrm>
           <a:prstGeom prst="roundRect">
             <a:avLst>
@@ -12141,7 +12275,7 @@
         </p:nvSpPr>
         <p:spPr>
           <a:xfrm>
-            <a:off x="5742432" y="2505456"/>
+            <a:off x="5742432" y="2596896"/>
             <a:ext cx="6108192" cy="201168"/>
           </a:xfrm>
           <a:prstGeom prst="rect">
@@ -12188,8 +12322,8 @@
         </p:blipFill>
         <p:spPr>
           <a:xfrm>
-            <a:off x="5742432" y="2724912"/>
-            <a:ext cx="6108192" cy="2761488"/>
+            <a:off x="5742432" y="2816352"/>
+            <a:ext cx="6108192" cy="2670048"/>
           </a:xfrm>
           <a:prstGeom prst="rect">
             <a:avLst/>
@@ -14179,7 +14313,7 @@
         <p:spPr>
           <a:xfrm>
             <a:off x="201168" y="987552"/>
-            <a:ext cx="11777472" cy="658368"/>
+            <a:ext cx="11777472" cy="1005840"/>
           </a:xfrm>
           <a:prstGeom prst="roundRect">
             <a:avLst>
@@ -14225,27 +14359,66 @@
         </p:nvSpPr>
         <p:spPr>
           <a:xfrm>
-            <a:off x="365760" y="1042415"/>
-            <a:ext cx="11475720" cy="548640"/>
-          </a:xfrm>
-          <a:prstGeom prst="rect">
-            <a:avLst/>
-          </a:prstGeom>
-          <a:noFill/>
-        </p:spPr>
-        <p:txBody>
-          <a:bodyPr wrap="square">
-            <a:spAutoFit/>
-          </a:bodyPr>
-          <a:lstStyle/>
-          <a:p>
-            <a:pPr algn="l">
-              <a:spcAft>
-                <a:spcPts val="300"/>
-              </a:spcAft>
-            </a:pPr>
-            <a:r>
-              <a:rPr sz="1400" b="0">
+            <a:off x="365760" y="1024128"/>
+            <a:ext cx="11475720" cy="182880"/>
+          </a:xfrm>
+          <a:prstGeom prst="rect">
+            <a:avLst/>
+          </a:prstGeom>
+          <a:noFill/>
+        </p:spPr>
+        <p:txBody>
+          <a:bodyPr wrap="square">
+            <a:spAutoFit/>
+          </a:bodyPr>
+          <a:lstStyle/>
+          <a:p>
+            <a:pPr algn="l">
+              <a:spcAft>
+                <a:spcPts val="300"/>
+              </a:spcAft>
+            </a:pPr>
+            <a:r>
+              <a:rPr sz="1100" b="1">
+                <a:solidFill>
+                  <a:srgbClr val="C9A227"/>
+                </a:solidFill>
+                <a:latin typeface="Calibri"/>
+              </a:rPr>
+              <a:t>HALLAZGOS</a:t>
+            </a:r>
+          </a:p>
+        </p:txBody>
+      </p:sp>
+      <p:sp>
+        <p:nvSpPr>
+          <p:cNvPr id="9" name="TextBox 8"/>
+          <p:cNvSpPr txBox="1"/>
+          <p:nvPr/>
+        </p:nvSpPr>
+        <p:spPr>
+          <a:xfrm>
+            <a:off x="365760" y="1207008"/>
+            <a:ext cx="11475720" cy="749808"/>
+          </a:xfrm>
+          <a:prstGeom prst="rect">
+            <a:avLst/>
+          </a:prstGeom>
+          <a:noFill/>
+        </p:spPr>
+        <p:txBody>
+          <a:bodyPr wrap="square">
+            <a:spAutoFit/>
+          </a:bodyPr>
+          <a:lstStyle/>
+          <a:p>
+            <a:pPr algn="l">
+              <a:spcAft>
+                <a:spcPts val="300"/>
+              </a:spcAft>
+            </a:pPr>
+            <a:r>
+              <a:rPr sz="1300" b="0">
                 <a:solidFill>
                   <a:srgbClr val="0D3B66"/>
                 </a:solidFill>
@@ -14254,18 +14427,34 @@
               <a:t>Placa Bancaria se lleva 68 % de julio (7.084 m³). Pasillo Técnico (26 m³) y ARROW (0,5 m³) casi no miden: son los puntos para reubicar y partir la línea.</a:t>
             </a:r>
           </a:p>
-        </p:txBody>
-      </p:sp>
-      <p:sp>
-        <p:nvSpPr>
-          <p:cNvPr id="9" name="Rounded Rectangle 8"/>
+          <a:p>
+            <a:pPr algn="l">
+              <a:spcAft>
+                <a:spcPts val="300"/>
+              </a:spcAft>
+            </a:pPr>
+            <a:r>
+              <a:rPr sz="1300" b="1">
+                <a:solidFill>
+                  <a:srgbClr val="0D3B66"/>
+                </a:solidFill>
+                <a:latin typeface="Calibri"/>
+              </a:rPr>
+              <a:t>Umbrales a activar (total 24 h): Placa 290 m³/día (julio andaba en 229)  ·  Falabella 140 m³/día (ahora ~112).</a:t>
+            </a:r>
+          </a:p>
+        </p:txBody>
+      </p:sp>
+      <p:sp>
+        <p:nvSpPr>
+          <p:cNvPr id="10" name="Rounded Rectangle 9"/>
           <p:cNvSpPr/>
           <p:nvPr/>
         </p:nvSpPr>
         <p:spPr>
           <a:xfrm>
-            <a:off x="201168" y="1737360"/>
-            <a:ext cx="5833872" cy="3803904"/>
+            <a:off x="201168" y="2084831"/>
+            <a:ext cx="5833872" cy="3456432"/>
           </a:xfrm>
           <a:prstGeom prst="roundRect">
             <a:avLst>
@@ -14303,13 +14492,13 @@
       </p:sp>
       <p:sp>
         <p:nvSpPr>
-          <p:cNvPr id="10" name="TextBox 9"/>
-          <p:cNvSpPr txBox="1"/>
-          <p:nvPr/>
-        </p:nvSpPr>
-        <p:spPr>
-          <a:xfrm>
-            <a:off x="329184" y="1773936"/>
+          <p:cNvPr id="11" name="TextBox 10"/>
+          <p:cNvSpPr txBox="1"/>
+          <p:nvPr/>
+        </p:nvSpPr>
+        <p:spPr>
+          <a:xfrm>
+            <a:off x="329184" y="2121408"/>
             <a:ext cx="5577840" cy="201168"/>
           </a:xfrm>
           <a:prstGeom prst="rect">
@@ -14342,7 +14531,7 @@
       </p:sp>
       <p:pic>
         <p:nvPicPr>
-          <p:cNvPr id="11" name="Picture 10" descr="mam_placa_vs_falabella.png"/>
+          <p:cNvPr id="12" name="Picture 11" descr="mam_placa_vs_falabella.png"/>
           <p:cNvPicPr>
             <a:picLocks noChangeAspect="1"/>
           </p:cNvPicPr>
@@ -14356,7 +14545,7 @@
         </p:blipFill>
         <p:spPr>
           <a:xfrm>
-            <a:off x="292608" y="2462304"/>
+            <a:off x="292608" y="2636040"/>
             <a:ext cx="5650992" cy="2518606"/>
           </a:xfrm>
           <a:prstGeom prst="rect">
@@ -14366,14 +14555,14 @@
       </p:pic>
       <p:sp>
         <p:nvSpPr>
-          <p:cNvPr id="12" name="Rounded Rectangle 11"/>
+          <p:cNvPr id="13" name="Rounded Rectangle 12"/>
           <p:cNvSpPr/>
           <p:nvPr/>
         </p:nvSpPr>
         <p:spPr>
           <a:xfrm>
-            <a:off x="6163056" y="1737360"/>
-            <a:ext cx="5815584" cy="3803904"/>
+            <a:off x="6163056" y="2084831"/>
+            <a:ext cx="5815584" cy="3456432"/>
           </a:xfrm>
           <a:prstGeom prst="roundRect">
             <a:avLst>
@@ -14411,13 +14600,13 @@
       </p:sp>
       <p:sp>
         <p:nvSpPr>
-          <p:cNvPr id="13" name="TextBox 12"/>
-          <p:cNvSpPr txBox="1"/>
-          <p:nvPr/>
-        </p:nvSpPr>
-        <p:spPr>
-          <a:xfrm>
-            <a:off x="6291072" y="1773936"/>
+          <p:cNvPr id="14" name="TextBox 13"/>
+          <p:cNvSpPr txBox="1"/>
+          <p:nvPr/>
+        </p:nvSpPr>
+        <p:spPr>
+          <a:xfrm>
+            <a:off x="6291072" y="2121408"/>
             <a:ext cx="5559552" cy="201168"/>
           </a:xfrm>
           <a:prstGeom prst="rect">
@@ -14450,7 +14639,7 @@
       </p:sp>
       <p:pic>
         <p:nvPicPr>
-          <p:cNvPr id="14" name="Picture 13" descr="mam_placa_noches_jul_ago.png"/>
+          <p:cNvPr id="15" name="Picture 14" descr="mam_placa_noches_jul_ago.png"/>
           <p:cNvPicPr>
             <a:picLocks noChangeAspect="1"/>
           </p:cNvPicPr>
@@ -14464,7 +14653,7 @@
         </p:blipFill>
         <p:spPr>
           <a:xfrm>
-            <a:off x="6254496" y="2466379"/>
+            <a:off x="6254496" y="2640115"/>
             <a:ext cx="5632704" cy="2510456"/>
           </a:xfrm>
           <a:prstGeom prst="rect">
@@ -14474,7 +14663,7 @@
       </p:pic>
       <p:sp>
         <p:nvSpPr>
-          <p:cNvPr id="15" name="Rounded Rectangle 14"/>
+          <p:cNvPr id="16" name="Rounded Rectangle 15"/>
           <p:cNvSpPr/>
           <p:nvPr/>
         </p:nvSpPr>
@@ -14521,7 +14710,7 @@
       </p:sp>
       <p:sp>
         <p:nvSpPr>
-          <p:cNvPr id="16" name="TextBox 15"/>
+          <p:cNvPr id="17" name="TextBox 16"/>
           <p:cNvSpPr txBox="1"/>
           <p:nvPr/>
         </p:nvSpPr>
@@ -14553,23 +14742,7 @@
                 </a:solidFill>
                 <a:latin typeface="Calibri"/>
               </a:rPr>
-              <a:t>Desde el 15/08 Placa se fue a 0. Ya pasó: se inyecta Falabella, se corta Placa y el mall sale por Falabella.</a:t>
-            </a:r>
-          </a:p>
-          <a:p>
-            <a:pPr algn="l">
-              <a:spcAft>
-                <a:spcPts val="300"/>
-              </a:spcAft>
-            </a:pPr>
-            <a:r>
-              <a:rPr sz="1400" b="1">
-                <a:solidFill>
-                  <a:srgbClr val="0D3B66"/>
-                </a:solidFill>
-                <a:latin typeface="Calibri"/>
-              </a:rPr>
-              <a:t>Umbrales: Placa 290 m³/día (julio andaba en 229). Falabella 140 m³/día (ahora ~112). Noche 15 m³: el mall está cerrado y esa madrugada es alta. Siguiente paso: subdividir la línea de Falabella para ver hacia dónde va el consumo de noche.</a:t>
+              <a:t>Desde el 15/08 Placa se fue a 0. Ya pasó: se inyecta Falabella, se corta Placa y el mall sale por Falabella. Siguiente paso: subdividir la línea de Falabella para ver hacia dónde va el consumo de noche.</a:t>
             </a:r>
           </a:p>
         </p:txBody>
@@ -15791,7 +15964,7 @@
         <p:spPr>
           <a:xfrm>
             <a:off x="201168" y="987552"/>
-            <a:ext cx="11777472" cy="658368"/>
+            <a:ext cx="11777472" cy="1005840"/>
           </a:xfrm>
           <a:prstGeom prst="roundRect">
             <a:avLst>
@@ -15837,27 +16010,66 @@
         </p:nvSpPr>
         <p:spPr>
           <a:xfrm>
-            <a:off x="365760" y="1042415"/>
-            <a:ext cx="11475720" cy="548640"/>
-          </a:xfrm>
-          <a:prstGeom prst="rect">
-            <a:avLst/>
-          </a:prstGeom>
-          <a:noFill/>
-        </p:spPr>
-        <p:txBody>
-          <a:bodyPr wrap="square">
-            <a:spAutoFit/>
-          </a:bodyPr>
-          <a:lstStyle/>
-          <a:p>
-            <a:pPr algn="l">
-              <a:spcAft>
-                <a:spcPts val="300"/>
-              </a:spcAft>
-            </a:pPr>
-            <a:r>
-              <a:rPr sz="1400" b="0">
+            <a:off x="365760" y="1024128"/>
+            <a:ext cx="11475720" cy="182880"/>
+          </a:xfrm>
+          <a:prstGeom prst="rect">
+            <a:avLst/>
+          </a:prstGeom>
+          <a:noFill/>
+        </p:spPr>
+        <p:txBody>
+          <a:bodyPr wrap="square">
+            <a:spAutoFit/>
+          </a:bodyPr>
+          <a:lstStyle/>
+          <a:p>
+            <a:pPr algn="l">
+              <a:spcAft>
+                <a:spcPts val="300"/>
+              </a:spcAft>
+            </a:pPr>
+            <a:r>
+              <a:rPr sz="1100" b="1">
+                <a:solidFill>
+                  <a:srgbClr val="C9A227"/>
+                </a:solidFill>
+                <a:latin typeface="Calibri"/>
+              </a:rPr>
+              <a:t>HALLAZGOS</a:t>
+            </a:r>
+          </a:p>
+        </p:txBody>
+      </p:sp>
+      <p:sp>
+        <p:nvSpPr>
+          <p:cNvPr id="9" name="TextBox 8"/>
+          <p:cNvSpPr txBox="1"/>
+          <p:nvPr/>
+        </p:nvSpPr>
+        <p:spPr>
+          <a:xfrm>
+            <a:off x="365760" y="1207008"/>
+            <a:ext cx="11475720" cy="749808"/>
+          </a:xfrm>
+          <a:prstGeom prst="rect">
+            <a:avLst/>
+          </a:prstGeom>
+          <a:noFill/>
+        </p:spPr>
+        <p:txBody>
+          <a:bodyPr wrap="square">
+            <a:spAutoFit/>
+          </a:bodyPr>
+          <a:lstStyle/>
+          <a:p>
+            <a:pPr algn="l">
+              <a:spcAft>
+                <a:spcPts val="300"/>
+              </a:spcAft>
+            </a:pPr>
+            <a:r>
+              <a:rPr sz="1300" b="0">
                 <a:solidFill>
                   <a:srgbClr val="0D3B66"/>
                 </a:solidFill>
@@ -15866,18 +16078,34 @@
               <a:t>Matriz Principal se lleva 99 % de julio. Desde el 22/06 el día se duplicó (junio 131 → julio 193 → agosto 202 m³/día) y se quedó arriba. Baños es uso hábil: no es el problema.</a:t>
             </a:r>
           </a:p>
-        </p:txBody>
-      </p:sp>
-      <p:sp>
-        <p:nvSpPr>
-          <p:cNvPr id="9" name="Rounded Rectangle 8"/>
+          <a:p>
+            <a:pPr algn="l">
+              <a:spcAft>
+                <a:spcPts val="300"/>
+              </a:spcAft>
+            </a:pPr>
+            <a:r>
+              <a:rPr sz="1300" b="1">
+                <a:solidFill>
+                  <a:srgbClr val="0D3B66"/>
+                </a:solidFill>
+                <a:latin typeface="Calibri"/>
+              </a:rPr>
+              <a:t>Umbral a activar (total 24 h): Matriz Principal 240 m³/día (julio ~193).</a:t>
+            </a:r>
+          </a:p>
+        </p:txBody>
+      </p:sp>
+      <p:sp>
+        <p:nvSpPr>
+          <p:cNvPr id="10" name="Rounded Rectangle 9"/>
           <p:cNvSpPr/>
           <p:nvPr/>
         </p:nvSpPr>
         <p:spPr>
           <a:xfrm>
-            <a:off x="201168" y="1737360"/>
-            <a:ext cx="5833872" cy="3803904"/>
+            <a:off x="201168" y="2084831"/>
+            <a:ext cx="5833872" cy="3456432"/>
           </a:xfrm>
           <a:prstGeom prst="roundRect">
             <a:avLst>
@@ -15915,13 +16143,13 @@
       </p:sp>
       <p:sp>
         <p:nvSpPr>
-          <p:cNvPr id="10" name="TextBox 9"/>
-          <p:cNvSpPr txBox="1"/>
-          <p:nvPr/>
-        </p:nvSpPr>
-        <p:spPr>
-          <a:xfrm>
-            <a:off x="329184" y="1773936"/>
+          <p:cNvPr id="11" name="TextBox 10"/>
+          <p:cNvSpPr txBox="1"/>
+          <p:nvPr/>
+        </p:nvSpPr>
+        <p:spPr>
+          <a:xfrm>
+            <a:off x="329184" y="2121408"/>
             <a:ext cx="5577840" cy="201168"/>
           </a:xfrm>
           <a:prstGeom prst="rect">
@@ -15954,7 +16182,7 @@
       </p:sp>
       <p:pic>
         <p:nvPicPr>
-          <p:cNvPr id="11" name="Picture 10" descr="maq_matriz_diario_jun_ago.png"/>
+          <p:cNvPr id="12" name="Picture 11" descr="maq_matriz_diario_jun_ago.png"/>
           <p:cNvPicPr>
             <a:picLocks noChangeAspect="1"/>
           </p:cNvPicPr>
@@ -15968,7 +16196,7 @@
         </p:blipFill>
         <p:spPr>
           <a:xfrm>
-            <a:off x="292608" y="2467595"/>
+            <a:off x="292608" y="2641331"/>
             <a:ext cx="5650992" cy="2508024"/>
           </a:xfrm>
           <a:prstGeom prst="rect">
@@ -15978,14 +16206,14 @@
       </p:pic>
       <p:sp>
         <p:nvSpPr>
-          <p:cNvPr id="12" name="Rounded Rectangle 11"/>
+          <p:cNvPr id="13" name="Rounded Rectangle 12"/>
           <p:cNvSpPr/>
           <p:nvPr/>
         </p:nvSpPr>
         <p:spPr>
           <a:xfrm>
-            <a:off x="6163056" y="1737360"/>
-            <a:ext cx="5815584" cy="3803904"/>
+            <a:off x="6163056" y="2084831"/>
+            <a:ext cx="5815584" cy="3456432"/>
           </a:xfrm>
           <a:prstGeom prst="roundRect">
             <a:avLst>
@@ -16023,13 +16251,13 @@
       </p:sp>
       <p:sp>
         <p:nvSpPr>
-          <p:cNvPr id="13" name="TextBox 12"/>
-          <p:cNvSpPr txBox="1"/>
-          <p:nvPr/>
-        </p:nvSpPr>
-        <p:spPr>
-          <a:xfrm>
-            <a:off x="6291072" y="1773936"/>
+          <p:cNvPr id="14" name="TextBox 13"/>
+          <p:cNvSpPr txBox="1"/>
+          <p:nvPr/>
+        </p:nvSpPr>
+        <p:spPr>
+          <a:xfrm>
+            <a:off x="6291072" y="2121408"/>
             <a:ext cx="5559552" cy="201168"/>
           </a:xfrm>
           <a:prstGeom prst="rect">
@@ -16062,7 +16290,7 @@
       </p:sp>
       <p:pic>
         <p:nvPicPr>
-          <p:cNvPr id="14" name="Picture 13" descr="maq_matriz_noches_jun_ago.png"/>
+          <p:cNvPr id="15" name="Picture 14" descr="maq_matriz_noches_jun_ago.png"/>
           <p:cNvPicPr>
             <a:picLocks noChangeAspect="1"/>
           </p:cNvPicPr>
@@ -16076,7 +16304,7 @@
         </p:blipFill>
         <p:spPr>
           <a:xfrm>
-            <a:off x="6254496" y="2458468"/>
+            <a:off x="6254496" y="2632204"/>
             <a:ext cx="5632704" cy="2526278"/>
           </a:xfrm>
           <a:prstGeom prst="rect">
@@ -16086,7 +16314,7 @@
       </p:pic>
       <p:sp>
         <p:nvSpPr>
-          <p:cNvPr id="15" name="Rounded Rectangle 14"/>
+          <p:cNvPr id="16" name="Rounded Rectangle 15"/>
           <p:cNvSpPr/>
           <p:nvPr/>
         </p:nvSpPr>
@@ -16133,7 +16361,7 @@
       </p:sp>
       <p:sp>
         <p:nvSpPr>
-          <p:cNvPr id="16" name="TextBox 15"/>
+          <p:cNvPr id="17" name="TextBox 16"/>
           <p:cNvSpPr txBox="1"/>
           <p:nvPr/>
         </p:nvSpPr>
@@ -16165,7 +16393,7 @@
                 </a:solidFill>
                 <a:latin typeface="Calibri"/>
               </a:rPr>
-              <a:t>Umbrales: diario 240 m³/día (julio ~193). Noche 15 m³. Desde el 22/06 la madrugada anda en 21,9 m³ (antes 11,2). Mínimo típico por hora 00–06: 3 m³/h.</a:t>
+              <a:t>Desde el 22/06 la madrugada anda en 21,9 m³ (antes 11,2). Mínimo típico por hora 00–06: 3 m³/h.</a:t>
             </a:r>
           </a:p>
           <a:p>
@@ -17403,7 +17631,7 @@
         <p:spPr>
           <a:xfrm>
             <a:off x="201168" y="987552"/>
-            <a:ext cx="11777472" cy="1170432"/>
+            <a:ext cx="11777472" cy="1207008"/>
           </a:xfrm>
           <a:prstGeom prst="roundRect">
             <a:avLst>
@@ -17489,7 +17717,7 @@
         <p:spPr>
           <a:xfrm>
             <a:off x="365760" y="1207008"/>
-            <a:ext cx="11475720" cy="896112"/>
+            <a:ext cx="11475720" cy="950976"/>
           </a:xfrm>
           <a:prstGeom prst="rect">
             <a:avLst/>
@@ -17531,6 +17759,22 @@
                 <a:latin typeface="Calibri"/>
               </a:rPr>
               <a:t>Ahorro del corte 00–06: 29,7 m³/noche = $41.566/noche  ·  $1.246.980/mes. Acumulado 17/07–17/08 (32 noches): 950 m³ = $1.330.112 (tarifa $1.400/m³).</a:t>
+            </a:r>
+          </a:p>
+          <a:p>
+            <a:pPr algn="l">
+              <a:spcAft>
+                <a:spcPts val="300"/>
+              </a:spcAft>
+            </a:pPr>
+            <a:r>
+              <a:rPr sz="1300" b="1">
+                <a:solidFill>
+                  <a:srgbClr val="0D3B66"/>
+                </a:solidFill>
+                <a:latin typeface="Calibri"/>
+              </a:rPr>
+              <a:t>Umbrales a activar (total 24 h): San Ignacio 500 145 m³/día (agosto ~115)  ·  San Ignacio 300 45 m³/día.</a:t>
             </a:r>
           </a:p>
         </p:txBody>
@@ -17543,8 +17787,8 @@
         </p:nvSpPr>
         <p:spPr>
           <a:xfrm>
-            <a:off x="201168" y="2249424"/>
-            <a:ext cx="5833872" cy="3291840"/>
+            <a:off x="201168" y="2286000"/>
+            <a:ext cx="5833872" cy="3255264"/>
           </a:xfrm>
           <a:prstGeom prst="roundRect">
             <a:avLst>
@@ -17588,7 +17832,7 @@
         </p:nvSpPr>
         <p:spPr>
           <a:xfrm>
-            <a:off x="329184" y="2286000"/>
+            <a:off x="329184" y="2322576"/>
             <a:ext cx="5577840" cy="201168"/>
           </a:xfrm>
           <a:prstGeom prst="rect">
@@ -17635,7 +17879,7 @@
         </p:blipFill>
         <p:spPr>
           <a:xfrm>
-            <a:off x="292608" y="2719514"/>
+            <a:off x="292608" y="2737802"/>
             <a:ext cx="5650992" cy="2516250"/>
           </a:xfrm>
           <a:prstGeom prst="rect">
@@ -17651,8 +17895,8 @@
         </p:nvSpPr>
         <p:spPr>
           <a:xfrm>
-            <a:off x="6163056" y="2249424"/>
-            <a:ext cx="5815584" cy="3291840"/>
+            <a:off x="6163056" y="2286000"/>
+            <a:ext cx="5815584" cy="3255264"/>
           </a:xfrm>
           <a:prstGeom prst="roundRect">
             <a:avLst>
@@ -17696,7 +17940,7 @@
         </p:nvSpPr>
         <p:spPr>
           <a:xfrm>
-            <a:off x="6291072" y="2286000"/>
+            <a:off x="6291072" y="2322576"/>
             <a:ext cx="5559552" cy="201168"/>
           </a:xfrm>
           <a:prstGeom prst="rect">
@@ -17743,7 +17987,7 @@
         </p:blipFill>
         <p:spPr>
           <a:xfrm>
-            <a:off x="6254496" y="2722411"/>
+            <a:off x="6254496" y="2740699"/>
             <a:ext cx="5632704" cy="2510456"/>
           </a:xfrm>
           <a:prstGeom prst="rect">
@@ -17832,7 +18076,7 @@
                 </a:solidFill>
                 <a:latin typeface="Calibri"/>
               </a:rPr>
-              <a:t>Desde el 17/07 no hay noche alta: residual típico 2 m³ (máximo 4,4). No se lee como fuga. Umbrales a activar: San Ignacio 500 diario 145 m³/día (agosto ~115) y noche 8 m³ (avisa si el corte se cae). San Ignacio 300: alerta de umbral noche 4 m³.</a:t>
+              <a:t>Desde el 17/07 no hay noche alta: residual típico 2 m³ (máximo 4,4). No se lee como fuga.</a:t>
             </a:r>
           </a:p>
         </p:txBody>

</xml_diff>